<commit_message>
i #22 Update network cheatsheets and revisions
Replace updated binary assets for the network cheatsheet. This commit updates PDFs and PPTX files in cheatsheets/ and revisions/: network-cheatsheet.pdf, network-cheatsheet.pptx, network-cheatsheet-revisions.pdf, and network-cheatsheet-revisions.pptx to incorporate the latest revisions.

---------

Signed-off-by: Jared Seto <jaredws@hawaii.edu>
</commit_message>
<xml_diff>
--- a/cheatsheets/network-cheatsheet.pptx
+++ b/cheatsheets/network-cheatsheet.pptx
@@ -8,7 +8,7 @@
     <p:notesMasterId r:id="rId3"/>
   </p:notesMasterIdLst>
   <p:sldIdLst>
-    <p:sldId id="264" r:id="rId2"/>
+    <p:sldId id="265" r:id="rId2"/>
   </p:sldIdLst>
   <p:sldSz cx="13970000" cy="10795000"/>
   <p:notesSz cx="6858000" cy="9144000"/>
@@ -509,7 +509,7 @@
         <p:cNvPr id="1" name="">
           <a:extLst>
             <a:ext uri="{FF2B5EF4-FFF2-40B4-BE49-F238E27FC236}">
-              <a16:creationId xmlns:a16="http://schemas.microsoft.com/office/drawing/2014/main" id="{2155C73C-D961-59A8-653C-FD1B41495B4C}"/>
+              <a16:creationId xmlns:a16="http://schemas.microsoft.com/office/drawing/2014/main" id="{9B4AD321-A92B-63F8-D75B-F54390243AD2}"/>
             </a:ext>
           </a:extLst>
         </p:cNvPr>
@@ -529,7 +529,7 @@
           <p:cNvPr id="2" name="Slide Image Placeholder 1">
             <a:extLst>
               <a:ext uri="{FF2B5EF4-FFF2-40B4-BE49-F238E27FC236}">
-                <a16:creationId xmlns:a16="http://schemas.microsoft.com/office/drawing/2014/main" id="{71D27989-13CA-2661-E63A-022EB3E8BD8D}"/>
+                <a16:creationId xmlns:a16="http://schemas.microsoft.com/office/drawing/2014/main" id="{F4DE87AF-175F-0586-C6A8-2F44C356C466}"/>
               </a:ext>
             </a:extLst>
           </p:cNvPr>
@@ -559,7 +559,7 @@
           <p:cNvPr id="3" name="Notes Placeholder 2">
             <a:extLst>
               <a:ext uri="{FF2B5EF4-FFF2-40B4-BE49-F238E27FC236}">
-                <a16:creationId xmlns:a16="http://schemas.microsoft.com/office/drawing/2014/main" id="{24CC2506-7156-0D76-A3E6-7FEF7C00CBB7}"/>
+                <a16:creationId xmlns:a16="http://schemas.microsoft.com/office/drawing/2014/main" id="{24D7ED30-3193-A9F3-96DA-3F4C3A08D68F}"/>
               </a:ext>
             </a:extLst>
           </p:cNvPr>
@@ -582,7 +582,7 @@
     </p:spTree>
     <p:extLst>
       <p:ext uri="{BB962C8B-B14F-4D97-AF65-F5344CB8AC3E}">
-        <p14:creationId xmlns:p14="http://schemas.microsoft.com/office/powerpoint/2010/main" val="1895375567"/>
+        <p14:creationId xmlns:p14="http://schemas.microsoft.com/office/powerpoint/2010/main" val="3042171841"/>
       </p:ext>
     </p:extLst>
   </p:cSld>
@@ -2046,7 +2046,7 @@
           </a:ln>
           <a:extLst>
             <a:ext uri="{C572A759-6A51-4108-AA02-DFA0A04FC94B}">
-              <ma14:wrappingTextBoxFlag xmlns:ma14="http://schemas.microsoft.com/office/mac/drawingml/2011/main" xmlns:a14="http://schemas.microsoft.com/office/drawing/2010/main" xmlns:m="http://schemas.openxmlformats.org/officeDocument/2006/math" xmlns="" val="1"/>
+              <ma14:wrappingTextBoxFlag xmlns="" xmlns:m="http://schemas.openxmlformats.org/officeDocument/2006/math" xmlns:a14="http://schemas.microsoft.com/office/drawing/2010/main" xmlns:ma14="http://schemas.microsoft.com/office/mac/drawingml/2011/main" val="1"/>
             </a:ext>
           </a:extLst>
         </p:spPr>
@@ -2085,7 +2085,7 @@
           </a:ln>
           <a:extLst>
             <a:ext uri="{C572A759-6A51-4108-AA02-DFA0A04FC94B}">
-              <ma14:wrappingTextBoxFlag xmlns:ma14="http://schemas.microsoft.com/office/mac/drawingml/2011/main" xmlns:a14="http://schemas.microsoft.com/office/drawing/2010/main" xmlns:m="http://schemas.openxmlformats.org/officeDocument/2006/math" xmlns="" val="1"/>
+              <ma14:wrappingTextBoxFlag xmlns="" xmlns:m="http://schemas.openxmlformats.org/officeDocument/2006/math" xmlns:a14="http://schemas.microsoft.com/office/drawing/2010/main" xmlns:ma14="http://schemas.microsoft.com/office/mac/drawingml/2011/main" val="1"/>
             </a:ext>
           </a:extLst>
         </p:spPr>
@@ -2995,7 +2995,7 @@
         <p:cNvPr id="1" name="">
           <a:extLst>
             <a:ext uri="{FF2B5EF4-FFF2-40B4-BE49-F238E27FC236}">
-              <a16:creationId xmlns:a16="http://schemas.microsoft.com/office/drawing/2014/main" id="{87AE75CB-94B8-D94D-4792-670E2E4F1E3D}"/>
+              <a16:creationId xmlns:a16="http://schemas.microsoft.com/office/drawing/2014/main" id="{C58960BA-5BA0-AF4F-261A-5A97ECE57743}"/>
             </a:ext>
           </a:extLst>
         </p:cNvPr>
@@ -3010,12 +3010,45 @@
           <a:chExt cx="0" cy="0"/>
         </a:xfrm>
       </p:grpSpPr>
+      <p:pic>
+        <p:nvPicPr>
+          <p:cNvPr id="56" name="Image" descr="Image">
+            <a:extLst>
+              <a:ext uri="{FF2B5EF4-FFF2-40B4-BE49-F238E27FC236}">
+                <a16:creationId xmlns:a16="http://schemas.microsoft.com/office/drawing/2014/main" id="{A2F62703-C143-B799-3593-561228B348A1}"/>
+              </a:ext>
+            </a:extLst>
+          </p:cNvPr>
+          <p:cNvPicPr>
+            <a:picLocks noChangeAspect="1"/>
+          </p:cNvPicPr>
+          <p:nvPr/>
+        </p:nvPicPr>
+        <p:blipFill>
+          <a:blip r:embed="rId3"/>
+          <a:stretch>
+            <a:fillRect/>
+          </a:stretch>
+        </p:blipFill>
+        <p:spPr>
+          <a:xfrm>
+            <a:off x="8371568" y="-682083"/>
+            <a:ext cx="5598432" cy="2990088"/>
+          </a:xfrm>
+          <a:prstGeom prst="rect">
+            <a:avLst/>
+          </a:prstGeom>
+          <a:ln w="12700">
+            <a:miter lim="400000"/>
+          </a:ln>
+        </p:spPr>
+      </p:pic>
       <p:sp>
         <p:nvSpPr>
           <p:cNvPr id="447" name="TextBox 446">
             <a:extLst>
               <a:ext uri="{FF2B5EF4-FFF2-40B4-BE49-F238E27FC236}">
-                <a16:creationId xmlns:a16="http://schemas.microsoft.com/office/drawing/2014/main" id="{CB52EFD3-14B3-CC6B-3593-435986ECCE54}"/>
+                <a16:creationId xmlns:a16="http://schemas.microsoft.com/office/drawing/2014/main" id="{B85EF6AD-A856-EB07-C50B-10E577548EE9}"/>
               </a:ext>
             </a:extLst>
           </p:cNvPr>
@@ -3094,7 +3127,7 @@
           <p:cNvPr id="512" name="TextBox 511">
             <a:extLst>
               <a:ext uri="{FF2B5EF4-FFF2-40B4-BE49-F238E27FC236}">
-                <a16:creationId xmlns:a16="http://schemas.microsoft.com/office/drawing/2014/main" id="{00175A15-8CCF-2D74-A709-B7D5E49F1DD2}"/>
+                <a16:creationId xmlns:a16="http://schemas.microsoft.com/office/drawing/2014/main" id="{F128F195-DB72-50E7-1E97-A9B539A937B2}"/>
               </a:ext>
             </a:extLst>
           </p:cNvPr>
@@ -3174,7 +3207,7 @@
           <p:cNvPr id="515" name="TextBox 514">
             <a:extLst>
               <a:ext uri="{FF2B5EF4-FFF2-40B4-BE49-F238E27FC236}">
-                <a16:creationId xmlns:a16="http://schemas.microsoft.com/office/drawing/2014/main" id="{92715091-098C-BA22-1EF1-6A8A3B3B7001}"/>
+                <a16:creationId xmlns:a16="http://schemas.microsoft.com/office/drawing/2014/main" id="{DF28AAD1-1D33-61B2-98AB-CC61CB9CFEC6}"/>
               </a:ext>
             </a:extLst>
           </p:cNvPr>
@@ -3253,7 +3286,7 @@
           <p:cNvPr id="516" name="TextBox 515">
             <a:extLst>
               <a:ext uri="{FF2B5EF4-FFF2-40B4-BE49-F238E27FC236}">
-                <a16:creationId xmlns:a16="http://schemas.microsoft.com/office/drawing/2014/main" id="{FB00A6E2-6F18-1C4F-E0CF-D0C2F298C719}"/>
+                <a16:creationId xmlns:a16="http://schemas.microsoft.com/office/drawing/2014/main" id="{42DA7EF8-AC4E-C6CB-9343-C30F15BCE25E}"/>
               </a:ext>
             </a:extLst>
           </p:cNvPr>
@@ -3332,7 +3365,7 @@
           <p:cNvPr id="7" name="TextBox 6">
             <a:extLst>
               <a:ext uri="{FF2B5EF4-FFF2-40B4-BE49-F238E27FC236}">
-                <a16:creationId xmlns:a16="http://schemas.microsoft.com/office/drawing/2014/main" id="{B77E5AED-F21D-F3C8-54E5-14C8DAA2492C}"/>
+                <a16:creationId xmlns:a16="http://schemas.microsoft.com/office/drawing/2014/main" id="{520C60E1-2663-3EC5-15DF-CEBC07458A14}"/>
               </a:ext>
             </a:extLst>
           </p:cNvPr>
@@ -3496,7 +3529,7 @@
           <p:cNvPr id="514" name="TextBox 513">
             <a:extLst>
               <a:ext uri="{FF2B5EF4-FFF2-40B4-BE49-F238E27FC236}">
-                <a16:creationId xmlns:a16="http://schemas.microsoft.com/office/drawing/2014/main" id="{A6A38651-6143-58E0-A426-291742B7F63E}"/>
+                <a16:creationId xmlns:a16="http://schemas.microsoft.com/office/drawing/2014/main" id="{E05E5074-A8A1-1C0F-7CBB-E71862B7B6B9}"/>
               </a:ext>
             </a:extLst>
           </p:cNvPr>
@@ -3570,45 +3603,12 @@
           </a:p>
         </p:txBody>
       </p:sp>
-      <p:pic>
-        <p:nvPicPr>
-          <p:cNvPr id="292" name="Image" descr="Image">
-            <a:extLst>
-              <a:ext uri="{FF2B5EF4-FFF2-40B4-BE49-F238E27FC236}">
-                <a16:creationId xmlns:a16="http://schemas.microsoft.com/office/drawing/2014/main" id="{D412143F-8C0B-8E9F-6A3D-7E14A3B531CE}"/>
-              </a:ext>
-            </a:extLst>
-          </p:cNvPr>
-          <p:cNvPicPr>
-            <a:picLocks noChangeAspect="1"/>
-          </p:cNvPicPr>
-          <p:nvPr/>
-        </p:nvPicPr>
-        <p:blipFill>
-          <a:blip r:embed="rId3"/>
-          <a:stretch>
-            <a:fillRect/>
-          </a:stretch>
-        </p:blipFill>
-        <p:spPr>
-          <a:xfrm>
-            <a:off x="8867009" y="-681823"/>
-            <a:ext cx="5121226" cy="2990088"/>
-          </a:xfrm>
-          <a:prstGeom prst="rect">
-            <a:avLst/>
-          </a:prstGeom>
-          <a:ln w="12700">
-            <a:miter lim="400000"/>
-          </a:ln>
-        </p:spPr>
-      </p:pic>
       <p:sp>
         <p:nvSpPr>
           <p:cNvPr id="312" name="Line">
             <a:extLst>
               <a:ext uri="{FF2B5EF4-FFF2-40B4-BE49-F238E27FC236}">
-                <a16:creationId xmlns:a16="http://schemas.microsoft.com/office/drawing/2014/main" id="{C11ACDA3-A330-A7FC-35FF-39E6F1C972A8}"/>
+                <a16:creationId xmlns:a16="http://schemas.microsoft.com/office/drawing/2014/main" id="{29E76B25-1FD2-46A2-2E78-AD9205E6C94B}"/>
               </a:ext>
             </a:extLst>
           </p:cNvPr>
@@ -3656,7 +3656,7 @@
           <p:cNvPr id="313" name="YOUR LOGO…">
             <a:extLst>
               <a:ext uri="{FF2B5EF4-FFF2-40B4-BE49-F238E27FC236}">
-                <a16:creationId xmlns:a16="http://schemas.microsoft.com/office/drawing/2014/main" id="{7AF3A487-ABDE-7E86-C609-05D77F192B61}"/>
+                <a16:creationId xmlns:a16="http://schemas.microsoft.com/office/drawing/2014/main" id="{5F5ED31A-0A1B-78DE-C2E1-F3E81941C44F}"/>
               </a:ext>
             </a:extLst>
           </p:cNvPr>
@@ -3719,7 +3719,7 @@
           <p:cNvPr id="334" name="Three Column Layout: : CHEAT SHEET">
             <a:extLst>
               <a:ext uri="{FF2B5EF4-FFF2-40B4-BE49-F238E27FC236}">
-                <a16:creationId xmlns:a16="http://schemas.microsoft.com/office/drawing/2014/main" id="{6B65408F-2C85-7530-C56E-E5ABBD2AA71E}"/>
+                <a16:creationId xmlns:a16="http://schemas.microsoft.com/office/drawing/2014/main" id="{B35D9F55-410C-702E-BD81-4E2418BA40C1}"/>
               </a:ext>
             </a:extLst>
           </p:cNvPr>
@@ -3772,7 +3772,7 @@
           <p:cNvPr id="384" name="Layout Suggestions">
             <a:extLst>
               <a:ext uri="{FF2B5EF4-FFF2-40B4-BE49-F238E27FC236}">
-                <a16:creationId xmlns:a16="http://schemas.microsoft.com/office/drawing/2014/main" id="{4453C3E4-42A9-B61F-8214-74E6D6EF2559}"/>
+                <a16:creationId xmlns:a16="http://schemas.microsoft.com/office/drawing/2014/main" id="{82EB782C-FFC7-044E-17F9-5B570C801F40}"/>
               </a:ext>
             </a:extLst>
           </p:cNvPr>
@@ -3823,48 +3823,12 @@
           </a:p>
         </p:txBody>
       </p:sp>
-      <p:pic>
-        <p:nvPicPr>
-          <p:cNvPr id="8" name="Picture 7" descr="A picture containing text&#10;&#10;Description automatically generated">
-            <a:extLst>
-              <a:ext uri="{FF2B5EF4-FFF2-40B4-BE49-F238E27FC236}">
-                <a16:creationId xmlns:a16="http://schemas.microsoft.com/office/drawing/2014/main" id="{CBA9E0E7-A9EB-DFF3-2296-C97A3DD37923}"/>
-              </a:ext>
-            </a:extLst>
-          </p:cNvPr>
-          <p:cNvPicPr>
-            <a:picLocks noChangeAspect="1"/>
-          </p:cNvPicPr>
-          <p:nvPr/>
-        </p:nvPicPr>
-        <p:blipFill>
-          <a:blip r:embed="rId4" cstate="print">
-            <a:extLst>
-              <a:ext uri="{28A0092B-C50C-407E-A947-70E740481C1C}">
-                <a14:useLocalDpi xmlns:a14="http://schemas.microsoft.com/office/drawing/2010/main" val="0"/>
-              </a:ext>
-            </a:extLst>
-          </a:blip>
-          <a:stretch>
-            <a:fillRect/>
-          </a:stretch>
-        </p:blipFill>
-        <p:spPr>
-          <a:xfrm>
-            <a:off x="12214310" y="122459"/>
-            <a:ext cx="1443262" cy="1676046"/>
-          </a:xfrm>
-          <a:prstGeom prst="rect">
-            <a:avLst/>
-          </a:prstGeom>
-        </p:spPr>
-      </p:pic>
       <p:sp>
         <p:nvSpPr>
           <p:cNvPr id="501" name="TextBox 500">
             <a:extLst>
               <a:ext uri="{FF2B5EF4-FFF2-40B4-BE49-F238E27FC236}">
-                <a16:creationId xmlns:a16="http://schemas.microsoft.com/office/drawing/2014/main" id="{2F2FF23E-9199-57EA-026B-924449FE61BB}"/>
+                <a16:creationId xmlns:a16="http://schemas.microsoft.com/office/drawing/2014/main" id="{E7B7BA2C-7409-C813-C0EE-091C39123808}"/>
               </a:ext>
             </a:extLst>
           </p:cNvPr>
@@ -3873,8 +3837,8 @@
         </p:nvSpPr>
         <p:spPr>
           <a:xfrm>
-            <a:off x="274319" y="1661397"/>
-            <a:ext cx="3284761" cy="1797847"/>
+            <a:off x="274319" y="1737360"/>
+            <a:ext cx="3284761" cy="1645920"/>
           </a:xfrm>
           <a:prstGeom prst="rect">
             <a:avLst/>
@@ -3904,15 +3868,7 @@
             </a:r>
             <a:r>
               <a:rPr lang="en-US" b="0" dirty="0"/>
-              <a:t> graph module unifies a variety of data sources (e.g. git logs, mailing lists) in a consistent </a:t>
-            </a:r>
-            <a:r>
-              <a:rPr lang="en-US" b="0"/>
-              <a:t>object-oriented structure </a:t>
-            </a:r>
-            <a:r>
-              <a:rPr lang="en-US" b="0" dirty="0"/>
-              <a:t>using S3 (R's object-oriented system). This abstraction allows future graph functions to be de-coupled from the data source. Graph functions will also apply the correct transformations depending on the graph object being passed as parameter (similarly to a print() function).</a:t>
+              <a:t> graph module unifies a variety of data sources (e.g. git logs, mailing lists) in a consistent object-oriented structure using S3 (R's object-oriented system). This abstraction allows future graph functions to be de-coupled from the data source. Graph functions will also apply the correct transformations depending on the graph object being passed as parameter (similarly to a print() function).</a:t>
             </a:r>
             <a:endParaRPr kumimoji="0" lang="en-US" b="0" i="0" u="none" strike="noStrike" cap="none" spc="0" normalizeH="0" dirty="0">
               <a:ln>
@@ -3927,68 +3883,12 @@
           </a:p>
         </p:txBody>
       </p:sp>
-      <p:sp>
-        <p:nvSpPr>
-          <p:cNvPr id="424" name="Layout Suggestions">
-            <a:extLst>
-              <a:ext uri="{FF2B5EF4-FFF2-40B4-BE49-F238E27FC236}">
-                <a16:creationId xmlns:a16="http://schemas.microsoft.com/office/drawing/2014/main" id="{D8B9ADEC-CA83-2673-D6C2-A2E2EE9D874C}"/>
-              </a:ext>
-            </a:extLst>
-          </p:cNvPr>
-          <p:cNvSpPr txBox="1"/>
-          <p:nvPr/>
-        </p:nvSpPr>
-        <p:spPr>
-          <a:xfrm>
-            <a:off x="4937760" y="1463040"/>
-            <a:ext cx="3892248" cy="340029"/>
-          </a:xfrm>
-          <a:prstGeom prst="rect">
-            <a:avLst/>
-          </a:prstGeom>
-          <a:ln w="12700">
-            <a:miter lim="400000"/>
-          </a:ln>
-          <a:extLst>
-            <a:ext uri="{C572A759-6A51-4108-AA02-DFA0A04FC94B}">
-              <ma14:wrappingTextBoxFlag xmlns:ma14="http://schemas.microsoft.com/office/mac/drawingml/2011/main" xmlns:a14="http://schemas.microsoft.com/office/drawing/2010/main" xmlns:m="http://schemas.openxmlformats.org/officeDocument/2006/math" xmlns="" val="1"/>
-            </a:ext>
-          </a:extLst>
-        </p:spPr>
-        <p:txBody>
-          <a:bodyPr wrap="square" lIns="12700" tIns="12700" rIns="12700" bIns="12700" anchor="ctr">
-            <a:spAutoFit/>
-          </a:bodyPr>
-          <a:lstStyle/>
-          <a:p>
-            <a:pPr lvl="1" indent="0">
-              <a:lnSpc>
-                <a:spcPct val="80000"/>
-              </a:lnSpc>
-              <a:spcBef>
-                <a:spcPts val="0"/>
-              </a:spcBef>
-              <a:defRPr sz="2500" b="0">
-                <a:solidFill>
-                  <a:srgbClr val="628DB5"/>
-                </a:solidFill>
-              </a:defRPr>
-            </a:pPr>
-            <a:r>
-              <a:rPr lang="en-US" dirty="0"/>
-              <a:t>Network Transform Pipeline</a:t>
-            </a:r>
-            <a:endParaRPr dirty="0"/>
-          </a:p>
-        </p:txBody>
-      </p:sp>
       <p:cxnSp>
         <p:nvCxnSpPr>
           <p:cNvPr id="510" name="Elbow Connector 509">
             <a:extLst>
               <a:ext uri="{FF2B5EF4-FFF2-40B4-BE49-F238E27FC236}">
-                <a16:creationId xmlns:a16="http://schemas.microsoft.com/office/drawing/2014/main" id="{E8C57EA0-3E21-7D0A-382E-548B3351106F}"/>
+                <a16:creationId xmlns:a16="http://schemas.microsoft.com/office/drawing/2014/main" id="{D4779BEB-0A33-DF0D-B3B7-D969C5569994}"/>
               </a:ext>
             </a:extLst>
           </p:cNvPr>
@@ -4037,7 +3937,7 @@
           <p:cNvPr id="323" name="Elbow Connector 322">
             <a:extLst>
               <a:ext uri="{FF2B5EF4-FFF2-40B4-BE49-F238E27FC236}">
-                <a16:creationId xmlns:a16="http://schemas.microsoft.com/office/drawing/2014/main" id="{D62725E0-088E-28DD-C11C-92446A1680A3}"/>
+                <a16:creationId xmlns:a16="http://schemas.microsoft.com/office/drawing/2014/main" id="{E5E1ED9C-D5E0-233C-6D96-CF00209C1B79}"/>
               </a:ext>
             </a:extLst>
           </p:cNvPr>
@@ -4085,7 +3985,7 @@
           <p:cNvPr id="326" name="Manipulate Variables">
             <a:extLst>
               <a:ext uri="{FF2B5EF4-FFF2-40B4-BE49-F238E27FC236}">
-                <a16:creationId xmlns:a16="http://schemas.microsoft.com/office/drawing/2014/main" id="{2F9498C8-3307-19D4-3FFB-BEE8A00DCD6C}"/>
+                <a16:creationId xmlns:a16="http://schemas.microsoft.com/office/drawing/2014/main" id="{7DCEF4F9-EE20-CAC5-6EF5-33D073B7BC00}"/>
               </a:ext>
             </a:extLst>
           </p:cNvPr>
@@ -4138,66 +4038,10 @@
       </p:sp>
       <p:sp>
         <p:nvSpPr>
-          <p:cNvPr id="421" name="Manipulate Variables">
-            <a:extLst>
-              <a:ext uri="{FF2B5EF4-FFF2-40B4-BE49-F238E27FC236}">
-                <a16:creationId xmlns:a16="http://schemas.microsoft.com/office/drawing/2014/main" id="{FA72E449-20FE-F250-AC94-A5497D4C26C8}"/>
-              </a:ext>
-            </a:extLst>
-          </p:cNvPr>
-          <p:cNvSpPr txBox="1"/>
-          <p:nvPr/>
-        </p:nvSpPr>
-        <p:spPr>
-          <a:xfrm>
-            <a:off x="9875520" y="8321040"/>
-            <a:ext cx="3085781" cy="340029"/>
-          </a:xfrm>
-          <a:prstGeom prst="rect">
-            <a:avLst/>
-          </a:prstGeom>
-          <a:ln w="12700">
-            <a:miter lim="400000"/>
-          </a:ln>
-          <a:extLst>
-            <a:ext uri="{C572A759-6A51-4108-AA02-DFA0A04FC94B}">
-              <ma14:wrappingTextBoxFlag xmlns:ma14="http://schemas.microsoft.com/office/mac/drawingml/2011/main" xmlns:a14="http://schemas.microsoft.com/office/drawing/2010/main" xmlns:m="http://schemas.openxmlformats.org/officeDocument/2006/math" xmlns="" val="1"/>
-            </a:ext>
-          </a:extLst>
-        </p:spPr>
-        <p:txBody>
-          <a:bodyPr wrap="none" lIns="12700" tIns="12700" rIns="12700" bIns="12700" anchor="ctr">
-            <a:spAutoFit/>
-          </a:bodyPr>
-          <a:lstStyle/>
-          <a:p>
-            <a:pPr lvl="1" indent="0">
-              <a:lnSpc>
-                <a:spcPct val="80000"/>
-              </a:lnSpc>
-              <a:spcBef>
-                <a:spcPts val="0"/>
-              </a:spcBef>
-              <a:defRPr sz="2500" b="0">
-                <a:solidFill>
-                  <a:srgbClr val="628DB5"/>
-                </a:solidFill>
-              </a:defRPr>
-            </a:pPr>
-            <a:r>
-              <a:rPr lang="en-US" dirty="0"/>
-              <a:t>Custom Graph Weights</a:t>
-            </a:r>
-            <a:endParaRPr dirty="0"/>
-          </a:p>
-        </p:txBody>
-      </p:sp>
-      <p:sp>
-        <p:nvSpPr>
           <p:cNvPr id="426" name="TextBox 425">
             <a:extLst>
               <a:ext uri="{FF2B5EF4-FFF2-40B4-BE49-F238E27FC236}">
-                <a16:creationId xmlns:a16="http://schemas.microsoft.com/office/drawing/2014/main" id="{2DDA2A86-B769-8136-86EB-0CFF91555CF0}"/>
+                <a16:creationId xmlns:a16="http://schemas.microsoft.com/office/drawing/2014/main" id="{8B47F1E2-681C-19F7-24A6-86F18ED45FAF}"/>
               </a:ext>
             </a:extLst>
           </p:cNvPr>
@@ -4324,66 +4168,10 @@
       </p:sp>
       <p:sp>
         <p:nvSpPr>
-          <p:cNvPr id="6" name="Manipulate Variables">
-            <a:extLst>
-              <a:ext uri="{FF2B5EF4-FFF2-40B4-BE49-F238E27FC236}">
-                <a16:creationId xmlns:a16="http://schemas.microsoft.com/office/drawing/2014/main" id="{D9CD50D7-683A-4B82-527A-E84ACEE9860B}"/>
-              </a:ext>
-            </a:extLst>
-          </p:cNvPr>
-          <p:cNvSpPr txBox="1"/>
-          <p:nvPr/>
-        </p:nvSpPr>
-        <p:spPr>
-          <a:xfrm>
-            <a:off x="9875520" y="1459299"/>
-            <a:ext cx="2644955" cy="340029"/>
-          </a:xfrm>
-          <a:prstGeom prst="rect">
-            <a:avLst/>
-          </a:prstGeom>
-          <a:ln w="12700">
-            <a:miter lim="400000"/>
-          </a:ln>
-          <a:extLst>
-            <a:ext uri="{C572A759-6A51-4108-AA02-DFA0A04FC94B}">
-              <ma14:wrappingTextBoxFlag xmlns:ma14="http://schemas.microsoft.com/office/mac/drawingml/2011/main" xmlns:a14="http://schemas.microsoft.com/office/drawing/2010/main" xmlns:m="http://schemas.openxmlformats.org/officeDocument/2006/math" xmlns="" val="1"/>
-            </a:ext>
-          </a:extLst>
-        </p:spPr>
-        <p:txBody>
-          <a:bodyPr wrap="none" lIns="12700" tIns="12700" rIns="12700" bIns="12700" anchor="ctr">
-            <a:spAutoFit/>
-          </a:bodyPr>
-          <a:lstStyle/>
-          <a:p>
-            <a:pPr lvl="1" indent="0">
-              <a:lnSpc>
-                <a:spcPct val="80000"/>
-              </a:lnSpc>
-              <a:spcBef>
-                <a:spcPts val="0"/>
-              </a:spcBef>
-              <a:defRPr sz="2500" b="0">
-                <a:solidFill>
-                  <a:srgbClr val="628DB5"/>
-                </a:solidFill>
-              </a:defRPr>
-            </a:pPr>
-            <a:r>
-              <a:rPr lang="en-US" dirty="0"/>
-              <a:t>Graph Constructors</a:t>
-            </a:r>
-            <a:endParaRPr dirty="0"/>
-          </a:p>
-        </p:txBody>
-      </p:sp>
-      <p:sp>
-        <p:nvSpPr>
           <p:cNvPr id="10" name="Manipulate Variables">
             <a:extLst>
               <a:ext uri="{FF2B5EF4-FFF2-40B4-BE49-F238E27FC236}">
-                <a16:creationId xmlns:a16="http://schemas.microsoft.com/office/drawing/2014/main" id="{BC8E8649-E6DB-14B3-DA18-C77D4490374E}"/>
+                <a16:creationId xmlns:a16="http://schemas.microsoft.com/office/drawing/2014/main" id="{DB0D10F1-C540-FE1F-662A-B33A51117CDA}"/>
               </a:ext>
             </a:extLst>
           </p:cNvPr>
@@ -4439,7 +4227,7 @@
           <p:cNvPr id="488" name="Manipulate Variables">
             <a:extLst>
               <a:ext uri="{FF2B5EF4-FFF2-40B4-BE49-F238E27FC236}">
-                <a16:creationId xmlns:a16="http://schemas.microsoft.com/office/drawing/2014/main" id="{A19A1B5F-591A-91BC-4C56-1DDE109EAE59}"/>
+                <a16:creationId xmlns:a16="http://schemas.microsoft.com/office/drawing/2014/main" id="{04130859-EED8-13E4-2FB9-49C85BEC95EB}"/>
               </a:ext>
             </a:extLst>
           </p:cNvPr>
@@ -4495,7 +4283,7 @@
           <p:cNvPr id="2" name="TextBox 1">
             <a:extLst>
               <a:ext uri="{FF2B5EF4-FFF2-40B4-BE49-F238E27FC236}">
-                <a16:creationId xmlns:a16="http://schemas.microsoft.com/office/drawing/2014/main" id="{AF3DD7FE-1D2F-33B5-E486-E1B17606F920}"/>
+                <a16:creationId xmlns:a16="http://schemas.microsoft.com/office/drawing/2014/main" id="{02B5345F-D81A-8B23-DA3E-CE6AE98B82F5}"/>
               </a:ext>
             </a:extLst>
           </p:cNvPr>
@@ -4576,7 +4364,7 @@
           <p:cNvPr id="43" name="Elbow Connector 42">
             <a:extLst>
               <a:ext uri="{FF2B5EF4-FFF2-40B4-BE49-F238E27FC236}">
-                <a16:creationId xmlns:a16="http://schemas.microsoft.com/office/drawing/2014/main" id="{D1D414F4-2453-F882-726F-688250CFFF9A}"/>
+                <a16:creationId xmlns:a16="http://schemas.microsoft.com/office/drawing/2014/main" id="{5C529D7C-C665-B0CC-CDDD-0CD782B82289}"/>
               </a:ext>
             </a:extLst>
           </p:cNvPr>
@@ -4625,7 +4413,7 @@
           <p:cNvPr id="490" name="Elbow Connector 489">
             <a:extLst>
               <a:ext uri="{FF2B5EF4-FFF2-40B4-BE49-F238E27FC236}">
-                <a16:creationId xmlns:a16="http://schemas.microsoft.com/office/drawing/2014/main" id="{28BABB3F-6289-4947-355B-11FACA129A9F}"/>
+                <a16:creationId xmlns:a16="http://schemas.microsoft.com/office/drawing/2014/main" id="{79272D89-C97A-E6E1-4BFE-31F8CE50D585}"/>
               </a:ext>
             </a:extLst>
           </p:cNvPr>
@@ -4674,7 +4462,7 @@
           <p:cNvPr id="267" name="Google Shape;156;p1">
             <a:extLst>
               <a:ext uri="{FF2B5EF4-FFF2-40B4-BE49-F238E27FC236}">
-                <a16:creationId xmlns:a16="http://schemas.microsoft.com/office/drawing/2014/main" id="{0200B923-6526-C1CE-2C0F-F6780D010CD9}"/>
+                <a16:creationId xmlns:a16="http://schemas.microsoft.com/office/drawing/2014/main" id="{86C73B11-1D70-CCE5-645F-240B4C804000}"/>
               </a:ext>
             </a:extLst>
           </p:cNvPr>
@@ -4697,7 +4485,7 @@
             <p:cNvPr id="268" name="Google Shape;157;p1">
               <a:extLst>
                 <a:ext uri="{FF2B5EF4-FFF2-40B4-BE49-F238E27FC236}">
-                  <a16:creationId xmlns:a16="http://schemas.microsoft.com/office/drawing/2014/main" id="{80549F22-C576-CE4B-6B43-EE1415571467}"/>
+                  <a16:creationId xmlns:a16="http://schemas.microsoft.com/office/drawing/2014/main" id="{04D6EDDB-FABF-BC43-BA4A-E71907C6EFCD}"/>
                 </a:ext>
               </a:extLst>
             </p:cNvPr>
@@ -4764,7 +4552,7 @@
             <p:cNvPr id="269" name="Google Shape;158;p1">
               <a:extLst>
                 <a:ext uri="{FF2B5EF4-FFF2-40B4-BE49-F238E27FC236}">
-                  <a16:creationId xmlns:a16="http://schemas.microsoft.com/office/drawing/2014/main" id="{60A03372-F9AA-C143-683A-50A494BF4E40}"/>
+                  <a16:creationId xmlns:a16="http://schemas.microsoft.com/office/drawing/2014/main" id="{AA94CE47-ED6F-D0F6-08BE-168AE4CD1D0E}"/>
                 </a:ext>
               </a:extLst>
             </p:cNvPr>
@@ -4831,7 +4619,7 @@
             <p:cNvPr id="270" name="Google Shape;159;p1">
               <a:extLst>
                 <a:ext uri="{FF2B5EF4-FFF2-40B4-BE49-F238E27FC236}">
-                  <a16:creationId xmlns:a16="http://schemas.microsoft.com/office/drawing/2014/main" id="{C5B6B6B3-1724-C4E3-F556-B6638BB6B045}"/>
+                  <a16:creationId xmlns:a16="http://schemas.microsoft.com/office/drawing/2014/main" id="{9DE3156B-EC63-0077-1E74-633201D483C2}"/>
                 </a:ext>
               </a:extLst>
             </p:cNvPr>
@@ -4900,7 +4688,7 @@
             <p:cNvPr id="271" name="Google Shape;160;p1">
               <a:extLst>
                 <a:ext uri="{FF2B5EF4-FFF2-40B4-BE49-F238E27FC236}">
-                  <a16:creationId xmlns:a16="http://schemas.microsoft.com/office/drawing/2014/main" id="{FB274E5C-CB04-01A8-7291-478E2339A03D}"/>
+                  <a16:creationId xmlns:a16="http://schemas.microsoft.com/office/drawing/2014/main" id="{1180336F-8BBB-F7CE-1D81-F05CECBB3BFB}"/>
                 </a:ext>
               </a:extLst>
             </p:cNvPr>
@@ -4967,7 +4755,7 @@
             <p:cNvPr id="272" name="Google Shape;161;p1">
               <a:extLst>
                 <a:ext uri="{FF2B5EF4-FFF2-40B4-BE49-F238E27FC236}">
-                  <a16:creationId xmlns:a16="http://schemas.microsoft.com/office/drawing/2014/main" id="{2B75F399-E6BD-188B-D1CF-DA94F4036679}"/>
+                  <a16:creationId xmlns:a16="http://schemas.microsoft.com/office/drawing/2014/main" id="{785C31C6-88DA-74A4-C524-74B180435D6E}"/>
                 </a:ext>
               </a:extLst>
             </p:cNvPr>
@@ -5036,7 +4824,7 @@
             <p:cNvPr id="273" name="Google Shape;162;p1">
               <a:extLst>
                 <a:ext uri="{FF2B5EF4-FFF2-40B4-BE49-F238E27FC236}">
-                  <a16:creationId xmlns:a16="http://schemas.microsoft.com/office/drawing/2014/main" id="{4984491A-3B0F-ACE7-ACB1-12C07CD18F64}"/>
+                  <a16:creationId xmlns:a16="http://schemas.microsoft.com/office/drawing/2014/main" id="{CF303448-C23A-9EAA-28D5-5A311D7F4AEB}"/>
                 </a:ext>
               </a:extLst>
             </p:cNvPr>
@@ -5105,7 +4893,7 @@
             <p:cNvPr id="274" name="Google Shape;163;p1">
               <a:extLst>
                 <a:ext uri="{FF2B5EF4-FFF2-40B4-BE49-F238E27FC236}">
-                  <a16:creationId xmlns:a16="http://schemas.microsoft.com/office/drawing/2014/main" id="{EA2A6675-A6AB-2DDD-5306-9FEC7C1832B1}"/>
+                  <a16:creationId xmlns:a16="http://schemas.microsoft.com/office/drawing/2014/main" id="{1722E6E2-A9F4-D8A3-EF75-64FD71114516}"/>
                 </a:ext>
               </a:extLst>
             </p:cNvPr>
@@ -5172,7 +4960,7 @@
             <p:cNvPr id="275" name="Google Shape;164;p1">
               <a:extLst>
                 <a:ext uri="{FF2B5EF4-FFF2-40B4-BE49-F238E27FC236}">
-                  <a16:creationId xmlns:a16="http://schemas.microsoft.com/office/drawing/2014/main" id="{EC4BE474-4748-C40A-D243-5524DE72567D}"/>
+                  <a16:creationId xmlns:a16="http://schemas.microsoft.com/office/drawing/2014/main" id="{CA540B69-D08D-3F93-69A1-B106A3C9D00E}"/>
                 </a:ext>
               </a:extLst>
             </p:cNvPr>
@@ -5239,7 +5027,7 @@
             <p:cNvPr id="276" name="Google Shape;165;p1">
               <a:extLst>
                 <a:ext uri="{FF2B5EF4-FFF2-40B4-BE49-F238E27FC236}">
-                  <a16:creationId xmlns:a16="http://schemas.microsoft.com/office/drawing/2014/main" id="{F393AAC1-8A2A-EB02-85F5-4649C860AD20}"/>
+                  <a16:creationId xmlns:a16="http://schemas.microsoft.com/office/drawing/2014/main" id="{3B47B3A9-F5C9-3842-5B22-4EAD8CE93FA0}"/>
                 </a:ext>
               </a:extLst>
             </p:cNvPr>
@@ -5308,7 +5096,7 @@
             <p:cNvPr id="277" name="Google Shape;166;p1">
               <a:extLst>
                 <a:ext uri="{FF2B5EF4-FFF2-40B4-BE49-F238E27FC236}">
-                  <a16:creationId xmlns:a16="http://schemas.microsoft.com/office/drawing/2014/main" id="{C37E909D-0552-42B4-5BFF-94A2D0F8C845}"/>
+                  <a16:creationId xmlns:a16="http://schemas.microsoft.com/office/drawing/2014/main" id="{58EB9847-94A0-5E8A-3C40-2188B4491888}"/>
                 </a:ext>
               </a:extLst>
             </p:cNvPr>
@@ -5377,7 +5165,7 @@
             <p:cNvPr id="278" name="Google Shape;167;p1">
               <a:extLst>
                 <a:ext uri="{FF2B5EF4-FFF2-40B4-BE49-F238E27FC236}">
-                  <a16:creationId xmlns:a16="http://schemas.microsoft.com/office/drawing/2014/main" id="{61219249-2FE5-B5E7-67FD-1168E0FA6BA4}"/>
+                  <a16:creationId xmlns:a16="http://schemas.microsoft.com/office/drawing/2014/main" id="{6F2F49E2-A70E-0A1E-9EDC-9BB029CEF3E6}"/>
                 </a:ext>
               </a:extLst>
             </p:cNvPr>
@@ -5446,7 +5234,7 @@
             <p:cNvPr id="279" name="Google Shape;168;p1">
               <a:extLst>
                 <a:ext uri="{FF2B5EF4-FFF2-40B4-BE49-F238E27FC236}">
-                  <a16:creationId xmlns:a16="http://schemas.microsoft.com/office/drawing/2014/main" id="{BCC98B69-E71E-3A59-E315-316CF74D54E4}"/>
+                  <a16:creationId xmlns:a16="http://schemas.microsoft.com/office/drawing/2014/main" id="{68161072-AE40-FC1F-B9B3-55AF9C1EDB03}"/>
                 </a:ext>
               </a:extLst>
             </p:cNvPr>
@@ -5513,7 +5301,7 @@
             <p:cNvPr id="280" name="Google Shape;169;p1">
               <a:extLst>
                 <a:ext uri="{FF2B5EF4-FFF2-40B4-BE49-F238E27FC236}">
-                  <a16:creationId xmlns:a16="http://schemas.microsoft.com/office/drawing/2014/main" id="{BD7DD295-D18B-C0B1-2AD5-E92A6269F805}"/>
+                  <a16:creationId xmlns:a16="http://schemas.microsoft.com/office/drawing/2014/main" id="{201719F0-C5C6-32D1-4AAF-9802E9685100}"/>
                 </a:ext>
               </a:extLst>
             </p:cNvPr>
@@ -5582,7 +5370,7 @@
             <p:cNvPr id="281" name="Google Shape;170;p1">
               <a:extLst>
                 <a:ext uri="{FF2B5EF4-FFF2-40B4-BE49-F238E27FC236}">
-                  <a16:creationId xmlns:a16="http://schemas.microsoft.com/office/drawing/2014/main" id="{DF0166E3-DC77-EE43-5C87-4729A9DEC195}"/>
+                  <a16:creationId xmlns:a16="http://schemas.microsoft.com/office/drawing/2014/main" id="{116F1915-ADBB-F832-91FE-2F735B358EF7}"/>
                 </a:ext>
               </a:extLst>
             </p:cNvPr>
@@ -5649,7 +5437,7 @@
             <p:cNvPr id="282" name="Google Shape;171;p1">
               <a:extLst>
                 <a:ext uri="{FF2B5EF4-FFF2-40B4-BE49-F238E27FC236}">
-                  <a16:creationId xmlns:a16="http://schemas.microsoft.com/office/drawing/2014/main" id="{E80EA9F3-EB5A-FABF-7BCC-D90277EA9667}"/>
+                  <a16:creationId xmlns:a16="http://schemas.microsoft.com/office/drawing/2014/main" id="{6B7E74DD-361E-6A6E-3BE7-AF3B0E29E781}"/>
                 </a:ext>
               </a:extLst>
             </p:cNvPr>
@@ -5718,7 +5506,7 @@
             <p:cNvPr id="283" name="Google Shape;172;p1">
               <a:extLst>
                 <a:ext uri="{FF2B5EF4-FFF2-40B4-BE49-F238E27FC236}">
-                  <a16:creationId xmlns:a16="http://schemas.microsoft.com/office/drawing/2014/main" id="{A4765164-3EBA-A2E9-99AF-0948E2E6C047}"/>
+                  <a16:creationId xmlns:a16="http://schemas.microsoft.com/office/drawing/2014/main" id="{FA7E3C09-42DF-D05B-E064-8F7AA1DED54F}"/>
                 </a:ext>
               </a:extLst>
             </p:cNvPr>
@@ -5767,7 +5555,7 @@
             <p:cNvPr id="284" name="Google Shape;173;p1">
               <a:extLst>
                 <a:ext uri="{FF2B5EF4-FFF2-40B4-BE49-F238E27FC236}">
-                  <a16:creationId xmlns:a16="http://schemas.microsoft.com/office/drawing/2014/main" id="{E470307F-E4DC-0A0B-D435-D0583ED9736B}"/>
+                  <a16:creationId xmlns:a16="http://schemas.microsoft.com/office/drawing/2014/main" id="{2112FED9-D359-C9AD-F0E5-D13ADA71B4C1}"/>
                 </a:ext>
               </a:extLst>
             </p:cNvPr>
@@ -5816,7 +5604,7 @@
             <p:cNvPr id="285" name="Google Shape;175;p1">
               <a:extLst>
                 <a:ext uri="{FF2B5EF4-FFF2-40B4-BE49-F238E27FC236}">
-                  <a16:creationId xmlns:a16="http://schemas.microsoft.com/office/drawing/2014/main" id="{F151BA6A-5472-0BBA-D6EF-58DD7E93780D}"/>
+                  <a16:creationId xmlns:a16="http://schemas.microsoft.com/office/drawing/2014/main" id="{91A97F52-C0F7-85B3-66AB-2927D90AE511}"/>
                 </a:ext>
               </a:extLst>
             </p:cNvPr>
@@ -5865,7 +5653,7 @@
             <p:cNvPr id="286" name="Google Shape;177;p1">
               <a:extLst>
                 <a:ext uri="{FF2B5EF4-FFF2-40B4-BE49-F238E27FC236}">
-                  <a16:creationId xmlns:a16="http://schemas.microsoft.com/office/drawing/2014/main" id="{28992B35-3DB8-67D2-EF54-D3870FEEF159}"/>
+                  <a16:creationId xmlns:a16="http://schemas.microsoft.com/office/drawing/2014/main" id="{FCB91EF3-4C3B-43FD-C9E7-436C04258A90}"/>
                 </a:ext>
               </a:extLst>
             </p:cNvPr>
@@ -5914,7 +5702,7 @@
             <p:cNvPr id="287" name="Google Shape;178;p1">
               <a:extLst>
                 <a:ext uri="{FF2B5EF4-FFF2-40B4-BE49-F238E27FC236}">
-                  <a16:creationId xmlns:a16="http://schemas.microsoft.com/office/drawing/2014/main" id="{5CA12ED4-93AA-D484-E913-58ACC82C5204}"/>
+                  <a16:creationId xmlns:a16="http://schemas.microsoft.com/office/drawing/2014/main" id="{11326CF0-262D-AAB8-C7AE-89215AC0A9A3}"/>
                 </a:ext>
               </a:extLst>
             </p:cNvPr>
@@ -5963,7 +5751,7 @@
             <p:cNvPr id="288" name="Google Shape;179;p1">
               <a:extLst>
                 <a:ext uri="{FF2B5EF4-FFF2-40B4-BE49-F238E27FC236}">
-                  <a16:creationId xmlns:a16="http://schemas.microsoft.com/office/drawing/2014/main" id="{29CD0455-185F-85BF-15B2-B4C272B00F78}"/>
+                  <a16:creationId xmlns:a16="http://schemas.microsoft.com/office/drawing/2014/main" id="{B9226557-AD6C-6072-452C-38BFC71F118E}"/>
                 </a:ext>
               </a:extLst>
             </p:cNvPr>
@@ -6012,7 +5800,7 @@
             <p:cNvPr id="289" name="Google Shape;180;p1">
               <a:extLst>
                 <a:ext uri="{FF2B5EF4-FFF2-40B4-BE49-F238E27FC236}">
-                  <a16:creationId xmlns:a16="http://schemas.microsoft.com/office/drawing/2014/main" id="{51F1E688-0C60-D9CD-0DF6-8D9E42998C31}"/>
+                  <a16:creationId xmlns:a16="http://schemas.microsoft.com/office/drawing/2014/main" id="{ED7815E5-E40E-D9BA-ECAC-0C4C91B07252}"/>
                 </a:ext>
               </a:extLst>
             </p:cNvPr>
@@ -6061,7 +5849,7 @@
             <p:cNvPr id="290" name="Google Shape;181;p1">
               <a:extLst>
                 <a:ext uri="{FF2B5EF4-FFF2-40B4-BE49-F238E27FC236}">
-                  <a16:creationId xmlns:a16="http://schemas.microsoft.com/office/drawing/2014/main" id="{E8A58B43-A20B-9CC5-2E85-727E5F968C50}"/>
+                  <a16:creationId xmlns:a16="http://schemas.microsoft.com/office/drawing/2014/main" id="{5DACBC2F-6D5F-1602-8BAC-96F81AC3E6CD}"/>
                 </a:ext>
               </a:extLst>
             </p:cNvPr>
@@ -6110,7 +5898,7 @@
             <p:cNvPr id="291" name="Google Shape;183;p1">
               <a:extLst>
                 <a:ext uri="{FF2B5EF4-FFF2-40B4-BE49-F238E27FC236}">
-                  <a16:creationId xmlns:a16="http://schemas.microsoft.com/office/drawing/2014/main" id="{028E7661-C1F4-DD67-E2D8-E791C630BD9B}"/>
+                  <a16:creationId xmlns:a16="http://schemas.microsoft.com/office/drawing/2014/main" id="{48AE4544-7869-966B-6F66-FDB5ED2C89F9}"/>
                 </a:ext>
               </a:extLst>
             </p:cNvPr>
@@ -6159,7 +5947,7 @@
             <p:cNvPr id="293" name="Google Shape;176;p1">
               <a:extLst>
                 <a:ext uri="{FF2B5EF4-FFF2-40B4-BE49-F238E27FC236}">
-                  <a16:creationId xmlns:a16="http://schemas.microsoft.com/office/drawing/2014/main" id="{5A9603ED-0430-5A73-102B-59FEE01D440F}"/>
+                  <a16:creationId xmlns:a16="http://schemas.microsoft.com/office/drawing/2014/main" id="{E1E6221B-C765-4AED-6149-4C4EDA20C9DE}"/>
                 </a:ext>
               </a:extLst>
             </p:cNvPr>
@@ -6226,7 +6014,7 @@
             <p:cNvPr id="294" name="Google Shape;184;p1">
               <a:extLst>
                 <a:ext uri="{FF2B5EF4-FFF2-40B4-BE49-F238E27FC236}">
-                  <a16:creationId xmlns:a16="http://schemas.microsoft.com/office/drawing/2014/main" id="{DB93B45A-97CE-9420-D7A9-3667E766F9A7}"/>
+                  <a16:creationId xmlns:a16="http://schemas.microsoft.com/office/drawing/2014/main" id="{21FC396C-D02A-7FEC-86CF-168E48D192B6}"/>
                 </a:ext>
               </a:extLst>
             </p:cNvPr>
@@ -6275,7 +6063,7 @@
             <p:cNvPr id="295" name="Google Shape;185;p1">
               <a:extLst>
                 <a:ext uri="{FF2B5EF4-FFF2-40B4-BE49-F238E27FC236}">
-                  <a16:creationId xmlns:a16="http://schemas.microsoft.com/office/drawing/2014/main" id="{405D54C8-7CC3-4785-5D12-EB75C124A4EB}"/>
+                  <a16:creationId xmlns:a16="http://schemas.microsoft.com/office/drawing/2014/main" id="{AFACB7FF-2EC4-0B2C-811D-3D2435942966}"/>
                 </a:ext>
               </a:extLst>
             </p:cNvPr>
@@ -6324,7 +6112,7 @@
             <p:cNvPr id="296" name="Google Shape;174;p1">
               <a:extLst>
                 <a:ext uri="{FF2B5EF4-FFF2-40B4-BE49-F238E27FC236}">
-                  <a16:creationId xmlns:a16="http://schemas.microsoft.com/office/drawing/2014/main" id="{8960A3E4-F4FE-EA03-DEC0-5D24B0F2F92F}"/>
+                  <a16:creationId xmlns:a16="http://schemas.microsoft.com/office/drawing/2014/main" id="{6539BB91-DD5D-DC71-5DAC-C46D5F3B22EE}"/>
                 </a:ext>
               </a:extLst>
             </p:cNvPr>
@@ -6391,7 +6179,7 @@
             <p:cNvPr id="297" name="Google Shape;186;p1">
               <a:extLst>
                 <a:ext uri="{FF2B5EF4-FFF2-40B4-BE49-F238E27FC236}">
-                  <a16:creationId xmlns:a16="http://schemas.microsoft.com/office/drawing/2014/main" id="{CDCA0B84-7406-8516-8C99-C39B4A31E22B}"/>
+                  <a16:creationId xmlns:a16="http://schemas.microsoft.com/office/drawing/2014/main" id="{80DFC4A2-319A-1D25-3064-CEFF5B607A5F}"/>
                 </a:ext>
               </a:extLst>
             </p:cNvPr>
@@ -6440,7 +6228,7 @@
             <p:cNvPr id="298" name="Google Shape;187;p1">
               <a:extLst>
                 <a:ext uri="{FF2B5EF4-FFF2-40B4-BE49-F238E27FC236}">
-                  <a16:creationId xmlns:a16="http://schemas.microsoft.com/office/drawing/2014/main" id="{309A9323-A0A4-2652-2A4B-6452DD09C6B5}"/>
+                  <a16:creationId xmlns:a16="http://schemas.microsoft.com/office/drawing/2014/main" id="{F383918C-EC7C-CF37-B205-ED7B792923A8}"/>
                 </a:ext>
               </a:extLst>
             </p:cNvPr>
@@ -6477,7 +6265,7 @@
             <p:cNvPr id="299" name="Google Shape;189;p1">
               <a:extLst>
                 <a:ext uri="{FF2B5EF4-FFF2-40B4-BE49-F238E27FC236}">
-                  <a16:creationId xmlns:a16="http://schemas.microsoft.com/office/drawing/2014/main" id="{560443F5-D97F-01D4-9B7C-8BEB7893A29D}"/>
+                  <a16:creationId xmlns:a16="http://schemas.microsoft.com/office/drawing/2014/main" id="{7073115C-753C-19B4-9FD1-7D71D65C8CAE}"/>
                 </a:ext>
               </a:extLst>
             </p:cNvPr>
@@ -6526,7 +6314,7 @@
             <p:cNvPr id="300" name="Google Shape;190;p1">
               <a:extLst>
                 <a:ext uri="{FF2B5EF4-FFF2-40B4-BE49-F238E27FC236}">
-                  <a16:creationId xmlns:a16="http://schemas.microsoft.com/office/drawing/2014/main" id="{092EA975-ED3D-7E48-902F-79BB92F85803}"/>
+                  <a16:creationId xmlns:a16="http://schemas.microsoft.com/office/drawing/2014/main" id="{6EAD997E-93D8-B182-86F7-AFC461CFFF96}"/>
                 </a:ext>
               </a:extLst>
             </p:cNvPr>
@@ -6575,7 +6363,7 @@
             <p:cNvPr id="301" name="Google Shape;191;p1">
               <a:extLst>
                 <a:ext uri="{FF2B5EF4-FFF2-40B4-BE49-F238E27FC236}">
-                  <a16:creationId xmlns:a16="http://schemas.microsoft.com/office/drawing/2014/main" id="{3618EA37-1B63-8750-0B9C-D546F5203037}"/>
+                  <a16:creationId xmlns:a16="http://schemas.microsoft.com/office/drawing/2014/main" id="{321F8888-E0C7-2D29-447E-0F03165F536A}"/>
                 </a:ext>
               </a:extLst>
             </p:cNvPr>
@@ -6624,7 +6412,7 @@
             <p:cNvPr id="302" name="Google Shape;188;p1">
               <a:extLst>
                 <a:ext uri="{FF2B5EF4-FFF2-40B4-BE49-F238E27FC236}">
-                  <a16:creationId xmlns:a16="http://schemas.microsoft.com/office/drawing/2014/main" id="{5AF6ED1B-64EF-DBB0-4CD7-24FD35C5D3E4}"/>
+                  <a16:creationId xmlns:a16="http://schemas.microsoft.com/office/drawing/2014/main" id="{0D188FB4-1CA2-BF06-89B8-7EEF4E94E469}"/>
                 </a:ext>
               </a:extLst>
             </p:cNvPr>
@@ -6693,7 +6481,7 @@
             <p:cNvPr id="303" name="Google Shape;192;p1">
               <a:extLst>
                 <a:ext uri="{FF2B5EF4-FFF2-40B4-BE49-F238E27FC236}">
-                  <a16:creationId xmlns:a16="http://schemas.microsoft.com/office/drawing/2014/main" id="{B26A54D6-C67D-A516-B50B-45E1D19C395B}"/>
+                  <a16:creationId xmlns:a16="http://schemas.microsoft.com/office/drawing/2014/main" id="{C81BF0A6-1CBF-70F4-79C9-5CB7A55C118C}"/>
                 </a:ext>
               </a:extLst>
             </p:cNvPr>
@@ -6742,7 +6530,7 @@
             <p:cNvPr id="304" name="Google Shape;182;p1">
               <a:extLst>
                 <a:ext uri="{FF2B5EF4-FFF2-40B4-BE49-F238E27FC236}">
-                  <a16:creationId xmlns:a16="http://schemas.microsoft.com/office/drawing/2014/main" id="{23D74E42-9647-E967-4CB1-9900307BB643}"/>
+                  <a16:creationId xmlns:a16="http://schemas.microsoft.com/office/drawing/2014/main" id="{DB9FC5F2-9C53-79AB-F5A1-F86B295700A2}"/>
                 </a:ext>
               </a:extLst>
             </p:cNvPr>
@@ -6809,7 +6597,7 @@
             <p:cNvPr id="305" name="Google Shape;193;p1">
               <a:extLst>
                 <a:ext uri="{FF2B5EF4-FFF2-40B4-BE49-F238E27FC236}">
-                  <a16:creationId xmlns:a16="http://schemas.microsoft.com/office/drawing/2014/main" id="{820DCFC4-4B0B-7C85-5261-C0F3FCC809B8}"/>
+                  <a16:creationId xmlns:a16="http://schemas.microsoft.com/office/drawing/2014/main" id="{4760CF25-539D-11B4-2B72-7B3BADFDFDF3}"/>
                 </a:ext>
               </a:extLst>
             </p:cNvPr>
@@ -6858,7 +6646,7 @@
             <p:cNvPr id="306" name="Google Shape;194;p1">
               <a:extLst>
                 <a:ext uri="{FF2B5EF4-FFF2-40B4-BE49-F238E27FC236}">
-                  <a16:creationId xmlns:a16="http://schemas.microsoft.com/office/drawing/2014/main" id="{840C78C3-BF45-1E85-9F7F-7AF1E94FEE83}"/>
+                  <a16:creationId xmlns:a16="http://schemas.microsoft.com/office/drawing/2014/main" id="{64E874FA-A650-E684-25B9-4E2E0F72878A}"/>
                 </a:ext>
               </a:extLst>
             </p:cNvPr>
@@ -6907,7 +6695,7 @@
             <p:cNvPr id="307" name="Google Shape;195;p1">
               <a:extLst>
                 <a:ext uri="{FF2B5EF4-FFF2-40B4-BE49-F238E27FC236}">
-                  <a16:creationId xmlns:a16="http://schemas.microsoft.com/office/drawing/2014/main" id="{2C72B216-2C2A-8A3A-9ED9-9A0B05AE0201}"/>
+                  <a16:creationId xmlns:a16="http://schemas.microsoft.com/office/drawing/2014/main" id="{5A50CBD0-E34B-2AAA-1FAA-271B0F17703B}"/>
                 </a:ext>
               </a:extLst>
             </p:cNvPr>
@@ -6956,7 +6744,7 @@
             <p:cNvPr id="308" name="Google Shape;196;p1">
               <a:extLst>
                 <a:ext uri="{FF2B5EF4-FFF2-40B4-BE49-F238E27FC236}">
-                  <a16:creationId xmlns:a16="http://schemas.microsoft.com/office/drawing/2014/main" id="{8A5DED4B-4189-56D3-DC8E-72352E7685CA}"/>
+                  <a16:creationId xmlns:a16="http://schemas.microsoft.com/office/drawing/2014/main" id="{8C7AA68B-9973-E35B-EA2F-FA33E7F2ED56}"/>
                 </a:ext>
               </a:extLst>
             </p:cNvPr>
@@ -6993,7 +6781,7 @@
             <p:cNvPr id="309" name="Google Shape;197;p1">
               <a:extLst>
                 <a:ext uri="{FF2B5EF4-FFF2-40B4-BE49-F238E27FC236}">
-                  <a16:creationId xmlns:a16="http://schemas.microsoft.com/office/drawing/2014/main" id="{1F5E8FA9-A28C-EDBB-2B05-6360A9026A3D}"/>
+                  <a16:creationId xmlns:a16="http://schemas.microsoft.com/office/drawing/2014/main" id="{18EB3C50-F4E3-A798-221D-0C761BBF053E}"/>
                 </a:ext>
               </a:extLst>
             </p:cNvPr>
@@ -7042,7 +6830,7 @@
             <p:cNvPr id="310" name="Google Shape;198;p1">
               <a:extLst>
                 <a:ext uri="{FF2B5EF4-FFF2-40B4-BE49-F238E27FC236}">
-                  <a16:creationId xmlns:a16="http://schemas.microsoft.com/office/drawing/2014/main" id="{8D301A68-A8DC-0FC2-AC3D-5C827A11A737}"/>
+                  <a16:creationId xmlns:a16="http://schemas.microsoft.com/office/drawing/2014/main" id="{FD52C051-DEBD-4B04-EEFB-59D1CDBC2DE9}"/>
                 </a:ext>
               </a:extLst>
             </p:cNvPr>
@@ -7079,7 +6867,7 @@
             <p:cNvPr id="311" name="Google Shape;199;p1">
               <a:extLst>
                 <a:ext uri="{FF2B5EF4-FFF2-40B4-BE49-F238E27FC236}">
-                  <a16:creationId xmlns:a16="http://schemas.microsoft.com/office/drawing/2014/main" id="{8F61631B-6E83-CBBB-E0FF-614D73D25E12}"/>
+                  <a16:creationId xmlns:a16="http://schemas.microsoft.com/office/drawing/2014/main" id="{9B9544A7-8A2A-3CBA-A557-6275326C5522}"/>
                 </a:ext>
               </a:extLst>
             </p:cNvPr>
@@ -7116,7 +6904,7 @@
             <p:cNvPr id="315" name="Google Shape;200;p1">
               <a:extLst>
                 <a:ext uri="{FF2B5EF4-FFF2-40B4-BE49-F238E27FC236}">
-                  <a16:creationId xmlns:a16="http://schemas.microsoft.com/office/drawing/2014/main" id="{8AC75B14-67B7-C3EC-AEE8-F3B232E889CF}"/>
+                  <a16:creationId xmlns:a16="http://schemas.microsoft.com/office/drawing/2014/main" id="{080C635F-E01C-2296-2387-F5713509B9CA}"/>
                 </a:ext>
               </a:extLst>
             </p:cNvPr>
@@ -7154,7 +6942,7 @@
           <p:cNvPr id="12" name="Table">
             <a:extLst>
               <a:ext uri="{FF2B5EF4-FFF2-40B4-BE49-F238E27FC236}">
-                <a16:creationId xmlns:a16="http://schemas.microsoft.com/office/drawing/2014/main" id="{8A6C3249-EAAC-0B4B-28AB-5C383679AE67}"/>
+                <a16:creationId xmlns:a16="http://schemas.microsoft.com/office/drawing/2014/main" id="{1755303D-5C17-AEDD-5094-13DD8D525F5E}"/>
               </a:ext>
             </a:extLst>
           </p:cNvPr>
@@ -8114,7 +7902,7 @@
           <p:cNvPr id="13" name="Table">
             <a:extLst>
               <a:ext uri="{FF2B5EF4-FFF2-40B4-BE49-F238E27FC236}">
-                <a16:creationId xmlns:a16="http://schemas.microsoft.com/office/drawing/2014/main" id="{D64A28F2-A7C2-FD87-85BB-1A25888CB68A}"/>
+                <a16:creationId xmlns:a16="http://schemas.microsoft.com/office/drawing/2014/main" id="{7DA1610B-0B9F-BAB5-BFB1-79517842568B}"/>
               </a:ext>
             </a:extLst>
           </p:cNvPr>
@@ -8791,7 +8579,7 @@
           <p:cNvPr id="15" name="Table">
             <a:extLst>
               <a:ext uri="{FF2B5EF4-FFF2-40B4-BE49-F238E27FC236}">
-                <a16:creationId xmlns:a16="http://schemas.microsoft.com/office/drawing/2014/main" id="{FE95B880-9A32-8FBF-6758-27E11486E7A2}"/>
+                <a16:creationId xmlns:a16="http://schemas.microsoft.com/office/drawing/2014/main" id="{8D3EDD3C-72A4-77C2-AB62-714E6D565E26}"/>
               </a:ext>
             </a:extLst>
           </p:cNvPr>
@@ -9751,7 +9539,7 @@
           <p:cNvPr id="18" name="Table">
             <a:extLst>
               <a:ext uri="{FF2B5EF4-FFF2-40B4-BE49-F238E27FC236}">
-                <a16:creationId xmlns:a16="http://schemas.microsoft.com/office/drawing/2014/main" id="{13180637-F841-743C-7CFD-8900EB4C00B1}"/>
+                <a16:creationId xmlns:a16="http://schemas.microsoft.com/office/drawing/2014/main" id="{DE0643F5-88B4-653C-A19B-812D1C1ABA7F}"/>
               </a:ext>
             </a:extLst>
           </p:cNvPr>
@@ -10711,7 +10499,7 @@
           <p:cNvPr id="20" name="TextBox 19">
             <a:extLst>
               <a:ext uri="{FF2B5EF4-FFF2-40B4-BE49-F238E27FC236}">
-                <a16:creationId xmlns:a16="http://schemas.microsoft.com/office/drawing/2014/main" id="{BEC8F253-EF3D-5F70-942B-A924D6D3FBCE}"/>
+                <a16:creationId xmlns:a16="http://schemas.microsoft.com/office/drawing/2014/main" id="{C075BC12-64BD-AB6F-9FCB-16E3978165C1}"/>
               </a:ext>
             </a:extLst>
           </p:cNvPr>
@@ -10791,7 +10579,7 @@
           <p:cNvPr id="21" name="Graphic 20" descr="Paper outline">
             <a:extLst>
               <a:ext uri="{FF2B5EF4-FFF2-40B4-BE49-F238E27FC236}">
-                <a16:creationId xmlns:a16="http://schemas.microsoft.com/office/drawing/2014/main" id="{F6F40F79-F5FF-D252-BA00-5AD33F288C54}"/>
+                <a16:creationId xmlns:a16="http://schemas.microsoft.com/office/drawing/2014/main" id="{4FEA852B-480D-5CDF-09DE-C3D906189267}"/>
               </a:ext>
             </a:extLst>
           </p:cNvPr>
@@ -10807,7 +10595,7 @@
                 <a14:useLocalDpi xmlns:a14="http://schemas.microsoft.com/office/drawing/2010/main" val="0"/>
               </a:ext>
               <a:ext uri="{96DAC541-7B7A-43D3-8B79-37D633B846F1}">
-                <asvg:svgBlip xmlns:asvg="http://schemas.microsoft.com/office/drawing/2016/SVG/main" r:embed="rId5"/>
+                <asvg:svgBlip xmlns:asvg="http://schemas.microsoft.com/office/drawing/2016/SVG/main" r:embed="rId4"/>
               </a:ext>
             </a:extLst>
           </a:blip>
@@ -10830,7 +10618,7 @@
           <p:cNvPr id="24" name="TextBox 23">
             <a:extLst>
               <a:ext uri="{FF2B5EF4-FFF2-40B4-BE49-F238E27FC236}">
-                <a16:creationId xmlns:a16="http://schemas.microsoft.com/office/drawing/2014/main" id="{F0B25E12-DDAA-2358-A945-D1DA0D285BB2}"/>
+                <a16:creationId xmlns:a16="http://schemas.microsoft.com/office/drawing/2014/main" id="{C54BE284-B20F-08CC-7F93-F1B057953257}"/>
               </a:ext>
             </a:extLst>
           </p:cNvPr>
@@ -10910,7 +10698,46 @@
           <p:cNvPr id="25" name="Graphic 24" descr="Paper outline">
             <a:extLst>
               <a:ext uri="{FF2B5EF4-FFF2-40B4-BE49-F238E27FC236}">
-                <a16:creationId xmlns:a16="http://schemas.microsoft.com/office/drawing/2014/main" id="{867B23D2-8558-ADBB-B70D-4E913E13BE47}"/>
+                <a16:creationId xmlns:a16="http://schemas.microsoft.com/office/drawing/2014/main" id="{1CD1528C-B0E6-2632-BB9F-D98503E41A54}"/>
+              </a:ext>
+            </a:extLst>
+          </p:cNvPr>
+          <p:cNvPicPr>
+            <a:picLocks noChangeAspect="1"/>
+          </p:cNvPicPr>
+          <p:nvPr/>
+        </p:nvPicPr>
+        <p:blipFill>
+          <a:blip>
+            <a:extLst>
+              <a:ext uri="{28A0092B-C50C-407E-A947-70E740481C1C}">
+                <a14:useLocalDpi xmlns:a14="http://schemas.microsoft.com/office/drawing/2010/main" val="0"/>
+              </a:ext>
+              <a:ext uri="{96DAC541-7B7A-43D3-8B79-37D633B846F1}">
+                <asvg:svgBlip xmlns:asvg="http://schemas.microsoft.com/office/drawing/2016/SVG/main" r:embed="rId4"/>
+              </a:ext>
+            </a:extLst>
+          </a:blip>
+          <a:stretch>
+            <a:fillRect/>
+          </a:stretch>
+        </p:blipFill>
+        <p:spPr>
+          <a:xfrm>
+            <a:off x="7983775" y="1920889"/>
+            <a:ext cx="430268" cy="430268"/>
+          </a:xfrm>
+          <a:prstGeom prst="rect">
+            <a:avLst/>
+          </a:prstGeom>
+        </p:spPr>
+      </p:pic>
+      <p:pic>
+        <p:nvPicPr>
+          <p:cNvPr id="27" name="Graphic 26" descr="Folder outline">
+            <a:extLst>
+              <a:ext uri="{FF2B5EF4-FFF2-40B4-BE49-F238E27FC236}">
+                <a16:creationId xmlns:a16="http://schemas.microsoft.com/office/drawing/2014/main" id="{F63B833C-8CBD-F3D4-C8D1-50269F9DD7E5}"/>
               </a:ext>
             </a:extLst>
           </p:cNvPr>
@@ -10936,45 +10763,6 @@
         </p:blipFill>
         <p:spPr>
           <a:xfrm>
-            <a:off x="7983775" y="1920889"/>
-            <a:ext cx="430268" cy="430268"/>
-          </a:xfrm>
-          <a:prstGeom prst="rect">
-            <a:avLst/>
-          </a:prstGeom>
-        </p:spPr>
-      </p:pic>
-      <p:pic>
-        <p:nvPicPr>
-          <p:cNvPr id="27" name="Graphic 26" descr="Folder outline">
-            <a:extLst>
-              <a:ext uri="{FF2B5EF4-FFF2-40B4-BE49-F238E27FC236}">
-                <a16:creationId xmlns:a16="http://schemas.microsoft.com/office/drawing/2014/main" id="{4AF09060-F7F0-B014-6A0E-05A5B311C41D}"/>
-              </a:ext>
-            </a:extLst>
-          </p:cNvPr>
-          <p:cNvPicPr>
-            <a:picLocks noChangeAspect="1"/>
-          </p:cNvPicPr>
-          <p:nvPr/>
-        </p:nvPicPr>
-        <p:blipFill>
-          <a:blip>
-            <a:extLst>
-              <a:ext uri="{28A0092B-C50C-407E-A947-70E740481C1C}">
-                <a14:useLocalDpi xmlns:a14="http://schemas.microsoft.com/office/drawing/2010/main" val="0"/>
-              </a:ext>
-              <a:ext uri="{96DAC541-7B7A-43D3-8B79-37D633B846F1}">
-                <asvg:svgBlip xmlns:asvg="http://schemas.microsoft.com/office/drawing/2016/SVG/main" r:embed="rId6"/>
-              </a:ext>
-            </a:extLst>
-          </a:blip>
-          <a:stretch>
-            <a:fillRect/>
-          </a:stretch>
-        </p:blipFill>
-        <p:spPr>
-          <a:xfrm>
             <a:off x="5407260" y="1920240"/>
             <a:ext cx="550611" cy="550611"/>
           </a:xfrm>
@@ -10988,7 +10776,7 @@
           <p:cNvPr id="28" name="TextBox 27">
             <a:extLst>
               <a:ext uri="{FF2B5EF4-FFF2-40B4-BE49-F238E27FC236}">
-                <a16:creationId xmlns:a16="http://schemas.microsoft.com/office/drawing/2014/main" id="{577FF68D-CC2C-66BF-4A13-1F3F6F186A5E}"/>
+                <a16:creationId xmlns:a16="http://schemas.microsoft.com/office/drawing/2014/main" id="{C5A7E690-6F88-06FA-F12E-CEF74B1A6A77}"/>
               </a:ext>
             </a:extLst>
           </p:cNvPr>
@@ -11068,7 +10856,7 @@
           <p:cNvPr id="257" name="TextBox 256">
             <a:extLst>
               <a:ext uri="{FF2B5EF4-FFF2-40B4-BE49-F238E27FC236}">
-                <a16:creationId xmlns:a16="http://schemas.microsoft.com/office/drawing/2014/main" id="{2047A232-AAB4-0B8C-F957-85BAAE0CB95E}"/>
+                <a16:creationId xmlns:a16="http://schemas.microsoft.com/office/drawing/2014/main" id="{7233FFDD-BDCD-208C-C124-8930A72318E7}"/>
               </a:ext>
             </a:extLst>
           </p:cNvPr>
@@ -11148,7 +10936,7 @@
           <p:cNvPr id="258" name="Graphic 257" descr="Paper outline">
             <a:extLst>
               <a:ext uri="{FF2B5EF4-FFF2-40B4-BE49-F238E27FC236}">
-                <a16:creationId xmlns:a16="http://schemas.microsoft.com/office/drawing/2014/main" id="{A28FEFAB-BFE5-EBA2-FD89-B56A6BDF15CF}"/>
+                <a16:creationId xmlns:a16="http://schemas.microsoft.com/office/drawing/2014/main" id="{FFD5D4C7-99BB-54A7-2ADF-7754F57C5A0F}"/>
               </a:ext>
             </a:extLst>
           </p:cNvPr>
@@ -11164,7 +10952,7 @@
                 <a14:useLocalDpi xmlns:a14="http://schemas.microsoft.com/office/drawing/2010/main" val="0"/>
               </a:ext>
               <a:ext uri="{96DAC541-7B7A-43D3-8B79-37D633B846F1}">
-                <asvg:svgBlip xmlns:asvg="http://schemas.microsoft.com/office/drawing/2016/SVG/main" r:embed="rId5"/>
+                <asvg:svgBlip xmlns:asvg="http://schemas.microsoft.com/office/drawing/2016/SVG/main" r:embed="rId4"/>
               </a:ext>
             </a:extLst>
           </a:blip>
@@ -11187,7 +10975,7 @@
           <p:cNvPr id="430" name="Table">
             <a:extLst>
               <a:ext uri="{FF2B5EF4-FFF2-40B4-BE49-F238E27FC236}">
-                <a16:creationId xmlns:a16="http://schemas.microsoft.com/office/drawing/2014/main" id="{393CD5AF-5531-C212-2C2A-760A5CA39117}"/>
+                <a16:creationId xmlns:a16="http://schemas.microsoft.com/office/drawing/2014/main" id="{CB16FD64-B883-9448-1EF0-4E8655977824}"/>
               </a:ext>
             </a:extLst>
           </p:cNvPr>
@@ -11864,7 +11652,7 @@
           <p:cNvPr id="431" name="Table">
             <a:extLst>
               <a:ext uri="{FF2B5EF4-FFF2-40B4-BE49-F238E27FC236}">
-                <a16:creationId xmlns:a16="http://schemas.microsoft.com/office/drawing/2014/main" id="{53FB9CC4-BC7C-EA7A-793E-2CAA6A6E5691}"/>
+                <a16:creationId xmlns:a16="http://schemas.microsoft.com/office/drawing/2014/main" id="{EAC8871A-5B43-7090-47A5-3686FDFF90A1}"/>
               </a:ext>
             </a:extLst>
           </p:cNvPr>
@@ -12541,7 +12329,7 @@
           <p:cNvPr id="432" name="Table">
             <a:extLst>
               <a:ext uri="{FF2B5EF4-FFF2-40B4-BE49-F238E27FC236}">
-                <a16:creationId xmlns:a16="http://schemas.microsoft.com/office/drawing/2014/main" id="{789A2292-A200-37D1-6329-42432E90E5BB}"/>
+                <a16:creationId xmlns:a16="http://schemas.microsoft.com/office/drawing/2014/main" id="{F49940EC-B134-F76C-63DD-2502E7245C70}"/>
               </a:ext>
             </a:extLst>
           </p:cNvPr>
@@ -13218,7 +13006,7 @@
           <p:cNvPr id="438" name="Table">
             <a:extLst>
               <a:ext uri="{FF2B5EF4-FFF2-40B4-BE49-F238E27FC236}">
-                <a16:creationId xmlns:a16="http://schemas.microsoft.com/office/drawing/2014/main" id="{BAAA4A15-A2CA-FA39-3B35-D308773C9432}"/>
+                <a16:creationId xmlns:a16="http://schemas.microsoft.com/office/drawing/2014/main" id="{6AE4D28F-F19A-AE75-7544-191C9079D48C}"/>
               </a:ext>
             </a:extLst>
           </p:cNvPr>
@@ -13895,7 +13683,7 @@
           <p:cNvPr id="439" name="Table">
             <a:extLst>
               <a:ext uri="{FF2B5EF4-FFF2-40B4-BE49-F238E27FC236}">
-                <a16:creationId xmlns:a16="http://schemas.microsoft.com/office/drawing/2014/main" id="{2CB44C32-FB87-514F-8C4C-92D7CBF7BE73}"/>
+                <a16:creationId xmlns:a16="http://schemas.microsoft.com/office/drawing/2014/main" id="{B099E51E-97F6-7EDE-EE76-AEEBCFCBE56C}"/>
               </a:ext>
             </a:extLst>
           </p:cNvPr>
@@ -14572,7 +14360,7 @@
           <p:cNvPr id="317" name="Google Shape;156;p1">
             <a:extLst>
               <a:ext uri="{FF2B5EF4-FFF2-40B4-BE49-F238E27FC236}">
-                <a16:creationId xmlns:a16="http://schemas.microsoft.com/office/drawing/2014/main" id="{661C4011-770F-71C2-2390-B3AA185EB8A8}"/>
+                <a16:creationId xmlns:a16="http://schemas.microsoft.com/office/drawing/2014/main" id="{A9F13FB3-3D3E-3A11-3EA2-C4EBEE59A380}"/>
               </a:ext>
             </a:extLst>
           </p:cNvPr>
@@ -14592,7 +14380,7 @@
             <p:cNvPr id="318" name="Google Shape;157;p1">
               <a:extLst>
                 <a:ext uri="{FF2B5EF4-FFF2-40B4-BE49-F238E27FC236}">
-                  <a16:creationId xmlns:a16="http://schemas.microsoft.com/office/drawing/2014/main" id="{BD4A2FAF-9962-0C53-F1AC-D787A43E9BC2}"/>
+                  <a16:creationId xmlns:a16="http://schemas.microsoft.com/office/drawing/2014/main" id="{30A40027-A839-D0B8-3617-DC63B61CE48F}"/>
                 </a:ext>
               </a:extLst>
             </p:cNvPr>
@@ -14659,7 +14447,7 @@
             <p:cNvPr id="320" name="Google Shape;158;p1">
               <a:extLst>
                 <a:ext uri="{FF2B5EF4-FFF2-40B4-BE49-F238E27FC236}">
-                  <a16:creationId xmlns:a16="http://schemas.microsoft.com/office/drawing/2014/main" id="{ECBCB881-C131-D11A-EC5E-246C2A06EC45}"/>
+                  <a16:creationId xmlns:a16="http://schemas.microsoft.com/office/drawing/2014/main" id="{AFB630B6-28BD-C342-280D-AACBF7F4DAA6}"/>
                 </a:ext>
               </a:extLst>
             </p:cNvPr>
@@ -14726,7 +14514,7 @@
             <p:cNvPr id="321" name="Google Shape;159;p1">
               <a:extLst>
                 <a:ext uri="{FF2B5EF4-FFF2-40B4-BE49-F238E27FC236}">
-                  <a16:creationId xmlns:a16="http://schemas.microsoft.com/office/drawing/2014/main" id="{DB71C440-092A-5014-8D84-19A26DEF86B1}"/>
+                  <a16:creationId xmlns:a16="http://schemas.microsoft.com/office/drawing/2014/main" id="{99AFE83E-96B4-9692-0F17-C0CD3AD96C52}"/>
                 </a:ext>
               </a:extLst>
             </p:cNvPr>
@@ -14793,7 +14581,7 @@
             <p:cNvPr id="322" name="Google Shape;160;p1">
               <a:extLst>
                 <a:ext uri="{FF2B5EF4-FFF2-40B4-BE49-F238E27FC236}">
-                  <a16:creationId xmlns:a16="http://schemas.microsoft.com/office/drawing/2014/main" id="{4CFE16C5-9B9F-2318-2761-3F1A675D36A6}"/>
+                  <a16:creationId xmlns:a16="http://schemas.microsoft.com/office/drawing/2014/main" id="{593E0308-5052-1036-ECC2-B90E19E6B744}"/>
                 </a:ext>
               </a:extLst>
             </p:cNvPr>
@@ -14860,7 +14648,7 @@
             <p:cNvPr id="325" name="Google Shape;161;p1">
               <a:extLst>
                 <a:ext uri="{FF2B5EF4-FFF2-40B4-BE49-F238E27FC236}">
-                  <a16:creationId xmlns:a16="http://schemas.microsoft.com/office/drawing/2014/main" id="{E5F92F66-6487-DB57-0F5C-3D9E99BEE169}"/>
+                  <a16:creationId xmlns:a16="http://schemas.microsoft.com/office/drawing/2014/main" id="{0FAA659A-A1D8-E2D1-26FF-5B0AF68484F4}"/>
                 </a:ext>
               </a:extLst>
             </p:cNvPr>
@@ -14927,7 +14715,7 @@
             <p:cNvPr id="327" name="Google Shape;162;p1">
               <a:extLst>
                 <a:ext uri="{FF2B5EF4-FFF2-40B4-BE49-F238E27FC236}">
-                  <a16:creationId xmlns:a16="http://schemas.microsoft.com/office/drawing/2014/main" id="{96EEE50A-3E4F-577D-74E0-1F4913DAA82B}"/>
+                  <a16:creationId xmlns:a16="http://schemas.microsoft.com/office/drawing/2014/main" id="{6793045B-5084-8B26-9586-3EBE30030213}"/>
                 </a:ext>
               </a:extLst>
             </p:cNvPr>
@@ -14998,7 +14786,7 @@
             <p:cNvPr id="328" name="Google Shape;163;p1">
               <a:extLst>
                 <a:ext uri="{FF2B5EF4-FFF2-40B4-BE49-F238E27FC236}">
-                  <a16:creationId xmlns:a16="http://schemas.microsoft.com/office/drawing/2014/main" id="{F17AC113-56C2-966E-EC77-735729C14ADA}"/>
+                  <a16:creationId xmlns:a16="http://schemas.microsoft.com/office/drawing/2014/main" id="{759363F7-56AF-1185-8F87-E17E294CEBB7}"/>
                 </a:ext>
               </a:extLst>
             </p:cNvPr>
@@ -15069,7 +14857,7 @@
             <p:cNvPr id="329" name="Google Shape;164;p1">
               <a:extLst>
                 <a:ext uri="{FF2B5EF4-FFF2-40B4-BE49-F238E27FC236}">
-                  <a16:creationId xmlns:a16="http://schemas.microsoft.com/office/drawing/2014/main" id="{F479B0C9-F7D3-D0D9-51C8-B2557547F5F6}"/>
+                  <a16:creationId xmlns:a16="http://schemas.microsoft.com/office/drawing/2014/main" id="{12B9438C-9C9D-943B-814B-D4B1AEE4A097}"/>
                 </a:ext>
               </a:extLst>
             </p:cNvPr>
@@ -15140,7 +14928,7 @@
             <p:cNvPr id="331" name="Google Shape;165;p1">
               <a:extLst>
                 <a:ext uri="{FF2B5EF4-FFF2-40B4-BE49-F238E27FC236}">
-                  <a16:creationId xmlns:a16="http://schemas.microsoft.com/office/drawing/2014/main" id="{F0C52D15-1BC3-75C9-B5CF-94F358FA2ED0}"/>
+                  <a16:creationId xmlns:a16="http://schemas.microsoft.com/office/drawing/2014/main" id="{7A09D6D5-8641-3AD4-3837-21FC3935B266}"/>
                 </a:ext>
               </a:extLst>
             </p:cNvPr>
@@ -15211,7 +14999,7 @@
             <p:cNvPr id="332" name="Google Shape;166;p1">
               <a:extLst>
                 <a:ext uri="{FF2B5EF4-FFF2-40B4-BE49-F238E27FC236}">
-                  <a16:creationId xmlns:a16="http://schemas.microsoft.com/office/drawing/2014/main" id="{03E587DD-251E-F6D6-9F46-0D6119148C53}"/>
+                  <a16:creationId xmlns:a16="http://schemas.microsoft.com/office/drawing/2014/main" id="{CFF58CDE-D609-80B3-93D5-84F243C8A525}"/>
                 </a:ext>
               </a:extLst>
             </p:cNvPr>
@@ -15278,7 +15066,7 @@
             <p:cNvPr id="333" name="Google Shape;167;p1">
               <a:extLst>
                 <a:ext uri="{FF2B5EF4-FFF2-40B4-BE49-F238E27FC236}">
-                  <a16:creationId xmlns:a16="http://schemas.microsoft.com/office/drawing/2014/main" id="{9C670EA1-0FE4-B5E1-269A-1E357F22C477}"/>
+                  <a16:creationId xmlns:a16="http://schemas.microsoft.com/office/drawing/2014/main" id="{3F6E6C49-97AE-1D4C-147F-8E0FA553D797}"/>
                 </a:ext>
               </a:extLst>
             </p:cNvPr>
@@ -15345,7 +15133,7 @@
             <p:cNvPr id="335" name="Google Shape;168;p1">
               <a:extLst>
                 <a:ext uri="{FF2B5EF4-FFF2-40B4-BE49-F238E27FC236}">
-                  <a16:creationId xmlns:a16="http://schemas.microsoft.com/office/drawing/2014/main" id="{C7AE135B-C7D7-43BE-151D-201FD73D8AB9}"/>
+                  <a16:creationId xmlns:a16="http://schemas.microsoft.com/office/drawing/2014/main" id="{47F5962B-7439-3365-D29B-F306D7BF5A54}"/>
                 </a:ext>
               </a:extLst>
             </p:cNvPr>
@@ -15412,7 +15200,7 @@
             <p:cNvPr id="336" name="Google Shape;169;p1">
               <a:extLst>
                 <a:ext uri="{FF2B5EF4-FFF2-40B4-BE49-F238E27FC236}">
-                  <a16:creationId xmlns:a16="http://schemas.microsoft.com/office/drawing/2014/main" id="{C4DCC4CA-40F6-D06D-37C3-429A433E3AA9}"/>
+                  <a16:creationId xmlns:a16="http://schemas.microsoft.com/office/drawing/2014/main" id="{1543EE12-C641-ABF8-5DED-E88D4C1AA66E}"/>
                 </a:ext>
               </a:extLst>
             </p:cNvPr>
@@ -15479,7 +15267,7 @@
             <p:cNvPr id="337" name="Google Shape;170;p1">
               <a:extLst>
                 <a:ext uri="{FF2B5EF4-FFF2-40B4-BE49-F238E27FC236}">
-                  <a16:creationId xmlns:a16="http://schemas.microsoft.com/office/drawing/2014/main" id="{453CC3B7-D5EC-FB52-2AAE-0B420A6C7BC0}"/>
+                  <a16:creationId xmlns:a16="http://schemas.microsoft.com/office/drawing/2014/main" id="{74867DDF-0E33-C0EC-DDAA-E9B62DEA31C9}"/>
                 </a:ext>
               </a:extLst>
             </p:cNvPr>
@@ -15546,7 +15334,7 @@
             <p:cNvPr id="338" name="Google Shape;171;p1">
               <a:extLst>
                 <a:ext uri="{FF2B5EF4-FFF2-40B4-BE49-F238E27FC236}">
-                  <a16:creationId xmlns:a16="http://schemas.microsoft.com/office/drawing/2014/main" id="{9A3C6B66-64A2-CECC-95DC-5945BEE992AD}"/>
+                  <a16:creationId xmlns:a16="http://schemas.microsoft.com/office/drawing/2014/main" id="{5D2CC866-403B-6F34-FAD9-0B0E6B96177D}"/>
                 </a:ext>
               </a:extLst>
             </p:cNvPr>
@@ -15617,7 +15405,7 @@
             <p:cNvPr id="339" name="Google Shape;172;p1">
               <a:extLst>
                 <a:ext uri="{FF2B5EF4-FFF2-40B4-BE49-F238E27FC236}">
-                  <a16:creationId xmlns:a16="http://schemas.microsoft.com/office/drawing/2014/main" id="{BC7C9399-BCB7-DDAD-9F9A-B6FEC8FCBBE9}"/>
+                  <a16:creationId xmlns:a16="http://schemas.microsoft.com/office/drawing/2014/main" id="{DF86432C-0CE6-884A-190A-138CDE7792CA}"/>
                 </a:ext>
               </a:extLst>
             </p:cNvPr>
@@ -15652,7 +15440,7 @@
             <p:cNvPr id="340" name="Google Shape;173;p1">
               <a:extLst>
                 <a:ext uri="{FF2B5EF4-FFF2-40B4-BE49-F238E27FC236}">
-                  <a16:creationId xmlns:a16="http://schemas.microsoft.com/office/drawing/2014/main" id="{099429B7-B63D-529A-66EB-2538DA977037}"/>
+                  <a16:creationId xmlns:a16="http://schemas.microsoft.com/office/drawing/2014/main" id="{F1E67139-FAD1-B29A-9D44-17487CE0A730}"/>
                 </a:ext>
               </a:extLst>
             </p:cNvPr>
@@ -15687,7 +15475,7 @@
             <p:cNvPr id="343" name="Google Shape;175;p1">
               <a:extLst>
                 <a:ext uri="{FF2B5EF4-FFF2-40B4-BE49-F238E27FC236}">
-                  <a16:creationId xmlns:a16="http://schemas.microsoft.com/office/drawing/2014/main" id="{DCC97C2A-00DA-5250-53FE-C2BD40894DD2}"/>
+                  <a16:creationId xmlns:a16="http://schemas.microsoft.com/office/drawing/2014/main" id="{2971FC46-2FFC-39ED-4D57-5A40A8F78A09}"/>
                 </a:ext>
               </a:extLst>
             </p:cNvPr>
@@ -15722,7 +15510,7 @@
             <p:cNvPr id="344" name="Google Shape;177;p1">
               <a:extLst>
                 <a:ext uri="{FF2B5EF4-FFF2-40B4-BE49-F238E27FC236}">
-                  <a16:creationId xmlns:a16="http://schemas.microsoft.com/office/drawing/2014/main" id="{E03C08D8-16F0-7223-FA32-FE9019729A0C}"/>
+                  <a16:creationId xmlns:a16="http://schemas.microsoft.com/office/drawing/2014/main" id="{3B1F8C53-C32A-803D-601F-3AFD43E348F9}"/>
                 </a:ext>
               </a:extLst>
             </p:cNvPr>
@@ -15757,7 +15545,7 @@
             <p:cNvPr id="345" name="Google Shape;178;p1">
               <a:extLst>
                 <a:ext uri="{FF2B5EF4-FFF2-40B4-BE49-F238E27FC236}">
-                  <a16:creationId xmlns:a16="http://schemas.microsoft.com/office/drawing/2014/main" id="{797072A7-008F-A19D-3DE8-94F9EA617731}"/>
+                  <a16:creationId xmlns:a16="http://schemas.microsoft.com/office/drawing/2014/main" id="{761A1E3A-A829-B76E-8405-CA01D887FBC9}"/>
                 </a:ext>
               </a:extLst>
             </p:cNvPr>
@@ -15792,7 +15580,7 @@
             <p:cNvPr id="346" name="Google Shape;179;p1">
               <a:extLst>
                 <a:ext uri="{FF2B5EF4-FFF2-40B4-BE49-F238E27FC236}">
-                  <a16:creationId xmlns:a16="http://schemas.microsoft.com/office/drawing/2014/main" id="{5875D63F-2413-F4B0-C86C-A901F2A0813C}"/>
+                  <a16:creationId xmlns:a16="http://schemas.microsoft.com/office/drawing/2014/main" id="{46CD6C9E-C4E6-2630-0058-1234E1F7F9D1}"/>
                 </a:ext>
               </a:extLst>
             </p:cNvPr>
@@ -15827,7 +15615,7 @@
             <p:cNvPr id="347" name="Google Shape;180;p1">
               <a:extLst>
                 <a:ext uri="{FF2B5EF4-FFF2-40B4-BE49-F238E27FC236}">
-                  <a16:creationId xmlns:a16="http://schemas.microsoft.com/office/drawing/2014/main" id="{B175E5A3-FED9-65A8-C4C4-3C1364C25F81}"/>
+                  <a16:creationId xmlns:a16="http://schemas.microsoft.com/office/drawing/2014/main" id="{2F0485EA-2BA7-B53F-24A8-03FCACC3C2F6}"/>
                 </a:ext>
               </a:extLst>
             </p:cNvPr>
@@ -15862,7 +15650,7 @@
             <p:cNvPr id="348" name="Google Shape;181;p1">
               <a:extLst>
                 <a:ext uri="{FF2B5EF4-FFF2-40B4-BE49-F238E27FC236}">
-                  <a16:creationId xmlns:a16="http://schemas.microsoft.com/office/drawing/2014/main" id="{5D043103-4ECA-E768-51E6-1BB4CAFB39BC}"/>
+                  <a16:creationId xmlns:a16="http://schemas.microsoft.com/office/drawing/2014/main" id="{C84DB7F6-FD22-568B-07D3-C23AE332C39A}"/>
                 </a:ext>
               </a:extLst>
             </p:cNvPr>
@@ -15897,7 +15685,7 @@
             <p:cNvPr id="349" name="Google Shape;183;p1">
               <a:extLst>
                 <a:ext uri="{FF2B5EF4-FFF2-40B4-BE49-F238E27FC236}">
-                  <a16:creationId xmlns:a16="http://schemas.microsoft.com/office/drawing/2014/main" id="{D1DE24CE-F4CB-2EB8-A84E-4A832D501AC3}"/>
+                  <a16:creationId xmlns:a16="http://schemas.microsoft.com/office/drawing/2014/main" id="{0262F3FA-8E18-E811-62E0-7C69EF9EFE3C}"/>
                 </a:ext>
               </a:extLst>
             </p:cNvPr>
@@ -15932,7 +15720,7 @@
             <p:cNvPr id="350" name="Google Shape;176;p1">
               <a:extLst>
                 <a:ext uri="{FF2B5EF4-FFF2-40B4-BE49-F238E27FC236}">
-                  <a16:creationId xmlns:a16="http://schemas.microsoft.com/office/drawing/2014/main" id="{40B6B233-3568-1180-83B6-158BCCA62E99}"/>
+                  <a16:creationId xmlns:a16="http://schemas.microsoft.com/office/drawing/2014/main" id="{EEDA684D-0083-DD67-4847-C5C5F9A1898D}"/>
                 </a:ext>
               </a:extLst>
             </p:cNvPr>
@@ -15999,7 +15787,7 @@
             <p:cNvPr id="351" name="Google Shape;184;p1">
               <a:extLst>
                 <a:ext uri="{FF2B5EF4-FFF2-40B4-BE49-F238E27FC236}">
-                  <a16:creationId xmlns:a16="http://schemas.microsoft.com/office/drawing/2014/main" id="{B3840EAB-E1F0-6604-A335-5A5A97534815}"/>
+                  <a16:creationId xmlns:a16="http://schemas.microsoft.com/office/drawing/2014/main" id="{B632B478-8C9F-E433-0308-D2A8F5964AF8}"/>
                 </a:ext>
               </a:extLst>
             </p:cNvPr>
@@ -16034,7 +15822,7 @@
             <p:cNvPr id="352" name="Google Shape;185;p1">
               <a:extLst>
                 <a:ext uri="{FF2B5EF4-FFF2-40B4-BE49-F238E27FC236}">
-                  <a16:creationId xmlns:a16="http://schemas.microsoft.com/office/drawing/2014/main" id="{7C0D42F6-3FFD-AD69-A622-397C13F6FE12}"/>
+                  <a16:creationId xmlns:a16="http://schemas.microsoft.com/office/drawing/2014/main" id="{B55D6418-410E-55D2-EB7E-91EBD451D1C9}"/>
                 </a:ext>
               </a:extLst>
             </p:cNvPr>
@@ -16069,7 +15857,7 @@
             <p:cNvPr id="353" name="Google Shape;174;p1">
               <a:extLst>
                 <a:ext uri="{FF2B5EF4-FFF2-40B4-BE49-F238E27FC236}">
-                  <a16:creationId xmlns:a16="http://schemas.microsoft.com/office/drawing/2014/main" id="{305C801D-0727-5AE5-0BFB-5B93D24D2172}"/>
+                  <a16:creationId xmlns:a16="http://schemas.microsoft.com/office/drawing/2014/main" id="{6BE61C55-EEC0-9C62-C430-C350F8EDA989}"/>
                 </a:ext>
               </a:extLst>
             </p:cNvPr>
@@ -16136,7 +15924,7 @@
             <p:cNvPr id="354" name="Google Shape;186;p1">
               <a:extLst>
                 <a:ext uri="{FF2B5EF4-FFF2-40B4-BE49-F238E27FC236}">
-                  <a16:creationId xmlns:a16="http://schemas.microsoft.com/office/drawing/2014/main" id="{4C229871-C930-BA17-D80A-34281E58A2A0}"/>
+                  <a16:creationId xmlns:a16="http://schemas.microsoft.com/office/drawing/2014/main" id="{0E433740-ADE1-6A64-E7C3-4948C4DA3EE0}"/>
                 </a:ext>
               </a:extLst>
             </p:cNvPr>
@@ -16171,7 +15959,7 @@
             <p:cNvPr id="356" name="Google Shape;189;p1">
               <a:extLst>
                 <a:ext uri="{FF2B5EF4-FFF2-40B4-BE49-F238E27FC236}">
-                  <a16:creationId xmlns:a16="http://schemas.microsoft.com/office/drawing/2014/main" id="{5A849896-A74D-F6B8-2F37-5FBCA78B1A61}"/>
+                  <a16:creationId xmlns:a16="http://schemas.microsoft.com/office/drawing/2014/main" id="{3776BDCC-B499-8497-AC33-5615906E3728}"/>
                 </a:ext>
               </a:extLst>
             </p:cNvPr>
@@ -16206,7 +15994,7 @@
             <p:cNvPr id="357" name="Google Shape;190;p1">
               <a:extLst>
                 <a:ext uri="{FF2B5EF4-FFF2-40B4-BE49-F238E27FC236}">
-                  <a16:creationId xmlns:a16="http://schemas.microsoft.com/office/drawing/2014/main" id="{41B3FC94-25B5-4CAF-02DD-8AD60AC024E4}"/>
+                  <a16:creationId xmlns:a16="http://schemas.microsoft.com/office/drawing/2014/main" id="{24A57129-F624-3AC9-4C31-B8BE5D41A582}"/>
                 </a:ext>
               </a:extLst>
             </p:cNvPr>
@@ -16241,7 +16029,7 @@
             <p:cNvPr id="358" name="Google Shape;191;p1">
               <a:extLst>
                 <a:ext uri="{FF2B5EF4-FFF2-40B4-BE49-F238E27FC236}">
-                  <a16:creationId xmlns:a16="http://schemas.microsoft.com/office/drawing/2014/main" id="{D4969438-DC1E-F5BF-6FE8-4A21E88911F8}"/>
+                  <a16:creationId xmlns:a16="http://schemas.microsoft.com/office/drawing/2014/main" id="{F5787252-753E-C987-20A0-EEE5A0FE94B7}"/>
                 </a:ext>
               </a:extLst>
             </p:cNvPr>
@@ -16276,7 +16064,7 @@
             <p:cNvPr id="359" name="Google Shape;188;p1">
               <a:extLst>
                 <a:ext uri="{FF2B5EF4-FFF2-40B4-BE49-F238E27FC236}">
-                  <a16:creationId xmlns:a16="http://schemas.microsoft.com/office/drawing/2014/main" id="{5403C421-B182-6172-3D82-780F4F2785F5}"/>
+                  <a16:creationId xmlns:a16="http://schemas.microsoft.com/office/drawing/2014/main" id="{5CA78F51-D947-7017-E2AE-F237C4508516}"/>
                 </a:ext>
               </a:extLst>
             </p:cNvPr>
@@ -16347,7 +16135,7 @@
             <p:cNvPr id="360" name="Google Shape;192;p1">
               <a:extLst>
                 <a:ext uri="{FF2B5EF4-FFF2-40B4-BE49-F238E27FC236}">
-                  <a16:creationId xmlns:a16="http://schemas.microsoft.com/office/drawing/2014/main" id="{AEEAEDDC-EB76-8569-65BE-9960D90ECC25}"/>
+                  <a16:creationId xmlns:a16="http://schemas.microsoft.com/office/drawing/2014/main" id="{5CD577ED-94DC-24BB-D81C-0E577A3BA4B9}"/>
                 </a:ext>
               </a:extLst>
             </p:cNvPr>
@@ -16382,7 +16170,7 @@
             <p:cNvPr id="361" name="Google Shape;182;p1">
               <a:extLst>
                 <a:ext uri="{FF2B5EF4-FFF2-40B4-BE49-F238E27FC236}">
-                  <a16:creationId xmlns:a16="http://schemas.microsoft.com/office/drawing/2014/main" id="{CF85D9F7-130D-B90E-9EE7-6976F77917FD}"/>
+                  <a16:creationId xmlns:a16="http://schemas.microsoft.com/office/drawing/2014/main" id="{7DA0D374-EA1B-E0F0-429E-E5924135BF52}"/>
                 </a:ext>
               </a:extLst>
             </p:cNvPr>
@@ -16449,7 +16237,7 @@
             <p:cNvPr id="362" name="Google Shape;193;p1">
               <a:extLst>
                 <a:ext uri="{FF2B5EF4-FFF2-40B4-BE49-F238E27FC236}">
-                  <a16:creationId xmlns:a16="http://schemas.microsoft.com/office/drawing/2014/main" id="{3E2CB464-2281-B225-64D0-C469A22133B2}"/>
+                  <a16:creationId xmlns:a16="http://schemas.microsoft.com/office/drawing/2014/main" id="{BA1F2F60-0846-820D-62D5-533CD0BD34CD}"/>
                 </a:ext>
               </a:extLst>
             </p:cNvPr>
@@ -16484,7 +16272,7 @@
             <p:cNvPr id="363" name="Google Shape;194;p1">
               <a:extLst>
                 <a:ext uri="{FF2B5EF4-FFF2-40B4-BE49-F238E27FC236}">
-                  <a16:creationId xmlns:a16="http://schemas.microsoft.com/office/drawing/2014/main" id="{FD69479A-ECA1-68A1-0E63-98FD1FCCC80F}"/>
+                  <a16:creationId xmlns:a16="http://schemas.microsoft.com/office/drawing/2014/main" id="{D00A0B20-11BF-C665-C876-CA710C41E238}"/>
                 </a:ext>
               </a:extLst>
             </p:cNvPr>
@@ -16519,7 +16307,7 @@
             <p:cNvPr id="364" name="Google Shape;195;p1">
               <a:extLst>
                 <a:ext uri="{FF2B5EF4-FFF2-40B4-BE49-F238E27FC236}">
-                  <a16:creationId xmlns:a16="http://schemas.microsoft.com/office/drawing/2014/main" id="{E1812DE6-62E3-FFEA-3C06-17F04C68A8A7}"/>
+                  <a16:creationId xmlns:a16="http://schemas.microsoft.com/office/drawing/2014/main" id="{EAD61222-5EF4-F4DD-5D9D-22894517C365}"/>
                 </a:ext>
               </a:extLst>
             </p:cNvPr>
@@ -16554,7 +16342,7 @@
             <p:cNvPr id="366" name="Google Shape;197;p1">
               <a:extLst>
                 <a:ext uri="{FF2B5EF4-FFF2-40B4-BE49-F238E27FC236}">
-                  <a16:creationId xmlns:a16="http://schemas.microsoft.com/office/drawing/2014/main" id="{2C54D3CB-8BB2-0418-CE8E-05108AE684A0}"/>
+                  <a16:creationId xmlns:a16="http://schemas.microsoft.com/office/drawing/2014/main" id="{BA7F2B51-87C7-9A55-2404-54A72CD607F3}"/>
                 </a:ext>
               </a:extLst>
             </p:cNvPr>
@@ -16590,7 +16378,7 @@
           <p:cNvPr id="32" name="Google Shape;156;p1">
             <a:extLst>
               <a:ext uri="{FF2B5EF4-FFF2-40B4-BE49-F238E27FC236}">
-                <a16:creationId xmlns:a16="http://schemas.microsoft.com/office/drawing/2014/main" id="{03433D60-A844-D0DA-02F2-32CE35D84614}"/>
+                <a16:creationId xmlns:a16="http://schemas.microsoft.com/office/drawing/2014/main" id="{74FBC34A-1C36-2268-A222-2B6D0B35A8D2}"/>
               </a:ext>
             </a:extLst>
           </p:cNvPr>
@@ -16610,7 +16398,7 @@
             <p:cNvPr id="33" name="Google Shape;157;p1">
               <a:extLst>
                 <a:ext uri="{FF2B5EF4-FFF2-40B4-BE49-F238E27FC236}">
-                  <a16:creationId xmlns:a16="http://schemas.microsoft.com/office/drawing/2014/main" id="{0D9A1D7B-2842-EAF9-8DEC-EE8A858A3820}"/>
+                  <a16:creationId xmlns:a16="http://schemas.microsoft.com/office/drawing/2014/main" id="{5BE52E71-A987-B066-BD71-8B1D332E76F6}"/>
                 </a:ext>
               </a:extLst>
             </p:cNvPr>
@@ -16681,7 +16469,7 @@
             <p:cNvPr id="35" name="Google Shape;158;p1">
               <a:extLst>
                 <a:ext uri="{FF2B5EF4-FFF2-40B4-BE49-F238E27FC236}">
-                  <a16:creationId xmlns:a16="http://schemas.microsoft.com/office/drawing/2014/main" id="{5A3E5A1A-7940-DCE8-0C76-330F87E90652}"/>
+                  <a16:creationId xmlns:a16="http://schemas.microsoft.com/office/drawing/2014/main" id="{E551ED69-4E13-8C52-E6CE-24FE4911C850}"/>
                 </a:ext>
               </a:extLst>
             </p:cNvPr>
@@ -16748,7 +16536,7 @@
             <p:cNvPr id="36" name="Google Shape;159;p1">
               <a:extLst>
                 <a:ext uri="{FF2B5EF4-FFF2-40B4-BE49-F238E27FC236}">
-                  <a16:creationId xmlns:a16="http://schemas.microsoft.com/office/drawing/2014/main" id="{3A903ADA-2E57-66BB-3FB0-6F39C9EDEA8B}"/>
+                  <a16:creationId xmlns:a16="http://schemas.microsoft.com/office/drawing/2014/main" id="{07B2708A-F49A-720B-2E1D-1C16C78C41A7}"/>
                 </a:ext>
               </a:extLst>
             </p:cNvPr>
@@ -16815,7 +16603,7 @@
             <p:cNvPr id="37" name="Google Shape;160;p1">
               <a:extLst>
                 <a:ext uri="{FF2B5EF4-FFF2-40B4-BE49-F238E27FC236}">
-                  <a16:creationId xmlns:a16="http://schemas.microsoft.com/office/drawing/2014/main" id="{008DB1EC-DB0A-1165-5F67-DF95D28E0193}"/>
+                  <a16:creationId xmlns:a16="http://schemas.microsoft.com/office/drawing/2014/main" id="{BAFC5518-F1AA-76A0-659D-7802FACC6115}"/>
                 </a:ext>
               </a:extLst>
             </p:cNvPr>
@@ -16882,7 +16670,7 @@
             <p:cNvPr id="38" name="Google Shape;161;p1">
               <a:extLst>
                 <a:ext uri="{FF2B5EF4-FFF2-40B4-BE49-F238E27FC236}">
-                  <a16:creationId xmlns:a16="http://schemas.microsoft.com/office/drawing/2014/main" id="{E48E85F0-E3B5-37F3-922B-FA5266C4F3B1}"/>
+                  <a16:creationId xmlns:a16="http://schemas.microsoft.com/office/drawing/2014/main" id="{961A7F1B-E616-20AB-46F5-E7B481EE9B68}"/>
                 </a:ext>
               </a:extLst>
             </p:cNvPr>
@@ -16949,7 +16737,7 @@
             <p:cNvPr id="39" name="Google Shape;162;p1">
               <a:extLst>
                 <a:ext uri="{FF2B5EF4-FFF2-40B4-BE49-F238E27FC236}">
-                  <a16:creationId xmlns:a16="http://schemas.microsoft.com/office/drawing/2014/main" id="{37E5B600-7C90-F4DC-A620-C79FAA4B71AB}"/>
+                  <a16:creationId xmlns:a16="http://schemas.microsoft.com/office/drawing/2014/main" id="{3C35BDAD-0CB2-3093-C460-786F202105B2}"/>
                 </a:ext>
               </a:extLst>
             </p:cNvPr>
@@ -17020,7 +16808,7 @@
             <p:cNvPr id="40" name="Google Shape;163;p1">
               <a:extLst>
                 <a:ext uri="{FF2B5EF4-FFF2-40B4-BE49-F238E27FC236}">
-                  <a16:creationId xmlns:a16="http://schemas.microsoft.com/office/drawing/2014/main" id="{1E10D562-6848-21DC-5407-0E16600FE279}"/>
+                  <a16:creationId xmlns:a16="http://schemas.microsoft.com/office/drawing/2014/main" id="{F642DCFC-61DA-EB65-5E63-4C52AA5B10A2}"/>
                 </a:ext>
               </a:extLst>
             </p:cNvPr>
@@ -17093,7 +16881,7 @@
             <p:cNvPr id="44" name="Google Shape;164;p1">
               <a:extLst>
                 <a:ext uri="{FF2B5EF4-FFF2-40B4-BE49-F238E27FC236}">
-                  <a16:creationId xmlns:a16="http://schemas.microsoft.com/office/drawing/2014/main" id="{582FE6D4-4078-0FFA-6485-5A15D047E605}"/>
+                  <a16:creationId xmlns:a16="http://schemas.microsoft.com/office/drawing/2014/main" id="{E39858C0-8CAC-F1CE-E626-32D958E24D20}"/>
                 </a:ext>
               </a:extLst>
             </p:cNvPr>
@@ -17164,7 +16952,7 @@
             <p:cNvPr id="45" name="Google Shape;165;p1">
               <a:extLst>
                 <a:ext uri="{FF2B5EF4-FFF2-40B4-BE49-F238E27FC236}">
-                  <a16:creationId xmlns:a16="http://schemas.microsoft.com/office/drawing/2014/main" id="{C45A999E-CD30-9AA1-C0D0-014564F53989}"/>
+                  <a16:creationId xmlns:a16="http://schemas.microsoft.com/office/drawing/2014/main" id="{BCF01995-8173-069A-1AD3-8F4EE65B9388}"/>
                 </a:ext>
               </a:extLst>
             </p:cNvPr>
@@ -17237,7 +17025,7 @@
             <p:cNvPr id="46" name="Google Shape;166;p1">
               <a:extLst>
                 <a:ext uri="{FF2B5EF4-FFF2-40B4-BE49-F238E27FC236}">
-                  <a16:creationId xmlns:a16="http://schemas.microsoft.com/office/drawing/2014/main" id="{19601A04-2B4D-1A9F-DDB5-6490DD97E79E}"/>
+                  <a16:creationId xmlns:a16="http://schemas.microsoft.com/office/drawing/2014/main" id="{1471DAA4-2B22-E535-629D-9F4779454A75}"/>
                 </a:ext>
               </a:extLst>
             </p:cNvPr>
@@ -17308,7 +17096,7 @@
             <p:cNvPr id="47" name="Google Shape;167;p1">
               <a:extLst>
                 <a:ext uri="{FF2B5EF4-FFF2-40B4-BE49-F238E27FC236}">
-                  <a16:creationId xmlns:a16="http://schemas.microsoft.com/office/drawing/2014/main" id="{EF8C878C-0B0A-E2E0-2BCD-ABA9714E1E30}"/>
+                  <a16:creationId xmlns:a16="http://schemas.microsoft.com/office/drawing/2014/main" id="{6CB07D33-B4AF-21CD-140E-519FC60CF127}"/>
                 </a:ext>
               </a:extLst>
             </p:cNvPr>
@@ -17375,7 +17163,7 @@
             <p:cNvPr id="49" name="Google Shape;168;p1">
               <a:extLst>
                 <a:ext uri="{FF2B5EF4-FFF2-40B4-BE49-F238E27FC236}">
-                  <a16:creationId xmlns:a16="http://schemas.microsoft.com/office/drawing/2014/main" id="{C547EBDF-504C-4CE7-3B7C-023E00DCA2CB}"/>
+                  <a16:creationId xmlns:a16="http://schemas.microsoft.com/office/drawing/2014/main" id="{1F080BD7-8552-8F66-6915-2E3315C0B220}"/>
                 </a:ext>
               </a:extLst>
             </p:cNvPr>
@@ -17442,7 +17230,7 @@
             <p:cNvPr id="50" name="Google Shape;169;p1">
               <a:extLst>
                 <a:ext uri="{FF2B5EF4-FFF2-40B4-BE49-F238E27FC236}">
-                  <a16:creationId xmlns:a16="http://schemas.microsoft.com/office/drawing/2014/main" id="{3B3DD9C5-2E62-1D2D-962E-D419A98BE416}"/>
+                  <a16:creationId xmlns:a16="http://schemas.microsoft.com/office/drawing/2014/main" id="{554C84CD-1D2C-D818-5661-1D6D42F73C15}"/>
                 </a:ext>
               </a:extLst>
             </p:cNvPr>
@@ -17515,7 +17303,7 @@
             <p:cNvPr id="51" name="Google Shape;170;p1">
               <a:extLst>
                 <a:ext uri="{FF2B5EF4-FFF2-40B4-BE49-F238E27FC236}">
-                  <a16:creationId xmlns:a16="http://schemas.microsoft.com/office/drawing/2014/main" id="{3D2EB38E-2FA4-93C8-DEAD-C7722F3EC67C}"/>
+                  <a16:creationId xmlns:a16="http://schemas.microsoft.com/office/drawing/2014/main" id="{1F5A2BE4-D053-C71B-4B60-97A973F8BDD2}"/>
                 </a:ext>
               </a:extLst>
             </p:cNvPr>
@@ -17582,7 +17370,7 @@
             <p:cNvPr id="52" name="Google Shape;171;p1">
               <a:extLst>
                 <a:ext uri="{FF2B5EF4-FFF2-40B4-BE49-F238E27FC236}">
-                  <a16:creationId xmlns:a16="http://schemas.microsoft.com/office/drawing/2014/main" id="{5943D9C0-ABB6-9ECE-864F-6BFB78D411CB}"/>
+                  <a16:creationId xmlns:a16="http://schemas.microsoft.com/office/drawing/2014/main" id="{27FCBC23-07D4-7E67-5353-05D9D5C7002E}"/>
                 </a:ext>
               </a:extLst>
             </p:cNvPr>
@@ -17655,7 +17443,7 @@
             <p:cNvPr id="54" name="Google Shape;172;p1">
               <a:extLst>
                 <a:ext uri="{FF2B5EF4-FFF2-40B4-BE49-F238E27FC236}">
-                  <a16:creationId xmlns:a16="http://schemas.microsoft.com/office/drawing/2014/main" id="{1745CAF4-EB11-44B7-F35E-BB4B2CB1B018}"/>
+                  <a16:creationId xmlns:a16="http://schemas.microsoft.com/office/drawing/2014/main" id="{239C55F7-F291-82B1-DA50-360A6B711FBB}"/>
                 </a:ext>
               </a:extLst>
             </p:cNvPr>
@@ -17693,7 +17481,7 @@
             <p:cNvPr id="55" name="Google Shape;173;p1">
               <a:extLst>
                 <a:ext uri="{FF2B5EF4-FFF2-40B4-BE49-F238E27FC236}">
-                  <a16:creationId xmlns:a16="http://schemas.microsoft.com/office/drawing/2014/main" id="{C6971447-EA1C-DF30-2E3B-7001597336FD}"/>
+                  <a16:creationId xmlns:a16="http://schemas.microsoft.com/office/drawing/2014/main" id="{2BC73A85-0286-7695-8637-B4A03BE9A780}"/>
                 </a:ext>
               </a:extLst>
             </p:cNvPr>
@@ -17730,7 +17518,7 @@
             <p:cNvPr id="57" name="Google Shape;175;p1">
               <a:extLst>
                 <a:ext uri="{FF2B5EF4-FFF2-40B4-BE49-F238E27FC236}">
-                  <a16:creationId xmlns:a16="http://schemas.microsoft.com/office/drawing/2014/main" id="{E0F13C2B-5528-2A35-735E-7E7BA540E6A3}"/>
+                  <a16:creationId xmlns:a16="http://schemas.microsoft.com/office/drawing/2014/main" id="{EA35013E-AF6E-9ED7-4048-8B083DEE8E95}"/>
                 </a:ext>
               </a:extLst>
             </p:cNvPr>
@@ -17765,7 +17553,7 @@
             <p:cNvPr id="58" name="Google Shape;177;p1">
               <a:extLst>
                 <a:ext uri="{FF2B5EF4-FFF2-40B4-BE49-F238E27FC236}">
-                  <a16:creationId xmlns:a16="http://schemas.microsoft.com/office/drawing/2014/main" id="{1F858A7B-E6EC-8A2E-7A3C-FBBE32957BF2}"/>
+                  <a16:creationId xmlns:a16="http://schemas.microsoft.com/office/drawing/2014/main" id="{5C3C69A3-C5DF-2F56-89F5-AF638899EFA3}"/>
                 </a:ext>
               </a:extLst>
             </p:cNvPr>
@@ -17800,7 +17588,7 @@
             <p:cNvPr id="59" name="Google Shape;178;p1">
               <a:extLst>
                 <a:ext uri="{FF2B5EF4-FFF2-40B4-BE49-F238E27FC236}">
-                  <a16:creationId xmlns:a16="http://schemas.microsoft.com/office/drawing/2014/main" id="{DE014F1F-6463-1698-9E10-5003544957CB}"/>
+                  <a16:creationId xmlns:a16="http://schemas.microsoft.com/office/drawing/2014/main" id="{8376F5A6-B044-0D27-F032-6B99752D5FD5}"/>
                 </a:ext>
               </a:extLst>
             </p:cNvPr>
@@ -17838,7 +17626,7 @@
             <p:cNvPr id="60" name="Google Shape;179;p1">
               <a:extLst>
                 <a:ext uri="{FF2B5EF4-FFF2-40B4-BE49-F238E27FC236}">
-                  <a16:creationId xmlns:a16="http://schemas.microsoft.com/office/drawing/2014/main" id="{9AFAB3F8-2D91-C349-EA30-B58D867618D4}"/>
+                  <a16:creationId xmlns:a16="http://schemas.microsoft.com/office/drawing/2014/main" id="{9F9D9CD0-148D-6C4C-70E8-91E3B2F780F6}"/>
                 </a:ext>
               </a:extLst>
             </p:cNvPr>
@@ -17873,7 +17661,7 @@
             <p:cNvPr id="61" name="Google Shape;180;p1">
               <a:extLst>
                 <a:ext uri="{FF2B5EF4-FFF2-40B4-BE49-F238E27FC236}">
-                  <a16:creationId xmlns:a16="http://schemas.microsoft.com/office/drawing/2014/main" id="{2DD1ABBE-4BF1-D15A-7C82-999CD5F50ED4}"/>
+                  <a16:creationId xmlns:a16="http://schemas.microsoft.com/office/drawing/2014/main" id="{F75A3143-7E95-868E-3F30-CBEC8282D41A}"/>
                 </a:ext>
               </a:extLst>
             </p:cNvPr>
@@ -17908,7 +17696,7 @@
             <p:cNvPr id="62" name="Google Shape;181;p1">
               <a:extLst>
                 <a:ext uri="{FF2B5EF4-FFF2-40B4-BE49-F238E27FC236}">
-                  <a16:creationId xmlns:a16="http://schemas.microsoft.com/office/drawing/2014/main" id="{3CF8E67E-7C59-E0AA-F574-C7BFE4E46B18}"/>
+                  <a16:creationId xmlns:a16="http://schemas.microsoft.com/office/drawing/2014/main" id="{9478C633-7072-87FE-47DF-5368589B89C1}"/>
                 </a:ext>
               </a:extLst>
             </p:cNvPr>
@@ -17943,7 +17731,7 @@
             <p:cNvPr id="63" name="Google Shape;183;p1">
               <a:extLst>
                 <a:ext uri="{FF2B5EF4-FFF2-40B4-BE49-F238E27FC236}">
-                  <a16:creationId xmlns:a16="http://schemas.microsoft.com/office/drawing/2014/main" id="{9ADD1A20-543B-31BD-9181-9961FB737E53}"/>
+                  <a16:creationId xmlns:a16="http://schemas.microsoft.com/office/drawing/2014/main" id="{2CBE79E8-85F5-2D73-BFAE-DF8932732D0D}"/>
                 </a:ext>
               </a:extLst>
             </p:cNvPr>
@@ -17978,7 +17766,7 @@
             <p:cNvPr id="448" name="Google Shape;176;p1">
               <a:extLst>
                 <a:ext uri="{FF2B5EF4-FFF2-40B4-BE49-F238E27FC236}">
-                  <a16:creationId xmlns:a16="http://schemas.microsoft.com/office/drawing/2014/main" id="{8B621B07-D6B9-3215-9A91-2C7CAC164A01}"/>
+                  <a16:creationId xmlns:a16="http://schemas.microsoft.com/office/drawing/2014/main" id="{2C5E3446-F93E-7BF4-D51E-F6E8AB5F261F}"/>
                 </a:ext>
               </a:extLst>
             </p:cNvPr>
@@ -18045,7 +17833,7 @@
             <p:cNvPr id="449" name="Google Shape;184;p1">
               <a:extLst>
                 <a:ext uri="{FF2B5EF4-FFF2-40B4-BE49-F238E27FC236}">
-                  <a16:creationId xmlns:a16="http://schemas.microsoft.com/office/drawing/2014/main" id="{35CECF86-A79A-2E3C-6E26-F760DDD9B8CF}"/>
+                  <a16:creationId xmlns:a16="http://schemas.microsoft.com/office/drawing/2014/main" id="{3B880F32-3C21-CD2D-536E-01EB211A6743}"/>
                 </a:ext>
               </a:extLst>
             </p:cNvPr>
@@ -18080,7 +17868,7 @@
             <p:cNvPr id="450" name="Google Shape;185;p1">
               <a:extLst>
                 <a:ext uri="{FF2B5EF4-FFF2-40B4-BE49-F238E27FC236}">
-                  <a16:creationId xmlns:a16="http://schemas.microsoft.com/office/drawing/2014/main" id="{969ED485-BA13-011B-4CB1-AE371D451599}"/>
+                  <a16:creationId xmlns:a16="http://schemas.microsoft.com/office/drawing/2014/main" id="{09BF4B71-277F-4407-D23E-E137FD9DF948}"/>
                 </a:ext>
               </a:extLst>
             </p:cNvPr>
@@ -18115,7 +17903,7 @@
             <p:cNvPr id="452" name="Google Shape;174;p1">
               <a:extLst>
                 <a:ext uri="{FF2B5EF4-FFF2-40B4-BE49-F238E27FC236}">
-                  <a16:creationId xmlns:a16="http://schemas.microsoft.com/office/drawing/2014/main" id="{DF8F2C9E-B6D4-F5D1-7963-9DBB091A7672}"/>
+                  <a16:creationId xmlns:a16="http://schemas.microsoft.com/office/drawing/2014/main" id="{CC2B2DE2-3EBE-728E-8D5C-17E8753BB6BD}"/>
                 </a:ext>
               </a:extLst>
             </p:cNvPr>
@@ -18186,7 +17974,7 @@
             <p:cNvPr id="453" name="Google Shape;186;p1">
               <a:extLst>
                 <a:ext uri="{FF2B5EF4-FFF2-40B4-BE49-F238E27FC236}">
-                  <a16:creationId xmlns:a16="http://schemas.microsoft.com/office/drawing/2014/main" id="{C7164743-2C8C-AF71-D123-7BFEA0B444A1}"/>
+                  <a16:creationId xmlns:a16="http://schemas.microsoft.com/office/drawing/2014/main" id="{44193011-1856-2AAE-2E8A-996679711660}"/>
                 </a:ext>
               </a:extLst>
             </p:cNvPr>
@@ -18221,7 +18009,7 @@
             <p:cNvPr id="456" name="Google Shape;187;p1">
               <a:extLst>
                 <a:ext uri="{FF2B5EF4-FFF2-40B4-BE49-F238E27FC236}">
-                  <a16:creationId xmlns:a16="http://schemas.microsoft.com/office/drawing/2014/main" id="{E32C7E87-3770-CD21-EC1D-742408BE7605}"/>
+                  <a16:creationId xmlns:a16="http://schemas.microsoft.com/office/drawing/2014/main" id="{0F2CF676-F257-5F88-0B12-B8F2B12184EB}"/>
                 </a:ext>
               </a:extLst>
             </p:cNvPr>
@@ -18258,7 +18046,7 @@
             <p:cNvPr id="457" name="Google Shape;189;p1">
               <a:extLst>
                 <a:ext uri="{FF2B5EF4-FFF2-40B4-BE49-F238E27FC236}">
-                  <a16:creationId xmlns:a16="http://schemas.microsoft.com/office/drawing/2014/main" id="{E11CD28C-6871-E901-D47C-0DC835436B7B}"/>
+                  <a16:creationId xmlns:a16="http://schemas.microsoft.com/office/drawing/2014/main" id="{12E0C394-F16A-E0BE-B325-71853337B579}"/>
                 </a:ext>
               </a:extLst>
             </p:cNvPr>
@@ -18293,7 +18081,7 @@
             <p:cNvPr id="458" name="Google Shape;190;p1">
               <a:extLst>
                 <a:ext uri="{FF2B5EF4-FFF2-40B4-BE49-F238E27FC236}">
-                  <a16:creationId xmlns:a16="http://schemas.microsoft.com/office/drawing/2014/main" id="{571F07DB-1937-EEA9-1548-DED38E72C3C0}"/>
+                  <a16:creationId xmlns:a16="http://schemas.microsoft.com/office/drawing/2014/main" id="{56425D35-98AC-4138-2E19-CFCEE1EA88DE}"/>
                 </a:ext>
               </a:extLst>
             </p:cNvPr>
@@ -18328,7 +18116,7 @@
             <p:cNvPr id="459" name="Google Shape;191;p1">
               <a:extLst>
                 <a:ext uri="{FF2B5EF4-FFF2-40B4-BE49-F238E27FC236}">
-                  <a16:creationId xmlns:a16="http://schemas.microsoft.com/office/drawing/2014/main" id="{6D4C6CF2-7736-9F68-82B6-3EA92D9A6FA5}"/>
+                  <a16:creationId xmlns:a16="http://schemas.microsoft.com/office/drawing/2014/main" id="{8616A146-5762-310A-7206-29F7B31BE0BD}"/>
                 </a:ext>
               </a:extLst>
             </p:cNvPr>
@@ -18363,7 +18151,7 @@
             <p:cNvPr id="461" name="Google Shape;188;p1">
               <a:extLst>
                 <a:ext uri="{FF2B5EF4-FFF2-40B4-BE49-F238E27FC236}">
-                  <a16:creationId xmlns:a16="http://schemas.microsoft.com/office/drawing/2014/main" id="{F2AFA970-3013-A28D-BDB6-ABC3C1761762}"/>
+                  <a16:creationId xmlns:a16="http://schemas.microsoft.com/office/drawing/2014/main" id="{2621FABC-9D40-F5BC-265F-070F677C60AA}"/>
                 </a:ext>
               </a:extLst>
             </p:cNvPr>
@@ -18434,7 +18222,7 @@
             <p:cNvPr id="465" name="Google Shape;192;p1">
               <a:extLst>
                 <a:ext uri="{FF2B5EF4-FFF2-40B4-BE49-F238E27FC236}">
-                  <a16:creationId xmlns:a16="http://schemas.microsoft.com/office/drawing/2014/main" id="{2DA2C577-98E7-E4F5-3F8F-B15D992B9754}"/>
+                  <a16:creationId xmlns:a16="http://schemas.microsoft.com/office/drawing/2014/main" id="{FB9A3F5F-D973-F81F-2318-6F058E8DE072}"/>
                 </a:ext>
               </a:extLst>
             </p:cNvPr>
@@ -18469,7 +18257,7 @@
             <p:cNvPr id="466" name="Google Shape;182;p1">
               <a:extLst>
                 <a:ext uri="{FF2B5EF4-FFF2-40B4-BE49-F238E27FC236}">
-                  <a16:creationId xmlns:a16="http://schemas.microsoft.com/office/drawing/2014/main" id="{07430157-D487-FE37-93B8-21E25D098736}"/>
+                  <a16:creationId xmlns:a16="http://schemas.microsoft.com/office/drawing/2014/main" id="{01BCD0E4-DD7C-08A8-8755-E6FE7442EBBB}"/>
                 </a:ext>
               </a:extLst>
             </p:cNvPr>
@@ -18536,7 +18324,7 @@
             <p:cNvPr id="468" name="Google Shape;193;p1">
               <a:extLst>
                 <a:ext uri="{FF2B5EF4-FFF2-40B4-BE49-F238E27FC236}">
-                  <a16:creationId xmlns:a16="http://schemas.microsoft.com/office/drawing/2014/main" id="{DDB41A31-BF67-4923-E431-7D88EE6EFBC8}"/>
+                  <a16:creationId xmlns:a16="http://schemas.microsoft.com/office/drawing/2014/main" id="{AC1A41EB-08AB-00EB-642B-BCC5E74C671C}"/>
                 </a:ext>
               </a:extLst>
             </p:cNvPr>
@@ -18571,7 +18359,7 @@
             <p:cNvPr id="470" name="Google Shape;194;p1">
               <a:extLst>
                 <a:ext uri="{FF2B5EF4-FFF2-40B4-BE49-F238E27FC236}">
-                  <a16:creationId xmlns:a16="http://schemas.microsoft.com/office/drawing/2014/main" id="{E687FC90-FB9C-384A-641C-AE7550712EC0}"/>
+                  <a16:creationId xmlns:a16="http://schemas.microsoft.com/office/drawing/2014/main" id="{73758FC8-99E6-7DB5-6A24-9C15F73EB9E7}"/>
                 </a:ext>
               </a:extLst>
             </p:cNvPr>
@@ -18608,7 +18396,7 @@
             <p:cNvPr id="471" name="Google Shape;195;p1">
               <a:extLst>
                 <a:ext uri="{FF2B5EF4-FFF2-40B4-BE49-F238E27FC236}">
-                  <a16:creationId xmlns:a16="http://schemas.microsoft.com/office/drawing/2014/main" id="{26344311-515B-50B5-7F73-75A484A6646A}"/>
+                  <a16:creationId xmlns:a16="http://schemas.microsoft.com/office/drawing/2014/main" id="{AA0FBCC7-01CE-6EE0-B83F-D3C8E3B13BCC}"/>
                 </a:ext>
               </a:extLst>
             </p:cNvPr>
@@ -18643,7 +18431,7 @@
             <p:cNvPr id="472" name="Google Shape;196;p1">
               <a:extLst>
                 <a:ext uri="{FF2B5EF4-FFF2-40B4-BE49-F238E27FC236}">
-                  <a16:creationId xmlns:a16="http://schemas.microsoft.com/office/drawing/2014/main" id="{CAA393BD-1369-8166-8EED-A536E3888A87}"/>
+                  <a16:creationId xmlns:a16="http://schemas.microsoft.com/office/drawing/2014/main" id="{CBC08898-85CD-324D-1873-4382E58CFE88}"/>
                 </a:ext>
               </a:extLst>
             </p:cNvPr>
@@ -18680,7 +18468,7 @@
             <p:cNvPr id="473" name="Google Shape;197;p1">
               <a:extLst>
                 <a:ext uri="{FF2B5EF4-FFF2-40B4-BE49-F238E27FC236}">
-                  <a16:creationId xmlns:a16="http://schemas.microsoft.com/office/drawing/2014/main" id="{0D1323CD-2731-24FB-5641-AD95FC452CAC}"/>
+                  <a16:creationId xmlns:a16="http://schemas.microsoft.com/office/drawing/2014/main" id="{16D7C0A6-5F7C-C894-117F-F1453BB970FD}"/>
                 </a:ext>
               </a:extLst>
             </p:cNvPr>
@@ -18717,7 +18505,7 @@
             <p:cNvPr id="478" name="Google Shape;198;p1">
               <a:extLst>
                 <a:ext uri="{FF2B5EF4-FFF2-40B4-BE49-F238E27FC236}">
-                  <a16:creationId xmlns:a16="http://schemas.microsoft.com/office/drawing/2014/main" id="{CE10506B-BE0B-7A97-8400-D8EFA370FCD2}"/>
+                  <a16:creationId xmlns:a16="http://schemas.microsoft.com/office/drawing/2014/main" id="{39BEE82F-CC69-1511-0CE8-07A40DCD081D}"/>
                 </a:ext>
               </a:extLst>
             </p:cNvPr>
@@ -18755,7 +18543,7 @@
             <p:cNvPr id="479" name="Google Shape;199;p1">
               <a:extLst>
                 <a:ext uri="{FF2B5EF4-FFF2-40B4-BE49-F238E27FC236}">
-                  <a16:creationId xmlns:a16="http://schemas.microsoft.com/office/drawing/2014/main" id="{A2F077F2-3EA0-BF5D-1A25-055FF430D953}"/>
+                  <a16:creationId xmlns:a16="http://schemas.microsoft.com/office/drawing/2014/main" id="{02C02D98-6FED-1B1A-E252-27356A6D021A}"/>
                 </a:ext>
               </a:extLst>
             </p:cNvPr>
@@ -18793,7 +18581,7 @@
             <p:cNvPr id="481" name="Google Shape;200;p1">
               <a:extLst>
                 <a:ext uri="{FF2B5EF4-FFF2-40B4-BE49-F238E27FC236}">
-                  <a16:creationId xmlns:a16="http://schemas.microsoft.com/office/drawing/2014/main" id="{D768B278-F553-72D6-2D50-4EB2E78080A6}"/>
+                  <a16:creationId xmlns:a16="http://schemas.microsoft.com/office/drawing/2014/main" id="{EC75B8AF-17B2-FFAD-38A7-10BBD158B980}"/>
                 </a:ext>
               </a:extLst>
             </p:cNvPr>
@@ -18832,7 +18620,7 @@
           <p:cNvPr id="9" name="Straight Connector 8">
             <a:extLst>
               <a:ext uri="{FF2B5EF4-FFF2-40B4-BE49-F238E27FC236}">
-                <a16:creationId xmlns:a16="http://schemas.microsoft.com/office/drawing/2014/main" id="{84000670-2F6A-BA47-6590-F3F8B0F8C80E}"/>
+                <a16:creationId xmlns:a16="http://schemas.microsoft.com/office/drawing/2014/main" id="{5F3E6CA7-E718-F83D-01FA-CA84424463F0}"/>
               </a:ext>
             </a:extLst>
           </p:cNvPr>
@@ -18879,7 +18667,7 @@
           <p:cNvPr id="19" name="Straight Connector 18">
             <a:extLst>
               <a:ext uri="{FF2B5EF4-FFF2-40B4-BE49-F238E27FC236}">
-                <a16:creationId xmlns:a16="http://schemas.microsoft.com/office/drawing/2014/main" id="{B7D5DFB1-FA2B-5A7D-26F7-616D3DD1569C}"/>
+                <a16:creationId xmlns:a16="http://schemas.microsoft.com/office/drawing/2014/main" id="{70786A80-75CF-6F20-C122-60B4BF075A10}"/>
               </a:ext>
             </a:extLst>
           </p:cNvPr>
@@ -18927,7 +18715,7 @@
           <p:cNvPr id="26" name="Straight Connector 25">
             <a:extLst>
               <a:ext uri="{FF2B5EF4-FFF2-40B4-BE49-F238E27FC236}">
-                <a16:creationId xmlns:a16="http://schemas.microsoft.com/office/drawing/2014/main" id="{C4760FB2-CB1D-45F3-7961-F42595D51F2C}"/>
+                <a16:creationId xmlns:a16="http://schemas.microsoft.com/office/drawing/2014/main" id="{93040EEC-144A-0086-B725-90106DE2044C}"/>
               </a:ext>
             </a:extLst>
           </p:cNvPr>
@@ -18974,7 +18762,7 @@
           <p:cNvPr id="42" name="Straight Connector 41">
             <a:extLst>
               <a:ext uri="{FF2B5EF4-FFF2-40B4-BE49-F238E27FC236}">
-                <a16:creationId xmlns:a16="http://schemas.microsoft.com/office/drawing/2014/main" id="{E94B8471-E4D2-15FC-762C-F13CB57BD87A}"/>
+                <a16:creationId xmlns:a16="http://schemas.microsoft.com/office/drawing/2014/main" id="{239882DC-36D9-B2FE-041B-053DD3B6438B}"/>
               </a:ext>
             </a:extLst>
           </p:cNvPr>
@@ -19021,7 +18809,7 @@
           <p:cNvPr id="48" name="Straight Connector 47">
             <a:extLst>
               <a:ext uri="{FF2B5EF4-FFF2-40B4-BE49-F238E27FC236}">
-                <a16:creationId xmlns:a16="http://schemas.microsoft.com/office/drawing/2014/main" id="{3082276C-1511-FD0E-7DAC-4D99E2791D09}"/>
+                <a16:creationId xmlns:a16="http://schemas.microsoft.com/office/drawing/2014/main" id="{C474D363-9C85-D36A-FB6F-1DCDD9F70289}"/>
               </a:ext>
             </a:extLst>
           </p:cNvPr>
@@ -19069,7 +18857,7 @@
           <p:cNvPr id="368" name="Line">
             <a:extLst>
               <a:ext uri="{FF2B5EF4-FFF2-40B4-BE49-F238E27FC236}">
-                <a16:creationId xmlns:a16="http://schemas.microsoft.com/office/drawing/2014/main" id="{07F93DC9-B015-1FE6-AD23-5629BAAC6B9B}"/>
+                <a16:creationId xmlns:a16="http://schemas.microsoft.com/office/drawing/2014/main" id="{3208538C-AD12-67FE-7450-6063EBA9F2E4}"/>
               </a:ext>
             </a:extLst>
           </p:cNvPr>
@@ -19117,7 +18905,7 @@
           <p:cNvPr id="441" name="Line">
             <a:extLst>
               <a:ext uri="{FF2B5EF4-FFF2-40B4-BE49-F238E27FC236}">
-                <a16:creationId xmlns:a16="http://schemas.microsoft.com/office/drawing/2014/main" id="{6C56CD6C-2DB9-B7D0-4DC5-23218D3C0750}"/>
+                <a16:creationId xmlns:a16="http://schemas.microsoft.com/office/drawing/2014/main" id="{DDC3206C-EE10-7829-30F0-735C01470498}"/>
               </a:ext>
             </a:extLst>
           </p:cNvPr>
@@ -19165,7 +18953,7 @@
           <p:cNvPr id="442" name="Line">
             <a:extLst>
               <a:ext uri="{FF2B5EF4-FFF2-40B4-BE49-F238E27FC236}">
-                <a16:creationId xmlns:a16="http://schemas.microsoft.com/office/drawing/2014/main" id="{5F5DBC1C-B109-B239-C093-E3947E684DC5}"/>
+                <a16:creationId xmlns:a16="http://schemas.microsoft.com/office/drawing/2014/main" id="{3EF9AC49-1B64-A0B4-35C1-74D39609DD10}"/>
               </a:ext>
             </a:extLst>
           </p:cNvPr>
@@ -19213,7 +19001,7 @@
           <p:cNvPr id="443" name="Line">
             <a:extLst>
               <a:ext uri="{FF2B5EF4-FFF2-40B4-BE49-F238E27FC236}">
-                <a16:creationId xmlns:a16="http://schemas.microsoft.com/office/drawing/2014/main" id="{0B070A94-484C-1F85-327C-B8522FA6B1DA}"/>
+                <a16:creationId xmlns:a16="http://schemas.microsoft.com/office/drawing/2014/main" id="{9E211AE0-28BC-722B-1958-EE44592D73A5}"/>
               </a:ext>
             </a:extLst>
           </p:cNvPr>
@@ -19261,7 +19049,7 @@
           <p:cNvPr id="444" name="Line">
             <a:extLst>
               <a:ext uri="{FF2B5EF4-FFF2-40B4-BE49-F238E27FC236}">
-                <a16:creationId xmlns:a16="http://schemas.microsoft.com/office/drawing/2014/main" id="{F3A79D4E-052A-881D-C04C-A21FD29931E8}"/>
+                <a16:creationId xmlns:a16="http://schemas.microsoft.com/office/drawing/2014/main" id="{D0E9FD65-C049-65A7-B6C0-3A603D16B6CA}"/>
               </a:ext>
             </a:extLst>
           </p:cNvPr>
@@ -19309,7 +19097,7 @@
           <p:cNvPr id="445" name="Line">
             <a:extLst>
               <a:ext uri="{FF2B5EF4-FFF2-40B4-BE49-F238E27FC236}">
-                <a16:creationId xmlns:a16="http://schemas.microsoft.com/office/drawing/2014/main" id="{A882E228-6013-469B-6720-295324934DD7}"/>
+                <a16:creationId xmlns:a16="http://schemas.microsoft.com/office/drawing/2014/main" id="{2292D67B-9D57-D88E-6900-85ECCA11FD6B}"/>
               </a:ext>
             </a:extLst>
           </p:cNvPr>
@@ -19357,7 +19145,7 @@
           <p:cNvPr id="513" name="TextBox 512">
             <a:extLst>
               <a:ext uri="{FF2B5EF4-FFF2-40B4-BE49-F238E27FC236}">
-                <a16:creationId xmlns:a16="http://schemas.microsoft.com/office/drawing/2014/main" id="{C7CF9F48-65E2-784B-F900-CDB9CE9106F8}"/>
+                <a16:creationId xmlns:a16="http://schemas.microsoft.com/office/drawing/2014/main" id="{05FD7C69-0475-9BAF-050A-DE7EBF21FD1E}"/>
               </a:ext>
             </a:extLst>
           </p:cNvPr>
@@ -19459,7 +19247,7 @@
           <p:cNvPr id="529" name="Manipulate Variables">
             <a:extLst>
               <a:ext uri="{FF2B5EF4-FFF2-40B4-BE49-F238E27FC236}">
-                <a16:creationId xmlns:a16="http://schemas.microsoft.com/office/drawing/2014/main" id="{FB2BE27B-97CE-9C42-523C-1C79AA5EC17C}"/>
+                <a16:creationId xmlns:a16="http://schemas.microsoft.com/office/drawing/2014/main" id="{A5F7FD4C-8100-CB1F-1E66-096E5944C08F}"/>
               </a:ext>
             </a:extLst>
           </p:cNvPr>
@@ -19515,7 +19303,7 @@
           <p:cNvPr id="5" name="TextBox 4">
             <a:extLst>
               <a:ext uri="{FF2B5EF4-FFF2-40B4-BE49-F238E27FC236}">
-                <a16:creationId xmlns:a16="http://schemas.microsoft.com/office/drawing/2014/main" id="{50FD7596-DFBC-AF09-A0D7-DE7222337296}"/>
+                <a16:creationId xmlns:a16="http://schemas.microsoft.com/office/drawing/2014/main" id="{A021A676-A332-26C1-5DF9-C26BDEDF25A8}"/>
               </a:ext>
             </a:extLst>
           </p:cNvPr>
@@ -19524,8 +19312,8 @@
         </p:nvSpPr>
         <p:spPr>
           <a:xfrm>
-            <a:off x="6080760" y="10327008"/>
-            <a:ext cx="7747698" cy="500056"/>
+            <a:off x="7737264" y="10327008"/>
+            <a:ext cx="6091194" cy="500056"/>
           </a:xfrm>
           <a:prstGeom prst="rect">
             <a:avLst/>
@@ -19577,7 +19365,7 @@
                 <a:solidFill>
                   <a:schemeClr val="tx1"/>
                 </a:solidFill>
-                <a:hlinkClick r:id="rId7">
+                <a:hlinkClick r:id="rId6">
                   <a:extLst>
                     <a:ext uri="{A12FA001-AC4F-418D-AE19-62706E023703}">
                       <ahyp:hlinkClr xmlns:ahyp="http://schemas.microsoft.com/office/drawing/2018/hyperlinkcolor" val="tx"/>
@@ -19613,7 +19401,7 @@
               <a:t>, Carlos Paradis • Kai</a:t>
             </a:r>
             <a:r>
-              <a:rPr kumimoji="0" lang="haw-US" sz="1000" b="0" i="0" u="none" strike="noStrike" cap="none" spc="0" normalizeH="0" baseline="0">
+              <a:rPr kumimoji="0" lang="haw-US" sz="1000" b="0" i="0" u="none" strike="noStrike" cap="none" spc="0" normalizeH="0" baseline="0" dirty="0">
                 <a:ln>
                   <a:noFill/>
                 </a:ln>
@@ -19686,7 +19474,7 @@
           <p:cNvPr id="519" name="Connector: Elbow 518">
             <a:extLst>
               <a:ext uri="{FF2B5EF4-FFF2-40B4-BE49-F238E27FC236}">
-                <a16:creationId xmlns:a16="http://schemas.microsoft.com/office/drawing/2014/main" id="{317BD4D3-2BDD-F486-BB37-C4C8B1B35A28}"/>
+                <a16:creationId xmlns:a16="http://schemas.microsoft.com/office/drawing/2014/main" id="{9BA869DB-971D-74A4-27C3-0A760733BDD8}"/>
               </a:ext>
             </a:extLst>
           </p:cNvPr>
@@ -19735,7 +19523,7 @@
           <p:cNvPr id="547" name="Connector: Elbow 546">
             <a:extLst>
               <a:ext uri="{FF2B5EF4-FFF2-40B4-BE49-F238E27FC236}">
-                <a16:creationId xmlns:a16="http://schemas.microsoft.com/office/drawing/2014/main" id="{FBE9EB6B-0DBF-FEDE-C370-176C677E5D6C}"/>
+                <a16:creationId xmlns:a16="http://schemas.microsoft.com/office/drawing/2014/main" id="{9FF53575-0D03-03D5-8563-ACEF5867A3E7}"/>
               </a:ext>
             </a:extLst>
           </p:cNvPr>
@@ -19784,7 +19572,7 @@
           <p:cNvPr id="550" name="Straight Connector 549">
             <a:extLst>
               <a:ext uri="{FF2B5EF4-FFF2-40B4-BE49-F238E27FC236}">
-                <a16:creationId xmlns:a16="http://schemas.microsoft.com/office/drawing/2014/main" id="{1852C2A1-04BC-91F2-2529-4ECE638025BE}"/>
+                <a16:creationId xmlns:a16="http://schemas.microsoft.com/office/drawing/2014/main" id="{889FE9ED-2B51-F3C3-FA77-893D112F5968}"/>
               </a:ext>
             </a:extLst>
           </p:cNvPr>
@@ -19834,7 +19622,7 @@
           <p:cNvPr id="556" name="Connector: Elbow 555">
             <a:extLst>
               <a:ext uri="{FF2B5EF4-FFF2-40B4-BE49-F238E27FC236}">
-                <a16:creationId xmlns:a16="http://schemas.microsoft.com/office/drawing/2014/main" id="{64BB1902-84BD-0E31-3105-CD8049B558C3}"/>
+                <a16:creationId xmlns:a16="http://schemas.microsoft.com/office/drawing/2014/main" id="{17FBEFDD-28C1-94DB-8761-9BD9249709CD}"/>
               </a:ext>
             </a:extLst>
           </p:cNvPr>
@@ -19884,7 +19672,7 @@
           <p:cNvPr id="565" name="Connector: Elbow 564">
             <a:extLst>
               <a:ext uri="{FF2B5EF4-FFF2-40B4-BE49-F238E27FC236}">
-                <a16:creationId xmlns:a16="http://schemas.microsoft.com/office/drawing/2014/main" id="{4D71BE41-7D5A-5406-24C8-A4C7A47C5CD2}"/>
+                <a16:creationId xmlns:a16="http://schemas.microsoft.com/office/drawing/2014/main" id="{F274FF41-671D-CF9E-7F86-E22B8144400D}"/>
               </a:ext>
             </a:extLst>
           </p:cNvPr>
@@ -19932,7 +19720,7 @@
           <p:cNvPr id="566" name="Connector: Elbow 565">
             <a:extLst>
               <a:ext uri="{FF2B5EF4-FFF2-40B4-BE49-F238E27FC236}">
-                <a16:creationId xmlns:a16="http://schemas.microsoft.com/office/drawing/2014/main" id="{8027A995-FDDF-0A87-70DC-835E4441C175}"/>
+                <a16:creationId xmlns:a16="http://schemas.microsoft.com/office/drawing/2014/main" id="{189587FC-9AFA-C56F-82DF-7BE506E32334}"/>
               </a:ext>
             </a:extLst>
           </p:cNvPr>
@@ -19981,7 +19769,7 @@
           <p:cNvPr id="569" name="Connector: Elbow 568">
             <a:extLst>
               <a:ext uri="{FF2B5EF4-FFF2-40B4-BE49-F238E27FC236}">
-                <a16:creationId xmlns:a16="http://schemas.microsoft.com/office/drawing/2014/main" id="{3F37A830-5C8F-6548-1AE9-6BC74F4A2171}"/>
+                <a16:creationId xmlns:a16="http://schemas.microsoft.com/office/drawing/2014/main" id="{C648418A-9600-9E5C-778F-D1FD96346F94}"/>
               </a:ext>
             </a:extLst>
           </p:cNvPr>
@@ -20032,7 +19820,7 @@
           <p:cNvPr id="572" name="Connector: Elbow 571">
             <a:extLst>
               <a:ext uri="{FF2B5EF4-FFF2-40B4-BE49-F238E27FC236}">
-                <a16:creationId xmlns:a16="http://schemas.microsoft.com/office/drawing/2014/main" id="{918CA74F-06D5-A3BC-8C96-F695EBE1B6AB}"/>
+                <a16:creationId xmlns:a16="http://schemas.microsoft.com/office/drawing/2014/main" id="{0B15C6E8-1347-2C75-176E-309DC5D9077F}"/>
               </a:ext>
             </a:extLst>
           </p:cNvPr>
@@ -20082,7 +19870,7 @@
           <p:cNvPr id="575" name="Connector: Elbow 574">
             <a:extLst>
               <a:ext uri="{FF2B5EF4-FFF2-40B4-BE49-F238E27FC236}">
-                <a16:creationId xmlns:a16="http://schemas.microsoft.com/office/drawing/2014/main" id="{AE1D04CA-4565-7701-20F7-2236388EAF49}"/>
+                <a16:creationId xmlns:a16="http://schemas.microsoft.com/office/drawing/2014/main" id="{25D4E70D-5A32-FEBA-309F-FDC24EAD1747}"/>
               </a:ext>
             </a:extLst>
           </p:cNvPr>
@@ -20132,7 +19920,7 @@
           <p:cNvPr id="261" name="Connector: Elbow 260">
             <a:extLst>
               <a:ext uri="{FF2B5EF4-FFF2-40B4-BE49-F238E27FC236}">
-                <a16:creationId xmlns:a16="http://schemas.microsoft.com/office/drawing/2014/main" id="{A500FA4A-CCEA-AD60-ACCF-DCF6E3EB7C8B}"/>
+                <a16:creationId xmlns:a16="http://schemas.microsoft.com/office/drawing/2014/main" id="{C458A771-B9C8-CF31-4AF9-C48AF26C9A6F}"/>
               </a:ext>
             </a:extLst>
           </p:cNvPr>
@@ -20182,7 +19970,7 @@
           <p:cNvPr id="355" name="Connector: Elbow 354">
             <a:extLst>
               <a:ext uri="{FF2B5EF4-FFF2-40B4-BE49-F238E27FC236}">
-                <a16:creationId xmlns:a16="http://schemas.microsoft.com/office/drawing/2014/main" id="{00C71DB0-8351-09C7-A0DF-3DCBFE5A9F96}"/>
+                <a16:creationId xmlns:a16="http://schemas.microsoft.com/office/drawing/2014/main" id="{E481BCF5-441D-2F21-AF62-230F42D166A0}"/>
               </a:ext>
             </a:extLst>
           </p:cNvPr>
@@ -20230,7 +20018,7 @@
           <p:cNvPr id="369" name="TextBox 368">
             <a:extLst>
               <a:ext uri="{FF2B5EF4-FFF2-40B4-BE49-F238E27FC236}">
-                <a16:creationId xmlns:a16="http://schemas.microsoft.com/office/drawing/2014/main" id="{5088E348-78A6-38A9-8B4A-8E7DA104013D}"/>
+                <a16:creationId xmlns:a16="http://schemas.microsoft.com/office/drawing/2014/main" id="{F408071B-0623-4FDE-544A-2D81799291ED}"/>
               </a:ext>
             </a:extLst>
           </p:cNvPr>
@@ -20360,7 +20148,7 @@
           <p:cNvPr id="382" name="Connector: Elbow 381">
             <a:extLst>
               <a:ext uri="{FF2B5EF4-FFF2-40B4-BE49-F238E27FC236}">
-                <a16:creationId xmlns:a16="http://schemas.microsoft.com/office/drawing/2014/main" id="{04DFAE84-CE06-30CC-E9DE-864CA3A6D37F}"/>
+                <a16:creationId xmlns:a16="http://schemas.microsoft.com/office/drawing/2014/main" id="{F8DB6194-64EF-EF89-A661-C8D371F0F56A}"/>
               </a:ext>
             </a:extLst>
           </p:cNvPr>
@@ -20408,7 +20196,7 @@
           <p:cNvPr id="425" name="Connector: Elbow 424">
             <a:extLst>
               <a:ext uri="{FF2B5EF4-FFF2-40B4-BE49-F238E27FC236}">
-                <a16:creationId xmlns:a16="http://schemas.microsoft.com/office/drawing/2014/main" id="{4E10EFFA-2171-A7FD-0BD3-82C4DDA8711B}"/>
+                <a16:creationId xmlns:a16="http://schemas.microsoft.com/office/drawing/2014/main" id="{DF96DCAF-7A15-2458-B9E4-A232AFD2D8BB}"/>
               </a:ext>
             </a:extLst>
           </p:cNvPr>
@@ -20456,7 +20244,7 @@
           <p:cNvPr id="433" name="Connector: Elbow 432">
             <a:extLst>
               <a:ext uri="{FF2B5EF4-FFF2-40B4-BE49-F238E27FC236}">
-                <a16:creationId xmlns:a16="http://schemas.microsoft.com/office/drawing/2014/main" id="{E6DBC591-E7A8-4F93-85F4-D44F5725C457}"/>
+                <a16:creationId xmlns:a16="http://schemas.microsoft.com/office/drawing/2014/main" id="{2F05E601-94EE-AD57-E695-339F28AEB042}"/>
               </a:ext>
             </a:extLst>
           </p:cNvPr>
@@ -20503,7 +20291,7 @@
           <p:cNvPr id="436" name="Connector: Elbow 435">
             <a:extLst>
               <a:ext uri="{FF2B5EF4-FFF2-40B4-BE49-F238E27FC236}">
-                <a16:creationId xmlns:a16="http://schemas.microsoft.com/office/drawing/2014/main" id="{BBCC7275-B0AF-E568-1CCE-8B7E583DACA5}"/>
+                <a16:creationId xmlns:a16="http://schemas.microsoft.com/office/drawing/2014/main" id="{434584EA-C5DF-4066-279F-D4298CDC6CBB}"/>
               </a:ext>
             </a:extLst>
           </p:cNvPr>
@@ -20551,7 +20339,7 @@
           <p:cNvPr id="440" name="TextBox 439">
             <a:extLst>
               <a:ext uri="{FF2B5EF4-FFF2-40B4-BE49-F238E27FC236}">
-                <a16:creationId xmlns:a16="http://schemas.microsoft.com/office/drawing/2014/main" id="{F56AA4A8-9F6D-24EA-E067-ADD0332962F4}"/>
+                <a16:creationId xmlns:a16="http://schemas.microsoft.com/office/drawing/2014/main" id="{5793ADFD-CCB8-8A89-70D9-D9892CABE987}"/>
               </a:ext>
             </a:extLst>
           </p:cNvPr>
@@ -20681,7 +20469,7 @@
           <p:cNvPr id="576" name="Connector: Elbow 575">
             <a:extLst>
               <a:ext uri="{FF2B5EF4-FFF2-40B4-BE49-F238E27FC236}">
-                <a16:creationId xmlns:a16="http://schemas.microsoft.com/office/drawing/2014/main" id="{40421267-B2A4-8395-C64C-14BD1EE24BD5}"/>
+                <a16:creationId xmlns:a16="http://schemas.microsoft.com/office/drawing/2014/main" id="{B3C20A9D-8742-1C1F-A519-76E6D3EDA865}"/>
               </a:ext>
             </a:extLst>
           </p:cNvPr>
@@ -20729,7 +20517,7 @@
           <p:cNvPr id="580" name="Connector: Elbow 579">
             <a:extLst>
               <a:ext uri="{FF2B5EF4-FFF2-40B4-BE49-F238E27FC236}">
-                <a16:creationId xmlns:a16="http://schemas.microsoft.com/office/drawing/2014/main" id="{00E6FF21-9201-632F-5617-DF2710A5BB82}"/>
+                <a16:creationId xmlns:a16="http://schemas.microsoft.com/office/drawing/2014/main" id="{9E2E05B6-082A-A05B-5F99-23C32DEDA2A8}"/>
               </a:ext>
             </a:extLst>
           </p:cNvPr>
@@ -20779,7 +20567,7 @@
           <p:cNvPr id="583" name="Connector: Elbow 582">
             <a:extLst>
               <a:ext uri="{FF2B5EF4-FFF2-40B4-BE49-F238E27FC236}">
-                <a16:creationId xmlns:a16="http://schemas.microsoft.com/office/drawing/2014/main" id="{A4ACA83D-3C45-F577-CA1A-76878A78AA4A}"/>
+                <a16:creationId xmlns:a16="http://schemas.microsoft.com/office/drawing/2014/main" id="{020176F5-FC7D-60E6-3F82-649F019E37BE}"/>
               </a:ext>
             </a:extLst>
           </p:cNvPr>
@@ -20826,7 +20614,7 @@
           <p:cNvPr id="588" name="Connector: Elbow 587">
             <a:extLst>
               <a:ext uri="{FF2B5EF4-FFF2-40B4-BE49-F238E27FC236}">
-                <a16:creationId xmlns:a16="http://schemas.microsoft.com/office/drawing/2014/main" id="{E6A199E4-C323-70D5-4DF0-48DBC5C4C438}"/>
+                <a16:creationId xmlns:a16="http://schemas.microsoft.com/office/drawing/2014/main" id="{E7CE68B9-2A64-7B5F-A49F-EE5DE157C86C}"/>
               </a:ext>
             </a:extLst>
           </p:cNvPr>
@@ -20876,7 +20664,7 @@
           <p:cNvPr id="31" name="Group 30">
             <a:extLst>
               <a:ext uri="{FF2B5EF4-FFF2-40B4-BE49-F238E27FC236}">
-                <a16:creationId xmlns:a16="http://schemas.microsoft.com/office/drawing/2014/main" id="{9A5440E2-B3EB-E626-9474-E5CED33B3ADE}"/>
+                <a16:creationId xmlns:a16="http://schemas.microsoft.com/office/drawing/2014/main" id="{8647FB9C-D8FA-4001-B1D2-B3657701513D}"/>
               </a:ext>
             </a:extLst>
           </p:cNvPr>
@@ -20896,7 +20684,7 @@
             <p:cNvPr id="373" name="Google Shape;156;p1">
               <a:extLst>
                 <a:ext uri="{FF2B5EF4-FFF2-40B4-BE49-F238E27FC236}">
-                  <a16:creationId xmlns:a16="http://schemas.microsoft.com/office/drawing/2014/main" id="{557DF384-9494-A8AD-BBE1-5D47A3076282}"/>
+                  <a16:creationId xmlns:a16="http://schemas.microsoft.com/office/drawing/2014/main" id="{BDC09C9D-132F-7914-DAC2-87355B91B2FB}"/>
                 </a:ext>
               </a:extLst>
             </p:cNvPr>
@@ -20916,7 +20704,7 @@
               <p:cNvPr id="374" name="Google Shape;157;p1">
                 <a:extLst>
                   <a:ext uri="{FF2B5EF4-FFF2-40B4-BE49-F238E27FC236}">
-                    <a16:creationId xmlns:a16="http://schemas.microsoft.com/office/drawing/2014/main" id="{4B367089-88A7-97FD-3F89-95D0932745EF}"/>
+                    <a16:creationId xmlns:a16="http://schemas.microsoft.com/office/drawing/2014/main" id="{BC50F154-031F-179A-51F4-EFA1E477332B}"/>
                   </a:ext>
                 </a:extLst>
               </p:cNvPr>
@@ -20978,7 +20766,7 @@
               <p:cNvPr id="375" name="Google Shape;158;p1">
                 <a:extLst>
                   <a:ext uri="{FF2B5EF4-FFF2-40B4-BE49-F238E27FC236}">
-                    <a16:creationId xmlns:a16="http://schemas.microsoft.com/office/drawing/2014/main" id="{F9F320CA-EA95-58E2-30DB-B1594273ED9B}"/>
+                    <a16:creationId xmlns:a16="http://schemas.microsoft.com/office/drawing/2014/main" id="{4ECB97E3-9D9C-43D5-D888-99C2B0A33512}"/>
                   </a:ext>
                 </a:extLst>
               </p:cNvPr>
@@ -21040,7 +20828,7 @@
               <p:cNvPr id="376" name="Google Shape;159;p1">
                 <a:extLst>
                   <a:ext uri="{FF2B5EF4-FFF2-40B4-BE49-F238E27FC236}">
-                    <a16:creationId xmlns:a16="http://schemas.microsoft.com/office/drawing/2014/main" id="{C73540F7-E851-A7BA-0190-4D93E3D13AAE}"/>
+                    <a16:creationId xmlns:a16="http://schemas.microsoft.com/office/drawing/2014/main" id="{6F0EECA8-2F5F-6328-88BA-775B5C0939B3}"/>
                   </a:ext>
                 </a:extLst>
               </p:cNvPr>
@@ -21102,7 +20890,7 @@
               <p:cNvPr id="377" name="Google Shape;160;p1">
                 <a:extLst>
                   <a:ext uri="{FF2B5EF4-FFF2-40B4-BE49-F238E27FC236}">
-                    <a16:creationId xmlns:a16="http://schemas.microsoft.com/office/drawing/2014/main" id="{9A3717E6-1C4B-E5A3-1E7E-6F0FA51076F7}"/>
+                    <a16:creationId xmlns:a16="http://schemas.microsoft.com/office/drawing/2014/main" id="{00640BFA-3D23-00B8-6D1A-BEC555CD3E9F}"/>
                   </a:ext>
                 </a:extLst>
               </p:cNvPr>
@@ -21164,7 +20952,7 @@
               <p:cNvPr id="378" name="Google Shape;161;p1">
                 <a:extLst>
                   <a:ext uri="{FF2B5EF4-FFF2-40B4-BE49-F238E27FC236}">
-                    <a16:creationId xmlns:a16="http://schemas.microsoft.com/office/drawing/2014/main" id="{7021E6C8-034E-B05E-749B-057B04DC7D3D}"/>
+                    <a16:creationId xmlns:a16="http://schemas.microsoft.com/office/drawing/2014/main" id="{8275E0F8-FC24-804C-FC38-762752C06019}"/>
                   </a:ext>
                 </a:extLst>
               </p:cNvPr>
@@ -21226,7 +21014,7 @@
               <p:cNvPr id="379" name="Google Shape;162;p1">
                 <a:extLst>
                   <a:ext uri="{FF2B5EF4-FFF2-40B4-BE49-F238E27FC236}">
-                    <a16:creationId xmlns:a16="http://schemas.microsoft.com/office/drawing/2014/main" id="{53BB3D37-908F-B0DB-D982-E0796F9B0DD5}"/>
+                    <a16:creationId xmlns:a16="http://schemas.microsoft.com/office/drawing/2014/main" id="{20C68E01-E92F-E760-C17D-3B33B1BF2CA1}"/>
                   </a:ext>
                 </a:extLst>
               </p:cNvPr>
@@ -21288,7 +21076,7 @@
               <p:cNvPr id="380" name="Google Shape;163;p1">
                 <a:extLst>
                   <a:ext uri="{FF2B5EF4-FFF2-40B4-BE49-F238E27FC236}">
-                    <a16:creationId xmlns:a16="http://schemas.microsoft.com/office/drawing/2014/main" id="{CFF00200-CEFC-C448-09E7-D6A6351A1DDA}"/>
+                    <a16:creationId xmlns:a16="http://schemas.microsoft.com/office/drawing/2014/main" id="{9955C53A-022D-F0E7-AB94-100463C8B5E3}"/>
                   </a:ext>
                 </a:extLst>
               </p:cNvPr>
@@ -21350,7 +21138,7 @@
               <p:cNvPr id="381" name="Google Shape;164;p1">
                 <a:extLst>
                   <a:ext uri="{FF2B5EF4-FFF2-40B4-BE49-F238E27FC236}">
-                    <a16:creationId xmlns:a16="http://schemas.microsoft.com/office/drawing/2014/main" id="{A7FB777C-400A-3B4E-A5A1-144290FE1C31}"/>
+                    <a16:creationId xmlns:a16="http://schemas.microsoft.com/office/drawing/2014/main" id="{4D7A62A7-0C2A-AE4A-780B-8FFB0718DDB2}"/>
                   </a:ext>
                 </a:extLst>
               </p:cNvPr>
@@ -21412,7 +21200,7 @@
               <p:cNvPr id="383" name="Google Shape;165;p1">
                 <a:extLst>
                   <a:ext uri="{FF2B5EF4-FFF2-40B4-BE49-F238E27FC236}">
-                    <a16:creationId xmlns:a16="http://schemas.microsoft.com/office/drawing/2014/main" id="{6A5B0B10-A48B-89E4-9C9A-CDBA751DC359}"/>
+                    <a16:creationId xmlns:a16="http://schemas.microsoft.com/office/drawing/2014/main" id="{CFC23351-7B1A-37A7-0E50-159AB3166A17}"/>
                   </a:ext>
                 </a:extLst>
               </p:cNvPr>
@@ -21474,7 +21262,7 @@
               <p:cNvPr id="385" name="Google Shape;166;p1">
                 <a:extLst>
                   <a:ext uri="{FF2B5EF4-FFF2-40B4-BE49-F238E27FC236}">
-                    <a16:creationId xmlns:a16="http://schemas.microsoft.com/office/drawing/2014/main" id="{89FBABE8-271F-B8D8-C6AD-7280022E0561}"/>
+                    <a16:creationId xmlns:a16="http://schemas.microsoft.com/office/drawing/2014/main" id="{7282C0EE-6CBD-064E-1BDB-950A1FEF7A66}"/>
                   </a:ext>
                 </a:extLst>
               </p:cNvPr>
@@ -21536,7 +21324,7 @@
               <p:cNvPr id="386" name="Google Shape;167;p1">
                 <a:extLst>
                   <a:ext uri="{FF2B5EF4-FFF2-40B4-BE49-F238E27FC236}">
-                    <a16:creationId xmlns:a16="http://schemas.microsoft.com/office/drawing/2014/main" id="{0FC31C3C-BF43-6479-6A2A-BFF847EA96D0}"/>
+                    <a16:creationId xmlns:a16="http://schemas.microsoft.com/office/drawing/2014/main" id="{BAFAB26C-9E9E-0532-DC27-FF16DF9C0093}"/>
                   </a:ext>
                 </a:extLst>
               </p:cNvPr>
@@ -21598,7 +21386,7 @@
               <p:cNvPr id="387" name="Google Shape;168;p1">
                 <a:extLst>
                   <a:ext uri="{FF2B5EF4-FFF2-40B4-BE49-F238E27FC236}">
-                    <a16:creationId xmlns:a16="http://schemas.microsoft.com/office/drawing/2014/main" id="{B61CE04E-E18B-1212-71F8-B0A4F3992B28}"/>
+                    <a16:creationId xmlns:a16="http://schemas.microsoft.com/office/drawing/2014/main" id="{57D3BB21-9AD3-DE0E-C4BD-B131F35777C9}"/>
                   </a:ext>
                 </a:extLst>
               </p:cNvPr>
@@ -21660,7 +21448,7 @@
               <p:cNvPr id="388" name="Google Shape;169;p1">
                 <a:extLst>
                   <a:ext uri="{FF2B5EF4-FFF2-40B4-BE49-F238E27FC236}">
-                    <a16:creationId xmlns:a16="http://schemas.microsoft.com/office/drawing/2014/main" id="{00FDCB4A-B4FC-8619-F9DC-464B2A32FD7C}"/>
+                    <a16:creationId xmlns:a16="http://schemas.microsoft.com/office/drawing/2014/main" id="{A782F540-7FC9-DF3D-F165-D8D152848118}"/>
                   </a:ext>
                 </a:extLst>
               </p:cNvPr>
@@ -21722,7 +21510,7 @@
               <p:cNvPr id="389" name="Google Shape;170;p1">
                 <a:extLst>
                   <a:ext uri="{FF2B5EF4-FFF2-40B4-BE49-F238E27FC236}">
-                    <a16:creationId xmlns:a16="http://schemas.microsoft.com/office/drawing/2014/main" id="{714F82B2-DBBE-09C1-832A-C15783751311}"/>
+                    <a16:creationId xmlns:a16="http://schemas.microsoft.com/office/drawing/2014/main" id="{800A3974-2421-1AA8-A5D6-17A2BE9AB7CC}"/>
                   </a:ext>
                 </a:extLst>
               </p:cNvPr>
@@ -21784,7 +21572,7 @@
               <p:cNvPr id="390" name="Google Shape;171;p1">
                 <a:extLst>
                   <a:ext uri="{FF2B5EF4-FFF2-40B4-BE49-F238E27FC236}">
-                    <a16:creationId xmlns:a16="http://schemas.microsoft.com/office/drawing/2014/main" id="{D6E152D1-5E04-331B-AC95-148F51196E81}"/>
+                    <a16:creationId xmlns:a16="http://schemas.microsoft.com/office/drawing/2014/main" id="{4E4768CE-4A3C-BC3C-2C84-79CDC149B7D8}"/>
                   </a:ext>
                 </a:extLst>
               </p:cNvPr>
@@ -21846,7 +21634,7 @@
               <p:cNvPr id="391" name="Google Shape;172;p1">
                 <a:extLst>
                   <a:ext uri="{FF2B5EF4-FFF2-40B4-BE49-F238E27FC236}">
-                    <a16:creationId xmlns:a16="http://schemas.microsoft.com/office/drawing/2014/main" id="{3547655A-0B68-88D1-9F54-A8045297F5ED}"/>
+                    <a16:creationId xmlns:a16="http://schemas.microsoft.com/office/drawing/2014/main" id="{DB8E1FCF-EC6F-8205-7512-2BA7B42B3AF5}"/>
                   </a:ext>
                 </a:extLst>
               </p:cNvPr>
@@ -21881,7 +21669,7 @@
               <p:cNvPr id="392" name="Google Shape;173;p1">
                 <a:extLst>
                   <a:ext uri="{FF2B5EF4-FFF2-40B4-BE49-F238E27FC236}">
-                    <a16:creationId xmlns:a16="http://schemas.microsoft.com/office/drawing/2014/main" id="{0E4427F2-DB0D-5446-8279-283A8F085389}"/>
+                    <a16:creationId xmlns:a16="http://schemas.microsoft.com/office/drawing/2014/main" id="{A882723A-C7B4-F531-D64C-C5E1E65F9A58}"/>
                   </a:ext>
                 </a:extLst>
               </p:cNvPr>
@@ -21916,7 +21704,7 @@
               <p:cNvPr id="393" name="Google Shape;175;p1">
                 <a:extLst>
                   <a:ext uri="{FF2B5EF4-FFF2-40B4-BE49-F238E27FC236}">
-                    <a16:creationId xmlns:a16="http://schemas.microsoft.com/office/drawing/2014/main" id="{3C9E4E7B-16A8-84A6-5CF2-DE7A7CFF1502}"/>
+                    <a16:creationId xmlns:a16="http://schemas.microsoft.com/office/drawing/2014/main" id="{40E8A6AB-DBDD-CE91-0B80-CC948611D658}"/>
                   </a:ext>
                 </a:extLst>
               </p:cNvPr>
@@ -21951,7 +21739,7 @@
               <p:cNvPr id="394" name="Google Shape;177;p1">
                 <a:extLst>
                   <a:ext uri="{FF2B5EF4-FFF2-40B4-BE49-F238E27FC236}">
-                    <a16:creationId xmlns:a16="http://schemas.microsoft.com/office/drawing/2014/main" id="{99758D70-7DE8-DCAC-0962-667BACADE27A}"/>
+                    <a16:creationId xmlns:a16="http://schemas.microsoft.com/office/drawing/2014/main" id="{16D2FD60-4B2B-699F-C8D8-2EAFAE7A1AD6}"/>
                   </a:ext>
                 </a:extLst>
               </p:cNvPr>
@@ -21986,7 +21774,7 @@
               <p:cNvPr id="395" name="Google Shape;178;p1">
                 <a:extLst>
                   <a:ext uri="{FF2B5EF4-FFF2-40B4-BE49-F238E27FC236}">
-                    <a16:creationId xmlns:a16="http://schemas.microsoft.com/office/drawing/2014/main" id="{8C4D5E36-559B-E7C0-FEBF-5E2B0F240B06}"/>
+                    <a16:creationId xmlns:a16="http://schemas.microsoft.com/office/drawing/2014/main" id="{2C0CB17F-D675-F827-796A-C269536161D7}"/>
                   </a:ext>
                 </a:extLst>
               </p:cNvPr>
@@ -22021,7 +21809,7 @@
               <p:cNvPr id="396" name="Google Shape;179;p1">
                 <a:extLst>
                   <a:ext uri="{FF2B5EF4-FFF2-40B4-BE49-F238E27FC236}">
-                    <a16:creationId xmlns:a16="http://schemas.microsoft.com/office/drawing/2014/main" id="{8A37B587-540B-3D9A-0378-5EB525585D5E}"/>
+                    <a16:creationId xmlns:a16="http://schemas.microsoft.com/office/drawing/2014/main" id="{E62052B5-A7DE-1DD5-2172-8351704850B8}"/>
                   </a:ext>
                 </a:extLst>
               </p:cNvPr>
@@ -22056,7 +21844,7 @@
               <p:cNvPr id="397" name="Google Shape;180;p1">
                 <a:extLst>
                   <a:ext uri="{FF2B5EF4-FFF2-40B4-BE49-F238E27FC236}">
-                    <a16:creationId xmlns:a16="http://schemas.microsoft.com/office/drawing/2014/main" id="{6A7204DD-220C-6AE5-1EC2-36EFB136C86E}"/>
+                    <a16:creationId xmlns:a16="http://schemas.microsoft.com/office/drawing/2014/main" id="{E8D509A2-0D8C-D6CD-B8F1-DD2997226B94}"/>
                   </a:ext>
                 </a:extLst>
               </p:cNvPr>
@@ -22091,7 +21879,7 @@
               <p:cNvPr id="398" name="Google Shape;181;p1">
                 <a:extLst>
                   <a:ext uri="{FF2B5EF4-FFF2-40B4-BE49-F238E27FC236}">
-                    <a16:creationId xmlns:a16="http://schemas.microsoft.com/office/drawing/2014/main" id="{2F6C80D0-1ACD-E8F1-7BCD-B0CB92F8A937}"/>
+                    <a16:creationId xmlns:a16="http://schemas.microsoft.com/office/drawing/2014/main" id="{3E30938F-A341-433F-3055-C31FF767CC64}"/>
                   </a:ext>
                 </a:extLst>
               </p:cNvPr>
@@ -22126,7 +21914,7 @@
               <p:cNvPr id="399" name="Google Shape;183;p1">
                 <a:extLst>
                   <a:ext uri="{FF2B5EF4-FFF2-40B4-BE49-F238E27FC236}">
-                    <a16:creationId xmlns:a16="http://schemas.microsoft.com/office/drawing/2014/main" id="{5398C726-9ED3-049F-78D9-29C6F83065AA}"/>
+                    <a16:creationId xmlns:a16="http://schemas.microsoft.com/office/drawing/2014/main" id="{D3B5F285-BD51-9242-8311-105F315C9168}"/>
                   </a:ext>
                 </a:extLst>
               </p:cNvPr>
@@ -22161,7 +21949,7 @@
               <p:cNvPr id="400" name="Google Shape;176;p1">
                 <a:extLst>
                   <a:ext uri="{FF2B5EF4-FFF2-40B4-BE49-F238E27FC236}">
-                    <a16:creationId xmlns:a16="http://schemas.microsoft.com/office/drawing/2014/main" id="{5670E7A9-AA9C-BF47-11BA-C751A375906A}"/>
+                    <a16:creationId xmlns:a16="http://schemas.microsoft.com/office/drawing/2014/main" id="{C0A095AB-B9BE-B8F7-EB9B-B90475F70692}"/>
                   </a:ext>
                 </a:extLst>
               </p:cNvPr>
@@ -22223,7 +22011,7 @@
               <p:cNvPr id="401" name="Google Shape;184;p1">
                 <a:extLst>
                   <a:ext uri="{FF2B5EF4-FFF2-40B4-BE49-F238E27FC236}">
-                    <a16:creationId xmlns:a16="http://schemas.microsoft.com/office/drawing/2014/main" id="{F895C011-0749-ED46-FE95-98304511E152}"/>
+                    <a16:creationId xmlns:a16="http://schemas.microsoft.com/office/drawing/2014/main" id="{BC96D185-DEF5-77EA-DAE6-1C76D9F23DB4}"/>
                   </a:ext>
                 </a:extLst>
               </p:cNvPr>
@@ -22258,7 +22046,7 @@
               <p:cNvPr id="402" name="Google Shape;185;p1">
                 <a:extLst>
                   <a:ext uri="{FF2B5EF4-FFF2-40B4-BE49-F238E27FC236}">
-                    <a16:creationId xmlns:a16="http://schemas.microsoft.com/office/drawing/2014/main" id="{6F6D821D-7757-CBD7-C733-E017C9CBD354}"/>
+                    <a16:creationId xmlns:a16="http://schemas.microsoft.com/office/drawing/2014/main" id="{E604A188-78FF-DE60-D012-522D665F3B67}"/>
                   </a:ext>
                 </a:extLst>
               </p:cNvPr>
@@ -22293,7 +22081,7 @@
               <p:cNvPr id="403" name="Google Shape;174;p1">
                 <a:extLst>
                   <a:ext uri="{FF2B5EF4-FFF2-40B4-BE49-F238E27FC236}">
-                    <a16:creationId xmlns:a16="http://schemas.microsoft.com/office/drawing/2014/main" id="{0760B263-FCA4-8895-FA7D-F07654B7E48E}"/>
+                    <a16:creationId xmlns:a16="http://schemas.microsoft.com/office/drawing/2014/main" id="{32961F1C-AC74-8E11-0A7B-1C8848AEEF14}"/>
                   </a:ext>
                 </a:extLst>
               </p:cNvPr>
@@ -22355,7 +22143,7 @@
               <p:cNvPr id="404" name="Google Shape;186;p1">
                 <a:extLst>
                   <a:ext uri="{FF2B5EF4-FFF2-40B4-BE49-F238E27FC236}">
-                    <a16:creationId xmlns:a16="http://schemas.microsoft.com/office/drawing/2014/main" id="{E39CEDDD-E01E-406C-AB4B-0F8BC088BF3F}"/>
+                    <a16:creationId xmlns:a16="http://schemas.microsoft.com/office/drawing/2014/main" id="{A8B4F513-5074-F07B-F35E-354510BB4E4F}"/>
                   </a:ext>
                 </a:extLst>
               </p:cNvPr>
@@ -22390,7 +22178,7 @@
               <p:cNvPr id="405" name="Google Shape;187;p1">
                 <a:extLst>
                   <a:ext uri="{FF2B5EF4-FFF2-40B4-BE49-F238E27FC236}">
-                    <a16:creationId xmlns:a16="http://schemas.microsoft.com/office/drawing/2014/main" id="{D25DAB40-36BA-673A-5010-17AB3001EDAB}"/>
+                    <a16:creationId xmlns:a16="http://schemas.microsoft.com/office/drawing/2014/main" id="{5A5A09E7-EA04-581E-BD8D-083E8306D8CD}"/>
                   </a:ext>
                 </a:extLst>
               </p:cNvPr>
@@ -22425,7 +22213,7 @@
               <p:cNvPr id="406" name="Google Shape;189;p1">
                 <a:extLst>
                   <a:ext uri="{FF2B5EF4-FFF2-40B4-BE49-F238E27FC236}">
-                    <a16:creationId xmlns:a16="http://schemas.microsoft.com/office/drawing/2014/main" id="{C60F9E9A-45BA-84A0-7AC5-B100F086CA3F}"/>
+                    <a16:creationId xmlns:a16="http://schemas.microsoft.com/office/drawing/2014/main" id="{BBCAAF01-F47D-BEC4-8586-4A329FDF4B93}"/>
                   </a:ext>
                 </a:extLst>
               </p:cNvPr>
@@ -22460,7 +22248,7 @@
               <p:cNvPr id="407" name="Google Shape;190;p1">
                 <a:extLst>
                   <a:ext uri="{FF2B5EF4-FFF2-40B4-BE49-F238E27FC236}">
-                    <a16:creationId xmlns:a16="http://schemas.microsoft.com/office/drawing/2014/main" id="{627F3916-102F-2D3B-F287-6B1607F166B8}"/>
+                    <a16:creationId xmlns:a16="http://schemas.microsoft.com/office/drawing/2014/main" id="{CD1B6A64-3EA5-2626-EE4B-0D84903B5CFA}"/>
                   </a:ext>
                 </a:extLst>
               </p:cNvPr>
@@ -22495,7 +22283,7 @@
               <p:cNvPr id="408" name="Google Shape;191;p1">
                 <a:extLst>
                   <a:ext uri="{FF2B5EF4-FFF2-40B4-BE49-F238E27FC236}">
-                    <a16:creationId xmlns:a16="http://schemas.microsoft.com/office/drawing/2014/main" id="{DBBF9DFC-676F-44A2-0275-FD68D3BDAB84}"/>
+                    <a16:creationId xmlns:a16="http://schemas.microsoft.com/office/drawing/2014/main" id="{633D3A88-6785-55AA-901E-A7B1B1D3F54F}"/>
                   </a:ext>
                 </a:extLst>
               </p:cNvPr>
@@ -22530,7 +22318,7 @@
               <p:cNvPr id="409" name="Google Shape;188;p1">
                 <a:extLst>
                   <a:ext uri="{FF2B5EF4-FFF2-40B4-BE49-F238E27FC236}">
-                    <a16:creationId xmlns:a16="http://schemas.microsoft.com/office/drawing/2014/main" id="{61C1DDE7-803C-A98D-DC8E-8C02E39DBC8D}"/>
+                    <a16:creationId xmlns:a16="http://schemas.microsoft.com/office/drawing/2014/main" id="{BA09D261-3DD4-7139-5F44-F0DC3163CC83}"/>
                   </a:ext>
                 </a:extLst>
               </p:cNvPr>
@@ -22592,7 +22380,7 @@
               <p:cNvPr id="410" name="Google Shape;192;p1">
                 <a:extLst>
                   <a:ext uri="{FF2B5EF4-FFF2-40B4-BE49-F238E27FC236}">
-                    <a16:creationId xmlns:a16="http://schemas.microsoft.com/office/drawing/2014/main" id="{CACF5458-FB36-53C0-DE5E-4111A96C4352}"/>
+                    <a16:creationId xmlns:a16="http://schemas.microsoft.com/office/drawing/2014/main" id="{C4815E66-157A-9AF7-1BD8-6C15A6026A13}"/>
                   </a:ext>
                 </a:extLst>
               </p:cNvPr>
@@ -22627,7 +22415,7 @@
               <p:cNvPr id="411" name="Google Shape;182;p1">
                 <a:extLst>
                   <a:ext uri="{FF2B5EF4-FFF2-40B4-BE49-F238E27FC236}">
-                    <a16:creationId xmlns:a16="http://schemas.microsoft.com/office/drawing/2014/main" id="{367C7319-BB16-52A3-FF62-C1E8E38DD335}"/>
+                    <a16:creationId xmlns:a16="http://schemas.microsoft.com/office/drawing/2014/main" id="{DA49F370-E2AF-E123-F08F-3BD62EDFFAFC}"/>
                   </a:ext>
                 </a:extLst>
               </p:cNvPr>
@@ -22689,7 +22477,7 @@
               <p:cNvPr id="412" name="Google Shape;193;p1">
                 <a:extLst>
                   <a:ext uri="{FF2B5EF4-FFF2-40B4-BE49-F238E27FC236}">
-                    <a16:creationId xmlns:a16="http://schemas.microsoft.com/office/drawing/2014/main" id="{B608ADF9-4FA7-6E29-49CC-063BBF344AB7}"/>
+                    <a16:creationId xmlns:a16="http://schemas.microsoft.com/office/drawing/2014/main" id="{BE0D87CA-556F-3D82-E04E-664749114205}"/>
                   </a:ext>
                 </a:extLst>
               </p:cNvPr>
@@ -22724,7 +22512,7 @@
               <p:cNvPr id="413" name="Google Shape;194;p1">
                 <a:extLst>
                   <a:ext uri="{FF2B5EF4-FFF2-40B4-BE49-F238E27FC236}">
-                    <a16:creationId xmlns:a16="http://schemas.microsoft.com/office/drawing/2014/main" id="{92184AC2-326D-F82D-CF13-5F416E388DB4}"/>
+                    <a16:creationId xmlns:a16="http://schemas.microsoft.com/office/drawing/2014/main" id="{C3D9A7E7-43B1-D03F-E826-C1A6707D54D7}"/>
                   </a:ext>
                 </a:extLst>
               </p:cNvPr>
@@ -22759,7 +22547,7 @@
               <p:cNvPr id="414" name="Google Shape;195;p1">
                 <a:extLst>
                   <a:ext uri="{FF2B5EF4-FFF2-40B4-BE49-F238E27FC236}">
-                    <a16:creationId xmlns:a16="http://schemas.microsoft.com/office/drawing/2014/main" id="{5D655AA9-FDA5-F2A4-8808-C30B43AF68FB}"/>
+                    <a16:creationId xmlns:a16="http://schemas.microsoft.com/office/drawing/2014/main" id="{1583BCDC-63A2-7FC8-FE05-1ED93E97688D}"/>
                   </a:ext>
                 </a:extLst>
               </p:cNvPr>
@@ -22794,7 +22582,7 @@
               <p:cNvPr id="415" name="Google Shape;196;p1">
                 <a:extLst>
                   <a:ext uri="{FF2B5EF4-FFF2-40B4-BE49-F238E27FC236}">
-                    <a16:creationId xmlns:a16="http://schemas.microsoft.com/office/drawing/2014/main" id="{E5831266-1C7C-81B1-C4DC-1D401E05A4EB}"/>
+                    <a16:creationId xmlns:a16="http://schemas.microsoft.com/office/drawing/2014/main" id="{DF229163-3E6C-9FBA-97E4-349B82AE0889}"/>
                   </a:ext>
                 </a:extLst>
               </p:cNvPr>
@@ -22829,7 +22617,7 @@
               <p:cNvPr id="416" name="Google Shape;197;p1">
                 <a:extLst>
                   <a:ext uri="{FF2B5EF4-FFF2-40B4-BE49-F238E27FC236}">
-                    <a16:creationId xmlns:a16="http://schemas.microsoft.com/office/drawing/2014/main" id="{8FA715C6-B197-1B5F-6FFD-E9B077BB5EB5}"/>
+                    <a16:creationId xmlns:a16="http://schemas.microsoft.com/office/drawing/2014/main" id="{DEFE91E6-83A3-392E-F143-F607BCCB8F93}"/>
                   </a:ext>
                 </a:extLst>
               </p:cNvPr>
@@ -22864,7 +22652,7 @@
               <p:cNvPr id="417" name="Google Shape;198;p1">
                 <a:extLst>
                   <a:ext uri="{FF2B5EF4-FFF2-40B4-BE49-F238E27FC236}">
-                    <a16:creationId xmlns:a16="http://schemas.microsoft.com/office/drawing/2014/main" id="{4DD749CD-1E84-7789-A13D-5A60CD628BB8}"/>
+                    <a16:creationId xmlns:a16="http://schemas.microsoft.com/office/drawing/2014/main" id="{894A9106-F17F-3A0E-94D4-0F321145F300}"/>
                   </a:ext>
                 </a:extLst>
               </p:cNvPr>
@@ -22899,7 +22687,7 @@
               <p:cNvPr id="418" name="Google Shape;199;p1">
                 <a:extLst>
                   <a:ext uri="{FF2B5EF4-FFF2-40B4-BE49-F238E27FC236}">
-                    <a16:creationId xmlns:a16="http://schemas.microsoft.com/office/drawing/2014/main" id="{31242443-454F-F5B9-B12A-9F6A57D2F134}"/>
+                    <a16:creationId xmlns:a16="http://schemas.microsoft.com/office/drawing/2014/main" id="{921F40C5-C444-AA18-7E25-EADF2B5DC104}"/>
                   </a:ext>
                 </a:extLst>
               </p:cNvPr>
@@ -22934,7 +22722,7 @@
               <p:cNvPr id="419" name="Google Shape;200;p1">
                 <a:extLst>
                   <a:ext uri="{FF2B5EF4-FFF2-40B4-BE49-F238E27FC236}">
-                    <a16:creationId xmlns:a16="http://schemas.microsoft.com/office/drawing/2014/main" id="{973099B0-5943-5508-A469-F9BDAAEFF17E}"/>
+                    <a16:creationId xmlns:a16="http://schemas.microsoft.com/office/drawing/2014/main" id="{5D66DFAD-8988-0832-603B-B71941F1361D}"/>
                   </a:ext>
                 </a:extLst>
               </p:cNvPr>
@@ -22970,7 +22758,7 @@
             <p:cNvPr id="17" name="Table">
               <a:extLst>
                 <a:ext uri="{FF2B5EF4-FFF2-40B4-BE49-F238E27FC236}">
-                  <a16:creationId xmlns:a16="http://schemas.microsoft.com/office/drawing/2014/main" id="{4BB3AF93-BC74-C905-2296-2170BD1AC16D}"/>
+                  <a16:creationId xmlns:a16="http://schemas.microsoft.com/office/drawing/2014/main" id="{19C8E28E-038C-BFED-70B1-A78228B93F0C}"/>
                 </a:ext>
               </a:extLst>
             </p:cNvPr>
@@ -23755,7 +23543,7 @@
           <p:cNvPr id="11" name="TextBox 10">
             <a:extLst>
               <a:ext uri="{FF2B5EF4-FFF2-40B4-BE49-F238E27FC236}">
-                <a16:creationId xmlns:a16="http://schemas.microsoft.com/office/drawing/2014/main" id="{CE080807-A0B1-E306-8BD4-B661C39F86AD}"/>
+                <a16:creationId xmlns:a16="http://schemas.microsoft.com/office/drawing/2014/main" id="{329408FF-87C0-734F-E8CA-FFBAC9B16ABF}"/>
               </a:ext>
             </a:extLst>
           </p:cNvPr>
@@ -23764,8 +23552,8 @@
         </p:nvSpPr>
         <p:spPr>
           <a:xfrm>
-            <a:off x="274319" y="3699618"/>
-            <a:ext cx="3291840" cy="1561885"/>
+            <a:off x="274319" y="3749040"/>
+            <a:ext cx="3291840" cy="1463040"/>
           </a:xfrm>
           <a:prstGeom prst="rect">
             <a:avLst/>
@@ -23831,7 +23619,7 @@
           <p:cNvPr id="14" name="TextBox 13">
             <a:extLst>
               <a:ext uri="{FF2B5EF4-FFF2-40B4-BE49-F238E27FC236}">
-                <a16:creationId xmlns:a16="http://schemas.microsoft.com/office/drawing/2014/main" id="{EEE584CB-EF20-1E9D-F6C6-E89DCCE6FDF7}"/>
+                <a16:creationId xmlns:a16="http://schemas.microsoft.com/office/drawing/2014/main" id="{9C00D49E-56F1-3DAF-C5D0-6E1EBB670E87}"/>
               </a:ext>
             </a:extLst>
           </p:cNvPr>
@@ -23840,8 +23628,8 @@
         </p:nvSpPr>
         <p:spPr>
           <a:xfrm>
-            <a:off x="274320" y="5493289"/>
-            <a:ext cx="3291840" cy="1997902"/>
+            <a:off x="274320" y="5577840"/>
+            <a:ext cx="3291840" cy="1828800"/>
           </a:xfrm>
           <a:prstGeom prst="rect">
             <a:avLst/>
@@ -23920,7 +23708,7 @@
           <p:cNvPr id="16" name="TextBox 15">
             <a:extLst>
               <a:ext uri="{FF2B5EF4-FFF2-40B4-BE49-F238E27FC236}">
-                <a16:creationId xmlns:a16="http://schemas.microsoft.com/office/drawing/2014/main" id="{D9B64059-CABF-AF93-E0DA-58AE0C6FA06F}"/>
+                <a16:creationId xmlns:a16="http://schemas.microsoft.com/office/drawing/2014/main" id="{4FD198A5-8126-BCFB-A80C-CD9FCD4D0792}"/>
               </a:ext>
             </a:extLst>
           </p:cNvPr>
@@ -24014,10 +23802,598 @@
           </a:p>
         </p:txBody>
       </p:sp>
+      <p:sp>
+        <p:nvSpPr>
+          <p:cNvPr id="3" name="Line">
+            <a:extLst>
+              <a:ext uri="{FF2B5EF4-FFF2-40B4-BE49-F238E27FC236}">
+                <a16:creationId xmlns:a16="http://schemas.microsoft.com/office/drawing/2014/main" id="{1B65CB05-C9BE-D047-A1EC-B1BDA2E90867}"/>
+              </a:ext>
+            </a:extLst>
+          </p:cNvPr>
+          <p:cNvSpPr/>
+          <p:nvPr/>
+        </p:nvSpPr>
+        <p:spPr>
+          <a:xfrm flipV="1">
+            <a:off x="274320" y="1737360"/>
+            <a:ext cx="3291840" cy="0"/>
+          </a:xfrm>
+          <a:prstGeom prst="line">
+            <a:avLst/>
+          </a:prstGeom>
+          <a:ln w="12700">
+            <a:solidFill>
+              <a:srgbClr val="E4E4E3"/>
+            </a:solidFill>
+            <a:miter lim="400000"/>
+          </a:ln>
+        </p:spPr>
+        <p:txBody>
+          <a:bodyPr lIns="54570" tIns="54570" rIns="54570" bIns="54570" anchor="ctr"/>
+          <a:lstStyle/>
+          <a:p>
+            <a:pPr>
+              <a:lnSpc>
+                <a:spcPct val="80000"/>
+              </a:lnSpc>
+              <a:spcBef>
+                <a:spcPts val="600"/>
+              </a:spcBef>
+              <a:defRPr b="0">
+                <a:solidFill>
+                  <a:srgbClr val="000000"/>
+                </a:solidFill>
+              </a:defRPr>
+            </a:pPr>
+            <a:endParaRPr/>
+          </a:p>
+        </p:txBody>
+      </p:sp>
+      <p:sp>
+        <p:nvSpPr>
+          <p:cNvPr id="4" name="Line">
+            <a:extLst>
+              <a:ext uri="{FF2B5EF4-FFF2-40B4-BE49-F238E27FC236}">
+                <a16:creationId xmlns:a16="http://schemas.microsoft.com/office/drawing/2014/main" id="{2627C03E-32E3-1503-AD05-1455FD21438A}"/>
+              </a:ext>
+            </a:extLst>
+          </p:cNvPr>
+          <p:cNvSpPr/>
+          <p:nvPr/>
+        </p:nvSpPr>
+        <p:spPr>
+          <a:xfrm flipV="1">
+            <a:off x="274320" y="3749040"/>
+            <a:ext cx="3291840" cy="0"/>
+          </a:xfrm>
+          <a:prstGeom prst="line">
+            <a:avLst/>
+          </a:prstGeom>
+          <a:ln w="12700">
+            <a:solidFill>
+              <a:srgbClr val="E4E4E3"/>
+            </a:solidFill>
+            <a:miter lim="400000"/>
+          </a:ln>
+        </p:spPr>
+        <p:txBody>
+          <a:bodyPr lIns="54570" tIns="54570" rIns="54570" bIns="54570" anchor="ctr"/>
+          <a:lstStyle/>
+          <a:p>
+            <a:pPr>
+              <a:lnSpc>
+                <a:spcPct val="80000"/>
+              </a:lnSpc>
+              <a:spcBef>
+                <a:spcPts val="600"/>
+              </a:spcBef>
+              <a:defRPr b="0">
+                <a:solidFill>
+                  <a:srgbClr val="000000"/>
+                </a:solidFill>
+              </a:defRPr>
+            </a:pPr>
+            <a:endParaRPr/>
+          </a:p>
+        </p:txBody>
+      </p:sp>
+      <p:sp>
+        <p:nvSpPr>
+          <p:cNvPr id="22" name="Line">
+            <a:extLst>
+              <a:ext uri="{FF2B5EF4-FFF2-40B4-BE49-F238E27FC236}">
+                <a16:creationId xmlns:a16="http://schemas.microsoft.com/office/drawing/2014/main" id="{3601EFF4-C6AE-DC65-15D1-D2E33045286A}"/>
+              </a:ext>
+            </a:extLst>
+          </p:cNvPr>
+          <p:cNvSpPr/>
+          <p:nvPr/>
+        </p:nvSpPr>
+        <p:spPr>
+          <a:xfrm flipV="1">
+            <a:off x="274320" y="5577840"/>
+            <a:ext cx="3291840" cy="0"/>
+          </a:xfrm>
+          <a:prstGeom prst="line">
+            <a:avLst/>
+          </a:prstGeom>
+          <a:ln w="12700">
+            <a:solidFill>
+              <a:srgbClr val="E4E4E3"/>
+            </a:solidFill>
+            <a:miter lim="400000"/>
+          </a:ln>
+        </p:spPr>
+        <p:txBody>
+          <a:bodyPr lIns="54570" tIns="54570" rIns="54570" bIns="54570" anchor="ctr"/>
+          <a:lstStyle/>
+          <a:p>
+            <a:pPr>
+              <a:lnSpc>
+                <a:spcPct val="80000"/>
+              </a:lnSpc>
+              <a:spcBef>
+                <a:spcPts val="600"/>
+              </a:spcBef>
+              <a:defRPr b="0">
+                <a:solidFill>
+                  <a:srgbClr val="000000"/>
+                </a:solidFill>
+              </a:defRPr>
+            </a:pPr>
+            <a:endParaRPr/>
+          </a:p>
+        </p:txBody>
+      </p:sp>
+      <p:sp>
+        <p:nvSpPr>
+          <p:cNvPr id="23" name="Line">
+            <a:extLst>
+              <a:ext uri="{FF2B5EF4-FFF2-40B4-BE49-F238E27FC236}">
+                <a16:creationId xmlns:a16="http://schemas.microsoft.com/office/drawing/2014/main" id="{FBFCD262-4877-94E5-FA47-2CB930FE66D9}"/>
+              </a:ext>
+            </a:extLst>
+          </p:cNvPr>
+          <p:cNvSpPr/>
+          <p:nvPr/>
+        </p:nvSpPr>
+        <p:spPr>
+          <a:xfrm flipV="1">
+            <a:off x="274320" y="7772400"/>
+            <a:ext cx="3291840" cy="0"/>
+          </a:xfrm>
+          <a:prstGeom prst="line">
+            <a:avLst/>
+          </a:prstGeom>
+          <a:ln w="12700">
+            <a:solidFill>
+              <a:srgbClr val="E4E4E3"/>
+            </a:solidFill>
+            <a:miter lim="400000"/>
+          </a:ln>
+        </p:spPr>
+        <p:txBody>
+          <a:bodyPr lIns="54570" tIns="54570" rIns="54570" bIns="54570" anchor="ctr"/>
+          <a:lstStyle/>
+          <a:p>
+            <a:pPr>
+              <a:lnSpc>
+                <a:spcPct val="80000"/>
+              </a:lnSpc>
+              <a:spcBef>
+                <a:spcPts val="600"/>
+              </a:spcBef>
+              <a:defRPr b="0">
+                <a:solidFill>
+                  <a:srgbClr val="000000"/>
+                </a:solidFill>
+              </a:defRPr>
+            </a:pPr>
+            <a:endParaRPr/>
+          </a:p>
+        </p:txBody>
+      </p:sp>
+      <p:sp>
+        <p:nvSpPr>
+          <p:cNvPr id="29" name="Line">
+            <a:extLst>
+              <a:ext uri="{FF2B5EF4-FFF2-40B4-BE49-F238E27FC236}">
+                <a16:creationId xmlns:a16="http://schemas.microsoft.com/office/drawing/2014/main" id="{141FD609-7B32-4ED3-6357-935B69313972}"/>
+              </a:ext>
+            </a:extLst>
+          </p:cNvPr>
+          <p:cNvSpPr/>
+          <p:nvPr/>
+        </p:nvSpPr>
+        <p:spPr>
+          <a:xfrm flipV="1">
+            <a:off x="9875518" y="1737360"/>
+            <a:ext cx="4023360" cy="0"/>
+          </a:xfrm>
+          <a:prstGeom prst="line">
+            <a:avLst/>
+          </a:prstGeom>
+          <a:ln w="12700">
+            <a:solidFill>
+              <a:srgbClr val="E4E4E3"/>
+            </a:solidFill>
+            <a:miter lim="400000"/>
+          </a:ln>
+        </p:spPr>
+        <p:txBody>
+          <a:bodyPr lIns="54570" tIns="54570" rIns="54570" bIns="54570" anchor="ctr"/>
+          <a:lstStyle/>
+          <a:p>
+            <a:pPr>
+              <a:lnSpc>
+                <a:spcPct val="80000"/>
+              </a:lnSpc>
+              <a:spcBef>
+                <a:spcPts val="600"/>
+              </a:spcBef>
+              <a:defRPr b="0">
+                <a:solidFill>
+                  <a:srgbClr val="000000"/>
+                </a:solidFill>
+              </a:defRPr>
+            </a:pPr>
+            <a:endParaRPr/>
+          </a:p>
+        </p:txBody>
+      </p:sp>
+      <p:pic>
+        <p:nvPicPr>
+          <p:cNvPr id="8" name="Picture 7" descr="A picture containing text&#10;&#10;Description automatically generated">
+            <a:extLst>
+              <a:ext uri="{FF2B5EF4-FFF2-40B4-BE49-F238E27FC236}">
+                <a16:creationId xmlns:a16="http://schemas.microsoft.com/office/drawing/2014/main" id="{B820F464-AE64-53D1-41F0-9489F72A3217}"/>
+              </a:ext>
+            </a:extLst>
+          </p:cNvPr>
+          <p:cNvPicPr>
+            <a:picLocks noChangeAspect="1"/>
+          </p:cNvPicPr>
+          <p:nvPr/>
+        </p:nvPicPr>
+        <p:blipFill>
+          <a:blip r:embed="rId7" cstate="print">
+            <a:extLst>
+              <a:ext uri="{28A0092B-C50C-407E-A947-70E740481C1C}">
+                <a14:useLocalDpi xmlns:a14="http://schemas.microsoft.com/office/drawing/2010/main" val="0"/>
+              </a:ext>
+            </a:extLst>
+          </a:blip>
+          <a:stretch>
+            <a:fillRect/>
+          </a:stretch>
+        </p:blipFill>
+        <p:spPr>
+          <a:xfrm>
+            <a:off x="12214310" y="122459"/>
+            <a:ext cx="1443262" cy="1676046"/>
+          </a:xfrm>
+          <a:prstGeom prst="rect">
+            <a:avLst/>
+          </a:prstGeom>
+        </p:spPr>
+      </p:pic>
+      <p:sp>
+        <p:nvSpPr>
+          <p:cNvPr id="30" name="Line">
+            <a:extLst>
+              <a:ext uri="{FF2B5EF4-FFF2-40B4-BE49-F238E27FC236}">
+                <a16:creationId xmlns:a16="http://schemas.microsoft.com/office/drawing/2014/main" id="{4B715B61-7107-3C4C-F533-4E659BE7B126}"/>
+              </a:ext>
+            </a:extLst>
+          </p:cNvPr>
+          <p:cNvSpPr/>
+          <p:nvPr/>
+        </p:nvSpPr>
+        <p:spPr>
+          <a:xfrm flipV="1">
+            <a:off x="9875518" y="3840480"/>
+            <a:ext cx="4023360" cy="0"/>
+          </a:xfrm>
+          <a:prstGeom prst="line">
+            <a:avLst/>
+          </a:prstGeom>
+          <a:ln w="12700">
+            <a:solidFill>
+              <a:srgbClr val="E4E4E3"/>
+            </a:solidFill>
+            <a:miter lim="400000"/>
+          </a:ln>
+        </p:spPr>
+        <p:txBody>
+          <a:bodyPr lIns="54570" tIns="54570" rIns="54570" bIns="54570" anchor="ctr"/>
+          <a:lstStyle/>
+          <a:p>
+            <a:pPr>
+              <a:lnSpc>
+                <a:spcPct val="80000"/>
+              </a:lnSpc>
+              <a:spcBef>
+                <a:spcPts val="600"/>
+              </a:spcBef>
+              <a:defRPr b="0">
+                <a:solidFill>
+                  <a:srgbClr val="000000"/>
+                </a:solidFill>
+              </a:defRPr>
+            </a:pPr>
+            <a:endParaRPr/>
+          </a:p>
+        </p:txBody>
+      </p:sp>
+      <p:sp>
+        <p:nvSpPr>
+          <p:cNvPr id="34" name="Line">
+            <a:extLst>
+              <a:ext uri="{FF2B5EF4-FFF2-40B4-BE49-F238E27FC236}">
+                <a16:creationId xmlns:a16="http://schemas.microsoft.com/office/drawing/2014/main" id="{4381059C-443F-62AB-6679-41D7ECFF8952}"/>
+              </a:ext>
+            </a:extLst>
+          </p:cNvPr>
+          <p:cNvSpPr/>
+          <p:nvPr/>
+        </p:nvSpPr>
+        <p:spPr>
+          <a:xfrm flipV="1">
+            <a:off x="9875518" y="8595360"/>
+            <a:ext cx="4023360" cy="0"/>
+          </a:xfrm>
+          <a:prstGeom prst="line">
+            <a:avLst/>
+          </a:prstGeom>
+          <a:ln w="12700">
+            <a:solidFill>
+              <a:srgbClr val="E4E4E3"/>
+            </a:solidFill>
+            <a:miter lim="400000"/>
+          </a:ln>
+        </p:spPr>
+        <p:txBody>
+          <a:bodyPr lIns="54570" tIns="54570" rIns="54570" bIns="54570" anchor="ctr"/>
+          <a:lstStyle/>
+          <a:p>
+            <a:pPr>
+              <a:lnSpc>
+                <a:spcPct val="80000"/>
+              </a:lnSpc>
+              <a:spcBef>
+                <a:spcPts val="600"/>
+              </a:spcBef>
+              <a:defRPr b="0">
+                <a:solidFill>
+                  <a:srgbClr val="000000"/>
+                </a:solidFill>
+              </a:defRPr>
+            </a:pPr>
+            <a:endParaRPr/>
+          </a:p>
+        </p:txBody>
+      </p:sp>
+      <p:sp>
+        <p:nvSpPr>
+          <p:cNvPr id="41" name="Line">
+            <a:extLst>
+              <a:ext uri="{FF2B5EF4-FFF2-40B4-BE49-F238E27FC236}">
+                <a16:creationId xmlns:a16="http://schemas.microsoft.com/office/drawing/2014/main" id="{9745F780-A0E0-51EC-01A0-AFADFD19ABEA}"/>
+              </a:ext>
+            </a:extLst>
+          </p:cNvPr>
+          <p:cNvSpPr/>
+          <p:nvPr/>
+        </p:nvSpPr>
+        <p:spPr>
+          <a:xfrm flipV="1">
+            <a:off x="4937760" y="1737360"/>
+            <a:ext cx="3749040" cy="0"/>
+          </a:xfrm>
+          <a:prstGeom prst="line">
+            <a:avLst/>
+          </a:prstGeom>
+          <a:ln w="12700">
+            <a:solidFill>
+              <a:srgbClr val="E4E4E3"/>
+            </a:solidFill>
+            <a:miter lim="400000"/>
+          </a:ln>
+        </p:spPr>
+        <p:txBody>
+          <a:bodyPr lIns="54570" tIns="54570" rIns="54570" bIns="54570" anchor="ctr"/>
+          <a:lstStyle/>
+          <a:p>
+            <a:pPr>
+              <a:lnSpc>
+                <a:spcPct val="80000"/>
+              </a:lnSpc>
+              <a:spcBef>
+                <a:spcPts val="600"/>
+              </a:spcBef>
+              <a:defRPr b="0">
+                <a:solidFill>
+                  <a:srgbClr val="000000"/>
+                </a:solidFill>
+              </a:defRPr>
+            </a:pPr>
+            <a:endParaRPr/>
+          </a:p>
+        </p:txBody>
+      </p:sp>
+      <p:sp>
+        <p:nvSpPr>
+          <p:cNvPr id="6" name="Manipulate Variables">
+            <a:extLst>
+              <a:ext uri="{FF2B5EF4-FFF2-40B4-BE49-F238E27FC236}">
+                <a16:creationId xmlns:a16="http://schemas.microsoft.com/office/drawing/2014/main" id="{3D3F03FD-A18D-898C-CDE9-57546DDF2966}"/>
+              </a:ext>
+            </a:extLst>
+          </p:cNvPr>
+          <p:cNvSpPr txBox="1"/>
+          <p:nvPr/>
+        </p:nvSpPr>
+        <p:spPr>
+          <a:xfrm>
+            <a:off x="9875520" y="1459299"/>
+            <a:ext cx="2644955" cy="340029"/>
+          </a:xfrm>
+          <a:prstGeom prst="rect">
+            <a:avLst/>
+          </a:prstGeom>
+          <a:ln w="12700">
+            <a:miter lim="400000"/>
+          </a:ln>
+          <a:extLst>
+            <a:ext uri="{C572A759-6A51-4108-AA02-DFA0A04FC94B}">
+              <ma14:wrappingTextBoxFlag xmlns:ma14="http://schemas.microsoft.com/office/mac/drawingml/2011/main" xmlns:a14="http://schemas.microsoft.com/office/drawing/2010/main" xmlns:m="http://schemas.openxmlformats.org/officeDocument/2006/math" xmlns="" val="1"/>
+            </a:ext>
+          </a:extLst>
+        </p:spPr>
+        <p:txBody>
+          <a:bodyPr wrap="none" lIns="12700" tIns="12700" rIns="12700" bIns="12700" anchor="ctr">
+            <a:spAutoFit/>
+          </a:bodyPr>
+          <a:lstStyle/>
+          <a:p>
+            <a:pPr lvl="1" indent="0">
+              <a:lnSpc>
+                <a:spcPct val="80000"/>
+              </a:lnSpc>
+              <a:spcBef>
+                <a:spcPts val="0"/>
+              </a:spcBef>
+              <a:defRPr sz="2500" b="0">
+                <a:solidFill>
+                  <a:srgbClr val="628DB5"/>
+                </a:solidFill>
+              </a:defRPr>
+            </a:pPr>
+            <a:r>
+              <a:rPr lang="en-US" dirty="0"/>
+              <a:t>Graph Constructors</a:t>
+            </a:r>
+            <a:endParaRPr dirty="0"/>
+          </a:p>
+        </p:txBody>
+      </p:sp>
+      <p:sp>
+        <p:nvSpPr>
+          <p:cNvPr id="421" name="Manipulate Variables">
+            <a:extLst>
+              <a:ext uri="{FF2B5EF4-FFF2-40B4-BE49-F238E27FC236}">
+                <a16:creationId xmlns:a16="http://schemas.microsoft.com/office/drawing/2014/main" id="{7C336D8E-19AF-48D0-5C2F-6C453E98D41D}"/>
+              </a:ext>
+            </a:extLst>
+          </p:cNvPr>
+          <p:cNvSpPr txBox="1"/>
+          <p:nvPr/>
+        </p:nvSpPr>
+        <p:spPr>
+          <a:xfrm>
+            <a:off x="9875520" y="8321040"/>
+            <a:ext cx="3085781" cy="340029"/>
+          </a:xfrm>
+          <a:prstGeom prst="rect">
+            <a:avLst/>
+          </a:prstGeom>
+          <a:ln w="12700">
+            <a:miter lim="400000"/>
+          </a:ln>
+          <a:extLst>
+            <a:ext uri="{C572A759-6A51-4108-AA02-DFA0A04FC94B}">
+              <ma14:wrappingTextBoxFlag xmlns:ma14="http://schemas.microsoft.com/office/mac/drawingml/2011/main" xmlns:a14="http://schemas.microsoft.com/office/drawing/2010/main" xmlns:m="http://schemas.openxmlformats.org/officeDocument/2006/math" xmlns="" val="1"/>
+            </a:ext>
+          </a:extLst>
+        </p:spPr>
+        <p:txBody>
+          <a:bodyPr wrap="none" lIns="12700" tIns="12700" rIns="12700" bIns="12700" anchor="ctr">
+            <a:spAutoFit/>
+          </a:bodyPr>
+          <a:lstStyle/>
+          <a:p>
+            <a:pPr lvl="1" indent="0">
+              <a:lnSpc>
+                <a:spcPct val="80000"/>
+              </a:lnSpc>
+              <a:spcBef>
+                <a:spcPts val="0"/>
+              </a:spcBef>
+              <a:defRPr sz="2500" b="0">
+                <a:solidFill>
+                  <a:srgbClr val="628DB5"/>
+                </a:solidFill>
+              </a:defRPr>
+            </a:pPr>
+            <a:r>
+              <a:rPr lang="en-US" dirty="0"/>
+              <a:t>Custom Graph Weights</a:t>
+            </a:r>
+            <a:endParaRPr dirty="0"/>
+          </a:p>
+        </p:txBody>
+      </p:sp>
+      <p:sp>
+        <p:nvSpPr>
+          <p:cNvPr id="424" name="Layout Suggestions">
+            <a:extLst>
+              <a:ext uri="{FF2B5EF4-FFF2-40B4-BE49-F238E27FC236}">
+                <a16:creationId xmlns:a16="http://schemas.microsoft.com/office/drawing/2014/main" id="{C740CFCB-250E-91D4-A09E-AFDE2D915000}"/>
+              </a:ext>
+            </a:extLst>
+          </p:cNvPr>
+          <p:cNvSpPr txBox="1"/>
+          <p:nvPr/>
+        </p:nvSpPr>
+        <p:spPr>
+          <a:xfrm>
+            <a:off x="4937760" y="1463040"/>
+            <a:ext cx="3840480" cy="340029"/>
+          </a:xfrm>
+          <a:prstGeom prst="rect">
+            <a:avLst/>
+          </a:prstGeom>
+          <a:ln w="12700">
+            <a:miter lim="400000"/>
+          </a:ln>
+          <a:extLst>
+            <a:ext uri="{C572A759-6A51-4108-AA02-DFA0A04FC94B}">
+              <ma14:wrappingTextBoxFlag xmlns:ma14="http://schemas.microsoft.com/office/mac/drawingml/2011/main" xmlns:a14="http://schemas.microsoft.com/office/drawing/2010/main" xmlns:m="http://schemas.openxmlformats.org/officeDocument/2006/math" xmlns="" val="1"/>
+            </a:ext>
+          </a:extLst>
+        </p:spPr>
+        <p:txBody>
+          <a:bodyPr wrap="square" lIns="12700" tIns="12700" rIns="12700" bIns="12700" anchor="ctr">
+            <a:spAutoFit/>
+          </a:bodyPr>
+          <a:lstStyle/>
+          <a:p>
+            <a:pPr lvl="1" indent="0">
+              <a:lnSpc>
+                <a:spcPct val="80000"/>
+              </a:lnSpc>
+              <a:spcBef>
+                <a:spcPts val="0"/>
+              </a:spcBef>
+              <a:defRPr sz="2500" b="0">
+                <a:solidFill>
+                  <a:srgbClr val="628DB5"/>
+                </a:solidFill>
+              </a:defRPr>
+            </a:pPr>
+            <a:r>
+              <a:rPr lang="en-US" dirty="0"/>
+              <a:t>Network Transform Pipeline</a:t>
+            </a:r>
+            <a:endParaRPr dirty="0"/>
+          </a:p>
+        </p:txBody>
+      </p:sp>
     </p:spTree>
     <p:extLst>
       <p:ext uri="{BB962C8B-B14F-4D97-AF65-F5344CB8AC3E}">
-        <p14:creationId xmlns:p14="http://schemas.microsoft.com/office/powerpoint/2010/main" val="3276859624"/>
+        <p14:creationId xmlns:p14="http://schemas.microsoft.com/office/powerpoint/2010/main" val="2043883487"/>
       </p:ext>
     </p:extLst>
   </p:cSld>

</xml_diff>

<commit_message>
i #22 Update network cheatsheet files
Replace updated network-cheatsheet assets (PDF and PPTX) and their corresponding revision files under cheatsheets/ and revisions/. Binary content updated for both formats.

---------

Signed-off-by: Jared Seto <jaredws@hawaii.edu>
</commit_message>
<xml_diff>
--- a/cheatsheets/network-cheatsheet.pptx
+++ b/cheatsheets/network-cheatsheet.pptx
@@ -8,7 +8,7 @@
     <p:notesMasterId r:id="rId3"/>
   </p:notesMasterIdLst>
   <p:sldIdLst>
-    <p:sldId id="265" r:id="rId2"/>
+    <p:sldId id="266" r:id="rId2"/>
   </p:sldIdLst>
   <p:sldSz cx="13970000" cy="10795000"/>
   <p:notesSz cx="6858000" cy="9144000"/>
@@ -509,7 +509,7 @@
         <p:cNvPr id="1" name="">
           <a:extLst>
             <a:ext uri="{FF2B5EF4-FFF2-40B4-BE49-F238E27FC236}">
-              <a16:creationId xmlns:a16="http://schemas.microsoft.com/office/drawing/2014/main" id="{9B4AD321-A92B-63F8-D75B-F54390243AD2}"/>
+              <a16:creationId xmlns:a16="http://schemas.microsoft.com/office/drawing/2014/main" id="{F5FF41F0-B138-816A-3E29-1FB8CEC4BD62}"/>
             </a:ext>
           </a:extLst>
         </p:cNvPr>
@@ -529,7 +529,7 @@
           <p:cNvPr id="2" name="Slide Image Placeholder 1">
             <a:extLst>
               <a:ext uri="{FF2B5EF4-FFF2-40B4-BE49-F238E27FC236}">
-                <a16:creationId xmlns:a16="http://schemas.microsoft.com/office/drawing/2014/main" id="{F4DE87AF-175F-0586-C6A8-2F44C356C466}"/>
+                <a16:creationId xmlns:a16="http://schemas.microsoft.com/office/drawing/2014/main" id="{9BCE236A-A0F9-4DCE-FD17-9074D667B603}"/>
               </a:ext>
             </a:extLst>
           </p:cNvPr>
@@ -559,7 +559,7 @@
           <p:cNvPr id="3" name="Notes Placeholder 2">
             <a:extLst>
               <a:ext uri="{FF2B5EF4-FFF2-40B4-BE49-F238E27FC236}">
-                <a16:creationId xmlns:a16="http://schemas.microsoft.com/office/drawing/2014/main" id="{24D7ED30-3193-A9F3-96DA-3F4C3A08D68F}"/>
+                <a16:creationId xmlns:a16="http://schemas.microsoft.com/office/drawing/2014/main" id="{5EEFCB9C-6BDF-14C3-313D-C6E3B2BF8CF0}"/>
               </a:ext>
             </a:extLst>
           </p:cNvPr>
@@ -582,7 +582,7 @@
     </p:spTree>
     <p:extLst>
       <p:ext uri="{BB962C8B-B14F-4D97-AF65-F5344CB8AC3E}">
-        <p14:creationId xmlns:p14="http://schemas.microsoft.com/office/powerpoint/2010/main" val="3042171841"/>
+        <p14:creationId xmlns:p14="http://schemas.microsoft.com/office/powerpoint/2010/main" val="1301853710"/>
       </p:ext>
     </p:extLst>
   </p:cSld>
@@ -2046,7 +2046,7 @@
           </a:ln>
           <a:extLst>
             <a:ext uri="{C572A759-6A51-4108-AA02-DFA0A04FC94B}">
-              <ma14:wrappingTextBoxFlag xmlns="" xmlns:m="http://schemas.openxmlformats.org/officeDocument/2006/math" xmlns:a14="http://schemas.microsoft.com/office/drawing/2010/main" xmlns:ma14="http://schemas.microsoft.com/office/mac/drawingml/2011/main" val="1"/>
+              <ma14:wrappingTextBoxFlag xmlns:ma14="http://schemas.microsoft.com/office/mac/drawingml/2011/main" xmlns:a14="http://schemas.microsoft.com/office/drawing/2010/main" xmlns:m="http://schemas.openxmlformats.org/officeDocument/2006/math" xmlns="" val="1"/>
             </a:ext>
           </a:extLst>
         </p:spPr>
@@ -2085,7 +2085,7 @@
           </a:ln>
           <a:extLst>
             <a:ext uri="{C572A759-6A51-4108-AA02-DFA0A04FC94B}">
-              <ma14:wrappingTextBoxFlag xmlns="" xmlns:m="http://schemas.openxmlformats.org/officeDocument/2006/math" xmlns:a14="http://schemas.microsoft.com/office/drawing/2010/main" xmlns:ma14="http://schemas.microsoft.com/office/mac/drawingml/2011/main" val="1"/>
+              <ma14:wrappingTextBoxFlag xmlns:ma14="http://schemas.microsoft.com/office/mac/drawingml/2011/main" xmlns:a14="http://schemas.microsoft.com/office/drawing/2010/main" xmlns:m="http://schemas.openxmlformats.org/officeDocument/2006/math" xmlns="" val="1"/>
             </a:ext>
           </a:extLst>
         </p:spPr>
@@ -2995,7 +2995,7 @@
         <p:cNvPr id="1" name="">
           <a:extLst>
             <a:ext uri="{FF2B5EF4-FFF2-40B4-BE49-F238E27FC236}">
-              <a16:creationId xmlns:a16="http://schemas.microsoft.com/office/drawing/2014/main" id="{C58960BA-5BA0-AF4F-261A-5A97ECE57743}"/>
+              <a16:creationId xmlns:a16="http://schemas.microsoft.com/office/drawing/2014/main" id="{B777AABC-1CA6-F756-F15F-C6815D61A7EC}"/>
             </a:ext>
           </a:extLst>
         </p:cNvPr>
@@ -3015,7 +3015,7 @@
           <p:cNvPr id="56" name="Image" descr="Image">
             <a:extLst>
               <a:ext uri="{FF2B5EF4-FFF2-40B4-BE49-F238E27FC236}">
-                <a16:creationId xmlns:a16="http://schemas.microsoft.com/office/drawing/2014/main" id="{A2F62703-C143-B799-3593-561228B348A1}"/>
+                <a16:creationId xmlns:a16="http://schemas.microsoft.com/office/drawing/2014/main" id="{44FD8155-CA48-DB84-070A-F4E5B0035DBD}"/>
               </a:ext>
             </a:extLst>
           </p:cNvPr>
@@ -3045,10 +3045,174 @@
       </p:pic>
       <p:sp>
         <p:nvSpPr>
-          <p:cNvPr id="447" name="TextBox 446">
+          <p:cNvPr id="312" name="Line">
             <a:extLst>
               <a:ext uri="{FF2B5EF4-FFF2-40B4-BE49-F238E27FC236}">
-                <a16:creationId xmlns:a16="http://schemas.microsoft.com/office/drawing/2014/main" id="{B85EF6AD-A856-EB07-C50B-10E577548EE9}"/>
+                <a16:creationId xmlns:a16="http://schemas.microsoft.com/office/drawing/2014/main" id="{9139428A-444A-8A61-9A29-1EF5CAF3F295}"/>
+              </a:ext>
+            </a:extLst>
+          </p:cNvPr>
+          <p:cNvSpPr/>
+          <p:nvPr/>
+        </p:nvSpPr>
+        <p:spPr>
+          <a:xfrm flipV="1">
+            <a:off x="213255" y="10296246"/>
+            <a:ext cx="13462982" cy="39499"/>
+          </a:xfrm>
+          <a:prstGeom prst="line">
+            <a:avLst/>
+          </a:prstGeom>
+          <a:ln w="12700">
+            <a:solidFill>
+              <a:srgbClr val="E4E4E3"/>
+            </a:solidFill>
+            <a:miter lim="400000"/>
+          </a:ln>
+        </p:spPr>
+        <p:txBody>
+          <a:bodyPr lIns="54570" tIns="54570" rIns="54570" bIns="54570" anchor="ctr"/>
+          <a:lstStyle/>
+          <a:p>
+            <a:pPr>
+              <a:lnSpc>
+                <a:spcPct val="80000"/>
+              </a:lnSpc>
+              <a:spcBef>
+                <a:spcPts val="600"/>
+              </a:spcBef>
+              <a:defRPr b="0">
+                <a:solidFill>
+                  <a:srgbClr val="000000"/>
+                </a:solidFill>
+              </a:defRPr>
+            </a:pPr>
+            <a:endParaRPr dirty="0"/>
+          </a:p>
+        </p:txBody>
+      </p:sp>
+      <p:sp>
+        <p:nvSpPr>
+          <p:cNvPr id="313" name="YOUR LOGO…">
+            <a:extLst>
+              <a:ext uri="{FF2B5EF4-FFF2-40B4-BE49-F238E27FC236}">
+                <a16:creationId xmlns:a16="http://schemas.microsoft.com/office/drawing/2014/main" id="{9597B098-F116-87DB-64F0-6933E830552F}"/>
+              </a:ext>
+            </a:extLst>
+          </p:cNvPr>
+          <p:cNvSpPr/>
+          <p:nvPr/>
+        </p:nvSpPr>
+        <p:spPr>
+          <a:xfrm>
+            <a:off x="170343" y="10207710"/>
+            <a:ext cx="1757945" cy="528270"/>
+          </a:xfrm>
+          <a:prstGeom prst="roundRect">
+            <a:avLst>
+              <a:gd name="adj" fmla="val 36061"/>
+            </a:avLst>
+          </a:prstGeom>
+          <a:solidFill>
+            <a:srgbClr val="FFFFFF"/>
+          </a:solidFill>
+          <a:ln w="12700">
+            <a:miter lim="400000"/>
+          </a:ln>
+          <a:extLst>
+            <a:ext uri="{C572A759-6A51-4108-AA02-DFA0A04FC94B}">
+              <ma14:wrappingTextBoxFlag xmlns:ma14="http://schemas.microsoft.com/office/mac/drawingml/2011/main" xmlns:a14="http://schemas.microsoft.com/office/drawing/2010/main" xmlns:m="http://schemas.openxmlformats.org/officeDocument/2006/math" xmlns="" val="1"/>
+            </a:ext>
+          </a:extLst>
+        </p:spPr>
+        <p:txBody>
+          <a:bodyPr lIns="0" tIns="0" rIns="0" bIns="0" anchor="ctr"/>
+          <a:lstStyle/>
+          <a:p>
+            <a:pPr algn="ctr">
+              <a:lnSpc>
+                <a:spcPct val="90000"/>
+              </a:lnSpc>
+              <a:spcBef>
+                <a:spcPts val="0"/>
+              </a:spcBef>
+              <a:defRPr>
+                <a:solidFill>
+                  <a:srgbClr val="407AAA"/>
+                </a:solidFill>
+                <a:latin typeface="Helvetica Neue"/>
+                <a:ea typeface="Helvetica Neue"/>
+                <a:cs typeface="Helvetica Neue"/>
+                <a:sym typeface="Helvetica Neue"/>
+              </a:defRPr>
+            </a:pPr>
+            <a:r>
+              <a:rPr lang="en-US" sz="2400" dirty="0"/>
+              <a:t>Kaiāulu</a:t>
+            </a:r>
+            <a:endParaRPr sz="2400" dirty="0"/>
+          </a:p>
+        </p:txBody>
+      </p:sp>
+      <p:sp>
+        <p:nvSpPr>
+          <p:cNvPr id="334" name="Three Column Layout: : CHEAT SHEET">
+            <a:extLst>
+              <a:ext uri="{FF2B5EF4-FFF2-40B4-BE49-F238E27FC236}">
+                <a16:creationId xmlns:a16="http://schemas.microsoft.com/office/drawing/2014/main" id="{9C5A2451-9FE8-0D78-13C6-81C9849DFD82}"/>
+              </a:ext>
+            </a:extLst>
+          </p:cNvPr>
+          <p:cNvSpPr txBox="1">
+            <a:spLocks noGrp="1"/>
+          </p:cNvSpPr>
+          <p:nvPr>
+            <p:ph type="title"/>
+          </p:nvPr>
+        </p:nvSpPr>
+        <p:spPr>
+          <a:xfrm>
+            <a:off x="275721" y="361177"/>
+            <a:ext cx="10898129" cy="803346"/>
+          </a:xfrm>
+          <a:prstGeom prst="rect">
+            <a:avLst/>
+          </a:prstGeom>
+        </p:spPr>
+        <p:txBody>
+          <a:bodyPr lIns="0" tIns="0" rIns="0" bIns="0" anchor="t"/>
+          <a:lstStyle/>
+          <a:p>
+            <a:r>
+              <a:rPr lang="en-US" dirty="0"/>
+              <a:t>Network Transform</a:t>
+            </a:r>
+            <a:r>
+              <a:rPr dirty="0"/>
+              <a:t>: : </a:t>
+            </a:r>
+            <a:r>
+              <a:rPr sz="3300" dirty="0">
+                <a:latin typeface="Source Sans Pro Semibold"/>
+                <a:ea typeface="Source Sans Pro Semibold"/>
+                <a:cs typeface="Source Sans Pro Semibold"/>
+                <a:sym typeface="Source Sans Pro Semibold"/>
+              </a:rPr>
+              <a:t>CHEAT SHEET</a:t>
+            </a:r>
+            <a:r>
+              <a:rPr dirty="0"/>
+              <a:t> </a:t>
+            </a:r>
+          </a:p>
+        </p:txBody>
+      </p:sp>
+      <p:sp>
+        <p:nvSpPr>
+          <p:cNvPr id="5" name="TextBox 4">
+            <a:extLst>
+              <a:ext uri="{FF2B5EF4-FFF2-40B4-BE49-F238E27FC236}">
+                <a16:creationId xmlns:a16="http://schemas.microsoft.com/office/drawing/2014/main" id="{2DD95D91-329A-A360-AAFD-0D31969F9E1D}"/>
               </a:ext>
             </a:extLst>
           </p:cNvPr>
@@ -3057,8 +3221,8 @@
         </p:nvSpPr>
         <p:spPr>
           <a:xfrm>
-            <a:off x="3840480" y="2004091"/>
-            <a:ext cx="670876" cy="289742"/>
+            <a:off x="7737264" y="10327008"/>
+            <a:ext cx="6091194" cy="500056"/>
           </a:xfrm>
           <a:prstGeom prst="rect">
             <a:avLst/>
@@ -3089,7 +3253,7 @@
           </a:bodyPr>
           <a:lstStyle/>
           <a:p>
-            <a:pPr marL="0" marR="0" indent="0" algn="ctr" defTabSz="584200" rtl="0" fontAlgn="auto" latinLnBrk="0" hangingPunct="0">
+            <a:pPr marL="0" marR="0" indent="0" algn="l" defTabSz="584200" rtl="0" fontAlgn="auto" latinLnBrk="0" hangingPunct="0">
               <a:lnSpc>
                 <a:spcPct val="100000"/>
               </a:lnSpc>
@@ -3106,69 +3270,82 @@
               <a:tabLst/>
             </a:pPr>
             <a:r>
+              <a:rPr lang="en-US" sz="1000" b="0" dirty="0">
+                <a:solidFill>
+                  <a:schemeClr val="tx1"/>
+                </a:solidFill>
+                <a:hlinkClick r:id="rId4">
+                  <a:extLst>
+                    <a:ext uri="{A12FA001-AC4F-418D-AE19-62706E023703}">
+                      <ahyp:hlinkClr xmlns:ahyp="http://schemas.microsoft.com/office/drawing/2018/hyperlinkcolor" val="tx"/>
+                    </a:ext>
+                  </a:extLst>
+                </a:hlinkClick>
+              </a:rPr>
+              <a:t>CC BY SA</a:t>
+            </a:r>
+            <a:r>
+              <a:rPr lang="en-US" sz="1000" b="0" dirty="0">
+                <a:solidFill>
+                  <a:schemeClr val="tx1"/>
+                </a:solidFill>
+              </a:rPr>
+              <a:t> Jared Seto</a:t>
+            </a:r>
+            <a:r>
               <a:rPr kumimoji="0" lang="en-US" sz="1000" b="0" i="0" u="none" strike="noStrike" cap="none" spc="0" normalizeH="0" baseline="0" dirty="0">
                 <a:ln>
                   <a:noFill/>
                 </a:ln>
                 <a:solidFill>
-                  <a:srgbClr val="4C4C4C"/>
+                  <a:schemeClr val="tx1"/>
                 </a:solidFill>
                 <a:effectLst/>
                 <a:uFillTx/>
+                <a:latin typeface="Source Sans Pro"/>
+                <a:ea typeface="Source Sans Pro"/>
+                <a:cs typeface="Source Sans Pro"/>
                 <a:sym typeface="Source Sans Pro"/>
               </a:rPr>
-              <a:t>Raw Data</a:t>
+              <a:t>, Carlos Paradis • Kai</a:t>
+            </a:r>
+            <a:r>
+              <a:rPr kumimoji="0" lang="haw-US" sz="1000" b="0" i="0" u="none" strike="noStrike" cap="none" spc="0" normalizeH="0" baseline="0">
+                <a:ln>
+                  <a:noFill/>
+                </a:ln>
+                <a:solidFill>
+                  <a:schemeClr val="tx1"/>
+                </a:solidFill>
+                <a:effectLst/>
+                <a:uFillTx/>
+                <a:latin typeface="Source Sans Pro"/>
+                <a:ea typeface="Source Sans Pro"/>
+                <a:cs typeface="Source Sans Pro"/>
+                <a:sym typeface="Source Sans Pro"/>
+              </a:rPr>
+              <a:t>ā</a:t>
+            </a:r>
+            <a:r>
+              <a:rPr kumimoji="0" lang="en-US" sz="1000" b="0" i="0" u="none" strike="noStrike" cap="none" spc="0" normalizeH="0" baseline="0" dirty="0">
+                <a:ln>
+                  <a:noFill/>
+                </a:ln>
+                <a:solidFill>
+                  <a:schemeClr val="tx1"/>
+                </a:solidFill>
+                <a:effectLst/>
+                <a:uFillTx/>
+                <a:latin typeface="Source Sans Pro"/>
+                <a:ea typeface="Source Sans Pro"/>
+                <a:cs typeface="Source Sans Pro"/>
+                <a:sym typeface="Source Sans Pro"/>
+              </a:rPr>
+              <a:t>ulu package version 0.0.0.9700 (in development) •  Updated: 2026-04</a:t>
             </a:r>
           </a:p>
-        </p:txBody>
-      </p:sp>
-      <p:sp>
-        <p:nvSpPr>
-          <p:cNvPr id="512" name="TextBox 511">
-            <a:extLst>
-              <a:ext uri="{FF2B5EF4-FFF2-40B4-BE49-F238E27FC236}">
-                <a16:creationId xmlns:a16="http://schemas.microsoft.com/office/drawing/2014/main" id="{F128F195-DB72-50E7-1E97-A9B539A937B2}"/>
-              </a:ext>
-            </a:extLst>
-          </p:cNvPr>
-          <p:cNvSpPr txBox="1"/>
-          <p:nvPr/>
-        </p:nvSpPr>
-        <p:spPr>
-          <a:xfrm>
-            <a:off x="3840480" y="2877765"/>
-            <a:ext cx="670876" cy="443630"/>
-          </a:xfrm>
-          <a:prstGeom prst="rect">
-            <a:avLst/>
-          </a:prstGeom>
-          <a:noFill/>
-          <a:ln w="12700" cap="flat">
-            <a:noFill/>
-            <a:miter lim="400000"/>
-          </a:ln>
-          <a:effectLst/>
-          <a:sp3d/>
-        </p:spPr>
-        <p:style>
-          <a:lnRef idx="0">
-            <a:scrgbClr r="0" g="0" b="0"/>
-          </a:lnRef>
-          <a:fillRef idx="0">
-            <a:scrgbClr r="0" g="0" b="0"/>
-          </a:fillRef>
-          <a:effectRef idx="0">
-            <a:scrgbClr r="0" g="0" b="0"/>
-          </a:effectRef>
-          <a:fontRef idx="none"/>
-        </p:style>
-        <p:txBody>
-          <a:bodyPr rot="0" spcFirstLastPara="1" vertOverflow="overflow" horzOverflow="overflow" vert="horz" wrap="square" lIns="54570" tIns="54570" rIns="54570" bIns="54570" numCol="1" spcCol="38100" rtlCol="0" anchor="ctr">
-            <a:spAutoFit/>
-          </a:bodyPr>
-          <a:lstStyle/>
           <a:p>
-            <a:pPr marL="0" marR="0" indent="0" algn="ctr" defTabSz="584200" rtl="0" fontAlgn="auto" latinLnBrk="0" hangingPunct="0">
+            <a:pPr marL="0" marR="0" indent="0" algn="l" defTabSz="584200" rtl="0" fontAlgn="auto" latinLnBrk="0" hangingPunct="0">
               <a:lnSpc>
                 <a:spcPct val="100000"/>
               </a:lnSpc>
@@ -3184,11 +3361,7 @@
               <a:buNone/>
               <a:tabLst/>
             </a:pPr>
-            <a:r>
-              <a:rPr lang="en-US" sz="1000" b="0" dirty="0"/>
-              <a:t>Tabular Data</a:t>
-            </a:r>
-            <a:endParaRPr kumimoji="0" lang="en-US" sz="1000" b="0" i="0" u="none" strike="noStrike" cap="none" spc="0" normalizeH="0" baseline="0" dirty="0">
+            <a:endParaRPr kumimoji="0" lang="en-US" sz="1200" b="1" i="0" u="none" strike="noStrike" cap="none" spc="0" normalizeH="0" baseline="0" dirty="0">
               <a:ln>
                 <a:noFill/>
               </a:ln>
@@ -3197,17 +3370,56 @@
               </a:solidFill>
               <a:effectLst/>
               <a:uFillTx/>
+              <a:latin typeface="Source Sans Pro"/>
+              <a:ea typeface="Source Sans Pro"/>
+              <a:cs typeface="Source Sans Pro"/>
               <a:sym typeface="Source Sans Pro"/>
             </a:endParaRPr>
           </a:p>
         </p:txBody>
       </p:sp>
+      <p:pic>
+        <p:nvPicPr>
+          <p:cNvPr id="8" name="Picture 7" descr="A picture containing text&#10;&#10;Description automatically generated">
+            <a:extLst>
+              <a:ext uri="{FF2B5EF4-FFF2-40B4-BE49-F238E27FC236}">
+                <a16:creationId xmlns:a16="http://schemas.microsoft.com/office/drawing/2014/main" id="{13AB636D-DB27-0AD7-D18D-BEC1F7FADD81}"/>
+              </a:ext>
+            </a:extLst>
+          </p:cNvPr>
+          <p:cNvPicPr>
+            <a:picLocks noChangeAspect="1"/>
+          </p:cNvPicPr>
+          <p:nvPr/>
+        </p:nvPicPr>
+        <p:blipFill>
+          <a:blip r:embed="rId5" cstate="print">
+            <a:extLst>
+              <a:ext uri="{28A0092B-C50C-407E-A947-70E740481C1C}">
+                <a14:useLocalDpi xmlns:a14="http://schemas.microsoft.com/office/drawing/2010/main" val="0"/>
+              </a:ext>
+            </a:extLst>
+          </a:blip>
+          <a:stretch>
+            <a:fillRect/>
+          </a:stretch>
+        </p:blipFill>
+        <p:spPr>
+          <a:xfrm>
+            <a:off x="12214310" y="122459"/>
+            <a:ext cx="1443262" cy="1676046"/>
+          </a:xfrm>
+          <a:prstGeom prst="rect">
+            <a:avLst/>
+          </a:prstGeom>
+        </p:spPr>
+      </p:pic>
       <p:sp>
         <p:nvSpPr>
-          <p:cNvPr id="515" name="TextBox 514">
+          <p:cNvPr id="7" name="TextBox 6">
             <a:extLst>
               <a:ext uri="{FF2B5EF4-FFF2-40B4-BE49-F238E27FC236}">
-                <a16:creationId xmlns:a16="http://schemas.microsoft.com/office/drawing/2014/main" id="{DF28AAD1-1D33-61B2-98AB-CC61CB9CFEC6}"/>
+                <a16:creationId xmlns:a16="http://schemas.microsoft.com/office/drawing/2014/main" id="{27936A67-4B2F-BD65-2C27-C205BF259C7B}"/>
               </a:ext>
             </a:extLst>
           </p:cNvPr>
@@ -3216,166 +3428,8 @@
         </p:nvSpPr>
         <p:spPr>
           <a:xfrm>
-            <a:off x="3840480" y="6652009"/>
-            <a:ext cx="670876" cy="443630"/>
-          </a:xfrm>
-          <a:prstGeom prst="rect">
-            <a:avLst/>
-          </a:prstGeom>
-          <a:noFill/>
-          <a:ln w="12700" cap="flat">
-            <a:noFill/>
-            <a:miter lim="400000"/>
-          </a:ln>
-          <a:effectLst/>
-          <a:sp3d/>
-        </p:spPr>
-        <p:style>
-          <a:lnRef idx="0">
-            <a:scrgbClr r="0" g="0" b="0"/>
-          </a:lnRef>
-          <a:fillRef idx="0">
-            <a:scrgbClr r="0" g="0" b="0"/>
-          </a:fillRef>
-          <a:effectRef idx="0">
-            <a:scrgbClr r="0" g="0" b="0"/>
-          </a:effectRef>
-          <a:fontRef idx="none"/>
-        </p:style>
-        <p:txBody>
-          <a:bodyPr rot="0" spcFirstLastPara="1" vertOverflow="overflow" horzOverflow="overflow" vert="horz" wrap="square" lIns="54570" tIns="54570" rIns="54570" bIns="54570" numCol="1" spcCol="38100" rtlCol="0" anchor="ctr">
-            <a:spAutoFit/>
-          </a:bodyPr>
-          <a:lstStyle/>
-          <a:p>
-            <a:pPr marL="0" marR="0" indent="0" algn="ctr" defTabSz="584200" rtl="0" fontAlgn="auto" latinLnBrk="0" hangingPunct="0">
-              <a:lnSpc>
-                <a:spcPct val="100000"/>
-              </a:lnSpc>
-              <a:spcBef>
-                <a:spcPts val="200"/>
-              </a:spcBef>
-              <a:spcAft>
-                <a:spcPts val="0"/>
-              </a:spcAft>
-              <a:buClrTx/>
-              <a:buSzTx/>
-              <a:buFontTx/>
-              <a:buNone/>
-              <a:tabLst/>
-            </a:pPr>
-            <a:r>
-              <a:rPr kumimoji="0" lang="en-US" sz="1000" b="0" i="0" u="none" strike="noStrike" cap="none" spc="0" normalizeH="0" baseline="0" dirty="0">
-                <a:ln>
-                  <a:noFill/>
-                </a:ln>
-                <a:solidFill>
-                  <a:srgbClr val="4C4C4C"/>
-                </a:solidFill>
-                <a:effectLst/>
-                <a:uFillTx/>
-                <a:sym typeface="Source Sans Pro"/>
-              </a:rPr>
-              <a:t>S3 Graph API</a:t>
-            </a:r>
-          </a:p>
-        </p:txBody>
-      </p:sp>
-      <p:sp>
-        <p:nvSpPr>
-          <p:cNvPr id="516" name="TextBox 515">
-            <a:extLst>
-              <a:ext uri="{FF2B5EF4-FFF2-40B4-BE49-F238E27FC236}">
-                <a16:creationId xmlns:a16="http://schemas.microsoft.com/office/drawing/2014/main" id="{42DA7EF8-AC4E-C6CB-9343-C30F15BCE25E}"/>
-              </a:ext>
-            </a:extLst>
-          </p:cNvPr>
-          <p:cNvSpPr txBox="1"/>
-          <p:nvPr/>
-        </p:nvSpPr>
-        <p:spPr>
-          <a:xfrm>
-            <a:off x="3840480" y="8209269"/>
-            <a:ext cx="670876" cy="443630"/>
-          </a:xfrm>
-          <a:prstGeom prst="rect">
-            <a:avLst/>
-          </a:prstGeom>
-          <a:noFill/>
-          <a:ln w="12700" cap="flat">
-            <a:noFill/>
-            <a:miter lim="400000"/>
-          </a:ln>
-          <a:effectLst/>
-          <a:sp3d/>
-        </p:spPr>
-        <p:style>
-          <a:lnRef idx="0">
-            <a:scrgbClr r="0" g="0" b="0"/>
-          </a:lnRef>
-          <a:fillRef idx="0">
-            <a:scrgbClr r="0" g="0" b="0"/>
-          </a:fillRef>
-          <a:effectRef idx="0">
-            <a:scrgbClr r="0" g="0" b="0"/>
-          </a:effectRef>
-          <a:fontRef idx="none"/>
-        </p:style>
-        <p:txBody>
-          <a:bodyPr rot="0" spcFirstLastPara="1" vertOverflow="overflow" horzOverflow="overflow" vert="horz" wrap="square" lIns="54570" tIns="54570" rIns="54570" bIns="54570" numCol="1" spcCol="38100" rtlCol="0" anchor="ctr">
-            <a:spAutoFit/>
-          </a:bodyPr>
-          <a:lstStyle/>
-          <a:p>
-            <a:pPr marL="0" marR="0" indent="0" algn="ctr" defTabSz="584200" rtl="0" fontAlgn="auto" latinLnBrk="0" hangingPunct="0">
-              <a:lnSpc>
-                <a:spcPct val="100000"/>
-              </a:lnSpc>
-              <a:spcBef>
-                <a:spcPts val="200"/>
-              </a:spcBef>
-              <a:spcAft>
-                <a:spcPts val="0"/>
-              </a:spcAft>
-              <a:buClrTx/>
-              <a:buSzTx/>
-              <a:buFontTx/>
-              <a:buNone/>
-              <a:tabLst/>
-            </a:pPr>
-            <a:r>
-              <a:rPr kumimoji="0" lang="en-US" sz="1000" b="0" i="0" u="none" strike="noStrike" cap="none" spc="0" normalizeH="0" baseline="0" dirty="0">
-                <a:ln>
-                  <a:noFill/>
-                </a:ln>
-                <a:solidFill>
-                  <a:srgbClr val="4C4C4C"/>
-                </a:solidFill>
-                <a:effectLst/>
-                <a:uFillTx/>
-                <a:sym typeface="Source Sans Pro"/>
-              </a:rPr>
-              <a:t>Graph Export</a:t>
-            </a:r>
-          </a:p>
-        </p:txBody>
-      </p:sp>
-      <p:sp>
-        <p:nvSpPr>
-          <p:cNvPr id="7" name="TextBox 6">
-            <a:extLst>
-              <a:ext uri="{FF2B5EF4-FFF2-40B4-BE49-F238E27FC236}">
-                <a16:creationId xmlns:a16="http://schemas.microsoft.com/office/drawing/2014/main" id="{520C60E1-2663-3EC5-15DF-CEBC07458A14}"/>
-              </a:ext>
-            </a:extLst>
-          </p:cNvPr>
-          <p:cNvSpPr txBox="1"/>
-          <p:nvPr/>
-        </p:nvSpPr>
-        <p:spPr>
-          <a:xfrm>
-            <a:off x="9875520" y="3840480"/>
-            <a:ext cx="4177348" cy="4023360"/>
+            <a:off x="9875520" y="4206240"/>
+            <a:ext cx="4177348" cy="4021610"/>
           </a:xfrm>
           <a:prstGeom prst="rect">
             <a:avLst/>
@@ -3526,10 +3580,10 @@
       </p:sp>
       <p:sp>
         <p:nvSpPr>
-          <p:cNvPr id="514" name="TextBox 513">
+          <p:cNvPr id="384" name="Layout Suggestions">
             <a:extLst>
               <a:ext uri="{FF2B5EF4-FFF2-40B4-BE49-F238E27FC236}">
-                <a16:creationId xmlns:a16="http://schemas.microsoft.com/office/drawing/2014/main" id="{E05E5074-A8A1-1C0F-7CBB-E71862B7B6B9}"/>
+                <a16:creationId xmlns:a16="http://schemas.microsoft.com/office/drawing/2014/main" id="{A788822F-EA6D-E420-8835-EF00A1B9C79F}"/>
               </a:ext>
             </a:extLst>
           </p:cNvPr>
@@ -3538,251 +3592,8 @@
         </p:nvSpPr>
         <p:spPr>
           <a:xfrm>
-            <a:off x="3840480" y="5027556"/>
-            <a:ext cx="670876" cy="443630"/>
-          </a:xfrm>
-          <a:prstGeom prst="rect">
-            <a:avLst/>
-          </a:prstGeom>
-          <a:noFill/>
-          <a:ln w="12700" cap="flat">
-            <a:noFill/>
-            <a:miter lim="400000"/>
-          </a:ln>
-          <a:effectLst/>
-          <a:sp3d/>
-        </p:spPr>
-        <p:style>
-          <a:lnRef idx="0">
-            <a:scrgbClr r="0" g="0" b="0"/>
-          </a:lnRef>
-          <a:fillRef idx="0">
-            <a:scrgbClr r="0" g="0" b="0"/>
-          </a:fillRef>
-          <a:effectRef idx="0">
-            <a:scrgbClr r="0" g="0" b="0"/>
-          </a:effectRef>
-          <a:fontRef idx="none"/>
-        </p:style>
-        <p:txBody>
-          <a:bodyPr rot="0" spcFirstLastPara="1" vertOverflow="overflow" horzOverflow="overflow" vert="horz" wrap="square" lIns="54570" tIns="54570" rIns="54570" bIns="54570" numCol="1" spcCol="38100" rtlCol="0" anchor="ctr">
-            <a:spAutoFit/>
-          </a:bodyPr>
-          <a:lstStyle/>
-          <a:p>
-            <a:pPr marL="0" marR="0" indent="0" algn="ctr" defTabSz="584200" rtl="0" fontAlgn="auto" latinLnBrk="0" hangingPunct="0">
-              <a:lnSpc>
-                <a:spcPct val="100000"/>
-              </a:lnSpc>
-              <a:spcBef>
-                <a:spcPts val="200"/>
-              </a:spcBef>
-              <a:spcAft>
-                <a:spcPts val="0"/>
-              </a:spcAft>
-              <a:buClrTx/>
-              <a:buSzTx/>
-              <a:buFontTx/>
-              <a:buNone/>
-              <a:tabLst/>
-            </a:pPr>
-            <a:r>
-              <a:rPr kumimoji="0" lang="en-US" sz="1000" b="0" i="0" u="none" strike="noStrike" cap="none" spc="0" normalizeH="0" baseline="0" dirty="0">
-                <a:ln>
-                  <a:noFill/>
-                </a:ln>
-                <a:solidFill>
-                  <a:srgbClr val="4C4C4C"/>
-                </a:solidFill>
-                <a:effectLst/>
-                <a:uFillTx/>
-                <a:sym typeface="Source Sans Pro"/>
-              </a:rPr>
-              <a:t>S3 Graph Class</a:t>
-            </a:r>
-          </a:p>
-        </p:txBody>
-      </p:sp>
-      <p:sp>
-        <p:nvSpPr>
-          <p:cNvPr id="312" name="Line">
-            <a:extLst>
-              <a:ext uri="{FF2B5EF4-FFF2-40B4-BE49-F238E27FC236}">
-                <a16:creationId xmlns:a16="http://schemas.microsoft.com/office/drawing/2014/main" id="{29E76B25-1FD2-46A2-2E78-AD9205E6C94B}"/>
-              </a:ext>
-            </a:extLst>
-          </p:cNvPr>
-          <p:cNvSpPr/>
-          <p:nvPr/>
-        </p:nvSpPr>
-        <p:spPr>
-          <a:xfrm flipV="1">
-            <a:off x="213255" y="10296246"/>
-            <a:ext cx="13462982" cy="39499"/>
-          </a:xfrm>
-          <a:prstGeom prst="line">
-            <a:avLst/>
-          </a:prstGeom>
-          <a:ln w="12700">
-            <a:solidFill>
-              <a:srgbClr val="E4E4E3"/>
-            </a:solidFill>
-            <a:miter lim="400000"/>
-          </a:ln>
-        </p:spPr>
-        <p:txBody>
-          <a:bodyPr lIns="54570" tIns="54570" rIns="54570" bIns="54570" anchor="ctr"/>
-          <a:lstStyle/>
-          <a:p>
-            <a:pPr>
-              <a:lnSpc>
-                <a:spcPct val="80000"/>
-              </a:lnSpc>
-              <a:spcBef>
-                <a:spcPts val="600"/>
-              </a:spcBef>
-              <a:defRPr b="0">
-                <a:solidFill>
-                  <a:srgbClr val="000000"/>
-                </a:solidFill>
-              </a:defRPr>
-            </a:pPr>
-            <a:endParaRPr dirty="0"/>
-          </a:p>
-        </p:txBody>
-      </p:sp>
-      <p:sp>
-        <p:nvSpPr>
-          <p:cNvPr id="313" name="YOUR LOGO…">
-            <a:extLst>
-              <a:ext uri="{FF2B5EF4-FFF2-40B4-BE49-F238E27FC236}">
-                <a16:creationId xmlns:a16="http://schemas.microsoft.com/office/drawing/2014/main" id="{5F5ED31A-0A1B-78DE-C2E1-F3E81941C44F}"/>
-              </a:ext>
-            </a:extLst>
-          </p:cNvPr>
-          <p:cNvSpPr/>
-          <p:nvPr/>
-        </p:nvSpPr>
-        <p:spPr>
-          <a:xfrm>
-            <a:off x="170343" y="10207710"/>
-            <a:ext cx="1757945" cy="528270"/>
-          </a:xfrm>
-          <a:prstGeom prst="roundRect">
-            <a:avLst>
-              <a:gd name="adj" fmla="val 36061"/>
-            </a:avLst>
-          </a:prstGeom>
-          <a:solidFill>
-            <a:srgbClr val="FFFFFF"/>
-          </a:solidFill>
-          <a:ln w="12700">
-            <a:miter lim="400000"/>
-          </a:ln>
-          <a:extLst>
-            <a:ext uri="{C572A759-6A51-4108-AA02-DFA0A04FC94B}">
-              <ma14:wrappingTextBoxFlag xmlns:ma14="http://schemas.microsoft.com/office/mac/drawingml/2011/main" xmlns:a14="http://schemas.microsoft.com/office/drawing/2010/main" xmlns:m="http://schemas.openxmlformats.org/officeDocument/2006/math" xmlns="" val="1"/>
-            </a:ext>
-          </a:extLst>
-        </p:spPr>
-        <p:txBody>
-          <a:bodyPr lIns="0" tIns="0" rIns="0" bIns="0" anchor="ctr"/>
-          <a:lstStyle/>
-          <a:p>
-            <a:pPr algn="ctr">
-              <a:lnSpc>
-                <a:spcPct val="90000"/>
-              </a:lnSpc>
-              <a:spcBef>
-                <a:spcPts val="0"/>
-              </a:spcBef>
-              <a:defRPr>
-                <a:solidFill>
-                  <a:srgbClr val="407AAA"/>
-                </a:solidFill>
-                <a:latin typeface="Helvetica Neue"/>
-                <a:ea typeface="Helvetica Neue"/>
-                <a:cs typeface="Helvetica Neue"/>
-                <a:sym typeface="Helvetica Neue"/>
-              </a:defRPr>
-            </a:pPr>
-            <a:r>
-              <a:rPr lang="en-US" sz="2400" dirty="0"/>
-              <a:t>Kaiāulu</a:t>
-            </a:r>
-            <a:endParaRPr sz="2400" dirty="0"/>
-          </a:p>
-        </p:txBody>
-      </p:sp>
-      <p:sp>
-        <p:nvSpPr>
-          <p:cNvPr id="334" name="Three Column Layout: : CHEAT SHEET">
-            <a:extLst>
-              <a:ext uri="{FF2B5EF4-FFF2-40B4-BE49-F238E27FC236}">
-                <a16:creationId xmlns:a16="http://schemas.microsoft.com/office/drawing/2014/main" id="{B35D9F55-410C-702E-BD81-4E2418BA40C1}"/>
-              </a:ext>
-            </a:extLst>
-          </p:cNvPr>
-          <p:cNvSpPr txBox="1">
-            <a:spLocks noGrp="1"/>
-          </p:cNvSpPr>
-          <p:nvPr>
-            <p:ph type="title"/>
-          </p:nvPr>
-        </p:nvSpPr>
-        <p:spPr>
-          <a:xfrm>
-            <a:off x="275721" y="361177"/>
-            <a:ext cx="10898129" cy="803346"/>
-          </a:xfrm>
-          <a:prstGeom prst="rect">
-            <a:avLst/>
-          </a:prstGeom>
-        </p:spPr>
-        <p:txBody>
-          <a:bodyPr lIns="0" tIns="0" rIns="0" bIns="0" anchor="t"/>
-          <a:lstStyle/>
-          <a:p>
-            <a:r>
-              <a:rPr lang="en-US" dirty="0"/>
-              <a:t>Network Transform</a:t>
-            </a:r>
-            <a:r>
-              <a:rPr dirty="0"/>
-              <a:t>: : </a:t>
-            </a:r>
-            <a:r>
-              <a:rPr sz="3300" dirty="0">
-                <a:latin typeface="Source Sans Pro Semibold"/>
-                <a:ea typeface="Source Sans Pro Semibold"/>
-                <a:cs typeface="Source Sans Pro Semibold"/>
-                <a:sym typeface="Source Sans Pro Semibold"/>
-              </a:rPr>
-              <a:t>CHEAT SHEET</a:t>
-            </a:r>
-            <a:r>
-              <a:rPr dirty="0"/>
-              <a:t> </a:t>
-            </a:r>
-          </a:p>
-        </p:txBody>
-      </p:sp>
-      <p:sp>
-        <p:nvSpPr>
-          <p:cNvPr id="384" name="Layout Suggestions">
-            <a:extLst>
-              <a:ext uri="{FF2B5EF4-FFF2-40B4-BE49-F238E27FC236}">
-                <a16:creationId xmlns:a16="http://schemas.microsoft.com/office/drawing/2014/main" id="{82EB782C-FFC7-044E-17F9-5B570C801F40}"/>
-              </a:ext>
-            </a:extLst>
-          </p:cNvPr>
-          <p:cNvSpPr txBox="1"/>
-          <p:nvPr/>
-        </p:nvSpPr>
-        <p:spPr>
-          <a:xfrm>
-            <a:off x="275721" y="1459299"/>
-            <a:ext cx="1349729" cy="340029"/>
+            <a:off x="275721" y="1645920"/>
+            <a:ext cx="1349729" cy="339881"/>
           </a:xfrm>
           <a:prstGeom prst="rect">
             <a:avLst/>
@@ -3828,7 +3639,7 @@
           <p:cNvPr id="501" name="TextBox 500">
             <a:extLst>
               <a:ext uri="{FF2B5EF4-FFF2-40B4-BE49-F238E27FC236}">
-                <a16:creationId xmlns:a16="http://schemas.microsoft.com/office/drawing/2014/main" id="{E7B7BA2C-7409-C813-C0EE-091C39123808}"/>
+                <a16:creationId xmlns:a16="http://schemas.microsoft.com/office/drawing/2014/main" id="{8FFC82D0-F3A0-4500-1011-116E30FAAE79}"/>
               </a:ext>
             </a:extLst>
           </p:cNvPr>
@@ -3837,8 +3648,8 @@
         </p:nvSpPr>
         <p:spPr>
           <a:xfrm>
-            <a:off x="274319" y="1737360"/>
-            <a:ext cx="3284761" cy="1645920"/>
+            <a:off x="274319" y="2103120"/>
+            <a:ext cx="3284761" cy="1280160"/>
           </a:xfrm>
           <a:prstGeom prst="rect">
             <a:avLst/>
@@ -3863,12 +3674,8 @@
           <a:lstStyle/>
           <a:p>
             <a:r>
-              <a:rPr lang="en-US" b="0" dirty="0" err="1"/>
-              <a:t>Kaiaulu’s</a:t>
-            </a:r>
-            <a:r>
               <a:rPr lang="en-US" b="0" dirty="0"/>
-              <a:t> graph module unifies a variety of data sources (e.g. git logs, mailing lists) in a consistent object-oriented structure using S3 (R's object-oriented system). This abstraction allows future graph functions to be de-coupled from the data source. Graph functions will also apply the correct transformations depending on the graph object being passed as parameter (similarly to a print() function).</a:t>
+              <a:t>Kaiaulu's graph module unifies data sources such as git logs and mailing lists into a consistent structure using R's S3 object-oriented system. This decouples graph functions from their data source, allowing each function to apply the correct transformation based on the graph object it receives, like how a `print()` function behaves.</a:t>
             </a:r>
             <a:endParaRPr kumimoji="0" lang="en-US" b="0" i="0" u="none" strike="noStrike" cap="none" spc="0" normalizeH="0" dirty="0">
               <a:ln>
@@ -3888,7 +3695,7 @@
           <p:cNvPr id="510" name="Elbow Connector 509">
             <a:extLst>
               <a:ext uri="{FF2B5EF4-FFF2-40B4-BE49-F238E27FC236}">
-                <a16:creationId xmlns:a16="http://schemas.microsoft.com/office/drawing/2014/main" id="{D4779BEB-0A33-DF0D-B3B7-D969C5569994}"/>
+                <a16:creationId xmlns:a16="http://schemas.microsoft.com/office/drawing/2014/main" id="{D317DF20-5556-6FF1-265D-E8BBEA2BBD72}"/>
               </a:ext>
             </a:extLst>
           </p:cNvPr>
@@ -3900,8 +3707,8 @@
         </p:nvCxnSpPr>
         <p:spPr>
           <a:xfrm flipV="1">
-            <a:off x="8102322" y="1629314"/>
-            <a:ext cx="1773198" cy="3659017"/>
+            <a:off x="8102322" y="1815861"/>
+            <a:ext cx="1773198" cy="3657425"/>
           </a:xfrm>
           <a:prstGeom prst="bentConnector3">
             <a:avLst>
@@ -3937,7 +3744,7 @@
           <p:cNvPr id="323" name="Elbow Connector 322">
             <a:extLst>
               <a:ext uri="{FF2B5EF4-FFF2-40B4-BE49-F238E27FC236}">
-                <a16:creationId xmlns:a16="http://schemas.microsoft.com/office/drawing/2014/main" id="{E5E1ED9C-D5E0-233C-6D96-CF00209C1B79}"/>
+                <a16:creationId xmlns:a16="http://schemas.microsoft.com/office/drawing/2014/main" id="{00AB4484-9BDC-755B-DB95-A623AFC51188}"/>
               </a:ext>
             </a:extLst>
           </p:cNvPr>
@@ -3948,8 +3755,8 @@
         </p:nvCxnSpPr>
         <p:spPr>
           <a:xfrm rot="16200000" flipV="1">
-            <a:off x="4503491" y="8322064"/>
-            <a:ext cx="1504272" cy="4430"/>
+            <a:off x="4503818" y="8505698"/>
+            <a:ext cx="1503618" cy="4430"/>
           </a:xfrm>
           <a:prstGeom prst="bentConnector3">
             <a:avLst>
@@ -3985,7 +3792,7 @@
           <p:cNvPr id="326" name="Manipulate Variables">
             <a:extLst>
               <a:ext uri="{FF2B5EF4-FFF2-40B4-BE49-F238E27FC236}">
-                <a16:creationId xmlns:a16="http://schemas.microsoft.com/office/drawing/2014/main" id="{7DCEF4F9-EE20-CAC5-6EF5-33D073B7BC00}"/>
+                <a16:creationId xmlns:a16="http://schemas.microsoft.com/office/drawing/2014/main" id="{797036F7-337E-EC5D-3071-9FBA8A0376DE}"/>
               </a:ext>
             </a:extLst>
           </p:cNvPr>
@@ -3994,8 +3801,8 @@
         </p:nvSpPr>
         <p:spPr>
           <a:xfrm>
-            <a:off x="274320" y="7498080"/>
-            <a:ext cx="1825821" cy="340029"/>
+            <a:off x="274320" y="7955280"/>
+            <a:ext cx="1825821" cy="339881"/>
           </a:xfrm>
           <a:prstGeom prst="rect">
             <a:avLst/>
@@ -4041,7 +3848,7 @@
           <p:cNvPr id="426" name="TextBox 425">
             <a:extLst>
               <a:ext uri="{FF2B5EF4-FFF2-40B4-BE49-F238E27FC236}">
-                <a16:creationId xmlns:a16="http://schemas.microsoft.com/office/drawing/2014/main" id="{8B47F1E2-681C-19F7-24A6-86F18ED45FAF}"/>
+                <a16:creationId xmlns:a16="http://schemas.microsoft.com/office/drawing/2014/main" id="{D302DD13-8606-6B71-0DBC-1ED0A5DD8B67}"/>
               </a:ext>
             </a:extLst>
           </p:cNvPr>
@@ -4050,8 +3857,8 @@
         </p:nvSpPr>
         <p:spPr>
           <a:xfrm>
-            <a:off x="9875520" y="8595360"/>
-            <a:ext cx="4138222" cy="1463040"/>
+            <a:off x="9875520" y="8778876"/>
+            <a:ext cx="4138222" cy="1462404"/>
           </a:xfrm>
           <a:prstGeom prst="rect">
             <a:avLst/>
@@ -4171,7 +3978,7 @@
           <p:cNvPr id="10" name="Manipulate Variables">
             <a:extLst>
               <a:ext uri="{FF2B5EF4-FFF2-40B4-BE49-F238E27FC236}">
-                <a16:creationId xmlns:a16="http://schemas.microsoft.com/office/drawing/2014/main" id="{DB0D10F1-C540-FE1F-662A-B33A51117CDA}"/>
+                <a16:creationId xmlns:a16="http://schemas.microsoft.com/office/drawing/2014/main" id="{29C43816-F46D-0DA5-7801-0C8A13D21FFF}"/>
               </a:ext>
             </a:extLst>
           </p:cNvPr>
@@ -4180,8 +3987,8 @@
         </p:nvSpPr>
         <p:spPr>
           <a:xfrm>
-            <a:off x="9875520" y="3566160"/>
-            <a:ext cx="1808187" cy="340029"/>
+            <a:off x="9875520" y="3751864"/>
+            <a:ext cx="1808187" cy="339881"/>
           </a:xfrm>
           <a:prstGeom prst="rect">
             <a:avLst/>
@@ -4227,7 +4034,7 @@
           <p:cNvPr id="488" name="Manipulate Variables">
             <a:extLst>
               <a:ext uri="{FF2B5EF4-FFF2-40B4-BE49-F238E27FC236}">
-                <a16:creationId xmlns:a16="http://schemas.microsoft.com/office/drawing/2014/main" id="{04130859-EED8-13E4-2FB9-49C85BEC95EB}"/>
+                <a16:creationId xmlns:a16="http://schemas.microsoft.com/office/drawing/2014/main" id="{32592A40-50EC-2050-F008-84C884187B2F}"/>
               </a:ext>
             </a:extLst>
           </p:cNvPr>
@@ -4236,8 +4043,8 @@
         </p:nvSpPr>
         <p:spPr>
           <a:xfrm>
-            <a:off x="274320" y="5303520"/>
-            <a:ext cx="1017907" cy="340029"/>
+            <a:off x="274320" y="5488469"/>
+            <a:ext cx="1017907" cy="339881"/>
           </a:xfrm>
           <a:prstGeom prst="rect">
             <a:avLst/>
@@ -4283,7 +4090,7 @@
           <p:cNvPr id="2" name="TextBox 1">
             <a:extLst>
               <a:ext uri="{FF2B5EF4-FFF2-40B4-BE49-F238E27FC236}">
-                <a16:creationId xmlns:a16="http://schemas.microsoft.com/office/drawing/2014/main" id="{02B5345F-D81A-8B23-DA3E-CE6AE98B82F5}"/>
+                <a16:creationId xmlns:a16="http://schemas.microsoft.com/office/drawing/2014/main" id="{D6AF1953-2DCC-12C2-FAE6-3991418E5557}"/>
               </a:ext>
             </a:extLst>
           </p:cNvPr>
@@ -4292,8 +4099,8 @@
         </p:nvSpPr>
         <p:spPr>
           <a:xfrm>
-            <a:off x="9875520" y="1675114"/>
-            <a:ext cx="4177348" cy="1587533"/>
+            <a:off x="9875520" y="2103120"/>
+            <a:ext cx="4177348" cy="1463040"/>
           </a:xfrm>
           <a:prstGeom prst="rect">
             <a:avLst/>
@@ -4364,7 +4171,7 @@
           <p:cNvPr id="43" name="Elbow Connector 42">
             <a:extLst>
               <a:ext uri="{FF2B5EF4-FFF2-40B4-BE49-F238E27FC236}">
-                <a16:creationId xmlns:a16="http://schemas.microsoft.com/office/drawing/2014/main" id="{5C529D7C-C665-B0CC-CDDD-0CD782B82289}"/>
+                <a16:creationId xmlns:a16="http://schemas.microsoft.com/office/drawing/2014/main" id="{833F01D1-19D5-01E4-F5A6-2A6D45D63E55}"/>
               </a:ext>
             </a:extLst>
           </p:cNvPr>
@@ -4376,12 +4183,12 @@
         </p:nvCxnSpPr>
         <p:spPr>
           <a:xfrm flipV="1">
-            <a:off x="7241179" y="6255621"/>
-            <a:ext cx="2634341" cy="2472576"/>
+            <a:off x="7241179" y="6633372"/>
+            <a:ext cx="2653728" cy="2278284"/>
           </a:xfrm>
           <a:prstGeom prst="bentConnector3">
             <a:avLst>
-              <a:gd name="adj1" fmla="val 87908"/>
+              <a:gd name="adj1" fmla="val 87534"/>
             </a:avLst>
           </a:prstGeom>
           <a:noFill/>
@@ -4413,7 +4220,7 @@
           <p:cNvPr id="490" name="Elbow Connector 489">
             <a:extLst>
               <a:ext uri="{FF2B5EF4-FFF2-40B4-BE49-F238E27FC236}">
-                <a16:creationId xmlns:a16="http://schemas.microsoft.com/office/drawing/2014/main" id="{79272D89-C97A-E6E1-4BFE-31F8CE50D585}"/>
+                <a16:creationId xmlns:a16="http://schemas.microsoft.com/office/drawing/2014/main" id="{B23B2644-D20D-A515-A60F-5BE471E00D56}"/>
               </a:ext>
             </a:extLst>
           </p:cNvPr>
@@ -4425,8 +4232,8 @@
         </p:nvCxnSpPr>
         <p:spPr>
           <a:xfrm flipV="1">
-            <a:off x="9277609" y="3736175"/>
-            <a:ext cx="597911" cy="3238528"/>
+            <a:off x="9277609" y="3921805"/>
+            <a:ext cx="597911" cy="3237119"/>
           </a:xfrm>
           <a:prstGeom prst="bentConnector3">
             <a:avLst>
@@ -4462,7 +4269,7 @@
           <p:cNvPr id="267" name="Google Shape;156;p1">
             <a:extLst>
               <a:ext uri="{FF2B5EF4-FFF2-40B4-BE49-F238E27FC236}">
-                <a16:creationId xmlns:a16="http://schemas.microsoft.com/office/drawing/2014/main" id="{86C73B11-1D70-CCE5-645F-240B4C804000}"/>
+                <a16:creationId xmlns:a16="http://schemas.microsoft.com/office/drawing/2014/main" id="{7EB390A8-72DF-0707-F3CD-6C597ECDFABA}"/>
               </a:ext>
             </a:extLst>
           </p:cNvPr>
@@ -4471,8 +4278,8 @@
         </p:nvGrpSpPr>
         <p:grpSpPr>
           <a:xfrm>
-            <a:off x="5817574" y="4638565"/>
-            <a:ext cx="2196419" cy="1216823"/>
+            <a:off x="5817574" y="4823803"/>
+            <a:ext cx="2196419" cy="1216294"/>
             <a:chOff x="10592773" y="5229745"/>
             <a:chExt cx="3298954" cy="1741391"/>
           </a:xfrm>
@@ -4485,7 +4292,7 @@
             <p:cNvPr id="268" name="Google Shape;157;p1">
               <a:extLst>
                 <a:ext uri="{FF2B5EF4-FFF2-40B4-BE49-F238E27FC236}">
-                  <a16:creationId xmlns:a16="http://schemas.microsoft.com/office/drawing/2014/main" id="{04D6EDDB-FABF-BC43-BA4A-E71907C6EFCD}"/>
+                  <a16:creationId xmlns:a16="http://schemas.microsoft.com/office/drawing/2014/main" id="{AEE4CC26-D210-DCFA-71F2-6D349BFA897F}"/>
                 </a:ext>
               </a:extLst>
             </p:cNvPr>
@@ -4552,7 +4359,7 @@
             <p:cNvPr id="269" name="Google Shape;158;p1">
               <a:extLst>
                 <a:ext uri="{FF2B5EF4-FFF2-40B4-BE49-F238E27FC236}">
-                  <a16:creationId xmlns:a16="http://schemas.microsoft.com/office/drawing/2014/main" id="{AA94CE47-ED6F-D0F6-08BE-168AE4CD1D0E}"/>
+                  <a16:creationId xmlns:a16="http://schemas.microsoft.com/office/drawing/2014/main" id="{C93CBA44-7471-E454-7196-E731015B7BE1}"/>
                 </a:ext>
               </a:extLst>
             </p:cNvPr>
@@ -4619,7 +4426,7 @@
             <p:cNvPr id="270" name="Google Shape;159;p1">
               <a:extLst>
                 <a:ext uri="{FF2B5EF4-FFF2-40B4-BE49-F238E27FC236}">
-                  <a16:creationId xmlns:a16="http://schemas.microsoft.com/office/drawing/2014/main" id="{9DE3156B-EC63-0077-1E74-633201D483C2}"/>
+                  <a16:creationId xmlns:a16="http://schemas.microsoft.com/office/drawing/2014/main" id="{57E7FB6E-EEC2-C286-6B1C-21F4A020E8EC}"/>
                 </a:ext>
               </a:extLst>
             </p:cNvPr>
@@ -4688,7 +4495,7 @@
             <p:cNvPr id="271" name="Google Shape;160;p1">
               <a:extLst>
                 <a:ext uri="{FF2B5EF4-FFF2-40B4-BE49-F238E27FC236}">
-                  <a16:creationId xmlns:a16="http://schemas.microsoft.com/office/drawing/2014/main" id="{1180336F-8BBB-F7CE-1D81-F05CECBB3BFB}"/>
+                  <a16:creationId xmlns:a16="http://schemas.microsoft.com/office/drawing/2014/main" id="{6AAD2614-2A2D-5EB8-2AD5-6B45E657101C}"/>
                 </a:ext>
               </a:extLst>
             </p:cNvPr>
@@ -4755,7 +4562,7 @@
             <p:cNvPr id="272" name="Google Shape;161;p1">
               <a:extLst>
                 <a:ext uri="{FF2B5EF4-FFF2-40B4-BE49-F238E27FC236}">
-                  <a16:creationId xmlns:a16="http://schemas.microsoft.com/office/drawing/2014/main" id="{785C31C6-88DA-74A4-C524-74B180435D6E}"/>
+                  <a16:creationId xmlns:a16="http://schemas.microsoft.com/office/drawing/2014/main" id="{F68E2126-5FAD-DA7E-3F52-C4A869AD0E6F}"/>
                 </a:ext>
               </a:extLst>
             </p:cNvPr>
@@ -4824,7 +4631,7 @@
             <p:cNvPr id="273" name="Google Shape;162;p1">
               <a:extLst>
                 <a:ext uri="{FF2B5EF4-FFF2-40B4-BE49-F238E27FC236}">
-                  <a16:creationId xmlns:a16="http://schemas.microsoft.com/office/drawing/2014/main" id="{CF303448-C23A-9EAA-28D5-5A311D7F4AEB}"/>
+                  <a16:creationId xmlns:a16="http://schemas.microsoft.com/office/drawing/2014/main" id="{9CA003DD-66DF-FF3C-C66D-5A6050BEE657}"/>
                 </a:ext>
               </a:extLst>
             </p:cNvPr>
@@ -4893,7 +4700,7 @@
             <p:cNvPr id="274" name="Google Shape;163;p1">
               <a:extLst>
                 <a:ext uri="{FF2B5EF4-FFF2-40B4-BE49-F238E27FC236}">
-                  <a16:creationId xmlns:a16="http://schemas.microsoft.com/office/drawing/2014/main" id="{1722E6E2-A9F4-D8A3-EF75-64FD71114516}"/>
+                  <a16:creationId xmlns:a16="http://schemas.microsoft.com/office/drawing/2014/main" id="{BE99CD3F-6AE1-501F-7ADD-CF9F8D215921}"/>
                 </a:ext>
               </a:extLst>
             </p:cNvPr>
@@ -4960,7 +4767,7 @@
             <p:cNvPr id="275" name="Google Shape;164;p1">
               <a:extLst>
                 <a:ext uri="{FF2B5EF4-FFF2-40B4-BE49-F238E27FC236}">
-                  <a16:creationId xmlns:a16="http://schemas.microsoft.com/office/drawing/2014/main" id="{CA540B69-D08D-3F93-69A1-B106A3C9D00E}"/>
+                  <a16:creationId xmlns:a16="http://schemas.microsoft.com/office/drawing/2014/main" id="{E473325E-ABE1-9957-9910-E7BA1EABAD3F}"/>
                 </a:ext>
               </a:extLst>
             </p:cNvPr>
@@ -5027,7 +4834,7 @@
             <p:cNvPr id="276" name="Google Shape;165;p1">
               <a:extLst>
                 <a:ext uri="{FF2B5EF4-FFF2-40B4-BE49-F238E27FC236}">
-                  <a16:creationId xmlns:a16="http://schemas.microsoft.com/office/drawing/2014/main" id="{3B47B3A9-F5C9-3842-5B22-4EAD8CE93FA0}"/>
+                  <a16:creationId xmlns:a16="http://schemas.microsoft.com/office/drawing/2014/main" id="{D6102D26-1558-ECCC-906C-F6EBBED99D53}"/>
                 </a:ext>
               </a:extLst>
             </p:cNvPr>
@@ -5096,7 +4903,7 @@
             <p:cNvPr id="277" name="Google Shape;166;p1">
               <a:extLst>
                 <a:ext uri="{FF2B5EF4-FFF2-40B4-BE49-F238E27FC236}">
-                  <a16:creationId xmlns:a16="http://schemas.microsoft.com/office/drawing/2014/main" id="{58EB9847-94A0-5E8A-3C40-2188B4491888}"/>
+                  <a16:creationId xmlns:a16="http://schemas.microsoft.com/office/drawing/2014/main" id="{BDFEABD3-D2FE-08E1-953B-FF3A6FA9E0E2}"/>
                 </a:ext>
               </a:extLst>
             </p:cNvPr>
@@ -5165,7 +4972,7 @@
             <p:cNvPr id="278" name="Google Shape;167;p1">
               <a:extLst>
                 <a:ext uri="{FF2B5EF4-FFF2-40B4-BE49-F238E27FC236}">
-                  <a16:creationId xmlns:a16="http://schemas.microsoft.com/office/drawing/2014/main" id="{6F2F49E2-A70E-0A1E-9EDC-9BB029CEF3E6}"/>
+                  <a16:creationId xmlns:a16="http://schemas.microsoft.com/office/drawing/2014/main" id="{B99FB95B-6CA3-2EA5-BD10-A3D6B7AB7200}"/>
                 </a:ext>
               </a:extLst>
             </p:cNvPr>
@@ -5234,7 +5041,7 @@
             <p:cNvPr id="279" name="Google Shape;168;p1">
               <a:extLst>
                 <a:ext uri="{FF2B5EF4-FFF2-40B4-BE49-F238E27FC236}">
-                  <a16:creationId xmlns:a16="http://schemas.microsoft.com/office/drawing/2014/main" id="{68161072-AE40-FC1F-B9B3-55AF9C1EDB03}"/>
+                  <a16:creationId xmlns:a16="http://schemas.microsoft.com/office/drawing/2014/main" id="{957D4E29-2384-E11E-967F-7C5D960C4805}"/>
                 </a:ext>
               </a:extLst>
             </p:cNvPr>
@@ -5301,7 +5108,7 @@
             <p:cNvPr id="280" name="Google Shape;169;p1">
               <a:extLst>
                 <a:ext uri="{FF2B5EF4-FFF2-40B4-BE49-F238E27FC236}">
-                  <a16:creationId xmlns:a16="http://schemas.microsoft.com/office/drawing/2014/main" id="{201719F0-C5C6-32D1-4AAF-9802E9685100}"/>
+                  <a16:creationId xmlns:a16="http://schemas.microsoft.com/office/drawing/2014/main" id="{845D17AE-B75E-5399-EBBF-7FFC1B93D1DE}"/>
                 </a:ext>
               </a:extLst>
             </p:cNvPr>
@@ -5370,7 +5177,7 @@
             <p:cNvPr id="281" name="Google Shape;170;p1">
               <a:extLst>
                 <a:ext uri="{FF2B5EF4-FFF2-40B4-BE49-F238E27FC236}">
-                  <a16:creationId xmlns:a16="http://schemas.microsoft.com/office/drawing/2014/main" id="{116F1915-ADBB-F832-91FE-2F735B358EF7}"/>
+                  <a16:creationId xmlns:a16="http://schemas.microsoft.com/office/drawing/2014/main" id="{88DD6884-1A3C-7E08-85AA-6617B54E413B}"/>
                 </a:ext>
               </a:extLst>
             </p:cNvPr>
@@ -5437,7 +5244,7 @@
             <p:cNvPr id="282" name="Google Shape;171;p1">
               <a:extLst>
                 <a:ext uri="{FF2B5EF4-FFF2-40B4-BE49-F238E27FC236}">
-                  <a16:creationId xmlns:a16="http://schemas.microsoft.com/office/drawing/2014/main" id="{6B7E74DD-361E-6A6E-3BE7-AF3B0E29E781}"/>
+                  <a16:creationId xmlns:a16="http://schemas.microsoft.com/office/drawing/2014/main" id="{22AAB6E7-705E-25F9-8CC3-C5031275723B}"/>
                 </a:ext>
               </a:extLst>
             </p:cNvPr>
@@ -5506,7 +5313,7 @@
             <p:cNvPr id="283" name="Google Shape;172;p1">
               <a:extLst>
                 <a:ext uri="{FF2B5EF4-FFF2-40B4-BE49-F238E27FC236}">
-                  <a16:creationId xmlns:a16="http://schemas.microsoft.com/office/drawing/2014/main" id="{FA7E3C09-42DF-D05B-E064-8F7AA1DED54F}"/>
+                  <a16:creationId xmlns:a16="http://schemas.microsoft.com/office/drawing/2014/main" id="{24240668-381D-39FD-B921-A75F2D8EEEE7}"/>
                 </a:ext>
               </a:extLst>
             </p:cNvPr>
@@ -5555,7 +5362,7 @@
             <p:cNvPr id="284" name="Google Shape;173;p1">
               <a:extLst>
                 <a:ext uri="{FF2B5EF4-FFF2-40B4-BE49-F238E27FC236}">
-                  <a16:creationId xmlns:a16="http://schemas.microsoft.com/office/drawing/2014/main" id="{2112FED9-D359-C9AD-F0E5-D13ADA71B4C1}"/>
+                  <a16:creationId xmlns:a16="http://schemas.microsoft.com/office/drawing/2014/main" id="{B2076A06-2094-507F-4996-CCEE18B62A2E}"/>
                 </a:ext>
               </a:extLst>
             </p:cNvPr>
@@ -5604,7 +5411,7 @@
             <p:cNvPr id="285" name="Google Shape;175;p1">
               <a:extLst>
                 <a:ext uri="{FF2B5EF4-FFF2-40B4-BE49-F238E27FC236}">
-                  <a16:creationId xmlns:a16="http://schemas.microsoft.com/office/drawing/2014/main" id="{91A97F52-C0F7-85B3-66AB-2927D90AE511}"/>
+                  <a16:creationId xmlns:a16="http://schemas.microsoft.com/office/drawing/2014/main" id="{6FFA1C8E-C9E4-D100-69F2-5175F4569757}"/>
                 </a:ext>
               </a:extLst>
             </p:cNvPr>
@@ -5653,7 +5460,7 @@
             <p:cNvPr id="286" name="Google Shape;177;p1">
               <a:extLst>
                 <a:ext uri="{FF2B5EF4-FFF2-40B4-BE49-F238E27FC236}">
-                  <a16:creationId xmlns:a16="http://schemas.microsoft.com/office/drawing/2014/main" id="{FCB91EF3-4C3B-43FD-C9E7-436C04258A90}"/>
+                  <a16:creationId xmlns:a16="http://schemas.microsoft.com/office/drawing/2014/main" id="{732EEBF3-99C6-02FC-72E3-8FEB321EE50B}"/>
                 </a:ext>
               </a:extLst>
             </p:cNvPr>
@@ -5702,7 +5509,7 @@
             <p:cNvPr id="287" name="Google Shape;178;p1">
               <a:extLst>
                 <a:ext uri="{FF2B5EF4-FFF2-40B4-BE49-F238E27FC236}">
-                  <a16:creationId xmlns:a16="http://schemas.microsoft.com/office/drawing/2014/main" id="{11326CF0-262D-AAB8-C7AE-89215AC0A9A3}"/>
+                  <a16:creationId xmlns:a16="http://schemas.microsoft.com/office/drawing/2014/main" id="{9C417426-89FF-3828-9B0E-BA67BADF0381}"/>
                 </a:ext>
               </a:extLst>
             </p:cNvPr>
@@ -5751,7 +5558,7 @@
             <p:cNvPr id="288" name="Google Shape;179;p1">
               <a:extLst>
                 <a:ext uri="{FF2B5EF4-FFF2-40B4-BE49-F238E27FC236}">
-                  <a16:creationId xmlns:a16="http://schemas.microsoft.com/office/drawing/2014/main" id="{B9226557-AD6C-6072-452C-38BFC71F118E}"/>
+                  <a16:creationId xmlns:a16="http://schemas.microsoft.com/office/drawing/2014/main" id="{154AA376-00CF-F34A-2DEF-9DD462E8C235}"/>
                 </a:ext>
               </a:extLst>
             </p:cNvPr>
@@ -5800,7 +5607,7 @@
             <p:cNvPr id="289" name="Google Shape;180;p1">
               <a:extLst>
                 <a:ext uri="{FF2B5EF4-FFF2-40B4-BE49-F238E27FC236}">
-                  <a16:creationId xmlns:a16="http://schemas.microsoft.com/office/drawing/2014/main" id="{ED7815E5-E40E-D9BA-ECAC-0C4C91B07252}"/>
+                  <a16:creationId xmlns:a16="http://schemas.microsoft.com/office/drawing/2014/main" id="{A9324A7D-7412-5652-400F-9F739B088678}"/>
                 </a:ext>
               </a:extLst>
             </p:cNvPr>
@@ -5849,7 +5656,7 @@
             <p:cNvPr id="290" name="Google Shape;181;p1">
               <a:extLst>
                 <a:ext uri="{FF2B5EF4-FFF2-40B4-BE49-F238E27FC236}">
-                  <a16:creationId xmlns:a16="http://schemas.microsoft.com/office/drawing/2014/main" id="{5DACBC2F-6D5F-1602-8BAC-96F81AC3E6CD}"/>
+                  <a16:creationId xmlns:a16="http://schemas.microsoft.com/office/drawing/2014/main" id="{7DC24167-7B38-391F-66C6-5E5D26D540A2}"/>
                 </a:ext>
               </a:extLst>
             </p:cNvPr>
@@ -5898,7 +5705,7 @@
             <p:cNvPr id="291" name="Google Shape;183;p1">
               <a:extLst>
                 <a:ext uri="{FF2B5EF4-FFF2-40B4-BE49-F238E27FC236}">
-                  <a16:creationId xmlns:a16="http://schemas.microsoft.com/office/drawing/2014/main" id="{48AE4544-7869-966B-6F66-FDB5ED2C89F9}"/>
+                  <a16:creationId xmlns:a16="http://schemas.microsoft.com/office/drawing/2014/main" id="{175572A3-2B6F-7C8B-3CC4-C05EDBBA89F8}"/>
                 </a:ext>
               </a:extLst>
             </p:cNvPr>
@@ -5947,7 +5754,7 @@
             <p:cNvPr id="293" name="Google Shape;176;p1">
               <a:extLst>
                 <a:ext uri="{FF2B5EF4-FFF2-40B4-BE49-F238E27FC236}">
-                  <a16:creationId xmlns:a16="http://schemas.microsoft.com/office/drawing/2014/main" id="{E1E6221B-C765-4AED-6149-4C4EDA20C9DE}"/>
+                  <a16:creationId xmlns:a16="http://schemas.microsoft.com/office/drawing/2014/main" id="{D25C5CFA-0E16-12F4-D7B6-CAAD5EFF84EE}"/>
                 </a:ext>
               </a:extLst>
             </p:cNvPr>
@@ -6014,7 +5821,7 @@
             <p:cNvPr id="294" name="Google Shape;184;p1">
               <a:extLst>
                 <a:ext uri="{FF2B5EF4-FFF2-40B4-BE49-F238E27FC236}">
-                  <a16:creationId xmlns:a16="http://schemas.microsoft.com/office/drawing/2014/main" id="{21FC396C-D02A-7FEC-86CF-168E48D192B6}"/>
+                  <a16:creationId xmlns:a16="http://schemas.microsoft.com/office/drawing/2014/main" id="{0F74BCA8-2C10-8539-73BB-1C20717151CA}"/>
                 </a:ext>
               </a:extLst>
             </p:cNvPr>
@@ -6063,7 +5870,7 @@
             <p:cNvPr id="295" name="Google Shape;185;p1">
               <a:extLst>
                 <a:ext uri="{FF2B5EF4-FFF2-40B4-BE49-F238E27FC236}">
-                  <a16:creationId xmlns:a16="http://schemas.microsoft.com/office/drawing/2014/main" id="{AFACB7FF-2EC4-0B2C-811D-3D2435942966}"/>
+                  <a16:creationId xmlns:a16="http://schemas.microsoft.com/office/drawing/2014/main" id="{C48AFFAE-B5F8-2607-E554-8B0D01E2FA2A}"/>
                 </a:ext>
               </a:extLst>
             </p:cNvPr>
@@ -6112,7 +5919,7 @@
             <p:cNvPr id="296" name="Google Shape;174;p1">
               <a:extLst>
                 <a:ext uri="{FF2B5EF4-FFF2-40B4-BE49-F238E27FC236}">
-                  <a16:creationId xmlns:a16="http://schemas.microsoft.com/office/drawing/2014/main" id="{6539BB91-DD5D-DC71-5DAC-C46D5F3B22EE}"/>
+                  <a16:creationId xmlns:a16="http://schemas.microsoft.com/office/drawing/2014/main" id="{B72C961B-155F-6608-BAA9-797FB5891BC9}"/>
                 </a:ext>
               </a:extLst>
             </p:cNvPr>
@@ -6179,7 +5986,7 @@
             <p:cNvPr id="297" name="Google Shape;186;p1">
               <a:extLst>
                 <a:ext uri="{FF2B5EF4-FFF2-40B4-BE49-F238E27FC236}">
-                  <a16:creationId xmlns:a16="http://schemas.microsoft.com/office/drawing/2014/main" id="{80DFC4A2-319A-1D25-3064-CEFF5B607A5F}"/>
+                  <a16:creationId xmlns:a16="http://schemas.microsoft.com/office/drawing/2014/main" id="{CD7D0E44-9B31-539C-AA4C-F4B155C35A5B}"/>
                 </a:ext>
               </a:extLst>
             </p:cNvPr>
@@ -6228,7 +6035,7 @@
             <p:cNvPr id="298" name="Google Shape;187;p1">
               <a:extLst>
                 <a:ext uri="{FF2B5EF4-FFF2-40B4-BE49-F238E27FC236}">
-                  <a16:creationId xmlns:a16="http://schemas.microsoft.com/office/drawing/2014/main" id="{F383918C-EC7C-CF37-B205-ED7B792923A8}"/>
+                  <a16:creationId xmlns:a16="http://schemas.microsoft.com/office/drawing/2014/main" id="{9ECA801F-5E58-7FE6-34AC-FC6875EA9BAA}"/>
                 </a:ext>
               </a:extLst>
             </p:cNvPr>
@@ -6265,7 +6072,7 @@
             <p:cNvPr id="299" name="Google Shape;189;p1">
               <a:extLst>
                 <a:ext uri="{FF2B5EF4-FFF2-40B4-BE49-F238E27FC236}">
-                  <a16:creationId xmlns:a16="http://schemas.microsoft.com/office/drawing/2014/main" id="{7073115C-753C-19B4-9FD1-7D71D65C8CAE}"/>
+                  <a16:creationId xmlns:a16="http://schemas.microsoft.com/office/drawing/2014/main" id="{B0E5706D-52D8-A2FD-B10F-DEAA2163AD5F}"/>
                 </a:ext>
               </a:extLst>
             </p:cNvPr>
@@ -6314,7 +6121,7 @@
             <p:cNvPr id="300" name="Google Shape;190;p1">
               <a:extLst>
                 <a:ext uri="{FF2B5EF4-FFF2-40B4-BE49-F238E27FC236}">
-                  <a16:creationId xmlns:a16="http://schemas.microsoft.com/office/drawing/2014/main" id="{6EAD997E-93D8-B182-86F7-AFC461CFFF96}"/>
+                  <a16:creationId xmlns:a16="http://schemas.microsoft.com/office/drawing/2014/main" id="{FAF90A23-5AD7-062E-8A30-53957E367500}"/>
                 </a:ext>
               </a:extLst>
             </p:cNvPr>
@@ -6363,7 +6170,7 @@
             <p:cNvPr id="301" name="Google Shape;191;p1">
               <a:extLst>
                 <a:ext uri="{FF2B5EF4-FFF2-40B4-BE49-F238E27FC236}">
-                  <a16:creationId xmlns:a16="http://schemas.microsoft.com/office/drawing/2014/main" id="{321F8888-E0C7-2D29-447E-0F03165F536A}"/>
+                  <a16:creationId xmlns:a16="http://schemas.microsoft.com/office/drawing/2014/main" id="{BAB49773-7128-291E-D1D0-F7CC7BA78B92}"/>
                 </a:ext>
               </a:extLst>
             </p:cNvPr>
@@ -6412,7 +6219,7 @@
             <p:cNvPr id="302" name="Google Shape;188;p1">
               <a:extLst>
                 <a:ext uri="{FF2B5EF4-FFF2-40B4-BE49-F238E27FC236}">
-                  <a16:creationId xmlns:a16="http://schemas.microsoft.com/office/drawing/2014/main" id="{0D188FB4-1CA2-BF06-89B8-7EEF4E94E469}"/>
+                  <a16:creationId xmlns:a16="http://schemas.microsoft.com/office/drawing/2014/main" id="{D462EEF4-1177-7139-6E06-B282A5AA9568}"/>
                 </a:ext>
               </a:extLst>
             </p:cNvPr>
@@ -6481,7 +6288,7 @@
             <p:cNvPr id="303" name="Google Shape;192;p1">
               <a:extLst>
                 <a:ext uri="{FF2B5EF4-FFF2-40B4-BE49-F238E27FC236}">
-                  <a16:creationId xmlns:a16="http://schemas.microsoft.com/office/drawing/2014/main" id="{C81BF0A6-1CBF-70F4-79C9-5CB7A55C118C}"/>
+                  <a16:creationId xmlns:a16="http://schemas.microsoft.com/office/drawing/2014/main" id="{C1973C9B-0FCD-014F-DB2A-3F92E3B33266}"/>
                 </a:ext>
               </a:extLst>
             </p:cNvPr>
@@ -6530,7 +6337,7 @@
             <p:cNvPr id="304" name="Google Shape;182;p1">
               <a:extLst>
                 <a:ext uri="{FF2B5EF4-FFF2-40B4-BE49-F238E27FC236}">
-                  <a16:creationId xmlns:a16="http://schemas.microsoft.com/office/drawing/2014/main" id="{DB9FC5F2-9C53-79AB-F5A1-F86B295700A2}"/>
+                  <a16:creationId xmlns:a16="http://schemas.microsoft.com/office/drawing/2014/main" id="{378332B6-9018-97A5-9D4F-E240D14C1769}"/>
                 </a:ext>
               </a:extLst>
             </p:cNvPr>
@@ -6597,7 +6404,7 @@
             <p:cNvPr id="305" name="Google Shape;193;p1">
               <a:extLst>
                 <a:ext uri="{FF2B5EF4-FFF2-40B4-BE49-F238E27FC236}">
-                  <a16:creationId xmlns:a16="http://schemas.microsoft.com/office/drawing/2014/main" id="{4760CF25-539D-11B4-2B72-7B3BADFDFDF3}"/>
+                  <a16:creationId xmlns:a16="http://schemas.microsoft.com/office/drawing/2014/main" id="{05774CBB-DC9E-4E7D-5678-54DE936DF589}"/>
                 </a:ext>
               </a:extLst>
             </p:cNvPr>
@@ -6646,7 +6453,7 @@
             <p:cNvPr id="306" name="Google Shape;194;p1">
               <a:extLst>
                 <a:ext uri="{FF2B5EF4-FFF2-40B4-BE49-F238E27FC236}">
-                  <a16:creationId xmlns:a16="http://schemas.microsoft.com/office/drawing/2014/main" id="{64E874FA-A650-E684-25B9-4E2E0F72878A}"/>
+                  <a16:creationId xmlns:a16="http://schemas.microsoft.com/office/drawing/2014/main" id="{9F0DA409-BB80-0273-67FA-2F474C4DEC55}"/>
                 </a:ext>
               </a:extLst>
             </p:cNvPr>
@@ -6695,7 +6502,7 @@
             <p:cNvPr id="307" name="Google Shape;195;p1">
               <a:extLst>
                 <a:ext uri="{FF2B5EF4-FFF2-40B4-BE49-F238E27FC236}">
-                  <a16:creationId xmlns:a16="http://schemas.microsoft.com/office/drawing/2014/main" id="{5A50CBD0-E34B-2AAA-1FAA-271B0F17703B}"/>
+                  <a16:creationId xmlns:a16="http://schemas.microsoft.com/office/drawing/2014/main" id="{6A28F714-F723-1C72-1FE8-E1EEDE2107F0}"/>
                 </a:ext>
               </a:extLst>
             </p:cNvPr>
@@ -6744,7 +6551,7 @@
             <p:cNvPr id="308" name="Google Shape;196;p1">
               <a:extLst>
                 <a:ext uri="{FF2B5EF4-FFF2-40B4-BE49-F238E27FC236}">
-                  <a16:creationId xmlns:a16="http://schemas.microsoft.com/office/drawing/2014/main" id="{8C7AA68B-9973-E35B-EA2F-FA33E7F2ED56}"/>
+                  <a16:creationId xmlns:a16="http://schemas.microsoft.com/office/drawing/2014/main" id="{01D6E4EB-197A-F582-6E00-AEF4117259C2}"/>
                 </a:ext>
               </a:extLst>
             </p:cNvPr>
@@ -6781,7 +6588,7 @@
             <p:cNvPr id="309" name="Google Shape;197;p1">
               <a:extLst>
                 <a:ext uri="{FF2B5EF4-FFF2-40B4-BE49-F238E27FC236}">
-                  <a16:creationId xmlns:a16="http://schemas.microsoft.com/office/drawing/2014/main" id="{18EB3C50-F4E3-A798-221D-0C761BBF053E}"/>
+                  <a16:creationId xmlns:a16="http://schemas.microsoft.com/office/drawing/2014/main" id="{F6850FDB-4611-0B12-AB22-A47C1CF59FCF}"/>
                 </a:ext>
               </a:extLst>
             </p:cNvPr>
@@ -6830,7 +6637,7 @@
             <p:cNvPr id="310" name="Google Shape;198;p1">
               <a:extLst>
                 <a:ext uri="{FF2B5EF4-FFF2-40B4-BE49-F238E27FC236}">
-                  <a16:creationId xmlns:a16="http://schemas.microsoft.com/office/drawing/2014/main" id="{FD52C051-DEBD-4B04-EEFB-59D1CDBC2DE9}"/>
+                  <a16:creationId xmlns:a16="http://schemas.microsoft.com/office/drawing/2014/main" id="{48110CCC-BDF0-809B-1194-D07AFA2296AA}"/>
                 </a:ext>
               </a:extLst>
             </p:cNvPr>
@@ -6867,7 +6674,7 @@
             <p:cNvPr id="311" name="Google Shape;199;p1">
               <a:extLst>
                 <a:ext uri="{FF2B5EF4-FFF2-40B4-BE49-F238E27FC236}">
-                  <a16:creationId xmlns:a16="http://schemas.microsoft.com/office/drawing/2014/main" id="{9B9544A7-8A2A-3CBA-A557-6275326C5522}"/>
+                  <a16:creationId xmlns:a16="http://schemas.microsoft.com/office/drawing/2014/main" id="{AE76360C-5D8D-10B7-94B3-693F940A41C5}"/>
                 </a:ext>
               </a:extLst>
             </p:cNvPr>
@@ -6904,7 +6711,7 @@
             <p:cNvPr id="315" name="Google Shape;200;p1">
               <a:extLst>
                 <a:ext uri="{FF2B5EF4-FFF2-40B4-BE49-F238E27FC236}">
-                  <a16:creationId xmlns:a16="http://schemas.microsoft.com/office/drawing/2014/main" id="{080C635F-E01C-2296-2387-F5713509B9CA}"/>
+                  <a16:creationId xmlns:a16="http://schemas.microsoft.com/office/drawing/2014/main" id="{0896C858-B5E6-7987-6A67-223A72530504}"/>
                 </a:ext>
               </a:extLst>
             </p:cNvPr>
@@ -6942,7 +6749,7 @@
           <p:cNvPr id="12" name="Table">
             <a:extLst>
               <a:ext uri="{FF2B5EF4-FFF2-40B4-BE49-F238E27FC236}">
-                <a16:creationId xmlns:a16="http://schemas.microsoft.com/office/drawing/2014/main" id="{1755303D-5C17-AEDD-5094-13DD8D525F5E}"/>
+                <a16:creationId xmlns:a16="http://schemas.microsoft.com/office/drawing/2014/main" id="{0DC98A19-5F37-4BD0-2E2F-F81303914EFE}"/>
               </a:ext>
             </a:extLst>
           </p:cNvPr>
@@ -6950,7 +6757,7 @@
           <p:nvPr/>
         </p:nvGraphicFramePr>
         <p:xfrm>
-          <a:off x="5367268" y="2834640"/>
+          <a:off x="5367268" y="3020663"/>
           <a:ext cx="627864" cy="593755"/>
         </p:xfrm>
         <a:graphic>
@@ -7902,7 +7709,7 @@
           <p:cNvPr id="13" name="Table">
             <a:extLst>
               <a:ext uri="{FF2B5EF4-FFF2-40B4-BE49-F238E27FC236}">
-                <a16:creationId xmlns:a16="http://schemas.microsoft.com/office/drawing/2014/main" id="{7DA1610B-0B9F-BAB5-BFB1-79517842568B}"/>
+                <a16:creationId xmlns:a16="http://schemas.microsoft.com/office/drawing/2014/main" id="{890C0040-B6F3-4745-3603-8AB4ECF4D4E6}"/>
               </a:ext>
             </a:extLst>
           </p:cNvPr>
@@ -7910,7 +7717,7 @@
           <p:nvPr/>
         </p:nvGraphicFramePr>
         <p:xfrm>
-          <a:off x="5217803" y="3657600"/>
+          <a:off x="5217803" y="3843265"/>
           <a:ext cx="418576" cy="593755"/>
         </p:xfrm>
         <a:graphic>
@@ -8579,7 +8386,7 @@
           <p:cNvPr id="15" name="Table">
             <a:extLst>
               <a:ext uri="{FF2B5EF4-FFF2-40B4-BE49-F238E27FC236}">
-                <a16:creationId xmlns:a16="http://schemas.microsoft.com/office/drawing/2014/main" id="{8D3EDD3C-72A4-77C2-AB62-714E6D565E26}"/>
+                <a16:creationId xmlns:a16="http://schemas.microsoft.com/office/drawing/2014/main" id="{5544A0FA-D58D-CB69-180F-6339C46CFE11}"/>
               </a:ext>
             </a:extLst>
           </p:cNvPr>
@@ -8587,7 +8394,7 @@
           <p:nvPr/>
         </p:nvGraphicFramePr>
         <p:xfrm>
-          <a:off x="6614203" y="2834640"/>
+          <a:off x="6614203" y="3020663"/>
           <a:ext cx="627864" cy="593755"/>
         </p:xfrm>
         <a:graphic>
@@ -9539,7 +9346,7 @@
           <p:cNvPr id="18" name="Table">
             <a:extLst>
               <a:ext uri="{FF2B5EF4-FFF2-40B4-BE49-F238E27FC236}">
-                <a16:creationId xmlns:a16="http://schemas.microsoft.com/office/drawing/2014/main" id="{DE0643F5-88B4-653C-A19B-812D1C1ABA7F}"/>
+                <a16:creationId xmlns:a16="http://schemas.microsoft.com/office/drawing/2014/main" id="{08F8EDCA-62C3-64D7-3DA8-6D7529E6F69C}"/>
               </a:ext>
             </a:extLst>
           </p:cNvPr>
@@ -9547,7 +9354,7 @@
           <p:nvPr/>
         </p:nvGraphicFramePr>
         <p:xfrm>
-          <a:off x="7890671" y="2834640"/>
+          <a:off x="7890671" y="3020663"/>
           <a:ext cx="627864" cy="593755"/>
         </p:xfrm>
         <a:graphic>
@@ -10499,7 +10306,7 @@
           <p:cNvPr id="20" name="TextBox 19">
             <a:extLst>
               <a:ext uri="{FF2B5EF4-FFF2-40B4-BE49-F238E27FC236}">
-                <a16:creationId xmlns:a16="http://schemas.microsoft.com/office/drawing/2014/main" id="{C075BC12-64BD-AB6F-9FCB-16E3978165C1}"/>
+                <a16:creationId xmlns:a16="http://schemas.microsoft.com/office/drawing/2014/main" id="{4D7FF592-54B7-05FB-48AB-D28C163BE172}"/>
               </a:ext>
             </a:extLst>
           </p:cNvPr>
@@ -10508,8 +10315,8 @@
         </p:nvSpPr>
         <p:spPr>
           <a:xfrm>
-            <a:off x="6659605" y="2309615"/>
-            <a:ext cx="512359" cy="236440"/>
+            <a:off x="6659605" y="2495866"/>
+            <a:ext cx="512359" cy="236337"/>
           </a:xfrm>
           <a:prstGeom prst="rect">
             <a:avLst/>
@@ -10579,7 +10386,7 @@
           <p:cNvPr id="21" name="Graphic 20" descr="Paper outline">
             <a:extLst>
               <a:ext uri="{FF2B5EF4-FFF2-40B4-BE49-F238E27FC236}">
-                <a16:creationId xmlns:a16="http://schemas.microsoft.com/office/drawing/2014/main" id="{4FEA852B-480D-5CDF-09DE-C3D906189267}"/>
+                <a16:creationId xmlns:a16="http://schemas.microsoft.com/office/drawing/2014/main" id="{07CA3F83-63CA-0C79-678E-053EF217BA22}"/>
               </a:ext>
             </a:extLst>
           </p:cNvPr>
@@ -10595,7 +10402,7 @@
                 <a14:useLocalDpi xmlns:a14="http://schemas.microsoft.com/office/drawing/2010/main" val="0"/>
               </a:ext>
               <a:ext uri="{96DAC541-7B7A-43D3-8B79-37D633B846F1}">
-                <asvg:svgBlip xmlns:asvg="http://schemas.microsoft.com/office/drawing/2016/SVG/main" r:embed="rId4"/>
+                <asvg:svgBlip xmlns:asvg="http://schemas.microsoft.com/office/drawing/2016/SVG/main" r:embed="rId6"/>
               </a:ext>
             </a:extLst>
           </a:blip>
@@ -10605,8 +10412,8 @@
         </p:blipFill>
         <p:spPr>
           <a:xfrm>
-            <a:off x="6700650" y="1920240"/>
-            <a:ext cx="430268" cy="430268"/>
+            <a:off x="6700650" y="2106660"/>
+            <a:ext cx="430268" cy="430081"/>
           </a:xfrm>
           <a:prstGeom prst="rect">
             <a:avLst/>
@@ -10618,7 +10425,7 @@
           <p:cNvPr id="24" name="TextBox 23">
             <a:extLst>
               <a:ext uri="{FF2B5EF4-FFF2-40B4-BE49-F238E27FC236}">
-                <a16:creationId xmlns:a16="http://schemas.microsoft.com/office/drawing/2014/main" id="{C54BE284-B20F-08CC-7F93-F1B057953257}"/>
+                <a16:creationId xmlns:a16="http://schemas.microsoft.com/office/drawing/2014/main" id="{D8A6530F-64A5-4E7C-0794-E2059FE61B9F}"/>
               </a:ext>
             </a:extLst>
           </p:cNvPr>
@@ -10627,8 +10434,8 @@
         </p:nvSpPr>
         <p:spPr>
           <a:xfrm>
-            <a:off x="7942729" y="2295378"/>
-            <a:ext cx="512359" cy="236440"/>
+            <a:off x="7942729" y="2481635"/>
+            <a:ext cx="512359" cy="236337"/>
           </a:xfrm>
           <a:prstGeom prst="rect">
             <a:avLst/>
@@ -10698,7 +10505,7 @@
           <p:cNvPr id="25" name="Graphic 24" descr="Paper outline">
             <a:extLst>
               <a:ext uri="{FF2B5EF4-FFF2-40B4-BE49-F238E27FC236}">
-                <a16:creationId xmlns:a16="http://schemas.microsoft.com/office/drawing/2014/main" id="{1CD1528C-B0E6-2632-BB9F-D98503E41A54}"/>
+                <a16:creationId xmlns:a16="http://schemas.microsoft.com/office/drawing/2014/main" id="{690D7AB4-09A7-B7EB-D0EC-74FAA1C8F169}"/>
               </a:ext>
             </a:extLst>
           </p:cNvPr>
@@ -10714,7 +10521,7 @@
                 <a14:useLocalDpi xmlns:a14="http://schemas.microsoft.com/office/drawing/2010/main" val="0"/>
               </a:ext>
               <a:ext uri="{96DAC541-7B7A-43D3-8B79-37D633B846F1}">
-                <asvg:svgBlip xmlns:asvg="http://schemas.microsoft.com/office/drawing/2016/SVG/main" r:embed="rId4"/>
+                <asvg:svgBlip xmlns:asvg="http://schemas.microsoft.com/office/drawing/2016/SVG/main" r:embed="rId6"/>
               </a:ext>
             </a:extLst>
           </a:blip>
@@ -10724,8 +10531,8 @@
         </p:blipFill>
         <p:spPr>
           <a:xfrm>
-            <a:off x="7983775" y="1920889"/>
-            <a:ext cx="430268" cy="430268"/>
+            <a:off x="7983775" y="2107309"/>
+            <a:ext cx="430268" cy="430081"/>
           </a:xfrm>
           <a:prstGeom prst="rect">
             <a:avLst/>
@@ -10737,7 +10544,7 @@
           <p:cNvPr id="27" name="Graphic 26" descr="Folder outline">
             <a:extLst>
               <a:ext uri="{FF2B5EF4-FFF2-40B4-BE49-F238E27FC236}">
-                <a16:creationId xmlns:a16="http://schemas.microsoft.com/office/drawing/2014/main" id="{F63B833C-8CBD-F3D4-C8D1-50269F9DD7E5}"/>
+                <a16:creationId xmlns:a16="http://schemas.microsoft.com/office/drawing/2014/main" id="{42570192-FAC8-8B2E-343D-75F1EC9BB8A1}"/>
               </a:ext>
             </a:extLst>
           </p:cNvPr>
@@ -10753,7 +10560,7 @@
                 <a14:useLocalDpi xmlns:a14="http://schemas.microsoft.com/office/drawing/2010/main" val="0"/>
               </a:ext>
               <a:ext uri="{96DAC541-7B7A-43D3-8B79-37D633B846F1}">
-                <asvg:svgBlip xmlns:asvg="http://schemas.microsoft.com/office/drawing/2016/SVG/main" r:embed="rId5"/>
+                <asvg:svgBlip xmlns:asvg="http://schemas.microsoft.com/office/drawing/2016/SVG/main" r:embed="rId7"/>
               </a:ext>
             </a:extLst>
           </a:blip>
@@ -10763,8 +10570,8 @@
         </p:blipFill>
         <p:spPr>
           <a:xfrm>
-            <a:off x="5407260" y="1920240"/>
-            <a:ext cx="550611" cy="550611"/>
+            <a:off x="5407260" y="2106660"/>
+            <a:ext cx="550611" cy="550371"/>
           </a:xfrm>
           <a:prstGeom prst="rect">
             <a:avLst/>
@@ -10776,7 +10583,7 @@
           <p:cNvPr id="28" name="TextBox 27">
             <a:extLst>
               <a:ext uri="{FF2B5EF4-FFF2-40B4-BE49-F238E27FC236}">
-                <a16:creationId xmlns:a16="http://schemas.microsoft.com/office/drawing/2014/main" id="{C5A7E690-6F88-06FA-F12E-CEF74B1A6A77}"/>
+                <a16:creationId xmlns:a16="http://schemas.microsoft.com/office/drawing/2014/main" id="{12A58C2F-720F-A7E7-D067-384099172488}"/>
               </a:ext>
             </a:extLst>
           </p:cNvPr>
@@ -10785,8 +10592,8 @@
         </p:nvSpPr>
         <p:spPr>
           <a:xfrm>
-            <a:off x="5422867" y="2337169"/>
-            <a:ext cx="512359" cy="236440"/>
+            <a:off x="5422867" y="2523408"/>
+            <a:ext cx="512359" cy="236337"/>
           </a:xfrm>
           <a:prstGeom prst="rect">
             <a:avLst/>
@@ -10856,7 +10663,7 @@
           <p:cNvPr id="257" name="TextBox 256">
             <a:extLst>
               <a:ext uri="{FF2B5EF4-FFF2-40B4-BE49-F238E27FC236}">
-                <a16:creationId xmlns:a16="http://schemas.microsoft.com/office/drawing/2014/main" id="{7233FFDD-BDCD-208C-C124-8930A72318E7}"/>
+                <a16:creationId xmlns:a16="http://schemas.microsoft.com/office/drawing/2014/main" id="{A7F3AB39-AFBC-1E41-ABBC-972B9895210F}"/>
               </a:ext>
             </a:extLst>
           </p:cNvPr>
@@ -10865,8 +10672,8 @@
         </p:nvSpPr>
         <p:spPr>
           <a:xfrm>
-            <a:off x="6728820" y="8583326"/>
-            <a:ext cx="512359" cy="289742"/>
+            <a:off x="6728820" y="8766848"/>
+            <a:ext cx="512359" cy="289616"/>
           </a:xfrm>
           <a:prstGeom prst="rect">
             <a:avLst/>
@@ -10936,7 +10743,7 @@
           <p:cNvPr id="258" name="Graphic 257" descr="Paper outline">
             <a:extLst>
               <a:ext uri="{FF2B5EF4-FFF2-40B4-BE49-F238E27FC236}">
-                <a16:creationId xmlns:a16="http://schemas.microsoft.com/office/drawing/2014/main" id="{FFD5D4C7-99BB-54A7-2ADF-7754F57C5A0F}"/>
+                <a16:creationId xmlns:a16="http://schemas.microsoft.com/office/drawing/2014/main" id="{9E496988-004B-62B8-AE33-325F805838E4}"/>
               </a:ext>
             </a:extLst>
           </p:cNvPr>
@@ -10952,7 +10759,7 @@
                 <a14:useLocalDpi xmlns:a14="http://schemas.microsoft.com/office/drawing/2010/main" val="0"/>
               </a:ext>
               <a:ext uri="{96DAC541-7B7A-43D3-8B79-37D633B846F1}">
-                <asvg:svgBlip xmlns:asvg="http://schemas.microsoft.com/office/drawing/2016/SVG/main" r:embed="rId4"/>
+                <asvg:svgBlip xmlns:asvg="http://schemas.microsoft.com/office/drawing/2016/SVG/main" r:embed="rId6"/>
               </a:ext>
             </a:extLst>
           </a:blip>
@@ -10962,8 +10769,8 @@
         </p:blipFill>
         <p:spPr>
           <a:xfrm>
-            <a:off x="6769866" y="8235488"/>
-            <a:ext cx="430268" cy="430268"/>
+            <a:off x="6769866" y="8419161"/>
+            <a:ext cx="430268" cy="430081"/>
           </a:xfrm>
           <a:prstGeom prst="rect">
             <a:avLst/>
@@ -10975,7 +10782,7 @@
           <p:cNvPr id="430" name="Table">
             <a:extLst>
               <a:ext uri="{FF2B5EF4-FFF2-40B4-BE49-F238E27FC236}">
-                <a16:creationId xmlns:a16="http://schemas.microsoft.com/office/drawing/2014/main" id="{CB16FD64-B883-9448-1EF0-4E8655977824}"/>
+                <a16:creationId xmlns:a16="http://schemas.microsoft.com/office/drawing/2014/main" id="{25CC114C-70E5-A4E7-49D2-C3D18C0C732B}"/>
               </a:ext>
             </a:extLst>
           </p:cNvPr>
@@ -10983,7 +10790,7 @@
           <p:nvPr/>
         </p:nvGraphicFramePr>
         <p:xfrm>
-          <a:off x="5717228" y="3657600"/>
+          <a:off x="5717228" y="3843265"/>
           <a:ext cx="418576" cy="593755"/>
         </p:xfrm>
         <a:graphic>
@@ -11652,7 +11459,7 @@
           <p:cNvPr id="431" name="Table">
             <a:extLst>
               <a:ext uri="{FF2B5EF4-FFF2-40B4-BE49-F238E27FC236}">
-                <a16:creationId xmlns:a16="http://schemas.microsoft.com/office/drawing/2014/main" id="{EAC8871A-5B43-7090-47A5-3686FDFF90A1}"/>
+                <a16:creationId xmlns:a16="http://schemas.microsoft.com/office/drawing/2014/main" id="{C18E3197-636C-C752-967E-3AACCA0210A1}"/>
               </a:ext>
             </a:extLst>
           </p:cNvPr>
@@ -11660,7 +11467,7 @@
           <p:nvPr/>
         </p:nvGraphicFramePr>
         <p:xfrm>
-          <a:off x="6459637" y="3657600"/>
+          <a:off x="6459637" y="3843265"/>
           <a:ext cx="418576" cy="593755"/>
         </p:xfrm>
         <a:graphic>
@@ -12329,7 +12136,7 @@
           <p:cNvPr id="432" name="Table">
             <a:extLst>
               <a:ext uri="{FF2B5EF4-FFF2-40B4-BE49-F238E27FC236}">
-                <a16:creationId xmlns:a16="http://schemas.microsoft.com/office/drawing/2014/main" id="{F49940EC-B134-F76C-63DD-2502E7245C70}"/>
+                <a16:creationId xmlns:a16="http://schemas.microsoft.com/office/drawing/2014/main" id="{EAF2C1DE-E382-7352-DDC5-60B1F11B879A}"/>
               </a:ext>
             </a:extLst>
           </p:cNvPr>
@@ -12337,7 +12144,7 @@
           <p:nvPr/>
         </p:nvGraphicFramePr>
         <p:xfrm>
-          <a:off x="6953164" y="3659028"/>
+          <a:off x="6953164" y="3844692"/>
           <a:ext cx="418576" cy="593755"/>
         </p:xfrm>
         <a:graphic>
@@ -13006,7 +12813,7 @@
           <p:cNvPr id="438" name="Table">
             <a:extLst>
               <a:ext uri="{FF2B5EF4-FFF2-40B4-BE49-F238E27FC236}">
-                <a16:creationId xmlns:a16="http://schemas.microsoft.com/office/drawing/2014/main" id="{6AE4D28F-F19A-AE75-7544-191C9079D48C}"/>
+                <a16:creationId xmlns:a16="http://schemas.microsoft.com/office/drawing/2014/main" id="{F48C1225-CFCE-1F1B-81FA-84EB65DD087A}"/>
               </a:ext>
             </a:extLst>
           </p:cNvPr>
@@ -13014,7 +12821,7 @@
           <p:nvPr/>
         </p:nvGraphicFramePr>
         <p:xfrm>
-          <a:off x="7737264" y="3657600"/>
+          <a:off x="7737264" y="3843265"/>
           <a:ext cx="418576" cy="593755"/>
         </p:xfrm>
         <a:graphic>
@@ -13683,7 +13490,7 @@
           <p:cNvPr id="439" name="Table">
             <a:extLst>
               <a:ext uri="{FF2B5EF4-FFF2-40B4-BE49-F238E27FC236}">
-                <a16:creationId xmlns:a16="http://schemas.microsoft.com/office/drawing/2014/main" id="{B099E51E-97F6-7EDE-EE76-AEEBCFCBE56C}"/>
+                <a16:creationId xmlns:a16="http://schemas.microsoft.com/office/drawing/2014/main" id="{9461E282-5754-E120-8E1D-56FDCDE2C9D2}"/>
               </a:ext>
             </a:extLst>
           </p:cNvPr>
@@ -13691,7 +13498,7 @@
           <p:nvPr/>
         </p:nvGraphicFramePr>
         <p:xfrm>
-          <a:off x="8230791" y="3657600"/>
+          <a:off x="8230791" y="3843265"/>
           <a:ext cx="418576" cy="593755"/>
         </p:xfrm>
         <a:graphic>
@@ -14360,7 +14167,7 @@
           <p:cNvPr id="317" name="Google Shape;156;p1">
             <a:extLst>
               <a:ext uri="{FF2B5EF4-FFF2-40B4-BE49-F238E27FC236}">
-                <a16:creationId xmlns:a16="http://schemas.microsoft.com/office/drawing/2014/main" id="{A9F13FB3-3D3E-3A11-3EA2-C4EBEE59A380}"/>
+                <a16:creationId xmlns:a16="http://schemas.microsoft.com/office/drawing/2014/main" id="{0158E966-E67D-6B5A-0150-C85F2D9F61A0}"/>
               </a:ext>
             </a:extLst>
           </p:cNvPr>
@@ -14369,8 +14176,8 @@
         </p:nvGrpSpPr>
         <p:grpSpPr>
           <a:xfrm>
-            <a:off x="7852504" y="6496126"/>
-            <a:ext cx="1357791" cy="804343"/>
+            <a:off x="7852504" y="6680556"/>
+            <a:ext cx="1357791" cy="803993"/>
             <a:chOff x="10592773" y="5229745"/>
             <a:chExt cx="3298954" cy="1741391"/>
           </a:xfrm>
@@ -14380,7 +14187,7 @@
             <p:cNvPr id="318" name="Google Shape;157;p1">
               <a:extLst>
                 <a:ext uri="{FF2B5EF4-FFF2-40B4-BE49-F238E27FC236}">
-                  <a16:creationId xmlns:a16="http://schemas.microsoft.com/office/drawing/2014/main" id="{30A40027-A839-D0B8-3617-DC63B61CE48F}"/>
+                  <a16:creationId xmlns:a16="http://schemas.microsoft.com/office/drawing/2014/main" id="{41E9CF99-D074-0959-17C6-4454221CCD8C}"/>
                 </a:ext>
               </a:extLst>
             </p:cNvPr>
@@ -14447,7 +14254,7 @@
             <p:cNvPr id="320" name="Google Shape;158;p1">
               <a:extLst>
                 <a:ext uri="{FF2B5EF4-FFF2-40B4-BE49-F238E27FC236}">
-                  <a16:creationId xmlns:a16="http://schemas.microsoft.com/office/drawing/2014/main" id="{AFB630B6-28BD-C342-280D-AACBF7F4DAA6}"/>
+                  <a16:creationId xmlns:a16="http://schemas.microsoft.com/office/drawing/2014/main" id="{3AAE314C-BBD1-11BB-4F46-13F5B495C1C2}"/>
                 </a:ext>
               </a:extLst>
             </p:cNvPr>
@@ -14514,7 +14321,7 @@
             <p:cNvPr id="321" name="Google Shape;159;p1">
               <a:extLst>
                 <a:ext uri="{FF2B5EF4-FFF2-40B4-BE49-F238E27FC236}">
-                  <a16:creationId xmlns:a16="http://schemas.microsoft.com/office/drawing/2014/main" id="{99AFE83E-96B4-9692-0F17-C0CD3AD96C52}"/>
+                  <a16:creationId xmlns:a16="http://schemas.microsoft.com/office/drawing/2014/main" id="{E1B57EED-8DF9-ED5B-88B8-B08B404A5267}"/>
                 </a:ext>
               </a:extLst>
             </p:cNvPr>
@@ -14581,7 +14388,7 @@
             <p:cNvPr id="322" name="Google Shape;160;p1">
               <a:extLst>
                 <a:ext uri="{FF2B5EF4-FFF2-40B4-BE49-F238E27FC236}">
-                  <a16:creationId xmlns:a16="http://schemas.microsoft.com/office/drawing/2014/main" id="{593E0308-5052-1036-ECC2-B90E19E6B744}"/>
+                  <a16:creationId xmlns:a16="http://schemas.microsoft.com/office/drawing/2014/main" id="{69D025CB-662A-5FBE-6913-1B4BA693CAE2}"/>
                 </a:ext>
               </a:extLst>
             </p:cNvPr>
@@ -14648,7 +14455,7 @@
             <p:cNvPr id="325" name="Google Shape;161;p1">
               <a:extLst>
                 <a:ext uri="{FF2B5EF4-FFF2-40B4-BE49-F238E27FC236}">
-                  <a16:creationId xmlns:a16="http://schemas.microsoft.com/office/drawing/2014/main" id="{0FAA659A-A1D8-E2D1-26FF-5B0AF68484F4}"/>
+                  <a16:creationId xmlns:a16="http://schemas.microsoft.com/office/drawing/2014/main" id="{8A1B0188-47AB-9FF1-2E5A-910BB3704BDF}"/>
                 </a:ext>
               </a:extLst>
             </p:cNvPr>
@@ -14715,7 +14522,7 @@
             <p:cNvPr id="327" name="Google Shape;162;p1">
               <a:extLst>
                 <a:ext uri="{FF2B5EF4-FFF2-40B4-BE49-F238E27FC236}">
-                  <a16:creationId xmlns:a16="http://schemas.microsoft.com/office/drawing/2014/main" id="{6793045B-5084-8B26-9586-3EBE30030213}"/>
+                  <a16:creationId xmlns:a16="http://schemas.microsoft.com/office/drawing/2014/main" id="{EC0FE858-DD5D-6C70-9442-C79177604F48}"/>
                 </a:ext>
               </a:extLst>
             </p:cNvPr>
@@ -14786,7 +14593,7 @@
             <p:cNvPr id="328" name="Google Shape;163;p1">
               <a:extLst>
                 <a:ext uri="{FF2B5EF4-FFF2-40B4-BE49-F238E27FC236}">
-                  <a16:creationId xmlns:a16="http://schemas.microsoft.com/office/drawing/2014/main" id="{759363F7-56AF-1185-8F87-E17E294CEBB7}"/>
+                  <a16:creationId xmlns:a16="http://schemas.microsoft.com/office/drawing/2014/main" id="{733A8C9B-C02F-0EBE-EEE6-C212C4B8954E}"/>
                 </a:ext>
               </a:extLst>
             </p:cNvPr>
@@ -14857,7 +14664,7 @@
             <p:cNvPr id="329" name="Google Shape;164;p1">
               <a:extLst>
                 <a:ext uri="{FF2B5EF4-FFF2-40B4-BE49-F238E27FC236}">
-                  <a16:creationId xmlns:a16="http://schemas.microsoft.com/office/drawing/2014/main" id="{12B9438C-9C9D-943B-814B-D4B1AEE4A097}"/>
+                  <a16:creationId xmlns:a16="http://schemas.microsoft.com/office/drawing/2014/main" id="{E40F8FA1-F0E8-414C-B0CB-254ABB981C3B}"/>
                 </a:ext>
               </a:extLst>
             </p:cNvPr>
@@ -14928,7 +14735,7 @@
             <p:cNvPr id="331" name="Google Shape;165;p1">
               <a:extLst>
                 <a:ext uri="{FF2B5EF4-FFF2-40B4-BE49-F238E27FC236}">
-                  <a16:creationId xmlns:a16="http://schemas.microsoft.com/office/drawing/2014/main" id="{7A09D6D5-8641-3AD4-3837-21FC3935B266}"/>
+                  <a16:creationId xmlns:a16="http://schemas.microsoft.com/office/drawing/2014/main" id="{96000E3D-E359-7575-10EA-90EE26C7EA6B}"/>
                 </a:ext>
               </a:extLst>
             </p:cNvPr>
@@ -14999,7 +14806,7 @@
             <p:cNvPr id="332" name="Google Shape;166;p1">
               <a:extLst>
                 <a:ext uri="{FF2B5EF4-FFF2-40B4-BE49-F238E27FC236}">
-                  <a16:creationId xmlns:a16="http://schemas.microsoft.com/office/drawing/2014/main" id="{CFF58CDE-D609-80B3-93D5-84F243C8A525}"/>
+                  <a16:creationId xmlns:a16="http://schemas.microsoft.com/office/drawing/2014/main" id="{FE078879-34D5-C80B-0AD5-5AF48CB4CAA8}"/>
                 </a:ext>
               </a:extLst>
             </p:cNvPr>
@@ -15066,7 +14873,7 @@
             <p:cNvPr id="333" name="Google Shape;167;p1">
               <a:extLst>
                 <a:ext uri="{FF2B5EF4-FFF2-40B4-BE49-F238E27FC236}">
-                  <a16:creationId xmlns:a16="http://schemas.microsoft.com/office/drawing/2014/main" id="{3F6E6C49-97AE-1D4C-147F-8E0FA553D797}"/>
+                  <a16:creationId xmlns:a16="http://schemas.microsoft.com/office/drawing/2014/main" id="{5F0E77EB-AAE6-4CEA-56BC-E6CDFBED6D4B}"/>
                 </a:ext>
               </a:extLst>
             </p:cNvPr>
@@ -15133,7 +14940,7 @@
             <p:cNvPr id="335" name="Google Shape;168;p1">
               <a:extLst>
                 <a:ext uri="{FF2B5EF4-FFF2-40B4-BE49-F238E27FC236}">
-                  <a16:creationId xmlns:a16="http://schemas.microsoft.com/office/drawing/2014/main" id="{47F5962B-7439-3365-D29B-F306D7BF5A54}"/>
+                  <a16:creationId xmlns:a16="http://schemas.microsoft.com/office/drawing/2014/main" id="{92AFFEA9-3D24-24ED-60B0-0D0A9467841A}"/>
                 </a:ext>
               </a:extLst>
             </p:cNvPr>
@@ -15200,7 +15007,7 @@
             <p:cNvPr id="336" name="Google Shape;169;p1">
               <a:extLst>
                 <a:ext uri="{FF2B5EF4-FFF2-40B4-BE49-F238E27FC236}">
-                  <a16:creationId xmlns:a16="http://schemas.microsoft.com/office/drawing/2014/main" id="{1543EE12-C641-ABF8-5DED-E88D4C1AA66E}"/>
+                  <a16:creationId xmlns:a16="http://schemas.microsoft.com/office/drawing/2014/main" id="{B0EF182C-447B-EC7D-42FB-8ECC2AC3CC9C}"/>
                 </a:ext>
               </a:extLst>
             </p:cNvPr>
@@ -15267,7 +15074,7 @@
             <p:cNvPr id="337" name="Google Shape;170;p1">
               <a:extLst>
                 <a:ext uri="{FF2B5EF4-FFF2-40B4-BE49-F238E27FC236}">
-                  <a16:creationId xmlns:a16="http://schemas.microsoft.com/office/drawing/2014/main" id="{74867DDF-0E33-C0EC-DDAA-E9B62DEA31C9}"/>
+                  <a16:creationId xmlns:a16="http://schemas.microsoft.com/office/drawing/2014/main" id="{B01695C2-F4BC-02EB-EC48-2A0AC7160AA2}"/>
                 </a:ext>
               </a:extLst>
             </p:cNvPr>
@@ -15334,7 +15141,7 @@
             <p:cNvPr id="338" name="Google Shape;171;p1">
               <a:extLst>
                 <a:ext uri="{FF2B5EF4-FFF2-40B4-BE49-F238E27FC236}">
-                  <a16:creationId xmlns:a16="http://schemas.microsoft.com/office/drawing/2014/main" id="{5D2CC866-403B-6F34-FAD9-0B0E6B96177D}"/>
+                  <a16:creationId xmlns:a16="http://schemas.microsoft.com/office/drawing/2014/main" id="{8819D081-CA03-7BEA-F274-1647708F9573}"/>
                 </a:ext>
               </a:extLst>
             </p:cNvPr>
@@ -15405,7 +15212,7 @@
             <p:cNvPr id="339" name="Google Shape;172;p1">
               <a:extLst>
                 <a:ext uri="{FF2B5EF4-FFF2-40B4-BE49-F238E27FC236}">
-                  <a16:creationId xmlns:a16="http://schemas.microsoft.com/office/drawing/2014/main" id="{DF86432C-0CE6-884A-190A-138CDE7792CA}"/>
+                  <a16:creationId xmlns:a16="http://schemas.microsoft.com/office/drawing/2014/main" id="{4685C659-1121-0CFF-7E16-927EF1B3F87E}"/>
                 </a:ext>
               </a:extLst>
             </p:cNvPr>
@@ -15440,7 +15247,7 @@
             <p:cNvPr id="340" name="Google Shape;173;p1">
               <a:extLst>
                 <a:ext uri="{FF2B5EF4-FFF2-40B4-BE49-F238E27FC236}">
-                  <a16:creationId xmlns:a16="http://schemas.microsoft.com/office/drawing/2014/main" id="{F1E67139-FAD1-B29A-9D44-17487CE0A730}"/>
+                  <a16:creationId xmlns:a16="http://schemas.microsoft.com/office/drawing/2014/main" id="{B3F47F9F-24B2-3FFC-B213-CC3B39F196D8}"/>
                 </a:ext>
               </a:extLst>
             </p:cNvPr>
@@ -15475,7 +15282,7 @@
             <p:cNvPr id="343" name="Google Shape;175;p1">
               <a:extLst>
                 <a:ext uri="{FF2B5EF4-FFF2-40B4-BE49-F238E27FC236}">
-                  <a16:creationId xmlns:a16="http://schemas.microsoft.com/office/drawing/2014/main" id="{2971FC46-2FFC-39ED-4D57-5A40A8F78A09}"/>
+                  <a16:creationId xmlns:a16="http://schemas.microsoft.com/office/drawing/2014/main" id="{65C31327-7037-74CC-3BD8-B1D0C9CD9974}"/>
                 </a:ext>
               </a:extLst>
             </p:cNvPr>
@@ -15510,7 +15317,7 @@
             <p:cNvPr id="344" name="Google Shape;177;p1">
               <a:extLst>
                 <a:ext uri="{FF2B5EF4-FFF2-40B4-BE49-F238E27FC236}">
-                  <a16:creationId xmlns:a16="http://schemas.microsoft.com/office/drawing/2014/main" id="{3B1F8C53-C32A-803D-601F-3AFD43E348F9}"/>
+                  <a16:creationId xmlns:a16="http://schemas.microsoft.com/office/drawing/2014/main" id="{4E6BF0F0-C4F4-DF9C-CA72-6E576DCB984F}"/>
                 </a:ext>
               </a:extLst>
             </p:cNvPr>
@@ -15545,7 +15352,7 @@
             <p:cNvPr id="345" name="Google Shape;178;p1">
               <a:extLst>
                 <a:ext uri="{FF2B5EF4-FFF2-40B4-BE49-F238E27FC236}">
-                  <a16:creationId xmlns:a16="http://schemas.microsoft.com/office/drawing/2014/main" id="{761A1E3A-A829-B76E-8405-CA01D887FBC9}"/>
+                  <a16:creationId xmlns:a16="http://schemas.microsoft.com/office/drawing/2014/main" id="{1E2C7CE4-2ED2-9DB2-946A-45A3BF371A64}"/>
                 </a:ext>
               </a:extLst>
             </p:cNvPr>
@@ -15580,7 +15387,7 @@
             <p:cNvPr id="346" name="Google Shape;179;p1">
               <a:extLst>
                 <a:ext uri="{FF2B5EF4-FFF2-40B4-BE49-F238E27FC236}">
-                  <a16:creationId xmlns:a16="http://schemas.microsoft.com/office/drawing/2014/main" id="{46CD6C9E-C4E6-2630-0058-1234E1F7F9D1}"/>
+                  <a16:creationId xmlns:a16="http://schemas.microsoft.com/office/drawing/2014/main" id="{11ABFE85-C1E6-58D8-C798-F5C0590B2966}"/>
                 </a:ext>
               </a:extLst>
             </p:cNvPr>
@@ -15615,7 +15422,7 @@
             <p:cNvPr id="347" name="Google Shape;180;p1">
               <a:extLst>
                 <a:ext uri="{FF2B5EF4-FFF2-40B4-BE49-F238E27FC236}">
-                  <a16:creationId xmlns:a16="http://schemas.microsoft.com/office/drawing/2014/main" id="{2F0485EA-2BA7-B53F-24A8-03FCACC3C2F6}"/>
+                  <a16:creationId xmlns:a16="http://schemas.microsoft.com/office/drawing/2014/main" id="{4455BD7D-B029-AA39-E5F2-1189B831F1D4}"/>
                 </a:ext>
               </a:extLst>
             </p:cNvPr>
@@ -15650,7 +15457,7 @@
             <p:cNvPr id="348" name="Google Shape;181;p1">
               <a:extLst>
                 <a:ext uri="{FF2B5EF4-FFF2-40B4-BE49-F238E27FC236}">
-                  <a16:creationId xmlns:a16="http://schemas.microsoft.com/office/drawing/2014/main" id="{C84DB7F6-FD22-568B-07D3-C23AE332C39A}"/>
+                  <a16:creationId xmlns:a16="http://schemas.microsoft.com/office/drawing/2014/main" id="{99850B13-20E6-BC1B-9DB0-EAD6FDD7F9D3}"/>
                 </a:ext>
               </a:extLst>
             </p:cNvPr>
@@ -15685,7 +15492,7 @@
             <p:cNvPr id="349" name="Google Shape;183;p1">
               <a:extLst>
                 <a:ext uri="{FF2B5EF4-FFF2-40B4-BE49-F238E27FC236}">
-                  <a16:creationId xmlns:a16="http://schemas.microsoft.com/office/drawing/2014/main" id="{0262F3FA-8E18-E811-62E0-7C69EF9EFE3C}"/>
+                  <a16:creationId xmlns:a16="http://schemas.microsoft.com/office/drawing/2014/main" id="{C3D42A44-927E-2214-21A1-C211D39167C5}"/>
                 </a:ext>
               </a:extLst>
             </p:cNvPr>
@@ -15720,7 +15527,7 @@
             <p:cNvPr id="350" name="Google Shape;176;p1">
               <a:extLst>
                 <a:ext uri="{FF2B5EF4-FFF2-40B4-BE49-F238E27FC236}">
-                  <a16:creationId xmlns:a16="http://schemas.microsoft.com/office/drawing/2014/main" id="{EEDA684D-0083-DD67-4847-C5C5F9A1898D}"/>
+                  <a16:creationId xmlns:a16="http://schemas.microsoft.com/office/drawing/2014/main" id="{7B09A09C-A213-2C8E-0950-D5A0F4296B1F}"/>
                 </a:ext>
               </a:extLst>
             </p:cNvPr>
@@ -15787,7 +15594,7 @@
             <p:cNvPr id="351" name="Google Shape;184;p1">
               <a:extLst>
                 <a:ext uri="{FF2B5EF4-FFF2-40B4-BE49-F238E27FC236}">
-                  <a16:creationId xmlns:a16="http://schemas.microsoft.com/office/drawing/2014/main" id="{B632B478-8C9F-E433-0308-D2A8F5964AF8}"/>
+                  <a16:creationId xmlns:a16="http://schemas.microsoft.com/office/drawing/2014/main" id="{0D75B026-97F0-C73B-4230-76A4D97BE498}"/>
                 </a:ext>
               </a:extLst>
             </p:cNvPr>
@@ -15822,7 +15629,7 @@
             <p:cNvPr id="352" name="Google Shape;185;p1">
               <a:extLst>
                 <a:ext uri="{FF2B5EF4-FFF2-40B4-BE49-F238E27FC236}">
-                  <a16:creationId xmlns:a16="http://schemas.microsoft.com/office/drawing/2014/main" id="{B55D6418-410E-55D2-EB7E-91EBD451D1C9}"/>
+                  <a16:creationId xmlns:a16="http://schemas.microsoft.com/office/drawing/2014/main" id="{B3FC0A11-00AE-479F-6C17-59B8AB54C76D}"/>
                 </a:ext>
               </a:extLst>
             </p:cNvPr>
@@ -15857,7 +15664,7 @@
             <p:cNvPr id="353" name="Google Shape;174;p1">
               <a:extLst>
                 <a:ext uri="{FF2B5EF4-FFF2-40B4-BE49-F238E27FC236}">
-                  <a16:creationId xmlns:a16="http://schemas.microsoft.com/office/drawing/2014/main" id="{6BE61C55-EEC0-9C62-C430-C350F8EDA989}"/>
+                  <a16:creationId xmlns:a16="http://schemas.microsoft.com/office/drawing/2014/main" id="{D0C971A5-CF18-2AFD-990B-E178831C7A90}"/>
                 </a:ext>
               </a:extLst>
             </p:cNvPr>
@@ -15924,7 +15731,7 @@
             <p:cNvPr id="354" name="Google Shape;186;p1">
               <a:extLst>
                 <a:ext uri="{FF2B5EF4-FFF2-40B4-BE49-F238E27FC236}">
-                  <a16:creationId xmlns:a16="http://schemas.microsoft.com/office/drawing/2014/main" id="{0E433740-ADE1-6A64-E7C3-4948C4DA3EE0}"/>
+                  <a16:creationId xmlns:a16="http://schemas.microsoft.com/office/drawing/2014/main" id="{4AD5222D-51FB-C3FE-4829-F9E0006F8477}"/>
                 </a:ext>
               </a:extLst>
             </p:cNvPr>
@@ -15959,7 +15766,7 @@
             <p:cNvPr id="356" name="Google Shape;189;p1">
               <a:extLst>
                 <a:ext uri="{FF2B5EF4-FFF2-40B4-BE49-F238E27FC236}">
-                  <a16:creationId xmlns:a16="http://schemas.microsoft.com/office/drawing/2014/main" id="{3776BDCC-B499-8497-AC33-5615906E3728}"/>
+                  <a16:creationId xmlns:a16="http://schemas.microsoft.com/office/drawing/2014/main" id="{C725637A-3046-4573-85C8-1425AF142727}"/>
                 </a:ext>
               </a:extLst>
             </p:cNvPr>
@@ -15994,7 +15801,7 @@
             <p:cNvPr id="357" name="Google Shape;190;p1">
               <a:extLst>
                 <a:ext uri="{FF2B5EF4-FFF2-40B4-BE49-F238E27FC236}">
-                  <a16:creationId xmlns:a16="http://schemas.microsoft.com/office/drawing/2014/main" id="{24A57129-F624-3AC9-4C31-B8BE5D41A582}"/>
+                  <a16:creationId xmlns:a16="http://schemas.microsoft.com/office/drawing/2014/main" id="{19307BF5-8CC1-14EB-2BEE-9BD7EB2E476D}"/>
                 </a:ext>
               </a:extLst>
             </p:cNvPr>
@@ -16029,7 +15836,7 @@
             <p:cNvPr id="358" name="Google Shape;191;p1">
               <a:extLst>
                 <a:ext uri="{FF2B5EF4-FFF2-40B4-BE49-F238E27FC236}">
-                  <a16:creationId xmlns:a16="http://schemas.microsoft.com/office/drawing/2014/main" id="{F5787252-753E-C987-20A0-EEE5A0FE94B7}"/>
+                  <a16:creationId xmlns:a16="http://schemas.microsoft.com/office/drawing/2014/main" id="{06201B3E-0828-E018-16CB-0C87EF8B372B}"/>
                 </a:ext>
               </a:extLst>
             </p:cNvPr>
@@ -16064,7 +15871,7 @@
             <p:cNvPr id="359" name="Google Shape;188;p1">
               <a:extLst>
                 <a:ext uri="{FF2B5EF4-FFF2-40B4-BE49-F238E27FC236}">
-                  <a16:creationId xmlns:a16="http://schemas.microsoft.com/office/drawing/2014/main" id="{5CA78F51-D947-7017-E2AE-F237C4508516}"/>
+                  <a16:creationId xmlns:a16="http://schemas.microsoft.com/office/drawing/2014/main" id="{FFFC5538-A06F-8371-DDD4-8BB3F74FEBEA}"/>
                 </a:ext>
               </a:extLst>
             </p:cNvPr>
@@ -16135,7 +15942,7 @@
             <p:cNvPr id="360" name="Google Shape;192;p1">
               <a:extLst>
                 <a:ext uri="{FF2B5EF4-FFF2-40B4-BE49-F238E27FC236}">
-                  <a16:creationId xmlns:a16="http://schemas.microsoft.com/office/drawing/2014/main" id="{5CD577ED-94DC-24BB-D81C-0E577A3BA4B9}"/>
+                  <a16:creationId xmlns:a16="http://schemas.microsoft.com/office/drawing/2014/main" id="{5C73D85D-5490-D03C-3740-3157670EF86F}"/>
                 </a:ext>
               </a:extLst>
             </p:cNvPr>
@@ -16170,7 +15977,7 @@
             <p:cNvPr id="361" name="Google Shape;182;p1">
               <a:extLst>
                 <a:ext uri="{FF2B5EF4-FFF2-40B4-BE49-F238E27FC236}">
-                  <a16:creationId xmlns:a16="http://schemas.microsoft.com/office/drawing/2014/main" id="{7DA0D374-EA1B-E0F0-429E-E5924135BF52}"/>
+                  <a16:creationId xmlns:a16="http://schemas.microsoft.com/office/drawing/2014/main" id="{3A867F5B-D8DE-417E-AE8A-A26CD624B6AF}"/>
                 </a:ext>
               </a:extLst>
             </p:cNvPr>
@@ -16237,7 +16044,7 @@
             <p:cNvPr id="362" name="Google Shape;193;p1">
               <a:extLst>
                 <a:ext uri="{FF2B5EF4-FFF2-40B4-BE49-F238E27FC236}">
-                  <a16:creationId xmlns:a16="http://schemas.microsoft.com/office/drawing/2014/main" id="{BA1F2F60-0846-820D-62D5-533CD0BD34CD}"/>
+                  <a16:creationId xmlns:a16="http://schemas.microsoft.com/office/drawing/2014/main" id="{B4E7487C-F39E-4229-EE08-4A7DE071E01A}"/>
                 </a:ext>
               </a:extLst>
             </p:cNvPr>
@@ -16272,7 +16079,7 @@
             <p:cNvPr id="363" name="Google Shape;194;p1">
               <a:extLst>
                 <a:ext uri="{FF2B5EF4-FFF2-40B4-BE49-F238E27FC236}">
-                  <a16:creationId xmlns:a16="http://schemas.microsoft.com/office/drawing/2014/main" id="{D00A0B20-11BF-C665-C876-CA710C41E238}"/>
+                  <a16:creationId xmlns:a16="http://schemas.microsoft.com/office/drawing/2014/main" id="{BF411E53-3BD9-6199-D988-29D2B4BECC79}"/>
                 </a:ext>
               </a:extLst>
             </p:cNvPr>
@@ -16307,7 +16114,7 @@
             <p:cNvPr id="364" name="Google Shape;195;p1">
               <a:extLst>
                 <a:ext uri="{FF2B5EF4-FFF2-40B4-BE49-F238E27FC236}">
-                  <a16:creationId xmlns:a16="http://schemas.microsoft.com/office/drawing/2014/main" id="{EAD61222-5EF4-F4DD-5D9D-22894517C365}"/>
+                  <a16:creationId xmlns:a16="http://schemas.microsoft.com/office/drawing/2014/main" id="{F65D38E2-2A58-FC59-3B5D-FBA716A13D12}"/>
                 </a:ext>
               </a:extLst>
             </p:cNvPr>
@@ -16342,7 +16149,7 @@
             <p:cNvPr id="366" name="Google Shape;197;p1">
               <a:extLst>
                 <a:ext uri="{FF2B5EF4-FFF2-40B4-BE49-F238E27FC236}">
-                  <a16:creationId xmlns:a16="http://schemas.microsoft.com/office/drawing/2014/main" id="{BA7F2B51-87C7-9A55-2404-54A72CD607F3}"/>
+                  <a16:creationId xmlns:a16="http://schemas.microsoft.com/office/drawing/2014/main" id="{22F91CD4-0064-64EC-E0B6-4D33EB5D5023}"/>
                 </a:ext>
               </a:extLst>
             </p:cNvPr>
@@ -16378,7 +16185,7 @@
           <p:cNvPr id="32" name="Google Shape;156;p1">
             <a:extLst>
               <a:ext uri="{FF2B5EF4-FFF2-40B4-BE49-F238E27FC236}">
-                <a16:creationId xmlns:a16="http://schemas.microsoft.com/office/drawing/2014/main" id="{74FBC34A-1C36-2268-A222-2B6D0B35A8D2}"/>
+                <a16:creationId xmlns:a16="http://schemas.microsoft.com/office/drawing/2014/main" id="{80D7FD95-FE74-7E10-376E-D7EC02AA64AB}"/>
               </a:ext>
             </a:extLst>
           </p:cNvPr>
@@ -16387,8 +16194,8 @@
         </p:nvGrpSpPr>
         <p:grpSpPr>
           <a:xfrm>
-            <a:off x="6353314" y="6492240"/>
-            <a:ext cx="1361060" cy="803822"/>
+            <a:off x="6353314" y="6676671"/>
+            <a:ext cx="1361060" cy="803472"/>
             <a:chOff x="10592773" y="5229745"/>
             <a:chExt cx="3298954" cy="1741391"/>
           </a:xfrm>
@@ -16398,7 +16205,7 @@
             <p:cNvPr id="33" name="Google Shape;157;p1">
               <a:extLst>
                 <a:ext uri="{FF2B5EF4-FFF2-40B4-BE49-F238E27FC236}">
-                  <a16:creationId xmlns:a16="http://schemas.microsoft.com/office/drawing/2014/main" id="{5BE52E71-A987-B066-BD71-8B1D332E76F6}"/>
+                  <a16:creationId xmlns:a16="http://schemas.microsoft.com/office/drawing/2014/main" id="{4C7378CF-ACA5-3AFA-A838-BC91891E20AC}"/>
                 </a:ext>
               </a:extLst>
             </p:cNvPr>
@@ -16469,7 +16276,7 @@
             <p:cNvPr id="35" name="Google Shape;158;p1">
               <a:extLst>
                 <a:ext uri="{FF2B5EF4-FFF2-40B4-BE49-F238E27FC236}">
-                  <a16:creationId xmlns:a16="http://schemas.microsoft.com/office/drawing/2014/main" id="{E551ED69-4E13-8C52-E6CE-24FE4911C850}"/>
+                  <a16:creationId xmlns:a16="http://schemas.microsoft.com/office/drawing/2014/main" id="{7DF95635-8A24-4936-C10B-B6B9D109343B}"/>
                 </a:ext>
               </a:extLst>
             </p:cNvPr>
@@ -16536,7 +16343,7 @@
             <p:cNvPr id="36" name="Google Shape;159;p1">
               <a:extLst>
                 <a:ext uri="{FF2B5EF4-FFF2-40B4-BE49-F238E27FC236}">
-                  <a16:creationId xmlns:a16="http://schemas.microsoft.com/office/drawing/2014/main" id="{07B2708A-F49A-720B-2E1D-1C16C78C41A7}"/>
+                  <a16:creationId xmlns:a16="http://schemas.microsoft.com/office/drawing/2014/main" id="{410AB6B3-CDE5-7C1F-FC07-3EF14434CE2F}"/>
                 </a:ext>
               </a:extLst>
             </p:cNvPr>
@@ -16603,7 +16410,7 @@
             <p:cNvPr id="37" name="Google Shape;160;p1">
               <a:extLst>
                 <a:ext uri="{FF2B5EF4-FFF2-40B4-BE49-F238E27FC236}">
-                  <a16:creationId xmlns:a16="http://schemas.microsoft.com/office/drawing/2014/main" id="{BAFC5518-F1AA-76A0-659D-7802FACC6115}"/>
+                  <a16:creationId xmlns:a16="http://schemas.microsoft.com/office/drawing/2014/main" id="{B3F9F454-5154-7AE5-83EE-06BDF50BF928}"/>
                 </a:ext>
               </a:extLst>
             </p:cNvPr>
@@ -16670,7 +16477,7 @@
             <p:cNvPr id="38" name="Google Shape;161;p1">
               <a:extLst>
                 <a:ext uri="{FF2B5EF4-FFF2-40B4-BE49-F238E27FC236}">
-                  <a16:creationId xmlns:a16="http://schemas.microsoft.com/office/drawing/2014/main" id="{961A7F1B-E616-20AB-46F5-E7B481EE9B68}"/>
+                  <a16:creationId xmlns:a16="http://schemas.microsoft.com/office/drawing/2014/main" id="{ECDC64A3-B6A7-8305-1311-BA36CFB7FA06}"/>
                 </a:ext>
               </a:extLst>
             </p:cNvPr>
@@ -16737,7 +16544,7 @@
             <p:cNvPr id="39" name="Google Shape;162;p1">
               <a:extLst>
                 <a:ext uri="{FF2B5EF4-FFF2-40B4-BE49-F238E27FC236}">
-                  <a16:creationId xmlns:a16="http://schemas.microsoft.com/office/drawing/2014/main" id="{3C35BDAD-0CB2-3093-C460-786F202105B2}"/>
+                  <a16:creationId xmlns:a16="http://schemas.microsoft.com/office/drawing/2014/main" id="{57D14F82-E97C-B0A3-586B-7B365A985E78}"/>
                 </a:ext>
               </a:extLst>
             </p:cNvPr>
@@ -16808,7 +16615,7 @@
             <p:cNvPr id="40" name="Google Shape;163;p1">
               <a:extLst>
                 <a:ext uri="{FF2B5EF4-FFF2-40B4-BE49-F238E27FC236}">
-                  <a16:creationId xmlns:a16="http://schemas.microsoft.com/office/drawing/2014/main" id="{F642DCFC-61DA-EB65-5E63-4C52AA5B10A2}"/>
+                  <a16:creationId xmlns:a16="http://schemas.microsoft.com/office/drawing/2014/main" id="{F7BCFA43-5019-7127-115E-9AFBB4E87CDF}"/>
                 </a:ext>
               </a:extLst>
             </p:cNvPr>
@@ -16881,7 +16688,7 @@
             <p:cNvPr id="44" name="Google Shape;164;p1">
               <a:extLst>
                 <a:ext uri="{FF2B5EF4-FFF2-40B4-BE49-F238E27FC236}">
-                  <a16:creationId xmlns:a16="http://schemas.microsoft.com/office/drawing/2014/main" id="{E39858C0-8CAC-F1CE-E626-32D958E24D20}"/>
+                  <a16:creationId xmlns:a16="http://schemas.microsoft.com/office/drawing/2014/main" id="{2ED99CAF-D453-E1AD-387B-4BD33D015385}"/>
                 </a:ext>
               </a:extLst>
             </p:cNvPr>
@@ -16952,7 +16759,7 @@
             <p:cNvPr id="45" name="Google Shape;165;p1">
               <a:extLst>
                 <a:ext uri="{FF2B5EF4-FFF2-40B4-BE49-F238E27FC236}">
-                  <a16:creationId xmlns:a16="http://schemas.microsoft.com/office/drawing/2014/main" id="{BCF01995-8173-069A-1AD3-8F4EE65B9388}"/>
+                  <a16:creationId xmlns:a16="http://schemas.microsoft.com/office/drawing/2014/main" id="{C822633F-3902-B6A8-BE60-F7B954FC076A}"/>
                 </a:ext>
               </a:extLst>
             </p:cNvPr>
@@ -17025,7 +16832,7 @@
             <p:cNvPr id="46" name="Google Shape;166;p1">
               <a:extLst>
                 <a:ext uri="{FF2B5EF4-FFF2-40B4-BE49-F238E27FC236}">
-                  <a16:creationId xmlns:a16="http://schemas.microsoft.com/office/drawing/2014/main" id="{1471DAA4-2B22-E535-629D-9F4779454A75}"/>
+                  <a16:creationId xmlns:a16="http://schemas.microsoft.com/office/drawing/2014/main" id="{3F4237B7-22EE-587F-4322-2388E3B918FA}"/>
                 </a:ext>
               </a:extLst>
             </p:cNvPr>
@@ -17096,7 +16903,7 @@
             <p:cNvPr id="47" name="Google Shape;167;p1">
               <a:extLst>
                 <a:ext uri="{FF2B5EF4-FFF2-40B4-BE49-F238E27FC236}">
-                  <a16:creationId xmlns:a16="http://schemas.microsoft.com/office/drawing/2014/main" id="{6CB07D33-B4AF-21CD-140E-519FC60CF127}"/>
+                  <a16:creationId xmlns:a16="http://schemas.microsoft.com/office/drawing/2014/main" id="{072A0096-F550-5F4D-BF06-BED740DE3BE7}"/>
                 </a:ext>
               </a:extLst>
             </p:cNvPr>
@@ -17163,7 +16970,7 @@
             <p:cNvPr id="49" name="Google Shape;168;p1">
               <a:extLst>
                 <a:ext uri="{FF2B5EF4-FFF2-40B4-BE49-F238E27FC236}">
-                  <a16:creationId xmlns:a16="http://schemas.microsoft.com/office/drawing/2014/main" id="{1F080BD7-8552-8F66-6915-2E3315C0B220}"/>
+                  <a16:creationId xmlns:a16="http://schemas.microsoft.com/office/drawing/2014/main" id="{EF33D479-84E5-4283-25CA-D713726C4B30}"/>
                 </a:ext>
               </a:extLst>
             </p:cNvPr>
@@ -17230,7 +17037,7 @@
             <p:cNvPr id="50" name="Google Shape;169;p1">
               <a:extLst>
                 <a:ext uri="{FF2B5EF4-FFF2-40B4-BE49-F238E27FC236}">
-                  <a16:creationId xmlns:a16="http://schemas.microsoft.com/office/drawing/2014/main" id="{554C84CD-1D2C-D818-5661-1D6D42F73C15}"/>
+                  <a16:creationId xmlns:a16="http://schemas.microsoft.com/office/drawing/2014/main" id="{FAB4E5ED-4597-05B5-5A0D-9AFBFB6B4B09}"/>
                 </a:ext>
               </a:extLst>
             </p:cNvPr>
@@ -17303,7 +17110,7 @@
             <p:cNvPr id="51" name="Google Shape;170;p1">
               <a:extLst>
                 <a:ext uri="{FF2B5EF4-FFF2-40B4-BE49-F238E27FC236}">
-                  <a16:creationId xmlns:a16="http://schemas.microsoft.com/office/drawing/2014/main" id="{1F5A2BE4-D053-C71B-4B60-97A973F8BDD2}"/>
+                  <a16:creationId xmlns:a16="http://schemas.microsoft.com/office/drawing/2014/main" id="{5DB92375-A626-CB9D-E3B6-ABF2E971AA7D}"/>
                 </a:ext>
               </a:extLst>
             </p:cNvPr>
@@ -17370,7 +17177,7 @@
             <p:cNvPr id="52" name="Google Shape;171;p1">
               <a:extLst>
                 <a:ext uri="{FF2B5EF4-FFF2-40B4-BE49-F238E27FC236}">
-                  <a16:creationId xmlns:a16="http://schemas.microsoft.com/office/drawing/2014/main" id="{27FCBC23-07D4-7E67-5353-05D9D5C7002E}"/>
+                  <a16:creationId xmlns:a16="http://schemas.microsoft.com/office/drawing/2014/main" id="{E2392C92-2555-0F53-790F-AD153D0A9B42}"/>
                 </a:ext>
               </a:extLst>
             </p:cNvPr>
@@ -17443,7 +17250,7 @@
             <p:cNvPr id="54" name="Google Shape;172;p1">
               <a:extLst>
                 <a:ext uri="{FF2B5EF4-FFF2-40B4-BE49-F238E27FC236}">
-                  <a16:creationId xmlns:a16="http://schemas.microsoft.com/office/drawing/2014/main" id="{239C55F7-F291-82B1-DA50-360A6B711FBB}"/>
+                  <a16:creationId xmlns:a16="http://schemas.microsoft.com/office/drawing/2014/main" id="{7E44907D-025C-3469-7844-19728FF85E7D}"/>
                 </a:ext>
               </a:extLst>
             </p:cNvPr>
@@ -17481,7 +17288,7 @@
             <p:cNvPr id="55" name="Google Shape;173;p1">
               <a:extLst>
                 <a:ext uri="{FF2B5EF4-FFF2-40B4-BE49-F238E27FC236}">
-                  <a16:creationId xmlns:a16="http://schemas.microsoft.com/office/drawing/2014/main" id="{2BC73A85-0286-7695-8637-B4A03BE9A780}"/>
+                  <a16:creationId xmlns:a16="http://schemas.microsoft.com/office/drawing/2014/main" id="{C78ADEE5-EFFF-7B0F-1612-C2A459B4E664}"/>
                 </a:ext>
               </a:extLst>
             </p:cNvPr>
@@ -17518,7 +17325,7 @@
             <p:cNvPr id="57" name="Google Shape;175;p1">
               <a:extLst>
                 <a:ext uri="{FF2B5EF4-FFF2-40B4-BE49-F238E27FC236}">
-                  <a16:creationId xmlns:a16="http://schemas.microsoft.com/office/drawing/2014/main" id="{EA35013E-AF6E-9ED7-4048-8B083DEE8E95}"/>
+                  <a16:creationId xmlns:a16="http://schemas.microsoft.com/office/drawing/2014/main" id="{668C6139-E30C-AF94-BE48-CCA6BC658487}"/>
                 </a:ext>
               </a:extLst>
             </p:cNvPr>
@@ -17553,7 +17360,7 @@
             <p:cNvPr id="58" name="Google Shape;177;p1">
               <a:extLst>
                 <a:ext uri="{FF2B5EF4-FFF2-40B4-BE49-F238E27FC236}">
-                  <a16:creationId xmlns:a16="http://schemas.microsoft.com/office/drawing/2014/main" id="{5C3C69A3-C5DF-2F56-89F5-AF638899EFA3}"/>
+                  <a16:creationId xmlns:a16="http://schemas.microsoft.com/office/drawing/2014/main" id="{A352E3A4-AFD4-59BB-A2F9-32342154A4EB}"/>
                 </a:ext>
               </a:extLst>
             </p:cNvPr>
@@ -17588,7 +17395,7 @@
             <p:cNvPr id="59" name="Google Shape;178;p1">
               <a:extLst>
                 <a:ext uri="{FF2B5EF4-FFF2-40B4-BE49-F238E27FC236}">
-                  <a16:creationId xmlns:a16="http://schemas.microsoft.com/office/drawing/2014/main" id="{8376F5A6-B044-0D27-F032-6B99752D5FD5}"/>
+                  <a16:creationId xmlns:a16="http://schemas.microsoft.com/office/drawing/2014/main" id="{AEA60D46-21F7-132A-9F6D-C7F918DDBFD6}"/>
                 </a:ext>
               </a:extLst>
             </p:cNvPr>
@@ -17626,7 +17433,7 @@
             <p:cNvPr id="60" name="Google Shape;179;p1">
               <a:extLst>
                 <a:ext uri="{FF2B5EF4-FFF2-40B4-BE49-F238E27FC236}">
-                  <a16:creationId xmlns:a16="http://schemas.microsoft.com/office/drawing/2014/main" id="{9F9D9CD0-148D-6C4C-70E8-91E3B2F780F6}"/>
+                  <a16:creationId xmlns:a16="http://schemas.microsoft.com/office/drawing/2014/main" id="{8EA79C63-38F6-88B8-E69A-B773BBD508B2}"/>
                 </a:ext>
               </a:extLst>
             </p:cNvPr>
@@ -17661,7 +17468,7 @@
             <p:cNvPr id="61" name="Google Shape;180;p1">
               <a:extLst>
                 <a:ext uri="{FF2B5EF4-FFF2-40B4-BE49-F238E27FC236}">
-                  <a16:creationId xmlns:a16="http://schemas.microsoft.com/office/drawing/2014/main" id="{F75A3143-7E95-868E-3F30-CBEC8282D41A}"/>
+                  <a16:creationId xmlns:a16="http://schemas.microsoft.com/office/drawing/2014/main" id="{C34B582C-FFBF-7A74-D09B-1E92CD408BCE}"/>
                 </a:ext>
               </a:extLst>
             </p:cNvPr>
@@ -17696,7 +17503,7 @@
             <p:cNvPr id="62" name="Google Shape;181;p1">
               <a:extLst>
                 <a:ext uri="{FF2B5EF4-FFF2-40B4-BE49-F238E27FC236}">
-                  <a16:creationId xmlns:a16="http://schemas.microsoft.com/office/drawing/2014/main" id="{9478C633-7072-87FE-47DF-5368589B89C1}"/>
+                  <a16:creationId xmlns:a16="http://schemas.microsoft.com/office/drawing/2014/main" id="{FB0AEFA0-ABD8-1650-9643-E15D2687C089}"/>
                 </a:ext>
               </a:extLst>
             </p:cNvPr>
@@ -17731,7 +17538,7 @@
             <p:cNvPr id="63" name="Google Shape;183;p1">
               <a:extLst>
                 <a:ext uri="{FF2B5EF4-FFF2-40B4-BE49-F238E27FC236}">
-                  <a16:creationId xmlns:a16="http://schemas.microsoft.com/office/drawing/2014/main" id="{2CBE79E8-85F5-2D73-BFAE-DF8932732D0D}"/>
+                  <a16:creationId xmlns:a16="http://schemas.microsoft.com/office/drawing/2014/main" id="{A94C11F5-6744-147A-88A8-08B5E5952931}"/>
                 </a:ext>
               </a:extLst>
             </p:cNvPr>
@@ -17766,7 +17573,7 @@
             <p:cNvPr id="448" name="Google Shape;176;p1">
               <a:extLst>
                 <a:ext uri="{FF2B5EF4-FFF2-40B4-BE49-F238E27FC236}">
-                  <a16:creationId xmlns:a16="http://schemas.microsoft.com/office/drawing/2014/main" id="{2C5E3446-F93E-7BF4-D51E-F6E8AB5F261F}"/>
+                  <a16:creationId xmlns:a16="http://schemas.microsoft.com/office/drawing/2014/main" id="{C5A85341-6470-E422-16C4-EF85CDA60794}"/>
                 </a:ext>
               </a:extLst>
             </p:cNvPr>
@@ -17833,7 +17640,7 @@
             <p:cNvPr id="449" name="Google Shape;184;p1">
               <a:extLst>
                 <a:ext uri="{FF2B5EF4-FFF2-40B4-BE49-F238E27FC236}">
-                  <a16:creationId xmlns:a16="http://schemas.microsoft.com/office/drawing/2014/main" id="{3B880F32-3C21-CD2D-536E-01EB211A6743}"/>
+                  <a16:creationId xmlns:a16="http://schemas.microsoft.com/office/drawing/2014/main" id="{2AADE52D-1020-BFD7-8C3D-5ACBAB08FF56}"/>
                 </a:ext>
               </a:extLst>
             </p:cNvPr>
@@ -17868,7 +17675,7 @@
             <p:cNvPr id="450" name="Google Shape;185;p1">
               <a:extLst>
                 <a:ext uri="{FF2B5EF4-FFF2-40B4-BE49-F238E27FC236}">
-                  <a16:creationId xmlns:a16="http://schemas.microsoft.com/office/drawing/2014/main" id="{09BF4B71-277F-4407-D23E-E137FD9DF948}"/>
+                  <a16:creationId xmlns:a16="http://schemas.microsoft.com/office/drawing/2014/main" id="{461E13CF-9555-0F83-89A4-1BED124D85D9}"/>
                 </a:ext>
               </a:extLst>
             </p:cNvPr>
@@ -17903,7 +17710,7 @@
             <p:cNvPr id="452" name="Google Shape;174;p1">
               <a:extLst>
                 <a:ext uri="{FF2B5EF4-FFF2-40B4-BE49-F238E27FC236}">
-                  <a16:creationId xmlns:a16="http://schemas.microsoft.com/office/drawing/2014/main" id="{CC2B2DE2-3EBE-728E-8D5C-17E8753BB6BD}"/>
+                  <a16:creationId xmlns:a16="http://schemas.microsoft.com/office/drawing/2014/main" id="{8CC122A4-A373-15C9-75C0-43155ACAA43A}"/>
                 </a:ext>
               </a:extLst>
             </p:cNvPr>
@@ -17974,7 +17781,7 @@
             <p:cNvPr id="453" name="Google Shape;186;p1">
               <a:extLst>
                 <a:ext uri="{FF2B5EF4-FFF2-40B4-BE49-F238E27FC236}">
-                  <a16:creationId xmlns:a16="http://schemas.microsoft.com/office/drawing/2014/main" id="{44193011-1856-2AAE-2E8A-996679711660}"/>
+                  <a16:creationId xmlns:a16="http://schemas.microsoft.com/office/drawing/2014/main" id="{B1FD3894-64E2-5342-632D-0BA42E5907F3}"/>
                 </a:ext>
               </a:extLst>
             </p:cNvPr>
@@ -18009,7 +17816,7 @@
             <p:cNvPr id="456" name="Google Shape;187;p1">
               <a:extLst>
                 <a:ext uri="{FF2B5EF4-FFF2-40B4-BE49-F238E27FC236}">
-                  <a16:creationId xmlns:a16="http://schemas.microsoft.com/office/drawing/2014/main" id="{0F2CF676-F257-5F88-0B12-B8F2B12184EB}"/>
+                  <a16:creationId xmlns:a16="http://schemas.microsoft.com/office/drawing/2014/main" id="{F587067E-8B7D-3D38-D227-6496A92D11E0}"/>
                 </a:ext>
               </a:extLst>
             </p:cNvPr>
@@ -18046,7 +17853,7 @@
             <p:cNvPr id="457" name="Google Shape;189;p1">
               <a:extLst>
                 <a:ext uri="{FF2B5EF4-FFF2-40B4-BE49-F238E27FC236}">
-                  <a16:creationId xmlns:a16="http://schemas.microsoft.com/office/drawing/2014/main" id="{12E0C394-F16A-E0BE-B325-71853337B579}"/>
+                  <a16:creationId xmlns:a16="http://schemas.microsoft.com/office/drawing/2014/main" id="{28F79748-6D9E-307C-E562-761775EC617A}"/>
                 </a:ext>
               </a:extLst>
             </p:cNvPr>
@@ -18081,7 +17888,7 @@
             <p:cNvPr id="458" name="Google Shape;190;p1">
               <a:extLst>
                 <a:ext uri="{FF2B5EF4-FFF2-40B4-BE49-F238E27FC236}">
-                  <a16:creationId xmlns:a16="http://schemas.microsoft.com/office/drawing/2014/main" id="{56425D35-98AC-4138-2E19-CFCEE1EA88DE}"/>
+                  <a16:creationId xmlns:a16="http://schemas.microsoft.com/office/drawing/2014/main" id="{31B44D8B-A8BA-C686-7916-3AE3EC883F51}"/>
                 </a:ext>
               </a:extLst>
             </p:cNvPr>
@@ -18116,7 +17923,7 @@
             <p:cNvPr id="459" name="Google Shape;191;p1">
               <a:extLst>
                 <a:ext uri="{FF2B5EF4-FFF2-40B4-BE49-F238E27FC236}">
-                  <a16:creationId xmlns:a16="http://schemas.microsoft.com/office/drawing/2014/main" id="{8616A146-5762-310A-7206-29F7B31BE0BD}"/>
+                  <a16:creationId xmlns:a16="http://schemas.microsoft.com/office/drawing/2014/main" id="{4C8C1901-5714-CAD2-B986-D18FB7601620}"/>
                 </a:ext>
               </a:extLst>
             </p:cNvPr>
@@ -18151,7 +17958,7 @@
             <p:cNvPr id="461" name="Google Shape;188;p1">
               <a:extLst>
                 <a:ext uri="{FF2B5EF4-FFF2-40B4-BE49-F238E27FC236}">
-                  <a16:creationId xmlns:a16="http://schemas.microsoft.com/office/drawing/2014/main" id="{2621FABC-9D40-F5BC-265F-070F677C60AA}"/>
+                  <a16:creationId xmlns:a16="http://schemas.microsoft.com/office/drawing/2014/main" id="{0CB3945D-7266-1345-B49A-D66FE91D28E2}"/>
                 </a:ext>
               </a:extLst>
             </p:cNvPr>
@@ -18222,7 +18029,7 @@
             <p:cNvPr id="465" name="Google Shape;192;p1">
               <a:extLst>
                 <a:ext uri="{FF2B5EF4-FFF2-40B4-BE49-F238E27FC236}">
-                  <a16:creationId xmlns:a16="http://schemas.microsoft.com/office/drawing/2014/main" id="{FB9A3F5F-D973-F81F-2318-6F058E8DE072}"/>
+                  <a16:creationId xmlns:a16="http://schemas.microsoft.com/office/drawing/2014/main" id="{63799BD2-E6F5-1225-2319-170E012BD21E}"/>
                 </a:ext>
               </a:extLst>
             </p:cNvPr>
@@ -18257,7 +18064,7 @@
             <p:cNvPr id="466" name="Google Shape;182;p1">
               <a:extLst>
                 <a:ext uri="{FF2B5EF4-FFF2-40B4-BE49-F238E27FC236}">
-                  <a16:creationId xmlns:a16="http://schemas.microsoft.com/office/drawing/2014/main" id="{01BCD0E4-DD7C-08A8-8755-E6FE7442EBBB}"/>
+                  <a16:creationId xmlns:a16="http://schemas.microsoft.com/office/drawing/2014/main" id="{E27C9DB4-65CC-A58E-A303-96C336D69341}"/>
                 </a:ext>
               </a:extLst>
             </p:cNvPr>
@@ -18324,7 +18131,7 @@
             <p:cNvPr id="468" name="Google Shape;193;p1">
               <a:extLst>
                 <a:ext uri="{FF2B5EF4-FFF2-40B4-BE49-F238E27FC236}">
-                  <a16:creationId xmlns:a16="http://schemas.microsoft.com/office/drawing/2014/main" id="{AC1A41EB-08AB-00EB-642B-BCC5E74C671C}"/>
+                  <a16:creationId xmlns:a16="http://schemas.microsoft.com/office/drawing/2014/main" id="{4F789A9A-C803-8516-B19E-AFCC74FBC0B6}"/>
                 </a:ext>
               </a:extLst>
             </p:cNvPr>
@@ -18359,7 +18166,7 @@
             <p:cNvPr id="470" name="Google Shape;194;p1">
               <a:extLst>
                 <a:ext uri="{FF2B5EF4-FFF2-40B4-BE49-F238E27FC236}">
-                  <a16:creationId xmlns:a16="http://schemas.microsoft.com/office/drawing/2014/main" id="{73758FC8-99E6-7DB5-6A24-9C15F73EB9E7}"/>
+                  <a16:creationId xmlns:a16="http://schemas.microsoft.com/office/drawing/2014/main" id="{24F30FFB-99C2-41EE-3803-7DA199EAF612}"/>
                 </a:ext>
               </a:extLst>
             </p:cNvPr>
@@ -18396,7 +18203,7 @@
             <p:cNvPr id="471" name="Google Shape;195;p1">
               <a:extLst>
                 <a:ext uri="{FF2B5EF4-FFF2-40B4-BE49-F238E27FC236}">
-                  <a16:creationId xmlns:a16="http://schemas.microsoft.com/office/drawing/2014/main" id="{AA0FBCC7-01CE-6EE0-B83F-D3C8E3B13BCC}"/>
+                  <a16:creationId xmlns:a16="http://schemas.microsoft.com/office/drawing/2014/main" id="{D2FF2FCA-4480-5B7B-1D12-F34F6EE8EDE3}"/>
                 </a:ext>
               </a:extLst>
             </p:cNvPr>
@@ -18431,7 +18238,7 @@
             <p:cNvPr id="472" name="Google Shape;196;p1">
               <a:extLst>
                 <a:ext uri="{FF2B5EF4-FFF2-40B4-BE49-F238E27FC236}">
-                  <a16:creationId xmlns:a16="http://schemas.microsoft.com/office/drawing/2014/main" id="{CBC08898-85CD-324D-1873-4382E58CFE88}"/>
+                  <a16:creationId xmlns:a16="http://schemas.microsoft.com/office/drawing/2014/main" id="{C0D7C11D-AB33-EE1D-BEC0-D7C79AD6830D}"/>
                 </a:ext>
               </a:extLst>
             </p:cNvPr>
@@ -18468,7 +18275,7 @@
             <p:cNvPr id="473" name="Google Shape;197;p1">
               <a:extLst>
                 <a:ext uri="{FF2B5EF4-FFF2-40B4-BE49-F238E27FC236}">
-                  <a16:creationId xmlns:a16="http://schemas.microsoft.com/office/drawing/2014/main" id="{16D7C0A6-5F7C-C894-117F-F1453BB970FD}"/>
+                  <a16:creationId xmlns:a16="http://schemas.microsoft.com/office/drawing/2014/main" id="{94ECA2ED-31F8-A905-91AB-C1AB30400C1D}"/>
                 </a:ext>
               </a:extLst>
             </p:cNvPr>
@@ -18505,7 +18312,7 @@
             <p:cNvPr id="478" name="Google Shape;198;p1">
               <a:extLst>
                 <a:ext uri="{FF2B5EF4-FFF2-40B4-BE49-F238E27FC236}">
-                  <a16:creationId xmlns:a16="http://schemas.microsoft.com/office/drawing/2014/main" id="{39BEE82F-CC69-1511-0CE8-07A40DCD081D}"/>
+                  <a16:creationId xmlns:a16="http://schemas.microsoft.com/office/drawing/2014/main" id="{DD5351F3-1BF2-CD13-6E16-052606919911}"/>
                 </a:ext>
               </a:extLst>
             </p:cNvPr>
@@ -18543,7 +18350,7 @@
             <p:cNvPr id="479" name="Google Shape;199;p1">
               <a:extLst>
                 <a:ext uri="{FF2B5EF4-FFF2-40B4-BE49-F238E27FC236}">
-                  <a16:creationId xmlns:a16="http://schemas.microsoft.com/office/drawing/2014/main" id="{02C02D98-6FED-1B1A-E252-27356A6D021A}"/>
+                  <a16:creationId xmlns:a16="http://schemas.microsoft.com/office/drawing/2014/main" id="{815B29F1-2228-C1DE-B4F8-29D3E8D11AF0}"/>
                 </a:ext>
               </a:extLst>
             </p:cNvPr>
@@ -18581,7 +18388,7 @@
             <p:cNvPr id="481" name="Google Shape;200;p1">
               <a:extLst>
                 <a:ext uri="{FF2B5EF4-FFF2-40B4-BE49-F238E27FC236}">
-                  <a16:creationId xmlns:a16="http://schemas.microsoft.com/office/drawing/2014/main" id="{EC75B8AF-17B2-FFAD-38A7-10BBD158B980}"/>
+                  <a16:creationId xmlns:a16="http://schemas.microsoft.com/office/drawing/2014/main" id="{800C6235-9CDB-EE6E-C61B-D8FC3B6A68D7}"/>
                 </a:ext>
               </a:extLst>
             </p:cNvPr>
@@ -18620,7 +18427,7 @@
           <p:cNvPr id="9" name="Straight Connector 8">
             <a:extLst>
               <a:ext uri="{FF2B5EF4-FFF2-40B4-BE49-F238E27FC236}">
-                <a16:creationId xmlns:a16="http://schemas.microsoft.com/office/drawing/2014/main" id="{5F3E6CA7-E718-F83D-01FA-CA84424463F0}"/>
+                <a16:creationId xmlns:a16="http://schemas.microsoft.com/office/drawing/2014/main" id="{7F553ADD-41D6-9607-69DF-9743E98B3153}"/>
               </a:ext>
             </a:extLst>
           </p:cNvPr>
@@ -18632,8 +18439,8 @@
         </p:nvCxnSpPr>
         <p:spPr>
           <a:xfrm flipH="1">
-            <a:off x="8399404" y="6857889"/>
-            <a:ext cx="192599" cy="171018"/>
+            <a:off x="8399404" y="7042161"/>
+            <a:ext cx="192599" cy="170944"/>
           </a:xfrm>
           <a:prstGeom prst="line">
             <a:avLst/>
@@ -18667,7 +18474,7 @@
           <p:cNvPr id="19" name="Straight Connector 18">
             <a:extLst>
               <a:ext uri="{FF2B5EF4-FFF2-40B4-BE49-F238E27FC236}">
-                <a16:creationId xmlns:a16="http://schemas.microsoft.com/office/drawing/2014/main" id="{70786A80-75CF-6F20-C122-60B4BF075A10}"/>
+                <a16:creationId xmlns:a16="http://schemas.microsoft.com/office/drawing/2014/main" id="{7AC1DB65-3A48-C1FB-8980-361A5C8F8E9F}"/>
               </a:ext>
             </a:extLst>
           </p:cNvPr>
@@ -18680,8 +18487,8 @@
         </p:nvCxnSpPr>
         <p:spPr>
           <a:xfrm>
-            <a:off x="8647968" y="6857889"/>
-            <a:ext cx="161412" cy="364517"/>
+            <a:off x="8647968" y="7042161"/>
+            <a:ext cx="161412" cy="364358"/>
           </a:xfrm>
           <a:prstGeom prst="line">
             <a:avLst/>
@@ -18715,7 +18522,7 @@
           <p:cNvPr id="26" name="Straight Connector 25">
             <a:extLst>
               <a:ext uri="{FF2B5EF4-FFF2-40B4-BE49-F238E27FC236}">
-                <a16:creationId xmlns:a16="http://schemas.microsoft.com/office/drawing/2014/main" id="{93040EEC-144A-0086-B725-90106DE2044C}"/>
+                <a16:creationId xmlns:a16="http://schemas.microsoft.com/office/drawing/2014/main" id="{06967AB6-3E6B-2C1E-B2FD-CC45D230D8C8}"/>
               </a:ext>
             </a:extLst>
           </p:cNvPr>
@@ -18727,8 +18534,8 @@
         </p:nvCxnSpPr>
         <p:spPr>
           <a:xfrm>
-            <a:off x="8659559" y="6825554"/>
-            <a:ext cx="310966" cy="309850"/>
+            <a:off x="8659559" y="7009840"/>
+            <a:ext cx="310966" cy="309715"/>
           </a:xfrm>
           <a:prstGeom prst="line">
             <a:avLst/>
@@ -18762,7 +18569,7 @@
           <p:cNvPr id="42" name="Straight Connector 41">
             <a:extLst>
               <a:ext uri="{FF2B5EF4-FFF2-40B4-BE49-F238E27FC236}">
-                <a16:creationId xmlns:a16="http://schemas.microsoft.com/office/drawing/2014/main" id="{239882DC-36D9-B2FE-041B-053DD3B6438B}"/>
+                <a16:creationId xmlns:a16="http://schemas.microsoft.com/office/drawing/2014/main" id="{188F13CC-4833-9B61-82DC-D50AC7051CD8}"/>
               </a:ext>
             </a:extLst>
           </p:cNvPr>
@@ -18774,8 +18581,8 @@
         </p:nvCxnSpPr>
         <p:spPr>
           <a:xfrm>
-            <a:off x="8659559" y="6825554"/>
-            <a:ext cx="317138" cy="117876"/>
+            <a:off x="8659559" y="7009840"/>
+            <a:ext cx="317138" cy="117825"/>
           </a:xfrm>
           <a:prstGeom prst="line">
             <a:avLst/>
@@ -18809,7 +18616,7 @@
           <p:cNvPr id="48" name="Straight Connector 47">
             <a:extLst>
               <a:ext uri="{FF2B5EF4-FFF2-40B4-BE49-F238E27FC236}">
-                <a16:creationId xmlns:a16="http://schemas.microsoft.com/office/drawing/2014/main" id="{C474D363-9C85-D36A-FB6F-1DCDD9F70289}"/>
+                <a16:creationId xmlns:a16="http://schemas.microsoft.com/office/drawing/2014/main" id="{74BD4078-BDC6-4826-F419-C5A1954247C5}"/>
               </a:ext>
             </a:extLst>
           </p:cNvPr>
@@ -18822,8 +18629,8 @@
         </p:nvCxnSpPr>
         <p:spPr>
           <a:xfrm flipV="1">
-            <a:off x="8647968" y="6733320"/>
-            <a:ext cx="191438" cy="59899"/>
+            <a:off x="8647968" y="6917647"/>
+            <a:ext cx="191438" cy="59873"/>
           </a:xfrm>
           <a:prstGeom prst="line">
             <a:avLst/>
@@ -18854,10 +18661,406 @@
       </p:cxnSp>
       <p:sp>
         <p:nvSpPr>
+          <p:cNvPr id="447" name="TextBox 446">
+            <a:extLst>
+              <a:ext uri="{FF2B5EF4-FFF2-40B4-BE49-F238E27FC236}">
+                <a16:creationId xmlns:a16="http://schemas.microsoft.com/office/drawing/2014/main" id="{152E59E1-6F36-8CCB-DA2F-058EC579C2BA}"/>
+              </a:ext>
+            </a:extLst>
+          </p:cNvPr>
+          <p:cNvSpPr txBox="1"/>
+          <p:nvPr/>
+        </p:nvSpPr>
+        <p:spPr>
+          <a:xfrm>
+            <a:off x="3840480" y="2190475"/>
+            <a:ext cx="670876" cy="289616"/>
+          </a:xfrm>
+          <a:prstGeom prst="rect">
+            <a:avLst/>
+          </a:prstGeom>
+          <a:noFill/>
+          <a:ln w="12700" cap="flat">
+            <a:noFill/>
+            <a:miter lim="400000"/>
+          </a:ln>
+          <a:effectLst/>
+          <a:sp3d/>
+        </p:spPr>
+        <p:style>
+          <a:lnRef idx="0">
+            <a:scrgbClr r="0" g="0" b="0"/>
+          </a:lnRef>
+          <a:fillRef idx="0">
+            <a:scrgbClr r="0" g="0" b="0"/>
+          </a:fillRef>
+          <a:effectRef idx="0">
+            <a:scrgbClr r="0" g="0" b="0"/>
+          </a:effectRef>
+          <a:fontRef idx="none"/>
+        </p:style>
+        <p:txBody>
+          <a:bodyPr rot="0" spcFirstLastPara="1" vertOverflow="overflow" horzOverflow="overflow" vert="horz" wrap="square" lIns="54570" tIns="54570" rIns="54570" bIns="54570" numCol="1" spcCol="38100" rtlCol="0" anchor="ctr">
+            <a:spAutoFit/>
+          </a:bodyPr>
+          <a:lstStyle/>
+          <a:p>
+            <a:pPr marL="0" marR="0" indent="0" algn="ctr" defTabSz="584200" rtl="0" fontAlgn="auto" latinLnBrk="0" hangingPunct="0">
+              <a:lnSpc>
+                <a:spcPct val="100000"/>
+              </a:lnSpc>
+              <a:spcBef>
+                <a:spcPts val="200"/>
+              </a:spcBef>
+              <a:spcAft>
+                <a:spcPts val="0"/>
+              </a:spcAft>
+              <a:buClrTx/>
+              <a:buSzTx/>
+              <a:buFontTx/>
+              <a:buNone/>
+              <a:tabLst/>
+            </a:pPr>
+            <a:r>
+              <a:rPr kumimoji="0" lang="en-US" sz="1000" b="0" i="0" u="none" strike="noStrike" cap="none" spc="0" normalizeH="0" baseline="0" dirty="0">
+                <a:ln>
+                  <a:noFill/>
+                </a:ln>
+                <a:solidFill>
+                  <a:srgbClr val="4C4C4C"/>
+                </a:solidFill>
+                <a:effectLst/>
+                <a:uFillTx/>
+                <a:sym typeface="Source Sans Pro"/>
+              </a:rPr>
+              <a:t>Raw Data</a:t>
+            </a:r>
+          </a:p>
+        </p:txBody>
+      </p:sp>
+      <p:sp>
+        <p:nvSpPr>
+          <p:cNvPr id="512" name="TextBox 511">
+            <a:extLst>
+              <a:ext uri="{FF2B5EF4-FFF2-40B4-BE49-F238E27FC236}">
+                <a16:creationId xmlns:a16="http://schemas.microsoft.com/office/drawing/2014/main" id="{698D061F-CF8C-C60A-83B5-7EEA6877F972}"/>
+              </a:ext>
+            </a:extLst>
+          </p:cNvPr>
+          <p:cNvSpPr txBox="1"/>
+          <p:nvPr/>
+        </p:nvSpPr>
+        <p:spPr>
+          <a:xfrm>
+            <a:off x="3840480" y="3063769"/>
+            <a:ext cx="670876" cy="443437"/>
+          </a:xfrm>
+          <a:prstGeom prst="rect">
+            <a:avLst/>
+          </a:prstGeom>
+          <a:noFill/>
+          <a:ln w="12700" cap="flat">
+            <a:noFill/>
+            <a:miter lim="400000"/>
+          </a:ln>
+          <a:effectLst/>
+          <a:sp3d/>
+        </p:spPr>
+        <p:style>
+          <a:lnRef idx="0">
+            <a:scrgbClr r="0" g="0" b="0"/>
+          </a:lnRef>
+          <a:fillRef idx="0">
+            <a:scrgbClr r="0" g="0" b="0"/>
+          </a:fillRef>
+          <a:effectRef idx="0">
+            <a:scrgbClr r="0" g="0" b="0"/>
+          </a:effectRef>
+          <a:fontRef idx="none"/>
+        </p:style>
+        <p:txBody>
+          <a:bodyPr rot="0" spcFirstLastPara="1" vertOverflow="overflow" horzOverflow="overflow" vert="horz" wrap="square" lIns="54570" tIns="54570" rIns="54570" bIns="54570" numCol="1" spcCol="38100" rtlCol="0" anchor="ctr">
+            <a:spAutoFit/>
+          </a:bodyPr>
+          <a:lstStyle/>
+          <a:p>
+            <a:pPr marL="0" marR="0" indent="0" algn="ctr" defTabSz="584200" rtl="0" fontAlgn="auto" latinLnBrk="0" hangingPunct="0">
+              <a:lnSpc>
+                <a:spcPct val="100000"/>
+              </a:lnSpc>
+              <a:spcBef>
+                <a:spcPts val="200"/>
+              </a:spcBef>
+              <a:spcAft>
+                <a:spcPts val="0"/>
+              </a:spcAft>
+              <a:buClrTx/>
+              <a:buSzTx/>
+              <a:buFontTx/>
+              <a:buNone/>
+              <a:tabLst/>
+            </a:pPr>
+            <a:r>
+              <a:rPr lang="en-US" sz="1000" b="0" dirty="0"/>
+              <a:t>Tabular Data</a:t>
+            </a:r>
+            <a:endParaRPr kumimoji="0" lang="en-US" sz="1000" b="0" i="0" u="none" strike="noStrike" cap="none" spc="0" normalizeH="0" baseline="0" dirty="0">
+              <a:ln>
+                <a:noFill/>
+              </a:ln>
+              <a:solidFill>
+                <a:srgbClr val="4C4C4C"/>
+              </a:solidFill>
+              <a:effectLst/>
+              <a:uFillTx/>
+              <a:sym typeface="Source Sans Pro"/>
+            </a:endParaRPr>
+          </a:p>
+        </p:txBody>
+      </p:sp>
+      <p:sp>
+        <p:nvSpPr>
+          <p:cNvPr id="515" name="TextBox 514">
+            <a:extLst>
+              <a:ext uri="{FF2B5EF4-FFF2-40B4-BE49-F238E27FC236}">
+                <a16:creationId xmlns:a16="http://schemas.microsoft.com/office/drawing/2014/main" id="{3B914486-5606-E6B6-D72B-9359ED4F4929}"/>
+              </a:ext>
+            </a:extLst>
+          </p:cNvPr>
+          <p:cNvSpPr txBox="1"/>
+          <p:nvPr/>
+        </p:nvSpPr>
+        <p:spPr>
+          <a:xfrm>
+            <a:off x="3840480" y="6836371"/>
+            <a:ext cx="670876" cy="443437"/>
+          </a:xfrm>
+          <a:prstGeom prst="rect">
+            <a:avLst/>
+          </a:prstGeom>
+          <a:noFill/>
+          <a:ln w="12700" cap="flat">
+            <a:noFill/>
+            <a:miter lim="400000"/>
+          </a:ln>
+          <a:effectLst/>
+          <a:sp3d/>
+        </p:spPr>
+        <p:style>
+          <a:lnRef idx="0">
+            <a:scrgbClr r="0" g="0" b="0"/>
+          </a:lnRef>
+          <a:fillRef idx="0">
+            <a:scrgbClr r="0" g="0" b="0"/>
+          </a:fillRef>
+          <a:effectRef idx="0">
+            <a:scrgbClr r="0" g="0" b="0"/>
+          </a:effectRef>
+          <a:fontRef idx="none"/>
+        </p:style>
+        <p:txBody>
+          <a:bodyPr rot="0" spcFirstLastPara="1" vertOverflow="overflow" horzOverflow="overflow" vert="horz" wrap="square" lIns="54570" tIns="54570" rIns="54570" bIns="54570" numCol="1" spcCol="38100" rtlCol="0" anchor="ctr">
+            <a:spAutoFit/>
+          </a:bodyPr>
+          <a:lstStyle/>
+          <a:p>
+            <a:pPr marL="0" marR="0" indent="0" algn="ctr" defTabSz="584200" rtl="0" fontAlgn="auto" latinLnBrk="0" hangingPunct="0">
+              <a:lnSpc>
+                <a:spcPct val="100000"/>
+              </a:lnSpc>
+              <a:spcBef>
+                <a:spcPts val="200"/>
+              </a:spcBef>
+              <a:spcAft>
+                <a:spcPts val="0"/>
+              </a:spcAft>
+              <a:buClrTx/>
+              <a:buSzTx/>
+              <a:buFontTx/>
+              <a:buNone/>
+              <a:tabLst/>
+            </a:pPr>
+            <a:r>
+              <a:rPr kumimoji="0" lang="en-US" sz="1000" b="0" i="0" u="none" strike="noStrike" cap="none" spc="0" normalizeH="0" baseline="0" dirty="0">
+                <a:ln>
+                  <a:noFill/>
+                </a:ln>
+                <a:solidFill>
+                  <a:srgbClr val="4C4C4C"/>
+                </a:solidFill>
+                <a:effectLst/>
+                <a:uFillTx/>
+                <a:sym typeface="Source Sans Pro"/>
+              </a:rPr>
+              <a:t>S3 Graph API</a:t>
+            </a:r>
+          </a:p>
+        </p:txBody>
+      </p:sp>
+      <p:sp>
+        <p:nvSpPr>
+          <p:cNvPr id="516" name="TextBox 515">
+            <a:extLst>
+              <a:ext uri="{FF2B5EF4-FFF2-40B4-BE49-F238E27FC236}">
+                <a16:creationId xmlns:a16="http://schemas.microsoft.com/office/drawing/2014/main" id="{8519F82D-B02C-CC16-ED3F-1F81824AED62}"/>
+              </a:ext>
+            </a:extLst>
+          </p:cNvPr>
+          <p:cNvSpPr txBox="1"/>
+          <p:nvPr/>
+        </p:nvSpPr>
+        <p:spPr>
+          <a:xfrm>
+            <a:off x="3840480" y="8392953"/>
+            <a:ext cx="670876" cy="443437"/>
+          </a:xfrm>
+          <a:prstGeom prst="rect">
+            <a:avLst/>
+          </a:prstGeom>
+          <a:noFill/>
+          <a:ln w="12700" cap="flat">
+            <a:noFill/>
+            <a:miter lim="400000"/>
+          </a:ln>
+          <a:effectLst/>
+          <a:sp3d/>
+        </p:spPr>
+        <p:style>
+          <a:lnRef idx="0">
+            <a:scrgbClr r="0" g="0" b="0"/>
+          </a:lnRef>
+          <a:fillRef idx="0">
+            <a:scrgbClr r="0" g="0" b="0"/>
+          </a:fillRef>
+          <a:effectRef idx="0">
+            <a:scrgbClr r="0" g="0" b="0"/>
+          </a:effectRef>
+          <a:fontRef idx="none"/>
+        </p:style>
+        <p:txBody>
+          <a:bodyPr rot="0" spcFirstLastPara="1" vertOverflow="overflow" horzOverflow="overflow" vert="horz" wrap="square" lIns="54570" tIns="54570" rIns="54570" bIns="54570" numCol="1" spcCol="38100" rtlCol="0" anchor="ctr">
+            <a:spAutoFit/>
+          </a:bodyPr>
+          <a:lstStyle/>
+          <a:p>
+            <a:pPr marL="0" marR="0" indent="0" algn="ctr" defTabSz="584200" rtl="0" fontAlgn="auto" latinLnBrk="0" hangingPunct="0">
+              <a:lnSpc>
+                <a:spcPct val="100000"/>
+              </a:lnSpc>
+              <a:spcBef>
+                <a:spcPts val="200"/>
+              </a:spcBef>
+              <a:spcAft>
+                <a:spcPts val="0"/>
+              </a:spcAft>
+              <a:buClrTx/>
+              <a:buSzTx/>
+              <a:buFontTx/>
+              <a:buNone/>
+              <a:tabLst/>
+            </a:pPr>
+            <a:r>
+              <a:rPr kumimoji="0" lang="en-US" sz="1000" b="0" i="0" u="none" strike="noStrike" cap="none" spc="0" normalizeH="0" baseline="0" dirty="0">
+                <a:ln>
+                  <a:noFill/>
+                </a:ln>
+                <a:solidFill>
+                  <a:srgbClr val="4C4C4C"/>
+                </a:solidFill>
+                <a:effectLst/>
+                <a:uFillTx/>
+                <a:sym typeface="Source Sans Pro"/>
+              </a:rPr>
+              <a:t>Graph Export</a:t>
+            </a:r>
+          </a:p>
+        </p:txBody>
+      </p:sp>
+      <p:sp>
+        <p:nvSpPr>
+          <p:cNvPr id="514" name="TextBox 513">
+            <a:extLst>
+              <a:ext uri="{FF2B5EF4-FFF2-40B4-BE49-F238E27FC236}">
+                <a16:creationId xmlns:a16="http://schemas.microsoft.com/office/drawing/2014/main" id="{F2F7BE4C-0638-2036-B1F5-1D337817606A}"/>
+              </a:ext>
+            </a:extLst>
+          </p:cNvPr>
+          <p:cNvSpPr txBox="1"/>
+          <p:nvPr/>
+        </p:nvSpPr>
+        <p:spPr>
+          <a:xfrm>
+            <a:off x="3840480" y="5212625"/>
+            <a:ext cx="670876" cy="443437"/>
+          </a:xfrm>
+          <a:prstGeom prst="rect">
+            <a:avLst/>
+          </a:prstGeom>
+          <a:noFill/>
+          <a:ln w="12700" cap="flat">
+            <a:noFill/>
+            <a:miter lim="400000"/>
+          </a:ln>
+          <a:effectLst/>
+          <a:sp3d/>
+        </p:spPr>
+        <p:style>
+          <a:lnRef idx="0">
+            <a:scrgbClr r="0" g="0" b="0"/>
+          </a:lnRef>
+          <a:fillRef idx="0">
+            <a:scrgbClr r="0" g="0" b="0"/>
+          </a:fillRef>
+          <a:effectRef idx="0">
+            <a:scrgbClr r="0" g="0" b="0"/>
+          </a:effectRef>
+          <a:fontRef idx="none"/>
+        </p:style>
+        <p:txBody>
+          <a:bodyPr rot="0" spcFirstLastPara="1" vertOverflow="overflow" horzOverflow="overflow" vert="horz" wrap="square" lIns="54570" tIns="54570" rIns="54570" bIns="54570" numCol="1" spcCol="38100" rtlCol="0" anchor="ctr">
+            <a:spAutoFit/>
+          </a:bodyPr>
+          <a:lstStyle/>
+          <a:p>
+            <a:pPr marL="0" marR="0" indent="0" algn="ctr" defTabSz="584200" rtl="0" fontAlgn="auto" latinLnBrk="0" hangingPunct="0">
+              <a:lnSpc>
+                <a:spcPct val="100000"/>
+              </a:lnSpc>
+              <a:spcBef>
+                <a:spcPts val="200"/>
+              </a:spcBef>
+              <a:spcAft>
+                <a:spcPts val="0"/>
+              </a:spcAft>
+              <a:buClrTx/>
+              <a:buSzTx/>
+              <a:buFontTx/>
+              <a:buNone/>
+              <a:tabLst/>
+            </a:pPr>
+            <a:r>
+              <a:rPr kumimoji="0" lang="en-US" sz="1000" b="0" i="0" u="none" strike="noStrike" cap="none" spc="0" normalizeH="0" baseline="0" dirty="0">
+                <a:ln>
+                  <a:noFill/>
+                </a:ln>
+                <a:solidFill>
+                  <a:srgbClr val="4C4C4C"/>
+                </a:solidFill>
+                <a:effectLst/>
+                <a:uFillTx/>
+                <a:sym typeface="Source Sans Pro"/>
+              </a:rPr>
+              <a:t>S3 Graph Class</a:t>
+            </a:r>
+          </a:p>
+        </p:txBody>
+      </p:sp>
+      <p:sp>
+        <p:nvSpPr>
           <p:cNvPr id="368" name="Line">
             <a:extLst>
               <a:ext uri="{FF2B5EF4-FFF2-40B4-BE49-F238E27FC236}">
-                <a16:creationId xmlns:a16="http://schemas.microsoft.com/office/drawing/2014/main" id="{3208538C-AD12-67FE-7450-6063EBA9F2E4}"/>
+                <a16:creationId xmlns:a16="http://schemas.microsoft.com/office/drawing/2014/main" id="{6CD73DF4-5705-9D9F-4FF5-460DA87BE290}"/>
               </a:ext>
             </a:extLst>
           </p:cNvPr>
@@ -18866,8 +19069,8 @@
         </p:nvSpPr>
         <p:spPr>
           <a:xfrm flipV="1">
-            <a:off x="4522135" y="1950770"/>
-            <a:ext cx="0" cy="426545"/>
+            <a:off x="4522135" y="2137177"/>
+            <a:ext cx="0" cy="426359"/>
           </a:xfrm>
           <a:prstGeom prst="line">
             <a:avLst/>
@@ -18905,7 +19108,7 @@
           <p:cNvPr id="441" name="Line">
             <a:extLst>
               <a:ext uri="{FF2B5EF4-FFF2-40B4-BE49-F238E27FC236}">
-                <a16:creationId xmlns:a16="http://schemas.microsoft.com/office/drawing/2014/main" id="{DDC3206C-EE10-7829-30F0-735C01470498}"/>
+                <a16:creationId xmlns:a16="http://schemas.microsoft.com/office/drawing/2014/main" id="{6E6F6ABF-7AD7-2DBC-06C7-5C5D0161348A}"/>
               </a:ext>
             </a:extLst>
           </p:cNvPr>
@@ -18914,8 +19117,8 @@
         </p:nvSpPr>
         <p:spPr>
           <a:xfrm flipV="1">
-            <a:off x="4528417" y="2925125"/>
-            <a:ext cx="0" cy="426545"/>
+            <a:off x="4528417" y="3111108"/>
+            <a:ext cx="0" cy="426359"/>
           </a:xfrm>
           <a:prstGeom prst="line">
             <a:avLst/>
@@ -18953,7 +19156,7 @@
           <p:cNvPr id="442" name="Line">
             <a:extLst>
               <a:ext uri="{FF2B5EF4-FFF2-40B4-BE49-F238E27FC236}">
-                <a16:creationId xmlns:a16="http://schemas.microsoft.com/office/drawing/2014/main" id="{3EF9AC49-1B64-A0B4-35C1-74D39609DD10}"/>
+                <a16:creationId xmlns:a16="http://schemas.microsoft.com/office/drawing/2014/main" id="{CDCD9254-B915-4550-63F1-DF060694AC9B}"/>
               </a:ext>
             </a:extLst>
           </p:cNvPr>
@@ -18962,8 +19165,8 @@
         </p:nvSpPr>
         <p:spPr>
           <a:xfrm flipV="1">
-            <a:off x="4522135" y="3712979"/>
-            <a:ext cx="0" cy="616883"/>
+            <a:off x="4522135" y="3898620"/>
+            <a:ext cx="0" cy="616615"/>
           </a:xfrm>
           <a:prstGeom prst="line">
             <a:avLst/>
@@ -19001,7 +19204,7 @@
           <p:cNvPr id="443" name="Line">
             <a:extLst>
               <a:ext uri="{FF2B5EF4-FFF2-40B4-BE49-F238E27FC236}">
-                <a16:creationId xmlns:a16="http://schemas.microsoft.com/office/drawing/2014/main" id="{9E211AE0-28BC-722B-1958-EE44592D73A5}"/>
+                <a16:creationId xmlns:a16="http://schemas.microsoft.com/office/drawing/2014/main" id="{CA331611-3419-507E-22F2-EE72AB63F851}"/>
               </a:ext>
             </a:extLst>
           </p:cNvPr>
@@ -19010,8 +19213,8 @@
         </p:nvSpPr>
         <p:spPr>
           <a:xfrm flipV="1">
-            <a:off x="4522135" y="4885657"/>
-            <a:ext cx="0" cy="859416"/>
+            <a:off x="4522135" y="5070787"/>
+            <a:ext cx="0" cy="859042"/>
           </a:xfrm>
           <a:prstGeom prst="line">
             <a:avLst/>
@@ -19049,7 +19252,7 @@
           <p:cNvPr id="444" name="Line">
             <a:extLst>
               <a:ext uri="{FF2B5EF4-FFF2-40B4-BE49-F238E27FC236}">
-                <a16:creationId xmlns:a16="http://schemas.microsoft.com/office/drawing/2014/main" id="{D0E9FD65-C049-65A7-B6C0-3A603D16B6CA}"/>
+                <a16:creationId xmlns:a16="http://schemas.microsoft.com/office/drawing/2014/main" id="{783934E5-8894-142F-3FDC-7E61CC9B86A1}"/>
               </a:ext>
             </a:extLst>
           </p:cNvPr>
@@ -19058,8 +19261,8 @@
         </p:nvSpPr>
         <p:spPr>
           <a:xfrm flipV="1">
-            <a:off x="4522135" y="6345871"/>
-            <a:ext cx="0" cy="1081129"/>
+            <a:off x="4522135" y="6530366"/>
+            <a:ext cx="0" cy="1080659"/>
           </a:xfrm>
           <a:prstGeom prst="line">
             <a:avLst/>
@@ -19097,7 +19300,7 @@
           <p:cNvPr id="445" name="Line">
             <a:extLst>
               <a:ext uri="{FF2B5EF4-FFF2-40B4-BE49-F238E27FC236}">
-                <a16:creationId xmlns:a16="http://schemas.microsoft.com/office/drawing/2014/main" id="{2292D67B-9D57-D88E-6900-85ECCA11FD6B}"/>
+                <a16:creationId xmlns:a16="http://schemas.microsoft.com/office/drawing/2014/main" id="{520E53C8-C9B4-3EC1-72DD-B457A422BA56}"/>
               </a:ext>
             </a:extLst>
           </p:cNvPr>
@@ -19106,8 +19309,8 @@
         </p:nvSpPr>
         <p:spPr>
           <a:xfrm flipV="1">
-            <a:off x="4526280" y="8228494"/>
-            <a:ext cx="0" cy="426545"/>
+            <a:off x="4526280" y="8412170"/>
+            <a:ext cx="0" cy="426359"/>
           </a:xfrm>
           <a:prstGeom prst="line">
             <a:avLst/>
@@ -19145,7 +19348,7 @@
           <p:cNvPr id="513" name="TextBox 512">
             <a:extLst>
               <a:ext uri="{FF2B5EF4-FFF2-40B4-BE49-F238E27FC236}">
-                <a16:creationId xmlns:a16="http://schemas.microsoft.com/office/drawing/2014/main" id="{05FD7C69-0475-9BAF-050A-DE7EBF21FD1E}"/>
+                <a16:creationId xmlns:a16="http://schemas.microsoft.com/office/drawing/2014/main" id="{42697ED6-BE8A-A7DD-963E-018B8D2609F4}"/>
               </a:ext>
             </a:extLst>
           </p:cNvPr>
@@ -19154,8 +19357,8 @@
         </p:nvSpPr>
         <p:spPr>
           <a:xfrm>
-            <a:off x="3840480" y="3761082"/>
-            <a:ext cx="582846" cy="469278"/>
+            <a:off x="3840480" y="3946702"/>
+            <a:ext cx="582846" cy="469074"/>
           </a:xfrm>
           <a:prstGeom prst="rect">
             <a:avLst/>
@@ -19247,7 +19450,7 @@
           <p:cNvPr id="529" name="Manipulate Variables">
             <a:extLst>
               <a:ext uri="{FF2B5EF4-FFF2-40B4-BE49-F238E27FC236}">
-                <a16:creationId xmlns:a16="http://schemas.microsoft.com/office/drawing/2014/main" id="{A5F7FD4C-8100-CB1F-1E66-096E5944C08F}"/>
+                <a16:creationId xmlns:a16="http://schemas.microsoft.com/office/drawing/2014/main" id="{09ED3F92-875A-0DE6-0C8E-899A696C03F3}"/>
               </a:ext>
             </a:extLst>
           </p:cNvPr>
@@ -19257,7 +19460,7 @@
         <p:spPr>
           <a:xfrm>
             <a:off x="274320" y="3474720"/>
-            <a:ext cx="1800173" cy="340029"/>
+            <a:ext cx="1800173" cy="339881"/>
           </a:xfrm>
           <a:prstGeom prst="rect">
             <a:avLst/>
@@ -19298,183 +19501,12 @@
           </a:p>
         </p:txBody>
       </p:sp>
-      <p:sp>
-        <p:nvSpPr>
-          <p:cNvPr id="5" name="TextBox 4">
-            <a:extLst>
-              <a:ext uri="{FF2B5EF4-FFF2-40B4-BE49-F238E27FC236}">
-                <a16:creationId xmlns:a16="http://schemas.microsoft.com/office/drawing/2014/main" id="{A021A676-A332-26C1-5DF9-C26BDEDF25A8}"/>
-              </a:ext>
-            </a:extLst>
-          </p:cNvPr>
-          <p:cNvSpPr txBox="1"/>
-          <p:nvPr/>
-        </p:nvSpPr>
-        <p:spPr>
-          <a:xfrm>
-            <a:off x="7737264" y="10327008"/>
-            <a:ext cx="6091194" cy="500056"/>
-          </a:xfrm>
-          <a:prstGeom prst="rect">
-            <a:avLst/>
-          </a:prstGeom>
-          <a:noFill/>
-          <a:ln w="12700" cap="flat">
-            <a:noFill/>
-            <a:miter lim="400000"/>
-          </a:ln>
-          <a:effectLst/>
-          <a:sp3d/>
-        </p:spPr>
-        <p:style>
-          <a:lnRef idx="0">
-            <a:scrgbClr r="0" g="0" b="0"/>
-          </a:lnRef>
-          <a:fillRef idx="0">
-            <a:scrgbClr r="0" g="0" b="0"/>
-          </a:fillRef>
-          <a:effectRef idx="0">
-            <a:scrgbClr r="0" g="0" b="0"/>
-          </a:effectRef>
-          <a:fontRef idx="none"/>
-        </p:style>
-        <p:txBody>
-          <a:bodyPr rot="0" spcFirstLastPara="1" vertOverflow="overflow" horzOverflow="overflow" vert="horz" wrap="square" lIns="54570" tIns="54570" rIns="54570" bIns="54570" numCol="1" spcCol="38100" rtlCol="0" anchor="ctr">
-            <a:spAutoFit/>
-          </a:bodyPr>
-          <a:lstStyle/>
-          <a:p>
-            <a:pPr marL="0" marR="0" indent="0" algn="l" defTabSz="584200" rtl="0" fontAlgn="auto" latinLnBrk="0" hangingPunct="0">
-              <a:lnSpc>
-                <a:spcPct val="100000"/>
-              </a:lnSpc>
-              <a:spcBef>
-                <a:spcPts val="200"/>
-              </a:spcBef>
-              <a:spcAft>
-                <a:spcPts val="0"/>
-              </a:spcAft>
-              <a:buClrTx/>
-              <a:buSzTx/>
-              <a:buFontTx/>
-              <a:buNone/>
-              <a:tabLst/>
-            </a:pPr>
-            <a:r>
-              <a:rPr lang="en-US" sz="1000" b="0" dirty="0">
-                <a:solidFill>
-                  <a:schemeClr val="tx1"/>
-                </a:solidFill>
-                <a:hlinkClick r:id="rId6">
-                  <a:extLst>
-                    <a:ext uri="{A12FA001-AC4F-418D-AE19-62706E023703}">
-                      <ahyp:hlinkClr xmlns:ahyp="http://schemas.microsoft.com/office/drawing/2018/hyperlinkcolor" val="tx"/>
-                    </a:ext>
-                  </a:extLst>
-                </a:hlinkClick>
-              </a:rPr>
-              <a:t>CC BY SA</a:t>
-            </a:r>
-            <a:r>
-              <a:rPr lang="en-US" sz="1000" b="0" dirty="0">
-                <a:solidFill>
-                  <a:schemeClr val="tx1"/>
-                </a:solidFill>
-              </a:rPr>
-              <a:t> Jared Seto</a:t>
-            </a:r>
-            <a:r>
-              <a:rPr kumimoji="0" lang="en-US" sz="1000" b="0" i="0" u="none" strike="noStrike" cap="none" spc="0" normalizeH="0" baseline="0" dirty="0">
-                <a:ln>
-                  <a:noFill/>
-                </a:ln>
-                <a:solidFill>
-                  <a:schemeClr val="tx1"/>
-                </a:solidFill>
-                <a:effectLst/>
-                <a:uFillTx/>
-                <a:latin typeface="Source Sans Pro"/>
-                <a:ea typeface="Source Sans Pro"/>
-                <a:cs typeface="Source Sans Pro"/>
-                <a:sym typeface="Source Sans Pro"/>
-              </a:rPr>
-              <a:t>, Carlos Paradis • Kai</a:t>
-            </a:r>
-            <a:r>
-              <a:rPr kumimoji="0" lang="haw-US" sz="1000" b="0" i="0" u="none" strike="noStrike" cap="none" spc="0" normalizeH="0" baseline="0" dirty="0">
-                <a:ln>
-                  <a:noFill/>
-                </a:ln>
-                <a:solidFill>
-                  <a:schemeClr val="tx1"/>
-                </a:solidFill>
-                <a:effectLst/>
-                <a:uFillTx/>
-                <a:latin typeface="Source Sans Pro"/>
-                <a:ea typeface="Source Sans Pro"/>
-                <a:cs typeface="Source Sans Pro"/>
-                <a:sym typeface="Source Sans Pro"/>
-              </a:rPr>
-              <a:t>ā</a:t>
-            </a:r>
-            <a:r>
-              <a:rPr kumimoji="0" lang="en-US" sz="1000" b="0" i="0" u="none" strike="noStrike" cap="none" spc="0" normalizeH="0" baseline="0" dirty="0">
-                <a:ln>
-                  <a:noFill/>
-                </a:ln>
-                <a:solidFill>
-                  <a:schemeClr val="tx1"/>
-                </a:solidFill>
-                <a:effectLst/>
-                <a:uFillTx/>
-                <a:latin typeface="Source Sans Pro"/>
-                <a:ea typeface="Source Sans Pro"/>
-                <a:cs typeface="Source Sans Pro"/>
-                <a:sym typeface="Source Sans Pro"/>
-              </a:rPr>
-              <a:t>ulu package version 0.0.0.9700 (in development) •  Updated: 2026-04</a:t>
-            </a:r>
-          </a:p>
-          <a:p>
-            <a:pPr marL="0" marR="0" indent="0" algn="l" defTabSz="584200" rtl="0" fontAlgn="auto" latinLnBrk="0" hangingPunct="0">
-              <a:lnSpc>
-                <a:spcPct val="100000"/>
-              </a:lnSpc>
-              <a:spcBef>
-                <a:spcPts val="200"/>
-              </a:spcBef>
-              <a:spcAft>
-                <a:spcPts val="0"/>
-              </a:spcAft>
-              <a:buClrTx/>
-              <a:buSzTx/>
-              <a:buFontTx/>
-              <a:buNone/>
-              <a:tabLst/>
-            </a:pPr>
-            <a:endParaRPr kumimoji="0" lang="en-US" sz="1200" b="1" i="0" u="none" strike="noStrike" cap="none" spc="0" normalizeH="0" baseline="0" dirty="0">
-              <a:ln>
-                <a:noFill/>
-              </a:ln>
-              <a:solidFill>
-                <a:srgbClr val="4C4C4C"/>
-              </a:solidFill>
-              <a:effectLst/>
-              <a:uFillTx/>
-              <a:latin typeface="Source Sans Pro"/>
-              <a:ea typeface="Source Sans Pro"/>
-              <a:cs typeface="Source Sans Pro"/>
-              <a:sym typeface="Source Sans Pro"/>
-            </a:endParaRPr>
-          </a:p>
-        </p:txBody>
-      </p:sp>
       <p:cxnSp>
         <p:nvCxnSpPr>
           <p:cNvPr id="519" name="Connector: Elbow 518">
             <a:extLst>
               <a:ext uri="{FF2B5EF4-FFF2-40B4-BE49-F238E27FC236}">
-                <a16:creationId xmlns:a16="http://schemas.microsoft.com/office/drawing/2014/main" id="{9BA869DB-971D-74A4-27C3-0A760733BDD8}"/>
+                <a16:creationId xmlns:a16="http://schemas.microsoft.com/office/drawing/2014/main" id="{F02E0EB9-E8F0-C8E0-77CD-037967C13C7F}"/>
               </a:ext>
             </a:extLst>
           </p:cNvPr>
@@ -19486,12 +19518,12 @@
         </p:nvCxnSpPr>
         <p:spPr>
           <a:xfrm flipV="1">
-            <a:off x="5249371" y="8491055"/>
-            <a:ext cx="4626149" cy="557801"/>
+            <a:off x="5253412" y="8490981"/>
+            <a:ext cx="4622108" cy="768741"/>
           </a:xfrm>
           <a:prstGeom prst="bentConnector3">
             <a:avLst>
-              <a:gd name="adj1" fmla="val 95719"/>
+              <a:gd name="adj1" fmla="val 96900"/>
             </a:avLst>
           </a:prstGeom>
           <a:noFill/>
@@ -19523,7 +19555,7 @@
           <p:cNvPr id="547" name="Connector: Elbow 546">
             <a:extLst>
               <a:ext uri="{FF2B5EF4-FFF2-40B4-BE49-F238E27FC236}">
-                <a16:creationId xmlns:a16="http://schemas.microsoft.com/office/drawing/2014/main" id="{9FF53575-0D03-03D5-8563-ACEF5867A3E7}"/>
+                <a16:creationId xmlns:a16="http://schemas.microsoft.com/office/drawing/2014/main" id="{56A8DEF2-D40B-F343-BAC6-2001D715DF0D}"/>
               </a:ext>
             </a:extLst>
           </p:cNvPr>
@@ -19535,12 +19567,12 @@
         </p:nvCxnSpPr>
         <p:spPr>
           <a:xfrm flipV="1">
-            <a:off x="2074493" y="2148962"/>
-            <a:ext cx="1765987" cy="1495773"/>
+            <a:off x="2074493" y="2335283"/>
+            <a:ext cx="1765987" cy="1309378"/>
           </a:xfrm>
           <a:prstGeom prst="bentConnector3">
             <a:avLst>
-              <a:gd name="adj1" fmla="val 82702"/>
+              <a:gd name="adj1" fmla="val 83560"/>
             </a:avLst>
           </a:prstGeom>
           <a:noFill/>
@@ -19572,7 +19604,7 @@
           <p:cNvPr id="550" name="Straight Connector 549">
             <a:extLst>
               <a:ext uri="{FF2B5EF4-FFF2-40B4-BE49-F238E27FC236}">
-                <a16:creationId xmlns:a16="http://schemas.microsoft.com/office/drawing/2014/main" id="{889FE9ED-2B51-F3C3-FA77-893D112F5968}"/>
+                <a16:creationId xmlns:a16="http://schemas.microsoft.com/office/drawing/2014/main" id="{8B69D299-1C72-C90C-7896-7666F616953E}"/>
               </a:ext>
             </a:extLst>
           </p:cNvPr>
@@ -19585,8 +19617,8 @@
         </p:nvCxnSpPr>
         <p:spPr>
           <a:xfrm flipV="1">
-            <a:off x="1292227" y="3099580"/>
-            <a:ext cx="2548253" cy="2373955"/>
+            <a:off x="1292227" y="3285487"/>
+            <a:ext cx="2548253" cy="2372922"/>
           </a:xfrm>
           <a:prstGeom prst="bentConnector3">
             <a:avLst>
@@ -19622,7 +19654,7 @@
           <p:cNvPr id="556" name="Connector: Elbow 555">
             <a:extLst>
               <a:ext uri="{FF2B5EF4-FFF2-40B4-BE49-F238E27FC236}">
-                <a16:creationId xmlns:a16="http://schemas.microsoft.com/office/drawing/2014/main" id="{17FBEFDD-28C1-94DB-8761-9BD9249709CD}"/>
+                <a16:creationId xmlns:a16="http://schemas.microsoft.com/office/drawing/2014/main" id="{8330692E-1811-56A8-D86E-C71BB0992C2B}"/>
               </a:ext>
             </a:extLst>
           </p:cNvPr>
@@ -19635,12 +19667,12 @@
         </p:nvCxnSpPr>
         <p:spPr>
           <a:xfrm flipV="1">
-            <a:off x="2100141" y="3995721"/>
-            <a:ext cx="1740339" cy="3672374"/>
+            <a:off x="2100141" y="4181239"/>
+            <a:ext cx="1740339" cy="3943982"/>
           </a:xfrm>
           <a:prstGeom prst="bentConnector3">
             <a:avLst>
-              <a:gd name="adj1" fmla="val 92171"/>
+              <a:gd name="adj1" fmla="val 94097"/>
             </a:avLst>
           </a:prstGeom>
           <a:noFill/>
@@ -19672,7 +19704,7 @@
           <p:cNvPr id="565" name="Connector: Elbow 564">
             <a:extLst>
               <a:ext uri="{FF2B5EF4-FFF2-40B4-BE49-F238E27FC236}">
-                <a16:creationId xmlns:a16="http://schemas.microsoft.com/office/drawing/2014/main" id="{F274FF41-671D-CF9E-7F86-E22B8144400D}"/>
+                <a16:creationId xmlns:a16="http://schemas.microsoft.com/office/drawing/2014/main" id="{BCA8B882-C6B6-A4DD-4311-3E1AAA2D773D}"/>
               </a:ext>
             </a:extLst>
           </p:cNvPr>
@@ -19684,11 +19716,13 @@
         </p:nvCxnSpPr>
         <p:spPr>
           <a:xfrm rot="16200000" flipH="1">
-            <a:off x="5549608" y="2703047"/>
-            <a:ext cx="261031" cy="2153"/>
+            <a:off x="5549664" y="2889127"/>
+            <a:ext cx="260918" cy="2153"/>
           </a:xfrm>
           <a:prstGeom prst="bentConnector3">
-            <a:avLst/>
+            <a:avLst>
+              <a:gd name="adj1" fmla="val 50000"/>
+            </a:avLst>
           </a:prstGeom>
           <a:noFill/>
           <a:ln w="25400" cap="flat">
@@ -19720,7 +19754,7 @@
           <p:cNvPr id="566" name="Connector: Elbow 565">
             <a:extLst>
               <a:ext uri="{FF2B5EF4-FFF2-40B4-BE49-F238E27FC236}">
-                <a16:creationId xmlns:a16="http://schemas.microsoft.com/office/drawing/2014/main" id="{189587FC-9AFA-C56F-82DF-7BE506E32334}"/>
+                <a16:creationId xmlns:a16="http://schemas.microsoft.com/office/drawing/2014/main" id="{F5990A00-F415-9D7B-35A9-77FF4B38C180}"/>
               </a:ext>
             </a:extLst>
           </p:cNvPr>
@@ -19733,11 +19767,13 @@
         </p:nvCxnSpPr>
         <p:spPr>
           <a:xfrm rot="16200000" flipH="1">
-            <a:off x="6777668" y="2684172"/>
-            <a:ext cx="288585" cy="12350"/>
+            <a:off x="6777730" y="2870258"/>
+            <a:ext cx="288460" cy="12350"/>
           </a:xfrm>
           <a:prstGeom prst="bentConnector3">
-            <a:avLst/>
+            <a:avLst>
+              <a:gd name="adj1" fmla="val 50000"/>
+            </a:avLst>
           </a:prstGeom>
           <a:noFill/>
           <a:ln w="25400" cap="flat">
@@ -19769,7 +19805,7 @@
           <p:cNvPr id="569" name="Connector: Elbow 568">
             <a:extLst>
               <a:ext uri="{FF2B5EF4-FFF2-40B4-BE49-F238E27FC236}">
-                <a16:creationId xmlns:a16="http://schemas.microsoft.com/office/drawing/2014/main" id="{C648418A-9600-9E5C-778F-D1FD96346F94}"/>
+                <a16:creationId xmlns:a16="http://schemas.microsoft.com/office/drawing/2014/main" id="{0AE795BF-03B0-78D4-F7CE-EE3912498F04}"/>
               </a:ext>
             </a:extLst>
           </p:cNvPr>
@@ -19782,8 +19818,8 @@
         </p:nvCxnSpPr>
         <p:spPr>
           <a:xfrm rot="16200000" flipH="1">
-            <a:off x="8050345" y="2680382"/>
-            <a:ext cx="302822" cy="5694"/>
+            <a:off x="8050411" y="2866470"/>
+            <a:ext cx="302691" cy="5694"/>
           </a:xfrm>
           <a:prstGeom prst="bentConnector3">
             <a:avLst>
@@ -19820,7 +19856,7 @@
           <p:cNvPr id="572" name="Connector: Elbow 571">
             <a:extLst>
               <a:ext uri="{FF2B5EF4-FFF2-40B4-BE49-F238E27FC236}">
-                <a16:creationId xmlns:a16="http://schemas.microsoft.com/office/drawing/2014/main" id="{0B15C6E8-1347-2C75-176E-309DC5D9077F}"/>
+                <a16:creationId xmlns:a16="http://schemas.microsoft.com/office/drawing/2014/main" id="{BD6E41A4-77D5-AF05-441F-2FB818FC6908}"/>
               </a:ext>
             </a:extLst>
           </p:cNvPr>
@@ -19832,8 +19868,8 @@
         </p:nvCxnSpPr>
         <p:spPr>
           <a:xfrm rot="16200000" flipH="1">
-            <a:off x="5570266" y="3539329"/>
-            <a:ext cx="223234" cy="1366"/>
+            <a:off x="5570444" y="3725173"/>
+            <a:ext cx="222875" cy="1363"/>
           </a:xfrm>
           <a:prstGeom prst="bentConnector3">
             <a:avLst>
@@ -19870,7 +19906,7 @@
           <p:cNvPr id="575" name="Connector: Elbow 574">
             <a:extLst>
               <a:ext uri="{FF2B5EF4-FFF2-40B4-BE49-F238E27FC236}">
-                <a16:creationId xmlns:a16="http://schemas.microsoft.com/office/drawing/2014/main" id="{25D4E70D-5A32-FEBA-309F-FDC24EAD1747}"/>
+                <a16:creationId xmlns:a16="http://schemas.microsoft.com/office/drawing/2014/main" id="{92354F6D-5E04-48F9-A18D-4188687EFF66}"/>
               </a:ext>
             </a:extLst>
           </p:cNvPr>
@@ -19882,8 +19918,8 @@
         </p:nvCxnSpPr>
         <p:spPr>
           <a:xfrm rot="5400000">
-            <a:off x="6822937" y="3533593"/>
-            <a:ext cx="210396" cy="0"/>
+            <a:off x="6816796" y="3719409"/>
+            <a:ext cx="216330" cy="6348"/>
           </a:xfrm>
           <a:prstGeom prst="bentConnector3">
             <a:avLst>
@@ -19920,7 +19956,7 @@
           <p:cNvPr id="261" name="Connector: Elbow 260">
             <a:extLst>
               <a:ext uri="{FF2B5EF4-FFF2-40B4-BE49-F238E27FC236}">
-                <a16:creationId xmlns:a16="http://schemas.microsoft.com/office/drawing/2014/main" id="{C458A771-B9C8-CF31-4AF9-C48AF26C9A6F}"/>
+                <a16:creationId xmlns:a16="http://schemas.microsoft.com/office/drawing/2014/main" id="{3FD55C3D-720E-D5F7-1387-C64DD9B57938}"/>
               </a:ext>
             </a:extLst>
           </p:cNvPr>
@@ -19932,8 +19968,8 @@
         </p:nvCxnSpPr>
         <p:spPr>
           <a:xfrm rot="5400000">
-            <a:off x="8099447" y="3533551"/>
-            <a:ext cx="210312" cy="0"/>
+            <a:off x="8093340" y="3719333"/>
+            <a:ext cx="216179" cy="6348"/>
           </a:xfrm>
           <a:prstGeom prst="bentConnector3">
             <a:avLst>
@@ -19970,7 +20006,7 @@
           <p:cNvPr id="355" name="Connector: Elbow 354">
             <a:extLst>
               <a:ext uri="{FF2B5EF4-FFF2-40B4-BE49-F238E27FC236}">
-                <a16:creationId xmlns:a16="http://schemas.microsoft.com/office/drawing/2014/main" id="{E481BCF5-441D-2F21-AF62-230F42D166A0}"/>
+                <a16:creationId xmlns:a16="http://schemas.microsoft.com/office/drawing/2014/main" id="{EDF85F35-718C-1383-480B-10C64C15D511}"/>
               </a:ext>
             </a:extLst>
           </p:cNvPr>
@@ -19982,8 +20018,8 @@
         </p:nvCxnSpPr>
         <p:spPr>
           <a:xfrm rot="16200000" flipH="1">
-            <a:off x="5457123" y="4535855"/>
-            <a:ext cx="664634" cy="213754"/>
+            <a:off x="5457268" y="4721091"/>
+            <a:ext cx="664345" cy="213754"/>
           </a:xfrm>
           <a:prstGeom prst="bentConnector2">
             <a:avLst/>
@@ -20018,7 +20054,7 @@
           <p:cNvPr id="369" name="TextBox 368">
             <a:extLst>
               <a:ext uri="{FF2B5EF4-FFF2-40B4-BE49-F238E27FC236}">
-                <a16:creationId xmlns:a16="http://schemas.microsoft.com/office/drawing/2014/main" id="{F408071B-0623-4FDE-544A-2D81799291ED}"/>
+                <a16:creationId xmlns:a16="http://schemas.microsoft.com/office/drawing/2014/main" id="{5A2A7A5D-319F-30BB-D29E-89B3CEFAA433}"/>
               </a:ext>
             </a:extLst>
           </p:cNvPr>
@@ -20027,8 +20063,8 @@
         </p:nvSpPr>
         <p:spPr>
           <a:xfrm>
-            <a:off x="5896317" y="4604475"/>
-            <a:ext cx="2124618" cy="741148"/>
+            <a:off x="5896317" y="4789728"/>
+            <a:ext cx="2124618" cy="740826"/>
           </a:xfrm>
           <a:prstGeom prst="rect">
             <a:avLst/>
@@ -20148,7 +20184,7 @@
           <p:cNvPr id="382" name="Connector: Elbow 381">
             <a:extLst>
               <a:ext uri="{FF2B5EF4-FFF2-40B4-BE49-F238E27FC236}">
-                <a16:creationId xmlns:a16="http://schemas.microsoft.com/office/drawing/2014/main" id="{F8DB6194-64EF-EF89-A661-C8D371F0F56A}"/>
+                <a16:creationId xmlns:a16="http://schemas.microsoft.com/office/drawing/2014/main" id="{B3BC2F61-4A8C-75D1-876E-445E671AE995}"/>
               </a:ext>
             </a:extLst>
           </p:cNvPr>
@@ -20160,8 +20196,8 @@
         </p:nvCxnSpPr>
         <p:spPr>
           <a:xfrm rot="16200000" flipH="1">
-            <a:off x="6776146" y="4452487"/>
-            <a:ext cx="303976" cy="0"/>
+            <a:off x="6776212" y="4637806"/>
+            <a:ext cx="303844" cy="0"/>
           </a:xfrm>
           <a:prstGeom prst="bentConnector3">
             <a:avLst/>
@@ -20196,7 +20232,7 @@
           <p:cNvPr id="425" name="Connector: Elbow 424">
             <a:extLst>
               <a:ext uri="{FF2B5EF4-FFF2-40B4-BE49-F238E27FC236}">
-                <a16:creationId xmlns:a16="http://schemas.microsoft.com/office/drawing/2014/main" id="{DF96DCAF-7A15-2458-B9E4-A232AFD2D8BB}"/>
+                <a16:creationId xmlns:a16="http://schemas.microsoft.com/office/drawing/2014/main" id="{DD720D28-0D7C-87D2-A19E-FE1B13916C20}"/>
               </a:ext>
             </a:extLst>
           </p:cNvPr>
@@ -20208,8 +20244,8 @@
         </p:nvCxnSpPr>
         <p:spPr>
           <a:xfrm rot="5400000">
-            <a:off x="7747432" y="4530189"/>
-            <a:ext cx="718364" cy="171357"/>
+            <a:off x="7747588" y="4715437"/>
+            <a:ext cx="718051" cy="171357"/>
           </a:xfrm>
           <a:prstGeom prst="bentConnector2">
             <a:avLst/>
@@ -20244,7 +20280,7 @@
           <p:cNvPr id="433" name="Connector: Elbow 432">
             <a:extLst>
               <a:ext uri="{FF2B5EF4-FFF2-40B4-BE49-F238E27FC236}">
-                <a16:creationId xmlns:a16="http://schemas.microsoft.com/office/drawing/2014/main" id="{2F05E601-94EE-AD57-E695-339F28AEB042}"/>
+                <a16:creationId xmlns:a16="http://schemas.microsoft.com/office/drawing/2014/main" id="{59B01F11-D318-BC50-6232-DC3B392986C6}"/>
               </a:ext>
             </a:extLst>
           </p:cNvPr>
@@ -20255,8 +20291,8 @@
         </p:nvCxnSpPr>
         <p:spPr>
           <a:xfrm rot="5400000">
-            <a:off x="6675120" y="6223177"/>
-            <a:ext cx="580803" cy="0"/>
+            <a:off x="6675246" y="6407725"/>
+            <a:ext cx="580550" cy="0"/>
           </a:xfrm>
           <a:prstGeom prst="bentConnector3">
             <a:avLst/>
@@ -20291,7 +20327,7 @@
           <p:cNvPr id="436" name="Connector: Elbow 435">
             <a:extLst>
               <a:ext uri="{FF2B5EF4-FFF2-40B4-BE49-F238E27FC236}">
-                <a16:creationId xmlns:a16="http://schemas.microsoft.com/office/drawing/2014/main" id="{434584EA-C5DF-4066-279F-D4298CDC6CBB}"/>
+                <a16:creationId xmlns:a16="http://schemas.microsoft.com/office/drawing/2014/main" id="{B614C890-8DF1-9AFA-F5C1-C65FF66F8442}"/>
               </a:ext>
             </a:extLst>
           </p:cNvPr>
@@ -20303,8 +20339,8 @@
         </p:nvCxnSpPr>
         <p:spPr>
           <a:xfrm rot="10800000" flipV="1">
-            <a:off x="5466126" y="5555851"/>
-            <a:ext cx="439624" cy="591063"/>
+            <a:off x="5466126" y="5740690"/>
+            <a:ext cx="439624" cy="590806"/>
           </a:xfrm>
           <a:prstGeom prst="bentConnector2">
             <a:avLst/>
@@ -20339,7 +20375,7 @@
           <p:cNvPr id="440" name="TextBox 439">
             <a:extLst>
               <a:ext uri="{FF2B5EF4-FFF2-40B4-BE49-F238E27FC236}">
-                <a16:creationId xmlns:a16="http://schemas.microsoft.com/office/drawing/2014/main" id="{5793ADFD-CCB8-8A89-70D9-D9892CABE987}"/>
+                <a16:creationId xmlns:a16="http://schemas.microsoft.com/office/drawing/2014/main" id="{27E334C2-1219-9FDD-CA4B-B1C7B7C9A800}"/>
               </a:ext>
             </a:extLst>
           </p:cNvPr>
@@ -20348,8 +20384,8 @@
         </p:nvSpPr>
         <p:spPr>
           <a:xfrm>
-            <a:off x="5905750" y="5185278"/>
-            <a:ext cx="2124618" cy="741148"/>
+            <a:off x="5905750" y="5370278"/>
+            <a:ext cx="2124618" cy="740826"/>
           </a:xfrm>
           <a:prstGeom prst="rect">
             <a:avLst/>
@@ -20469,7 +20505,7 @@
           <p:cNvPr id="576" name="Connector: Elbow 575">
             <a:extLst>
               <a:ext uri="{FF2B5EF4-FFF2-40B4-BE49-F238E27FC236}">
-                <a16:creationId xmlns:a16="http://schemas.microsoft.com/office/drawing/2014/main" id="{B3C20A9D-8742-1C1F-A519-76E6D3EDA865}"/>
+                <a16:creationId xmlns:a16="http://schemas.microsoft.com/office/drawing/2014/main" id="{6E551EF7-74B5-3C71-111B-DA0E615F35C7}"/>
               </a:ext>
             </a:extLst>
           </p:cNvPr>
@@ -20481,8 +20517,8 @@
         </p:nvCxnSpPr>
         <p:spPr>
           <a:xfrm>
-            <a:off x="8030368" y="5555852"/>
-            <a:ext cx="542787" cy="893070"/>
+            <a:off x="8030368" y="5740691"/>
+            <a:ext cx="542787" cy="892681"/>
           </a:xfrm>
           <a:prstGeom prst="bentConnector2">
             <a:avLst/>
@@ -20517,7 +20553,7 @@
           <p:cNvPr id="580" name="Connector: Elbow 579">
             <a:extLst>
               <a:ext uri="{FF2B5EF4-FFF2-40B4-BE49-F238E27FC236}">
-                <a16:creationId xmlns:a16="http://schemas.microsoft.com/office/drawing/2014/main" id="{9E2E05B6-082A-A05B-5F99-23C32DEDA2A8}"/>
+                <a16:creationId xmlns:a16="http://schemas.microsoft.com/office/drawing/2014/main" id="{8F217B19-AD53-B1FA-EA55-DFF3D807F6B7}"/>
               </a:ext>
             </a:extLst>
           </p:cNvPr>
@@ -20529,8 +20565,8 @@
         </p:nvCxnSpPr>
         <p:spPr>
           <a:xfrm>
-            <a:off x="5705594" y="7554120"/>
-            <a:ext cx="1064272" cy="896502"/>
+            <a:off x="5705594" y="7738089"/>
+            <a:ext cx="1064272" cy="896112"/>
           </a:xfrm>
           <a:prstGeom prst="bentConnector3">
             <a:avLst>
@@ -20567,7 +20603,7 @@
           <p:cNvPr id="583" name="Connector: Elbow 582">
             <a:extLst>
               <a:ext uri="{FF2B5EF4-FFF2-40B4-BE49-F238E27FC236}">
-                <a16:creationId xmlns:a16="http://schemas.microsoft.com/office/drawing/2014/main" id="{020176F5-FC7D-60E6-3F82-649F019E37BE}"/>
+                <a16:creationId xmlns:a16="http://schemas.microsoft.com/office/drawing/2014/main" id="{B283991E-5BC6-7E64-EF14-F45D3E811DF5}"/>
               </a:ext>
             </a:extLst>
           </p:cNvPr>
@@ -20578,8 +20614,8 @@
         </p:nvCxnSpPr>
         <p:spPr>
           <a:xfrm rot="5400000">
-            <a:off x="6583680" y="7835471"/>
-            <a:ext cx="800034" cy="0"/>
+            <a:off x="6583854" y="8019318"/>
+            <a:ext cx="799686" cy="0"/>
           </a:xfrm>
           <a:prstGeom prst="bentConnector3">
             <a:avLst/>
@@ -20614,7 +20650,7 @@
           <p:cNvPr id="588" name="Connector: Elbow 587">
             <a:extLst>
               <a:ext uri="{FF2B5EF4-FFF2-40B4-BE49-F238E27FC236}">
-                <a16:creationId xmlns:a16="http://schemas.microsoft.com/office/drawing/2014/main" id="{E7CE68B9-2A64-7B5F-A49F-EE5DE157C86C}"/>
+                <a16:creationId xmlns:a16="http://schemas.microsoft.com/office/drawing/2014/main" id="{D2EFB4B0-426A-CAF5-7290-BFDF7A52E52C}"/>
               </a:ext>
             </a:extLst>
           </p:cNvPr>
@@ -20626,8 +20662,8 @@
         </p:nvCxnSpPr>
         <p:spPr>
           <a:xfrm rot="10800000" flipV="1">
-            <a:off x="7276368" y="7477246"/>
-            <a:ext cx="1371600" cy="973376"/>
+            <a:off x="7276368" y="7661249"/>
+            <a:ext cx="1371600" cy="972953"/>
           </a:xfrm>
           <a:prstGeom prst="bentConnector3">
             <a:avLst>
@@ -20664,7 +20700,7 @@
           <p:cNvPr id="31" name="Group 30">
             <a:extLst>
               <a:ext uri="{FF2B5EF4-FFF2-40B4-BE49-F238E27FC236}">
-                <a16:creationId xmlns:a16="http://schemas.microsoft.com/office/drawing/2014/main" id="{8647FB9C-D8FA-4001-B1D2-B3657701513D}"/>
+                <a16:creationId xmlns:a16="http://schemas.microsoft.com/office/drawing/2014/main" id="{94409BD0-DCDC-3513-7F68-76FE4EFBE7B0}"/>
               </a:ext>
             </a:extLst>
           </p:cNvPr>
@@ -20673,8 +20709,8 @@
         </p:nvGrpSpPr>
         <p:grpSpPr>
           <a:xfrm>
-            <a:off x="4743746" y="6200121"/>
-            <a:ext cx="1467990" cy="1268806"/>
+            <a:off x="4743746" y="6384680"/>
+            <a:ext cx="1467990" cy="1268254"/>
             <a:chOff x="4743746" y="6200121"/>
             <a:chExt cx="1467990" cy="1268806"/>
           </a:xfrm>
@@ -20684,7 +20720,7 @@
             <p:cNvPr id="373" name="Google Shape;156;p1">
               <a:extLst>
                 <a:ext uri="{FF2B5EF4-FFF2-40B4-BE49-F238E27FC236}">
-                  <a16:creationId xmlns:a16="http://schemas.microsoft.com/office/drawing/2014/main" id="{BDC09C9D-132F-7914-DAC2-87355B91B2FB}"/>
+                  <a16:creationId xmlns:a16="http://schemas.microsoft.com/office/drawing/2014/main" id="{607ECD8A-61FA-E922-E51A-E9D8CB1F3BD4}"/>
                 </a:ext>
               </a:extLst>
             </p:cNvPr>
@@ -20704,7 +20740,7 @@
               <p:cNvPr id="374" name="Google Shape;157;p1">
                 <a:extLst>
                   <a:ext uri="{FF2B5EF4-FFF2-40B4-BE49-F238E27FC236}">
-                    <a16:creationId xmlns:a16="http://schemas.microsoft.com/office/drawing/2014/main" id="{BC50F154-031F-179A-51F4-EFA1E477332B}"/>
+                    <a16:creationId xmlns:a16="http://schemas.microsoft.com/office/drawing/2014/main" id="{47BE0489-A4CC-76CB-A652-087D8DE5A95A}"/>
                   </a:ext>
                 </a:extLst>
               </p:cNvPr>
@@ -20766,7 +20802,7 @@
               <p:cNvPr id="375" name="Google Shape;158;p1">
                 <a:extLst>
                   <a:ext uri="{FF2B5EF4-FFF2-40B4-BE49-F238E27FC236}">
-                    <a16:creationId xmlns:a16="http://schemas.microsoft.com/office/drawing/2014/main" id="{4ECB97E3-9D9C-43D5-D888-99C2B0A33512}"/>
+                    <a16:creationId xmlns:a16="http://schemas.microsoft.com/office/drawing/2014/main" id="{DDEEF1D8-804D-B79B-CBE6-6DA2401527E4}"/>
                   </a:ext>
                 </a:extLst>
               </p:cNvPr>
@@ -20828,7 +20864,7 @@
               <p:cNvPr id="376" name="Google Shape;159;p1">
                 <a:extLst>
                   <a:ext uri="{FF2B5EF4-FFF2-40B4-BE49-F238E27FC236}">
-                    <a16:creationId xmlns:a16="http://schemas.microsoft.com/office/drawing/2014/main" id="{6F0EECA8-2F5F-6328-88BA-775B5C0939B3}"/>
+                    <a16:creationId xmlns:a16="http://schemas.microsoft.com/office/drawing/2014/main" id="{2701943D-13CE-2C9A-810F-6510AEE5F06A}"/>
                   </a:ext>
                 </a:extLst>
               </p:cNvPr>
@@ -20890,7 +20926,7 @@
               <p:cNvPr id="377" name="Google Shape;160;p1">
                 <a:extLst>
                   <a:ext uri="{FF2B5EF4-FFF2-40B4-BE49-F238E27FC236}">
-                    <a16:creationId xmlns:a16="http://schemas.microsoft.com/office/drawing/2014/main" id="{00640BFA-3D23-00B8-6D1A-BEC555CD3E9F}"/>
+                    <a16:creationId xmlns:a16="http://schemas.microsoft.com/office/drawing/2014/main" id="{C957BCB9-7054-BA5B-7AAD-E1EBC8D3FDF3}"/>
                   </a:ext>
                 </a:extLst>
               </p:cNvPr>
@@ -20952,7 +20988,7 @@
               <p:cNvPr id="378" name="Google Shape;161;p1">
                 <a:extLst>
                   <a:ext uri="{FF2B5EF4-FFF2-40B4-BE49-F238E27FC236}">
-                    <a16:creationId xmlns:a16="http://schemas.microsoft.com/office/drawing/2014/main" id="{8275E0F8-FC24-804C-FC38-762752C06019}"/>
+                    <a16:creationId xmlns:a16="http://schemas.microsoft.com/office/drawing/2014/main" id="{D9E8C5B4-532B-12D5-6EBC-BB809BD6F772}"/>
                   </a:ext>
                 </a:extLst>
               </p:cNvPr>
@@ -21014,7 +21050,7 @@
               <p:cNvPr id="379" name="Google Shape;162;p1">
                 <a:extLst>
                   <a:ext uri="{FF2B5EF4-FFF2-40B4-BE49-F238E27FC236}">
-                    <a16:creationId xmlns:a16="http://schemas.microsoft.com/office/drawing/2014/main" id="{20C68E01-E92F-E760-C17D-3B33B1BF2CA1}"/>
+                    <a16:creationId xmlns:a16="http://schemas.microsoft.com/office/drawing/2014/main" id="{3A1FBAD3-FBBF-9E9B-2361-36A3BA74CE54}"/>
                   </a:ext>
                 </a:extLst>
               </p:cNvPr>
@@ -21076,7 +21112,7 @@
               <p:cNvPr id="380" name="Google Shape;163;p1">
                 <a:extLst>
                   <a:ext uri="{FF2B5EF4-FFF2-40B4-BE49-F238E27FC236}">
-                    <a16:creationId xmlns:a16="http://schemas.microsoft.com/office/drawing/2014/main" id="{9955C53A-022D-F0E7-AB94-100463C8B5E3}"/>
+                    <a16:creationId xmlns:a16="http://schemas.microsoft.com/office/drawing/2014/main" id="{7BD51C2A-699A-7B63-468D-5ECA5B2D14CD}"/>
                   </a:ext>
                 </a:extLst>
               </p:cNvPr>
@@ -21138,7 +21174,7 @@
               <p:cNvPr id="381" name="Google Shape;164;p1">
                 <a:extLst>
                   <a:ext uri="{FF2B5EF4-FFF2-40B4-BE49-F238E27FC236}">
-                    <a16:creationId xmlns:a16="http://schemas.microsoft.com/office/drawing/2014/main" id="{4D7A62A7-0C2A-AE4A-780B-8FFB0718DDB2}"/>
+                    <a16:creationId xmlns:a16="http://schemas.microsoft.com/office/drawing/2014/main" id="{FDDB2FAB-AF7F-C3A3-E97B-6B3F1C49D224}"/>
                   </a:ext>
                 </a:extLst>
               </p:cNvPr>
@@ -21200,7 +21236,7 @@
               <p:cNvPr id="383" name="Google Shape;165;p1">
                 <a:extLst>
                   <a:ext uri="{FF2B5EF4-FFF2-40B4-BE49-F238E27FC236}">
-                    <a16:creationId xmlns:a16="http://schemas.microsoft.com/office/drawing/2014/main" id="{CFC23351-7B1A-37A7-0E50-159AB3166A17}"/>
+                    <a16:creationId xmlns:a16="http://schemas.microsoft.com/office/drawing/2014/main" id="{5E2339CC-8B24-BA4E-AC74-59A8B9141947}"/>
                   </a:ext>
                 </a:extLst>
               </p:cNvPr>
@@ -21262,7 +21298,7 @@
               <p:cNvPr id="385" name="Google Shape;166;p1">
                 <a:extLst>
                   <a:ext uri="{FF2B5EF4-FFF2-40B4-BE49-F238E27FC236}">
-                    <a16:creationId xmlns:a16="http://schemas.microsoft.com/office/drawing/2014/main" id="{7282C0EE-6CBD-064E-1BDB-950A1FEF7A66}"/>
+                    <a16:creationId xmlns:a16="http://schemas.microsoft.com/office/drawing/2014/main" id="{4B8F02AB-495A-FC3F-C5D0-EC34FFB6F86E}"/>
                   </a:ext>
                 </a:extLst>
               </p:cNvPr>
@@ -21324,7 +21360,7 @@
               <p:cNvPr id="386" name="Google Shape;167;p1">
                 <a:extLst>
                   <a:ext uri="{FF2B5EF4-FFF2-40B4-BE49-F238E27FC236}">
-                    <a16:creationId xmlns:a16="http://schemas.microsoft.com/office/drawing/2014/main" id="{BAFAB26C-9E9E-0532-DC27-FF16DF9C0093}"/>
+                    <a16:creationId xmlns:a16="http://schemas.microsoft.com/office/drawing/2014/main" id="{C284512F-117C-4DCD-770C-1B5B4E33553A}"/>
                   </a:ext>
                 </a:extLst>
               </p:cNvPr>
@@ -21386,7 +21422,7 @@
               <p:cNvPr id="387" name="Google Shape;168;p1">
                 <a:extLst>
                   <a:ext uri="{FF2B5EF4-FFF2-40B4-BE49-F238E27FC236}">
-                    <a16:creationId xmlns:a16="http://schemas.microsoft.com/office/drawing/2014/main" id="{57D3BB21-9AD3-DE0E-C4BD-B131F35777C9}"/>
+                    <a16:creationId xmlns:a16="http://schemas.microsoft.com/office/drawing/2014/main" id="{6F49490B-B322-A848-A769-5CDD3BE9E5D5}"/>
                   </a:ext>
                 </a:extLst>
               </p:cNvPr>
@@ -21448,7 +21484,7 @@
               <p:cNvPr id="388" name="Google Shape;169;p1">
                 <a:extLst>
                   <a:ext uri="{FF2B5EF4-FFF2-40B4-BE49-F238E27FC236}">
-                    <a16:creationId xmlns:a16="http://schemas.microsoft.com/office/drawing/2014/main" id="{A782F540-7FC9-DF3D-F165-D8D152848118}"/>
+                    <a16:creationId xmlns:a16="http://schemas.microsoft.com/office/drawing/2014/main" id="{8E26ADDB-81B5-FC50-9700-113338531472}"/>
                   </a:ext>
                 </a:extLst>
               </p:cNvPr>
@@ -21510,7 +21546,7 @@
               <p:cNvPr id="389" name="Google Shape;170;p1">
                 <a:extLst>
                   <a:ext uri="{FF2B5EF4-FFF2-40B4-BE49-F238E27FC236}">
-                    <a16:creationId xmlns:a16="http://schemas.microsoft.com/office/drawing/2014/main" id="{800A3974-2421-1AA8-A5D6-17A2BE9AB7CC}"/>
+                    <a16:creationId xmlns:a16="http://schemas.microsoft.com/office/drawing/2014/main" id="{7F977B6F-D9F0-AD6F-32FA-24D7732D3A6A}"/>
                   </a:ext>
                 </a:extLst>
               </p:cNvPr>
@@ -21572,7 +21608,7 @@
               <p:cNvPr id="390" name="Google Shape;171;p1">
                 <a:extLst>
                   <a:ext uri="{FF2B5EF4-FFF2-40B4-BE49-F238E27FC236}">
-                    <a16:creationId xmlns:a16="http://schemas.microsoft.com/office/drawing/2014/main" id="{4E4768CE-4A3C-BC3C-2C84-79CDC149B7D8}"/>
+                    <a16:creationId xmlns:a16="http://schemas.microsoft.com/office/drawing/2014/main" id="{F488CFDA-19DA-0953-DF34-3B620883E4A1}"/>
                   </a:ext>
                 </a:extLst>
               </p:cNvPr>
@@ -21634,7 +21670,7 @@
               <p:cNvPr id="391" name="Google Shape;172;p1">
                 <a:extLst>
                   <a:ext uri="{FF2B5EF4-FFF2-40B4-BE49-F238E27FC236}">
-                    <a16:creationId xmlns:a16="http://schemas.microsoft.com/office/drawing/2014/main" id="{DB8E1FCF-EC6F-8205-7512-2BA7B42B3AF5}"/>
+                    <a16:creationId xmlns:a16="http://schemas.microsoft.com/office/drawing/2014/main" id="{0D244070-7031-BFE7-378C-C617038E4B6F}"/>
                   </a:ext>
                 </a:extLst>
               </p:cNvPr>
@@ -21669,7 +21705,7 @@
               <p:cNvPr id="392" name="Google Shape;173;p1">
                 <a:extLst>
                   <a:ext uri="{FF2B5EF4-FFF2-40B4-BE49-F238E27FC236}">
-                    <a16:creationId xmlns:a16="http://schemas.microsoft.com/office/drawing/2014/main" id="{A882723A-C7B4-F531-D64C-C5E1E65F9A58}"/>
+                    <a16:creationId xmlns:a16="http://schemas.microsoft.com/office/drawing/2014/main" id="{D6E98888-F982-586C-F760-B4E5A61D9940}"/>
                   </a:ext>
                 </a:extLst>
               </p:cNvPr>
@@ -21704,7 +21740,7 @@
               <p:cNvPr id="393" name="Google Shape;175;p1">
                 <a:extLst>
                   <a:ext uri="{FF2B5EF4-FFF2-40B4-BE49-F238E27FC236}">
-                    <a16:creationId xmlns:a16="http://schemas.microsoft.com/office/drawing/2014/main" id="{40E8A6AB-DBDD-CE91-0B80-CC948611D658}"/>
+                    <a16:creationId xmlns:a16="http://schemas.microsoft.com/office/drawing/2014/main" id="{029B868F-1801-A8F7-5CA6-96B88121403C}"/>
                   </a:ext>
                 </a:extLst>
               </p:cNvPr>
@@ -21739,7 +21775,7 @@
               <p:cNvPr id="394" name="Google Shape;177;p1">
                 <a:extLst>
                   <a:ext uri="{FF2B5EF4-FFF2-40B4-BE49-F238E27FC236}">
-                    <a16:creationId xmlns:a16="http://schemas.microsoft.com/office/drawing/2014/main" id="{16D2FD60-4B2B-699F-C8D8-2EAFAE7A1AD6}"/>
+                    <a16:creationId xmlns:a16="http://schemas.microsoft.com/office/drawing/2014/main" id="{73C17E5D-C3F0-E0F4-7F27-D4088FEB891B}"/>
                   </a:ext>
                 </a:extLst>
               </p:cNvPr>
@@ -21774,7 +21810,7 @@
               <p:cNvPr id="395" name="Google Shape;178;p1">
                 <a:extLst>
                   <a:ext uri="{FF2B5EF4-FFF2-40B4-BE49-F238E27FC236}">
-                    <a16:creationId xmlns:a16="http://schemas.microsoft.com/office/drawing/2014/main" id="{2C0CB17F-D675-F827-796A-C269536161D7}"/>
+                    <a16:creationId xmlns:a16="http://schemas.microsoft.com/office/drawing/2014/main" id="{6CEAE81D-D9FA-C338-1581-466DDDAB37C0}"/>
                   </a:ext>
                 </a:extLst>
               </p:cNvPr>
@@ -21809,7 +21845,7 @@
               <p:cNvPr id="396" name="Google Shape;179;p1">
                 <a:extLst>
                   <a:ext uri="{FF2B5EF4-FFF2-40B4-BE49-F238E27FC236}">
-                    <a16:creationId xmlns:a16="http://schemas.microsoft.com/office/drawing/2014/main" id="{E62052B5-A7DE-1DD5-2172-8351704850B8}"/>
+                    <a16:creationId xmlns:a16="http://schemas.microsoft.com/office/drawing/2014/main" id="{DE1A80C4-C2F2-5C0C-9446-E9EB063C2A16}"/>
                   </a:ext>
                 </a:extLst>
               </p:cNvPr>
@@ -21844,7 +21880,7 @@
               <p:cNvPr id="397" name="Google Shape;180;p1">
                 <a:extLst>
                   <a:ext uri="{FF2B5EF4-FFF2-40B4-BE49-F238E27FC236}">
-                    <a16:creationId xmlns:a16="http://schemas.microsoft.com/office/drawing/2014/main" id="{E8D509A2-0D8C-D6CD-B8F1-DD2997226B94}"/>
+                    <a16:creationId xmlns:a16="http://schemas.microsoft.com/office/drawing/2014/main" id="{EE2C4800-73A2-A8E3-CFA5-47C3BBC0A326}"/>
                   </a:ext>
                 </a:extLst>
               </p:cNvPr>
@@ -21879,7 +21915,7 @@
               <p:cNvPr id="398" name="Google Shape;181;p1">
                 <a:extLst>
                   <a:ext uri="{FF2B5EF4-FFF2-40B4-BE49-F238E27FC236}">
-                    <a16:creationId xmlns:a16="http://schemas.microsoft.com/office/drawing/2014/main" id="{3E30938F-A341-433F-3055-C31FF767CC64}"/>
+                    <a16:creationId xmlns:a16="http://schemas.microsoft.com/office/drawing/2014/main" id="{BF63AA9D-2D31-4E30-61A3-B0372BBF7575}"/>
                   </a:ext>
                 </a:extLst>
               </p:cNvPr>
@@ -21914,7 +21950,7 @@
               <p:cNvPr id="399" name="Google Shape;183;p1">
                 <a:extLst>
                   <a:ext uri="{FF2B5EF4-FFF2-40B4-BE49-F238E27FC236}">
-                    <a16:creationId xmlns:a16="http://schemas.microsoft.com/office/drawing/2014/main" id="{D3B5F285-BD51-9242-8311-105F315C9168}"/>
+                    <a16:creationId xmlns:a16="http://schemas.microsoft.com/office/drawing/2014/main" id="{3E6EC4BD-4B11-151D-7C07-D9D2C58EFA96}"/>
                   </a:ext>
                 </a:extLst>
               </p:cNvPr>
@@ -21949,7 +21985,7 @@
               <p:cNvPr id="400" name="Google Shape;176;p1">
                 <a:extLst>
                   <a:ext uri="{FF2B5EF4-FFF2-40B4-BE49-F238E27FC236}">
-                    <a16:creationId xmlns:a16="http://schemas.microsoft.com/office/drawing/2014/main" id="{C0A095AB-B9BE-B8F7-EB9B-B90475F70692}"/>
+                    <a16:creationId xmlns:a16="http://schemas.microsoft.com/office/drawing/2014/main" id="{B9ADE50F-276C-B6B0-12F1-31B921EAF1DF}"/>
                   </a:ext>
                 </a:extLst>
               </p:cNvPr>
@@ -22011,7 +22047,7 @@
               <p:cNvPr id="401" name="Google Shape;184;p1">
                 <a:extLst>
                   <a:ext uri="{FF2B5EF4-FFF2-40B4-BE49-F238E27FC236}">
-                    <a16:creationId xmlns:a16="http://schemas.microsoft.com/office/drawing/2014/main" id="{BC96D185-DEF5-77EA-DAE6-1C76D9F23DB4}"/>
+                    <a16:creationId xmlns:a16="http://schemas.microsoft.com/office/drawing/2014/main" id="{4A80ACD9-AEAB-B21B-4AA1-ED455B124CBB}"/>
                   </a:ext>
                 </a:extLst>
               </p:cNvPr>
@@ -22046,7 +22082,7 @@
               <p:cNvPr id="402" name="Google Shape;185;p1">
                 <a:extLst>
                   <a:ext uri="{FF2B5EF4-FFF2-40B4-BE49-F238E27FC236}">
-                    <a16:creationId xmlns:a16="http://schemas.microsoft.com/office/drawing/2014/main" id="{E604A188-78FF-DE60-D012-522D665F3B67}"/>
+                    <a16:creationId xmlns:a16="http://schemas.microsoft.com/office/drawing/2014/main" id="{3F7D0B8A-858A-36CD-5F01-5BC448428FAA}"/>
                   </a:ext>
                 </a:extLst>
               </p:cNvPr>
@@ -22081,7 +22117,7 @@
               <p:cNvPr id="403" name="Google Shape;174;p1">
                 <a:extLst>
                   <a:ext uri="{FF2B5EF4-FFF2-40B4-BE49-F238E27FC236}">
-                    <a16:creationId xmlns:a16="http://schemas.microsoft.com/office/drawing/2014/main" id="{32961F1C-AC74-8E11-0A7B-1C8848AEEF14}"/>
+                    <a16:creationId xmlns:a16="http://schemas.microsoft.com/office/drawing/2014/main" id="{BF73F92F-F91D-E5B4-A902-7C08600E36ED}"/>
                   </a:ext>
                 </a:extLst>
               </p:cNvPr>
@@ -22143,7 +22179,7 @@
               <p:cNvPr id="404" name="Google Shape;186;p1">
                 <a:extLst>
                   <a:ext uri="{FF2B5EF4-FFF2-40B4-BE49-F238E27FC236}">
-                    <a16:creationId xmlns:a16="http://schemas.microsoft.com/office/drawing/2014/main" id="{A8B4F513-5074-F07B-F35E-354510BB4E4F}"/>
+                    <a16:creationId xmlns:a16="http://schemas.microsoft.com/office/drawing/2014/main" id="{3D365C0B-0BC3-B94F-D206-CC8F03325638}"/>
                   </a:ext>
                 </a:extLst>
               </p:cNvPr>
@@ -22178,7 +22214,7 @@
               <p:cNvPr id="405" name="Google Shape;187;p1">
                 <a:extLst>
                   <a:ext uri="{FF2B5EF4-FFF2-40B4-BE49-F238E27FC236}">
-                    <a16:creationId xmlns:a16="http://schemas.microsoft.com/office/drawing/2014/main" id="{5A5A09E7-EA04-581E-BD8D-083E8306D8CD}"/>
+                    <a16:creationId xmlns:a16="http://schemas.microsoft.com/office/drawing/2014/main" id="{9A3A77DD-6E0C-0F0B-1489-D919CE1BADC5}"/>
                   </a:ext>
                 </a:extLst>
               </p:cNvPr>
@@ -22213,7 +22249,7 @@
               <p:cNvPr id="406" name="Google Shape;189;p1">
                 <a:extLst>
                   <a:ext uri="{FF2B5EF4-FFF2-40B4-BE49-F238E27FC236}">
-                    <a16:creationId xmlns:a16="http://schemas.microsoft.com/office/drawing/2014/main" id="{BBCAAF01-F47D-BEC4-8586-4A329FDF4B93}"/>
+                    <a16:creationId xmlns:a16="http://schemas.microsoft.com/office/drawing/2014/main" id="{4EE0D13A-5BED-4536-4595-FD9FA468092B}"/>
                   </a:ext>
                 </a:extLst>
               </p:cNvPr>
@@ -22248,7 +22284,7 @@
               <p:cNvPr id="407" name="Google Shape;190;p1">
                 <a:extLst>
                   <a:ext uri="{FF2B5EF4-FFF2-40B4-BE49-F238E27FC236}">
-                    <a16:creationId xmlns:a16="http://schemas.microsoft.com/office/drawing/2014/main" id="{CD1B6A64-3EA5-2626-EE4B-0D84903B5CFA}"/>
+                    <a16:creationId xmlns:a16="http://schemas.microsoft.com/office/drawing/2014/main" id="{4E415A28-1515-A706-6F5F-BFEEDA5AD392}"/>
                   </a:ext>
                 </a:extLst>
               </p:cNvPr>
@@ -22283,7 +22319,7 @@
               <p:cNvPr id="408" name="Google Shape;191;p1">
                 <a:extLst>
                   <a:ext uri="{FF2B5EF4-FFF2-40B4-BE49-F238E27FC236}">
-                    <a16:creationId xmlns:a16="http://schemas.microsoft.com/office/drawing/2014/main" id="{633D3A88-6785-55AA-901E-A7B1B1D3F54F}"/>
+                    <a16:creationId xmlns:a16="http://schemas.microsoft.com/office/drawing/2014/main" id="{4D1A132A-B880-97B1-676F-F4EF716BA991}"/>
                   </a:ext>
                 </a:extLst>
               </p:cNvPr>
@@ -22318,7 +22354,7 @@
               <p:cNvPr id="409" name="Google Shape;188;p1">
                 <a:extLst>
                   <a:ext uri="{FF2B5EF4-FFF2-40B4-BE49-F238E27FC236}">
-                    <a16:creationId xmlns:a16="http://schemas.microsoft.com/office/drawing/2014/main" id="{BA09D261-3DD4-7139-5F44-F0DC3163CC83}"/>
+                    <a16:creationId xmlns:a16="http://schemas.microsoft.com/office/drawing/2014/main" id="{4123478D-87F1-87A7-9176-2CC143180A11}"/>
                   </a:ext>
                 </a:extLst>
               </p:cNvPr>
@@ -22380,7 +22416,7 @@
               <p:cNvPr id="410" name="Google Shape;192;p1">
                 <a:extLst>
                   <a:ext uri="{FF2B5EF4-FFF2-40B4-BE49-F238E27FC236}">
-                    <a16:creationId xmlns:a16="http://schemas.microsoft.com/office/drawing/2014/main" id="{C4815E66-157A-9AF7-1BD8-6C15A6026A13}"/>
+                    <a16:creationId xmlns:a16="http://schemas.microsoft.com/office/drawing/2014/main" id="{F622FDB6-4EC6-8100-BC99-1AF11AFF5859}"/>
                   </a:ext>
                 </a:extLst>
               </p:cNvPr>
@@ -22415,7 +22451,7 @@
               <p:cNvPr id="411" name="Google Shape;182;p1">
                 <a:extLst>
                   <a:ext uri="{FF2B5EF4-FFF2-40B4-BE49-F238E27FC236}">
-                    <a16:creationId xmlns:a16="http://schemas.microsoft.com/office/drawing/2014/main" id="{DA49F370-E2AF-E123-F08F-3BD62EDFFAFC}"/>
+                    <a16:creationId xmlns:a16="http://schemas.microsoft.com/office/drawing/2014/main" id="{B38BDC3A-DFFE-6AA4-7B37-404474D6C979}"/>
                   </a:ext>
                 </a:extLst>
               </p:cNvPr>
@@ -22477,7 +22513,7 @@
               <p:cNvPr id="412" name="Google Shape;193;p1">
                 <a:extLst>
                   <a:ext uri="{FF2B5EF4-FFF2-40B4-BE49-F238E27FC236}">
-                    <a16:creationId xmlns:a16="http://schemas.microsoft.com/office/drawing/2014/main" id="{BE0D87CA-556F-3D82-E04E-664749114205}"/>
+                    <a16:creationId xmlns:a16="http://schemas.microsoft.com/office/drawing/2014/main" id="{9091DDD0-6121-A6EA-02F2-8DFC8FD95358}"/>
                   </a:ext>
                 </a:extLst>
               </p:cNvPr>
@@ -22512,7 +22548,7 @@
               <p:cNvPr id="413" name="Google Shape;194;p1">
                 <a:extLst>
                   <a:ext uri="{FF2B5EF4-FFF2-40B4-BE49-F238E27FC236}">
-                    <a16:creationId xmlns:a16="http://schemas.microsoft.com/office/drawing/2014/main" id="{C3D9A7E7-43B1-D03F-E826-C1A6707D54D7}"/>
+                    <a16:creationId xmlns:a16="http://schemas.microsoft.com/office/drawing/2014/main" id="{69794FB9-8CD7-EB35-5932-A5EFDA6F55E5}"/>
                   </a:ext>
                 </a:extLst>
               </p:cNvPr>
@@ -22547,7 +22583,7 @@
               <p:cNvPr id="414" name="Google Shape;195;p1">
                 <a:extLst>
                   <a:ext uri="{FF2B5EF4-FFF2-40B4-BE49-F238E27FC236}">
-                    <a16:creationId xmlns:a16="http://schemas.microsoft.com/office/drawing/2014/main" id="{1583BCDC-63A2-7FC8-FE05-1ED93E97688D}"/>
+                    <a16:creationId xmlns:a16="http://schemas.microsoft.com/office/drawing/2014/main" id="{29864068-C842-852C-1745-2453F5D29DF4}"/>
                   </a:ext>
                 </a:extLst>
               </p:cNvPr>
@@ -22582,7 +22618,7 @@
               <p:cNvPr id="415" name="Google Shape;196;p1">
                 <a:extLst>
                   <a:ext uri="{FF2B5EF4-FFF2-40B4-BE49-F238E27FC236}">
-                    <a16:creationId xmlns:a16="http://schemas.microsoft.com/office/drawing/2014/main" id="{DF229163-3E6C-9FBA-97E4-349B82AE0889}"/>
+                    <a16:creationId xmlns:a16="http://schemas.microsoft.com/office/drawing/2014/main" id="{2DFD50F0-7D86-E58B-ADE1-2D0FA7156FF3}"/>
                   </a:ext>
                 </a:extLst>
               </p:cNvPr>
@@ -22617,7 +22653,7 @@
               <p:cNvPr id="416" name="Google Shape;197;p1">
                 <a:extLst>
                   <a:ext uri="{FF2B5EF4-FFF2-40B4-BE49-F238E27FC236}">
-                    <a16:creationId xmlns:a16="http://schemas.microsoft.com/office/drawing/2014/main" id="{DEFE91E6-83A3-392E-F143-F607BCCB8F93}"/>
+                    <a16:creationId xmlns:a16="http://schemas.microsoft.com/office/drawing/2014/main" id="{9B89B0A9-D0DA-EED8-E88F-A92358ACA2D2}"/>
                   </a:ext>
                 </a:extLst>
               </p:cNvPr>
@@ -22652,7 +22688,7 @@
               <p:cNvPr id="417" name="Google Shape;198;p1">
                 <a:extLst>
                   <a:ext uri="{FF2B5EF4-FFF2-40B4-BE49-F238E27FC236}">
-                    <a16:creationId xmlns:a16="http://schemas.microsoft.com/office/drawing/2014/main" id="{894A9106-F17F-3A0E-94D4-0F321145F300}"/>
+                    <a16:creationId xmlns:a16="http://schemas.microsoft.com/office/drawing/2014/main" id="{FC624C4B-75E7-B9C7-DEFE-64B66718155D}"/>
                   </a:ext>
                 </a:extLst>
               </p:cNvPr>
@@ -22687,7 +22723,7 @@
               <p:cNvPr id="418" name="Google Shape;199;p1">
                 <a:extLst>
                   <a:ext uri="{FF2B5EF4-FFF2-40B4-BE49-F238E27FC236}">
-                    <a16:creationId xmlns:a16="http://schemas.microsoft.com/office/drawing/2014/main" id="{921F40C5-C444-AA18-7E25-EADF2B5DC104}"/>
+                    <a16:creationId xmlns:a16="http://schemas.microsoft.com/office/drawing/2014/main" id="{EFC88DDD-85FD-73DF-3BD5-29AC4FA46131}"/>
                   </a:ext>
                 </a:extLst>
               </p:cNvPr>
@@ -22722,7 +22758,7 @@
               <p:cNvPr id="419" name="Google Shape;200;p1">
                 <a:extLst>
                   <a:ext uri="{FF2B5EF4-FFF2-40B4-BE49-F238E27FC236}">
-                    <a16:creationId xmlns:a16="http://schemas.microsoft.com/office/drawing/2014/main" id="{5D66DFAD-8988-0832-603B-B71941F1361D}"/>
+                    <a16:creationId xmlns:a16="http://schemas.microsoft.com/office/drawing/2014/main" id="{49646157-9960-5C39-A90F-301912418625}"/>
                   </a:ext>
                 </a:extLst>
               </p:cNvPr>
@@ -22758,7 +22794,7 @@
             <p:cNvPr id="17" name="Table">
               <a:extLst>
                 <a:ext uri="{FF2B5EF4-FFF2-40B4-BE49-F238E27FC236}">
-                  <a16:creationId xmlns:a16="http://schemas.microsoft.com/office/drawing/2014/main" id="{19C8E28E-038C-BFED-70B1-A78228B93F0C}"/>
+                  <a16:creationId xmlns:a16="http://schemas.microsoft.com/office/drawing/2014/main" id="{CEFB0C1D-ED73-AF85-3CE6-22AA7743DC4B}"/>
                 </a:ext>
               </a:extLst>
             </p:cNvPr>
@@ -22767,7 +22803,7 @@
           </p:nvGraphicFramePr>
           <p:xfrm>
             <a:off x="5154380" y="6200121"/>
-            <a:ext cx="627864" cy="475004"/>
+            <a:ext cx="627864" cy="475211"/>
           </p:xfrm>
           <a:graphic>
             <a:graphicData uri="http://schemas.openxmlformats.org/drawingml/2006/table">
@@ -23543,7 +23579,7 @@
           <p:cNvPr id="11" name="TextBox 10">
             <a:extLst>
               <a:ext uri="{FF2B5EF4-FFF2-40B4-BE49-F238E27FC236}">
-                <a16:creationId xmlns:a16="http://schemas.microsoft.com/office/drawing/2014/main" id="{329408FF-87C0-734F-E8CA-FFBAC9B16ABF}"/>
+                <a16:creationId xmlns:a16="http://schemas.microsoft.com/office/drawing/2014/main" id="{D3EE9BA8-4298-2F34-B040-0221447605E3}"/>
               </a:ext>
             </a:extLst>
           </p:cNvPr>
@@ -23552,8 +23588,8 @@
         </p:nvSpPr>
         <p:spPr>
           <a:xfrm>
-            <a:off x="274319" y="3749040"/>
-            <a:ext cx="3291840" cy="1463040"/>
+            <a:off x="274319" y="3931920"/>
+            <a:ext cx="3291840" cy="1462404"/>
           </a:xfrm>
           <a:prstGeom prst="rect">
             <a:avLst/>
@@ -23619,7 +23655,7 @@
           <p:cNvPr id="14" name="TextBox 13">
             <a:extLst>
               <a:ext uri="{FF2B5EF4-FFF2-40B4-BE49-F238E27FC236}">
-                <a16:creationId xmlns:a16="http://schemas.microsoft.com/office/drawing/2014/main" id="{9C00D49E-56F1-3DAF-C5D0-6E1EBB670E87}"/>
+                <a16:creationId xmlns:a16="http://schemas.microsoft.com/office/drawing/2014/main" id="{5AB50F7E-9925-3F1F-F830-CF5F44D0D919}"/>
               </a:ext>
             </a:extLst>
           </p:cNvPr>
@@ -23628,8 +23664,8 @@
         </p:nvSpPr>
         <p:spPr>
           <a:xfrm>
-            <a:off x="274320" y="5577840"/>
-            <a:ext cx="3291840" cy="1828800"/>
+            <a:off x="274320" y="5943600"/>
+            <a:ext cx="3291840" cy="1828004"/>
           </a:xfrm>
           <a:prstGeom prst="rect">
             <a:avLst/>
@@ -23708,7 +23744,7 @@
           <p:cNvPr id="16" name="TextBox 15">
             <a:extLst>
               <a:ext uri="{FF2B5EF4-FFF2-40B4-BE49-F238E27FC236}">
-                <a16:creationId xmlns:a16="http://schemas.microsoft.com/office/drawing/2014/main" id="{4FD198A5-8126-BCFB-A80C-CD9FCD4D0792}"/>
+                <a16:creationId xmlns:a16="http://schemas.microsoft.com/office/drawing/2014/main" id="{BF842AE7-B865-BC06-D907-9C8FDDC5F5DB}"/>
               </a:ext>
             </a:extLst>
           </p:cNvPr>
@@ -23717,8 +23753,8 @@
         </p:nvSpPr>
         <p:spPr>
           <a:xfrm>
-            <a:off x="274320" y="7772400"/>
-            <a:ext cx="3566160" cy="2286000"/>
+            <a:off x="274320" y="8312142"/>
+            <a:ext cx="3566160" cy="2028680"/>
           </a:xfrm>
           <a:prstGeom prst="rect">
             <a:avLst/>
@@ -23784,19 +23820,7 @@
           <a:p>
             <a:r>
               <a:rPr lang="en-US" sz="1300" dirty="0"/>
-              <a:t>3. transform_reply_to_bipartite_network()</a:t>
-            </a:r>
-          </a:p>
-          <a:p>
-            <a:r>
-              <a:rPr lang="en-US" b="0" dirty="0"/>
-              <a:t>Reply table → person-issue bipartite graph.</a:t>
-            </a:r>
-          </a:p>
-          <a:p>
-            <a:r>
-              <a:rPr lang="en-US" sz="1300" dirty="0"/>
-              <a:t>4. …</a:t>
+              <a:t>3. …</a:t>
             </a:r>
             <a:endParaRPr lang="en-US" sz="1400" b="0" dirty="0"/>
           </a:p>
@@ -23807,7 +23831,7 @@
           <p:cNvPr id="3" name="Line">
             <a:extLst>
               <a:ext uri="{FF2B5EF4-FFF2-40B4-BE49-F238E27FC236}">
-                <a16:creationId xmlns:a16="http://schemas.microsoft.com/office/drawing/2014/main" id="{1B65CB05-C9BE-D047-A1EC-B1BDA2E90867}"/>
+                <a16:creationId xmlns:a16="http://schemas.microsoft.com/office/drawing/2014/main" id="{2E7DC389-9F22-01EE-682A-DDFB748C5E53}"/>
               </a:ext>
             </a:extLst>
           </p:cNvPr>
@@ -23816,7 +23840,7 @@
         </p:nvSpPr>
         <p:spPr>
           <a:xfrm flipV="1">
-            <a:off x="274320" y="1737360"/>
+            <a:off x="274320" y="2011680"/>
             <a:ext cx="3291840" cy="0"/>
           </a:xfrm>
           <a:prstGeom prst="line">
@@ -23846,7 +23870,7 @@
                 </a:solidFill>
               </a:defRPr>
             </a:pPr>
-            <a:endParaRPr/>
+            <a:endParaRPr dirty="0"/>
           </a:p>
         </p:txBody>
       </p:sp>
@@ -23855,7 +23879,7 @@
           <p:cNvPr id="4" name="Line">
             <a:extLst>
               <a:ext uri="{FF2B5EF4-FFF2-40B4-BE49-F238E27FC236}">
-                <a16:creationId xmlns:a16="http://schemas.microsoft.com/office/drawing/2014/main" id="{2627C03E-32E3-1503-AD05-1455FD21438A}"/>
+                <a16:creationId xmlns:a16="http://schemas.microsoft.com/office/drawing/2014/main" id="{938669AC-B0A7-7F53-AD7D-8D3E73F176A3}"/>
               </a:ext>
             </a:extLst>
           </p:cNvPr>
@@ -23864,7 +23888,7 @@
         </p:nvSpPr>
         <p:spPr>
           <a:xfrm flipV="1">
-            <a:off x="274320" y="3749040"/>
+            <a:off x="274320" y="3840480"/>
             <a:ext cx="3291840" cy="0"/>
           </a:xfrm>
           <a:prstGeom prst="line">
@@ -23894,7 +23918,7 @@
                 </a:solidFill>
               </a:defRPr>
             </a:pPr>
-            <a:endParaRPr/>
+            <a:endParaRPr dirty="0"/>
           </a:p>
         </p:txBody>
       </p:sp>
@@ -23903,7 +23927,7 @@
           <p:cNvPr id="22" name="Line">
             <a:extLst>
               <a:ext uri="{FF2B5EF4-FFF2-40B4-BE49-F238E27FC236}">
-                <a16:creationId xmlns:a16="http://schemas.microsoft.com/office/drawing/2014/main" id="{3601EFF4-C6AE-DC65-15D1-D2E33045286A}"/>
+                <a16:creationId xmlns:a16="http://schemas.microsoft.com/office/drawing/2014/main" id="{1AC7F835-7F14-94BB-ACF9-022F8A641DE1}"/>
               </a:ext>
             </a:extLst>
           </p:cNvPr>
@@ -23912,7 +23936,7 @@
         </p:nvSpPr>
         <p:spPr>
           <a:xfrm flipV="1">
-            <a:off x="274320" y="5577840"/>
+            <a:off x="274320" y="5852160"/>
             <a:ext cx="3291840" cy="0"/>
           </a:xfrm>
           <a:prstGeom prst="line">
@@ -23942,7 +23966,7 @@
                 </a:solidFill>
               </a:defRPr>
             </a:pPr>
-            <a:endParaRPr/>
+            <a:endParaRPr dirty="0"/>
           </a:p>
         </p:txBody>
       </p:sp>
@@ -23951,7 +23975,7 @@
           <p:cNvPr id="23" name="Line">
             <a:extLst>
               <a:ext uri="{FF2B5EF4-FFF2-40B4-BE49-F238E27FC236}">
-                <a16:creationId xmlns:a16="http://schemas.microsoft.com/office/drawing/2014/main" id="{FBFCD262-4877-94E5-FA47-2CB930FE66D9}"/>
+                <a16:creationId xmlns:a16="http://schemas.microsoft.com/office/drawing/2014/main" id="{3F8AF958-7D9C-1B34-2E94-46B81DD88353}"/>
               </a:ext>
             </a:extLst>
           </p:cNvPr>
@@ -23960,7 +23984,7 @@
         </p:nvSpPr>
         <p:spPr>
           <a:xfrm flipV="1">
-            <a:off x="274320" y="7772400"/>
+            <a:off x="274320" y="8321040"/>
             <a:ext cx="3291840" cy="0"/>
           </a:xfrm>
           <a:prstGeom prst="line">
@@ -23990,7 +24014,7 @@
                 </a:solidFill>
               </a:defRPr>
             </a:pPr>
-            <a:endParaRPr/>
+            <a:endParaRPr dirty="0"/>
           </a:p>
         </p:txBody>
       </p:sp>
@@ -23999,7 +24023,7 @@
           <p:cNvPr id="29" name="Line">
             <a:extLst>
               <a:ext uri="{FF2B5EF4-FFF2-40B4-BE49-F238E27FC236}">
-                <a16:creationId xmlns:a16="http://schemas.microsoft.com/office/drawing/2014/main" id="{141FD609-7B32-4ED3-6357-935B69313972}"/>
+                <a16:creationId xmlns:a16="http://schemas.microsoft.com/office/drawing/2014/main" id="{52F48625-0EAD-F540-FC9A-C4ACB0C6FB4E}"/>
               </a:ext>
             </a:extLst>
           </p:cNvPr>
@@ -24008,7 +24032,7 @@
         </p:nvSpPr>
         <p:spPr>
           <a:xfrm flipV="1">
-            <a:off x="9875518" y="1737360"/>
+            <a:off x="9875518" y="2011680"/>
             <a:ext cx="4023360" cy="0"/>
           </a:xfrm>
           <a:prstGeom prst="line">
@@ -24038,52 +24062,16 @@
                 </a:solidFill>
               </a:defRPr>
             </a:pPr>
-            <a:endParaRPr/>
+            <a:endParaRPr dirty="0"/>
           </a:p>
         </p:txBody>
       </p:sp>
-      <p:pic>
-        <p:nvPicPr>
-          <p:cNvPr id="8" name="Picture 7" descr="A picture containing text&#10;&#10;Description automatically generated">
-            <a:extLst>
-              <a:ext uri="{FF2B5EF4-FFF2-40B4-BE49-F238E27FC236}">
-                <a16:creationId xmlns:a16="http://schemas.microsoft.com/office/drawing/2014/main" id="{B820F464-AE64-53D1-41F0-9489F72A3217}"/>
-              </a:ext>
-            </a:extLst>
-          </p:cNvPr>
-          <p:cNvPicPr>
-            <a:picLocks noChangeAspect="1"/>
-          </p:cNvPicPr>
-          <p:nvPr/>
-        </p:nvPicPr>
-        <p:blipFill>
-          <a:blip r:embed="rId7" cstate="print">
-            <a:extLst>
-              <a:ext uri="{28A0092B-C50C-407E-A947-70E740481C1C}">
-                <a14:useLocalDpi xmlns:a14="http://schemas.microsoft.com/office/drawing/2010/main" val="0"/>
-              </a:ext>
-            </a:extLst>
-          </a:blip>
-          <a:stretch>
-            <a:fillRect/>
-          </a:stretch>
-        </p:blipFill>
-        <p:spPr>
-          <a:xfrm>
-            <a:off x="12214310" y="122459"/>
-            <a:ext cx="1443262" cy="1676046"/>
-          </a:xfrm>
-          <a:prstGeom prst="rect">
-            <a:avLst/>
-          </a:prstGeom>
-        </p:spPr>
-      </p:pic>
       <p:sp>
         <p:nvSpPr>
           <p:cNvPr id="30" name="Line">
             <a:extLst>
               <a:ext uri="{FF2B5EF4-FFF2-40B4-BE49-F238E27FC236}">
-                <a16:creationId xmlns:a16="http://schemas.microsoft.com/office/drawing/2014/main" id="{4B715B61-7107-3C4C-F533-4E659BE7B126}"/>
+                <a16:creationId xmlns:a16="http://schemas.microsoft.com/office/drawing/2014/main" id="{295A37EB-B8E9-CB58-4DF8-8BADD874A03D}"/>
               </a:ext>
             </a:extLst>
           </p:cNvPr>
@@ -24092,7 +24080,7 @@
         </p:nvSpPr>
         <p:spPr>
           <a:xfrm flipV="1">
-            <a:off x="9875518" y="3840480"/>
+            <a:off x="9875518" y="4114800"/>
             <a:ext cx="4023360" cy="0"/>
           </a:xfrm>
           <a:prstGeom prst="line">
@@ -24122,7 +24110,7 @@
                 </a:solidFill>
               </a:defRPr>
             </a:pPr>
-            <a:endParaRPr/>
+            <a:endParaRPr dirty="0"/>
           </a:p>
         </p:txBody>
       </p:sp>
@@ -24131,7 +24119,7 @@
           <p:cNvPr id="34" name="Line">
             <a:extLst>
               <a:ext uri="{FF2B5EF4-FFF2-40B4-BE49-F238E27FC236}">
-                <a16:creationId xmlns:a16="http://schemas.microsoft.com/office/drawing/2014/main" id="{4381059C-443F-62AB-6679-41D7ECFF8952}"/>
+                <a16:creationId xmlns:a16="http://schemas.microsoft.com/office/drawing/2014/main" id="{45E426F2-CB7D-F357-04F9-512BC89E458C}"/>
               </a:ext>
             </a:extLst>
           </p:cNvPr>
@@ -24140,7 +24128,7 @@
         </p:nvSpPr>
         <p:spPr>
           <a:xfrm flipV="1">
-            <a:off x="9875518" y="8595360"/>
+            <a:off x="9875518" y="8686800"/>
             <a:ext cx="4023360" cy="0"/>
           </a:xfrm>
           <a:prstGeom prst="line">
@@ -24170,7 +24158,7 @@
                 </a:solidFill>
               </a:defRPr>
             </a:pPr>
-            <a:endParaRPr/>
+            <a:endParaRPr dirty="0"/>
           </a:p>
         </p:txBody>
       </p:sp>
@@ -24179,7 +24167,7 @@
           <p:cNvPr id="41" name="Line">
             <a:extLst>
               <a:ext uri="{FF2B5EF4-FFF2-40B4-BE49-F238E27FC236}">
-                <a16:creationId xmlns:a16="http://schemas.microsoft.com/office/drawing/2014/main" id="{9745F780-A0E0-51EC-01A0-AFADFD19ABEA}"/>
+                <a16:creationId xmlns:a16="http://schemas.microsoft.com/office/drawing/2014/main" id="{2995FA16-4C6F-72D3-BFE2-7C33D7B3005B}"/>
               </a:ext>
             </a:extLst>
           </p:cNvPr>
@@ -24188,7 +24176,7 @@
         </p:nvSpPr>
         <p:spPr>
           <a:xfrm flipV="1">
-            <a:off x="4937760" y="1737360"/>
+            <a:off x="4937760" y="2011680"/>
             <a:ext cx="3749040" cy="0"/>
           </a:xfrm>
           <a:prstGeom prst="line">
@@ -24218,7 +24206,7 @@
                 </a:solidFill>
               </a:defRPr>
             </a:pPr>
-            <a:endParaRPr/>
+            <a:endParaRPr dirty="0"/>
           </a:p>
         </p:txBody>
       </p:sp>
@@ -24227,7 +24215,7 @@
           <p:cNvPr id="6" name="Manipulate Variables">
             <a:extLst>
               <a:ext uri="{FF2B5EF4-FFF2-40B4-BE49-F238E27FC236}">
-                <a16:creationId xmlns:a16="http://schemas.microsoft.com/office/drawing/2014/main" id="{3D3F03FD-A18D-898C-CDE9-57546DDF2966}"/>
+                <a16:creationId xmlns:a16="http://schemas.microsoft.com/office/drawing/2014/main" id="{B939833B-A5F2-8362-B569-3466D533B04A}"/>
               </a:ext>
             </a:extLst>
           </p:cNvPr>
@@ -24236,8 +24224,8 @@
         </p:nvSpPr>
         <p:spPr>
           <a:xfrm>
-            <a:off x="9875520" y="1459299"/>
-            <a:ext cx="2644955" cy="340029"/>
+            <a:off x="9875520" y="1645920"/>
+            <a:ext cx="2644955" cy="339881"/>
           </a:xfrm>
           <a:prstGeom prst="rect">
             <a:avLst/>
@@ -24283,7 +24271,7 @@
           <p:cNvPr id="421" name="Manipulate Variables">
             <a:extLst>
               <a:ext uri="{FF2B5EF4-FFF2-40B4-BE49-F238E27FC236}">
-                <a16:creationId xmlns:a16="http://schemas.microsoft.com/office/drawing/2014/main" id="{7C336D8E-19AF-48D0-5C2F-6C453E98D41D}"/>
+                <a16:creationId xmlns:a16="http://schemas.microsoft.com/office/drawing/2014/main" id="{90C35465-FC5C-C207-7547-8A8AECAA8E54}"/>
               </a:ext>
             </a:extLst>
           </p:cNvPr>
@@ -24293,7 +24281,7 @@
         <p:spPr>
           <a:xfrm>
             <a:off x="9875520" y="8321040"/>
-            <a:ext cx="3085781" cy="340029"/>
+            <a:ext cx="3085781" cy="339881"/>
           </a:xfrm>
           <a:prstGeom prst="rect">
             <a:avLst/>
@@ -24339,7 +24327,7 @@
           <p:cNvPr id="424" name="Layout Suggestions">
             <a:extLst>
               <a:ext uri="{FF2B5EF4-FFF2-40B4-BE49-F238E27FC236}">
-                <a16:creationId xmlns:a16="http://schemas.microsoft.com/office/drawing/2014/main" id="{C740CFCB-250E-91D4-A09E-AFDE2D915000}"/>
+                <a16:creationId xmlns:a16="http://schemas.microsoft.com/office/drawing/2014/main" id="{3FCD3430-6D3D-1A52-F2F3-36E77C1816B4}"/>
               </a:ext>
             </a:extLst>
           </p:cNvPr>
@@ -24348,8 +24336,8 @@
         </p:nvSpPr>
         <p:spPr>
           <a:xfrm>
-            <a:off x="4937760" y="1463040"/>
-            <a:ext cx="3840480" cy="340029"/>
+            <a:off x="4937760" y="1649659"/>
+            <a:ext cx="3840480" cy="339881"/>
           </a:xfrm>
           <a:prstGeom prst="rect">
             <a:avLst/>
@@ -24393,7 +24381,7 @@
     </p:spTree>
     <p:extLst>
       <p:ext uri="{BB962C8B-B14F-4D97-AF65-F5344CB8AC3E}">
-        <p14:creationId xmlns:p14="http://schemas.microsoft.com/office/powerpoint/2010/main" val="2043883487"/>
+        <p14:creationId xmlns:p14="http://schemas.microsoft.com/office/powerpoint/2010/main" val="4203992668"/>
       </p:ext>
     </p:extLst>
   </p:cSld>

</xml_diff>